<commit_message>
3D: textured bevels, light angles and per-shape lighting
Co-Authored-By: Claude Opus 5.5 <noreply@anthropic.com>
</commit_message>
<xml_diff>
--- a/tests/corpus/pptx/generated/three-d.pptx
+++ b/tests/corpus/pptx/generated/three-d.pptx
@@ -10,6 +10,8 @@
     <p:sldId id="258" r:id="rId4"/>
     <p:sldId id="259" r:id="rId5"/>
     <p:sldId id="260" r:id="rId6"/>
+    <p:sldId id="261" r:id="rId7"/>
+    <p:sldId id="262" r:id="rId8"/>
   </p:sldIdLst>
   <p:sldSz cx="12192000" cy="6858000"/>
   <p:notesSz cx="6858000" cy="9144000"/>
@@ -133,7 +135,7 @@
           <p:cNvPr id="2" name="Titel 1">
             <a:extLst>
               <a:ext uri="{FF2B5EF4-FFF2-40B4-BE49-F238E27FC236}">
-                <a16:creationId xmlns:a16="http://schemas.microsoft.com/office/drawing/2014/main" id="{1249D408-4B49-18EB-867A-5D130588CE8F}"/>
+                <a16:creationId xmlns:a16="http://schemas.microsoft.com/office/drawing/2014/main" id="{3086B9CB-5317-3D1E-B703-C53E153F8FD0}"/>
               </a:ext>
             </a:extLst>
           </p:cNvPr>
@@ -170,7 +172,7 @@
           <p:cNvPr id="3" name="Untertitel 2">
             <a:extLst>
               <a:ext uri="{FF2B5EF4-FFF2-40B4-BE49-F238E27FC236}">
-                <a16:creationId xmlns:a16="http://schemas.microsoft.com/office/drawing/2014/main" id="{4CF353C4-28E8-1228-BDE5-4E1138A21B7E}"/>
+                <a16:creationId xmlns:a16="http://schemas.microsoft.com/office/drawing/2014/main" id="{7EFF0B3E-9321-D164-7B49-EF4F1D82691B}"/>
               </a:ext>
             </a:extLst>
           </p:cNvPr>
@@ -240,7 +242,7 @@
           <p:cNvPr id="4" name="Datumsplatzhalter 3">
             <a:extLst>
               <a:ext uri="{FF2B5EF4-FFF2-40B4-BE49-F238E27FC236}">
-                <a16:creationId xmlns:a16="http://schemas.microsoft.com/office/drawing/2014/main" id="{4C2B3606-8F4E-931B-F26C-B183DF94AC6B}"/>
+                <a16:creationId xmlns:a16="http://schemas.microsoft.com/office/drawing/2014/main" id="{5A2C85ED-068B-43FF-515F-FD7DC5BE34AD}"/>
               </a:ext>
             </a:extLst>
           </p:cNvPr>
@@ -256,7 +258,7 @@
           <a:bodyPr/>
           <a:lstStyle/>
           <a:p>
-            <a:fld id="{B5996854-510B-471A-9832-4FFEEC0483F4}" type="datetimeFigureOut">
+            <a:fld id="{8DFF278A-23B3-4EF2-94AC-4635568519FC}" type="datetimeFigureOut">
               <a:rPr lang="de-DE" smtClean="0"/>
               <a:t>08.10.2026</a:t>
             </a:fld>
@@ -269,7 +271,7 @@
           <p:cNvPr id="5" name="Fußzeilenplatzhalter 4">
             <a:extLst>
               <a:ext uri="{FF2B5EF4-FFF2-40B4-BE49-F238E27FC236}">
-                <a16:creationId xmlns:a16="http://schemas.microsoft.com/office/drawing/2014/main" id="{4038743E-2D0D-8171-9370-7B1DB649CDE2}"/>
+                <a16:creationId xmlns:a16="http://schemas.microsoft.com/office/drawing/2014/main" id="{00FF9B0F-B59A-6F35-203C-F4AD10CBB079}"/>
               </a:ext>
             </a:extLst>
           </p:cNvPr>
@@ -294,7 +296,7 @@
           <p:cNvPr id="6" name="Foliennummernplatzhalter 5">
             <a:extLst>
               <a:ext uri="{FF2B5EF4-FFF2-40B4-BE49-F238E27FC236}">
-                <a16:creationId xmlns:a16="http://schemas.microsoft.com/office/drawing/2014/main" id="{A47A15F0-6F70-AF19-A1FE-1983BB8C0A04}"/>
+                <a16:creationId xmlns:a16="http://schemas.microsoft.com/office/drawing/2014/main" id="{E38BDAC6-C29A-3E73-6FD1-3C1C49B8E8A6}"/>
               </a:ext>
             </a:extLst>
           </p:cNvPr>
@@ -310,7 +312,7 @@
           <a:bodyPr/>
           <a:lstStyle/>
           <a:p>
-            <a:fld id="{32C934A3-C752-4D88-870D-A6DA01E5DE15}" type="slidenum">
+            <a:fld id="{D1E4F72E-E169-431D-AEEC-457F8EDE78E5}" type="slidenum">
               <a:rPr lang="de-DE" smtClean="0"/>
               <a:t>‹Nr.›</a:t>
             </a:fld>
@@ -321,7 +323,7 @@
     </p:spTree>
     <p:extLst>
       <p:ext uri="{BB962C8B-B14F-4D97-AF65-F5344CB8AC3E}">
-        <p14:creationId xmlns:p14="http://schemas.microsoft.com/office/powerpoint/2010/main" val="106006651"/>
+        <p14:creationId xmlns:p14="http://schemas.microsoft.com/office/powerpoint/2010/main" val="3470613746"/>
       </p:ext>
     </p:extLst>
   </p:cSld>
@@ -353,7 +355,7 @@
           <p:cNvPr id="2" name="Titel 1">
             <a:extLst>
               <a:ext uri="{FF2B5EF4-FFF2-40B4-BE49-F238E27FC236}">
-                <a16:creationId xmlns:a16="http://schemas.microsoft.com/office/drawing/2014/main" id="{A90EB742-1927-A8E7-FE10-DCF1E164C8FF}"/>
+                <a16:creationId xmlns:a16="http://schemas.microsoft.com/office/drawing/2014/main" id="{8E8FE892-9C35-15FF-AC27-3DCEA2E7DB3B}"/>
               </a:ext>
             </a:extLst>
           </p:cNvPr>
@@ -381,7 +383,7 @@
           <p:cNvPr id="3" name="Vertikaler Textplatzhalter 2">
             <a:extLst>
               <a:ext uri="{FF2B5EF4-FFF2-40B4-BE49-F238E27FC236}">
-                <a16:creationId xmlns:a16="http://schemas.microsoft.com/office/drawing/2014/main" id="{513A387F-6F5E-5D20-FF5C-5DD10CD3EE4E}"/>
+                <a16:creationId xmlns:a16="http://schemas.microsoft.com/office/drawing/2014/main" id="{D6BF9F9E-DEC0-5EAB-776E-50B09613348B}"/>
               </a:ext>
             </a:extLst>
           </p:cNvPr>
@@ -438,7 +440,7 @@
           <p:cNvPr id="4" name="Datumsplatzhalter 3">
             <a:extLst>
               <a:ext uri="{FF2B5EF4-FFF2-40B4-BE49-F238E27FC236}">
-                <a16:creationId xmlns:a16="http://schemas.microsoft.com/office/drawing/2014/main" id="{F8A2D35C-A945-6E57-0A80-C77CECD9CC65}"/>
+                <a16:creationId xmlns:a16="http://schemas.microsoft.com/office/drawing/2014/main" id="{7980D30C-5F60-0C00-3876-B77A86681305}"/>
               </a:ext>
             </a:extLst>
           </p:cNvPr>
@@ -454,7 +456,7 @@
           <a:bodyPr/>
           <a:lstStyle/>
           <a:p>
-            <a:fld id="{B5996854-510B-471A-9832-4FFEEC0483F4}" type="datetimeFigureOut">
+            <a:fld id="{8DFF278A-23B3-4EF2-94AC-4635568519FC}" type="datetimeFigureOut">
               <a:rPr lang="de-DE" smtClean="0"/>
               <a:t>08.10.2026</a:t>
             </a:fld>
@@ -467,7 +469,7 @@
           <p:cNvPr id="5" name="Fußzeilenplatzhalter 4">
             <a:extLst>
               <a:ext uri="{FF2B5EF4-FFF2-40B4-BE49-F238E27FC236}">
-                <a16:creationId xmlns:a16="http://schemas.microsoft.com/office/drawing/2014/main" id="{FED5EC5C-070A-CBD1-C460-AAFC3F419A1F}"/>
+                <a16:creationId xmlns:a16="http://schemas.microsoft.com/office/drawing/2014/main" id="{117745B5-1633-2A0B-DA74-B7DD9DB128D0}"/>
               </a:ext>
             </a:extLst>
           </p:cNvPr>
@@ -492,7 +494,7 @@
           <p:cNvPr id="6" name="Foliennummernplatzhalter 5">
             <a:extLst>
               <a:ext uri="{FF2B5EF4-FFF2-40B4-BE49-F238E27FC236}">
-                <a16:creationId xmlns:a16="http://schemas.microsoft.com/office/drawing/2014/main" id="{AAC86E9C-65EA-8D40-671A-82236E819B50}"/>
+                <a16:creationId xmlns:a16="http://schemas.microsoft.com/office/drawing/2014/main" id="{1372A0A7-49BF-76C5-8C72-327954EAB859}"/>
               </a:ext>
             </a:extLst>
           </p:cNvPr>
@@ -508,7 +510,7 @@
           <a:bodyPr/>
           <a:lstStyle/>
           <a:p>
-            <a:fld id="{32C934A3-C752-4D88-870D-A6DA01E5DE15}" type="slidenum">
+            <a:fld id="{D1E4F72E-E169-431D-AEEC-457F8EDE78E5}" type="slidenum">
               <a:rPr lang="de-DE" smtClean="0"/>
               <a:t>‹Nr.›</a:t>
             </a:fld>
@@ -519,7 +521,7 @@
     </p:spTree>
     <p:extLst>
       <p:ext uri="{BB962C8B-B14F-4D97-AF65-F5344CB8AC3E}">
-        <p14:creationId xmlns:p14="http://schemas.microsoft.com/office/powerpoint/2010/main" val="926021657"/>
+        <p14:creationId xmlns:p14="http://schemas.microsoft.com/office/powerpoint/2010/main" val="200738675"/>
       </p:ext>
     </p:extLst>
   </p:cSld>
@@ -551,7 +553,7 @@
           <p:cNvPr id="2" name="Vertikaler Titel 1">
             <a:extLst>
               <a:ext uri="{FF2B5EF4-FFF2-40B4-BE49-F238E27FC236}">
-                <a16:creationId xmlns:a16="http://schemas.microsoft.com/office/drawing/2014/main" id="{69496035-CE23-FB6B-CF5F-DBC82A5B6822}"/>
+                <a16:creationId xmlns:a16="http://schemas.microsoft.com/office/drawing/2014/main" id="{8E3163E5-0C40-AB58-5118-B4FC5DAAA1EE}"/>
               </a:ext>
             </a:extLst>
           </p:cNvPr>
@@ -584,7 +586,7 @@
           <p:cNvPr id="3" name="Vertikaler Textplatzhalter 2">
             <a:extLst>
               <a:ext uri="{FF2B5EF4-FFF2-40B4-BE49-F238E27FC236}">
-                <a16:creationId xmlns:a16="http://schemas.microsoft.com/office/drawing/2014/main" id="{926C4095-2C4E-E2BB-992C-2C7C5BD23599}"/>
+                <a16:creationId xmlns:a16="http://schemas.microsoft.com/office/drawing/2014/main" id="{27044CD9-C976-51B6-45E3-5A1FAD08560E}"/>
               </a:ext>
             </a:extLst>
           </p:cNvPr>
@@ -646,7 +648,7 @@
           <p:cNvPr id="4" name="Datumsplatzhalter 3">
             <a:extLst>
               <a:ext uri="{FF2B5EF4-FFF2-40B4-BE49-F238E27FC236}">
-                <a16:creationId xmlns:a16="http://schemas.microsoft.com/office/drawing/2014/main" id="{189D2A54-3BD3-294A-1C9A-2FECC16541C9}"/>
+                <a16:creationId xmlns:a16="http://schemas.microsoft.com/office/drawing/2014/main" id="{A89CF696-C947-ABFD-6382-7AC1539382A1}"/>
               </a:ext>
             </a:extLst>
           </p:cNvPr>
@@ -662,7 +664,7 @@
           <a:bodyPr/>
           <a:lstStyle/>
           <a:p>
-            <a:fld id="{B5996854-510B-471A-9832-4FFEEC0483F4}" type="datetimeFigureOut">
+            <a:fld id="{8DFF278A-23B3-4EF2-94AC-4635568519FC}" type="datetimeFigureOut">
               <a:rPr lang="de-DE" smtClean="0"/>
               <a:t>08.10.2026</a:t>
             </a:fld>
@@ -675,7 +677,7 @@
           <p:cNvPr id="5" name="Fußzeilenplatzhalter 4">
             <a:extLst>
               <a:ext uri="{FF2B5EF4-FFF2-40B4-BE49-F238E27FC236}">
-                <a16:creationId xmlns:a16="http://schemas.microsoft.com/office/drawing/2014/main" id="{CEB8D198-9628-B80C-DECB-E65F0D482F5B}"/>
+                <a16:creationId xmlns:a16="http://schemas.microsoft.com/office/drawing/2014/main" id="{69D65BB5-D2FC-3887-1AB7-239842E9F529}"/>
               </a:ext>
             </a:extLst>
           </p:cNvPr>
@@ -700,7 +702,7 @@
           <p:cNvPr id="6" name="Foliennummernplatzhalter 5">
             <a:extLst>
               <a:ext uri="{FF2B5EF4-FFF2-40B4-BE49-F238E27FC236}">
-                <a16:creationId xmlns:a16="http://schemas.microsoft.com/office/drawing/2014/main" id="{EC4F50E3-0D50-2DD4-C09F-3A25A6AC7E9C}"/>
+                <a16:creationId xmlns:a16="http://schemas.microsoft.com/office/drawing/2014/main" id="{B418F604-C901-8EF7-135E-00991F1CD0AE}"/>
               </a:ext>
             </a:extLst>
           </p:cNvPr>
@@ -716,7 +718,7 @@
           <a:bodyPr/>
           <a:lstStyle/>
           <a:p>
-            <a:fld id="{32C934A3-C752-4D88-870D-A6DA01E5DE15}" type="slidenum">
+            <a:fld id="{D1E4F72E-E169-431D-AEEC-457F8EDE78E5}" type="slidenum">
               <a:rPr lang="de-DE" smtClean="0"/>
               <a:t>‹Nr.›</a:t>
             </a:fld>
@@ -727,7 +729,7 @@
     </p:spTree>
     <p:extLst>
       <p:ext uri="{BB962C8B-B14F-4D97-AF65-F5344CB8AC3E}">
-        <p14:creationId xmlns:p14="http://schemas.microsoft.com/office/powerpoint/2010/main" val="154593724"/>
+        <p14:creationId xmlns:p14="http://schemas.microsoft.com/office/powerpoint/2010/main" val="1900602023"/>
       </p:ext>
     </p:extLst>
   </p:cSld>
@@ -759,7 +761,7 @@
           <p:cNvPr id="2" name="Titel 1">
             <a:extLst>
               <a:ext uri="{FF2B5EF4-FFF2-40B4-BE49-F238E27FC236}">
-                <a16:creationId xmlns:a16="http://schemas.microsoft.com/office/drawing/2014/main" id="{73B196A5-DB66-4187-F041-18355706A865}"/>
+                <a16:creationId xmlns:a16="http://schemas.microsoft.com/office/drawing/2014/main" id="{14254B91-D2BF-1E7B-E485-889A25AF9D0A}"/>
               </a:ext>
             </a:extLst>
           </p:cNvPr>
@@ -787,7 +789,7 @@
           <p:cNvPr id="3" name="Inhaltsplatzhalter 2">
             <a:extLst>
               <a:ext uri="{FF2B5EF4-FFF2-40B4-BE49-F238E27FC236}">
-                <a16:creationId xmlns:a16="http://schemas.microsoft.com/office/drawing/2014/main" id="{335A2945-9366-74CA-D9A6-F981C4BE9B50}"/>
+                <a16:creationId xmlns:a16="http://schemas.microsoft.com/office/drawing/2014/main" id="{5992DC21-1F09-B703-348D-2047BA52FDA5}"/>
               </a:ext>
             </a:extLst>
           </p:cNvPr>
@@ -844,7 +846,7 @@
           <p:cNvPr id="4" name="Datumsplatzhalter 3">
             <a:extLst>
               <a:ext uri="{FF2B5EF4-FFF2-40B4-BE49-F238E27FC236}">
-                <a16:creationId xmlns:a16="http://schemas.microsoft.com/office/drawing/2014/main" id="{8DE5E889-6B38-BBCC-3762-0D61BDA4711B}"/>
+                <a16:creationId xmlns:a16="http://schemas.microsoft.com/office/drawing/2014/main" id="{A158F9FA-A667-D3B4-EC96-A97DB1AA2880}"/>
               </a:ext>
             </a:extLst>
           </p:cNvPr>
@@ -860,7 +862,7 @@
           <a:bodyPr/>
           <a:lstStyle/>
           <a:p>
-            <a:fld id="{B5996854-510B-471A-9832-4FFEEC0483F4}" type="datetimeFigureOut">
+            <a:fld id="{8DFF278A-23B3-4EF2-94AC-4635568519FC}" type="datetimeFigureOut">
               <a:rPr lang="de-DE" smtClean="0"/>
               <a:t>08.10.2026</a:t>
             </a:fld>
@@ -873,7 +875,7 @@
           <p:cNvPr id="5" name="Fußzeilenplatzhalter 4">
             <a:extLst>
               <a:ext uri="{FF2B5EF4-FFF2-40B4-BE49-F238E27FC236}">
-                <a16:creationId xmlns:a16="http://schemas.microsoft.com/office/drawing/2014/main" id="{2608DEEC-A017-CD80-D20D-BAB2B18BADD5}"/>
+                <a16:creationId xmlns:a16="http://schemas.microsoft.com/office/drawing/2014/main" id="{F87999E5-FB19-F3FB-4BAF-DB4D050441BD}"/>
               </a:ext>
             </a:extLst>
           </p:cNvPr>
@@ -898,7 +900,7 @@
           <p:cNvPr id="6" name="Foliennummernplatzhalter 5">
             <a:extLst>
               <a:ext uri="{FF2B5EF4-FFF2-40B4-BE49-F238E27FC236}">
-                <a16:creationId xmlns:a16="http://schemas.microsoft.com/office/drawing/2014/main" id="{256610B5-F504-B00B-4CCC-AC2B5DC9FC85}"/>
+                <a16:creationId xmlns:a16="http://schemas.microsoft.com/office/drawing/2014/main" id="{2D66F9F2-943C-77FA-094C-56D214B57234}"/>
               </a:ext>
             </a:extLst>
           </p:cNvPr>
@@ -914,7 +916,7 @@
           <a:bodyPr/>
           <a:lstStyle/>
           <a:p>
-            <a:fld id="{32C934A3-C752-4D88-870D-A6DA01E5DE15}" type="slidenum">
+            <a:fld id="{D1E4F72E-E169-431D-AEEC-457F8EDE78E5}" type="slidenum">
               <a:rPr lang="de-DE" smtClean="0"/>
               <a:t>‹Nr.›</a:t>
             </a:fld>
@@ -925,7 +927,7 @@
     </p:spTree>
     <p:extLst>
       <p:ext uri="{BB962C8B-B14F-4D97-AF65-F5344CB8AC3E}">
-        <p14:creationId xmlns:p14="http://schemas.microsoft.com/office/powerpoint/2010/main" val="1191833536"/>
+        <p14:creationId xmlns:p14="http://schemas.microsoft.com/office/powerpoint/2010/main" val="314679000"/>
       </p:ext>
     </p:extLst>
   </p:cSld>
@@ -957,7 +959,7 @@
           <p:cNvPr id="2" name="Titel 1">
             <a:extLst>
               <a:ext uri="{FF2B5EF4-FFF2-40B4-BE49-F238E27FC236}">
-                <a16:creationId xmlns:a16="http://schemas.microsoft.com/office/drawing/2014/main" id="{6A0889D3-493E-7952-CC1F-3625732234AA}"/>
+                <a16:creationId xmlns:a16="http://schemas.microsoft.com/office/drawing/2014/main" id="{C225E834-BDA2-6C0A-9F0C-99A8FA26D823}"/>
               </a:ext>
             </a:extLst>
           </p:cNvPr>
@@ -994,7 +996,7 @@
           <p:cNvPr id="3" name="Textplatzhalter 2">
             <a:extLst>
               <a:ext uri="{FF2B5EF4-FFF2-40B4-BE49-F238E27FC236}">
-                <a16:creationId xmlns:a16="http://schemas.microsoft.com/office/drawing/2014/main" id="{4BEFA05A-5F20-DDCC-8EC0-E96C0A5D283B}"/>
+                <a16:creationId xmlns:a16="http://schemas.microsoft.com/office/drawing/2014/main" id="{92818C10-D25A-0482-12D5-09815E1B1EF0}"/>
               </a:ext>
             </a:extLst>
           </p:cNvPr>
@@ -1119,7 +1121,7 @@
           <p:cNvPr id="4" name="Datumsplatzhalter 3">
             <a:extLst>
               <a:ext uri="{FF2B5EF4-FFF2-40B4-BE49-F238E27FC236}">
-                <a16:creationId xmlns:a16="http://schemas.microsoft.com/office/drawing/2014/main" id="{36C556A7-0397-D98C-5501-1BD55B7BF323}"/>
+                <a16:creationId xmlns:a16="http://schemas.microsoft.com/office/drawing/2014/main" id="{E1624197-EAC6-DB4F-FB11-472F30088CCC}"/>
               </a:ext>
             </a:extLst>
           </p:cNvPr>
@@ -1135,7 +1137,7 @@
           <a:bodyPr/>
           <a:lstStyle/>
           <a:p>
-            <a:fld id="{B5996854-510B-471A-9832-4FFEEC0483F4}" type="datetimeFigureOut">
+            <a:fld id="{8DFF278A-23B3-4EF2-94AC-4635568519FC}" type="datetimeFigureOut">
               <a:rPr lang="de-DE" smtClean="0"/>
               <a:t>08.10.2026</a:t>
             </a:fld>
@@ -1148,7 +1150,7 @@
           <p:cNvPr id="5" name="Fußzeilenplatzhalter 4">
             <a:extLst>
               <a:ext uri="{FF2B5EF4-FFF2-40B4-BE49-F238E27FC236}">
-                <a16:creationId xmlns:a16="http://schemas.microsoft.com/office/drawing/2014/main" id="{0C4E438E-FECF-2542-1820-901961D7DCE4}"/>
+                <a16:creationId xmlns:a16="http://schemas.microsoft.com/office/drawing/2014/main" id="{A6C95215-26AF-EF8E-A6AD-90DAD768BDAC}"/>
               </a:ext>
             </a:extLst>
           </p:cNvPr>
@@ -1173,7 +1175,7 @@
           <p:cNvPr id="6" name="Foliennummernplatzhalter 5">
             <a:extLst>
               <a:ext uri="{FF2B5EF4-FFF2-40B4-BE49-F238E27FC236}">
-                <a16:creationId xmlns:a16="http://schemas.microsoft.com/office/drawing/2014/main" id="{AD73F5A2-FACA-2B74-82E3-98528CA3F8A9}"/>
+                <a16:creationId xmlns:a16="http://schemas.microsoft.com/office/drawing/2014/main" id="{19494B76-2DA3-0FB4-2954-673F8D114282}"/>
               </a:ext>
             </a:extLst>
           </p:cNvPr>
@@ -1189,7 +1191,7 @@
           <a:bodyPr/>
           <a:lstStyle/>
           <a:p>
-            <a:fld id="{32C934A3-C752-4D88-870D-A6DA01E5DE15}" type="slidenum">
+            <a:fld id="{D1E4F72E-E169-431D-AEEC-457F8EDE78E5}" type="slidenum">
               <a:rPr lang="de-DE" smtClean="0"/>
               <a:t>‹Nr.›</a:t>
             </a:fld>
@@ -1200,7 +1202,7 @@
     </p:spTree>
     <p:extLst>
       <p:ext uri="{BB962C8B-B14F-4D97-AF65-F5344CB8AC3E}">
-        <p14:creationId xmlns:p14="http://schemas.microsoft.com/office/powerpoint/2010/main" val="2956670242"/>
+        <p14:creationId xmlns:p14="http://schemas.microsoft.com/office/powerpoint/2010/main" val="1362218903"/>
       </p:ext>
     </p:extLst>
   </p:cSld>
@@ -1232,7 +1234,7 @@
           <p:cNvPr id="2" name="Titel 1">
             <a:extLst>
               <a:ext uri="{FF2B5EF4-FFF2-40B4-BE49-F238E27FC236}">
-                <a16:creationId xmlns:a16="http://schemas.microsoft.com/office/drawing/2014/main" id="{75670A1E-3FD8-0192-CC18-9B8B94EEA52B}"/>
+                <a16:creationId xmlns:a16="http://schemas.microsoft.com/office/drawing/2014/main" id="{5675038A-815D-758B-837B-EB0CD01C124A}"/>
               </a:ext>
             </a:extLst>
           </p:cNvPr>
@@ -1260,7 +1262,7 @@
           <p:cNvPr id="3" name="Inhaltsplatzhalter 2">
             <a:extLst>
               <a:ext uri="{FF2B5EF4-FFF2-40B4-BE49-F238E27FC236}">
-                <a16:creationId xmlns:a16="http://schemas.microsoft.com/office/drawing/2014/main" id="{79D4C2EB-C5D5-80D2-44F3-22EBD74DAD88}"/>
+                <a16:creationId xmlns:a16="http://schemas.microsoft.com/office/drawing/2014/main" id="{84511824-CB0D-6CBA-4531-5E7DCF6A6600}"/>
               </a:ext>
             </a:extLst>
           </p:cNvPr>
@@ -1322,7 +1324,7 @@
           <p:cNvPr id="4" name="Inhaltsplatzhalter 3">
             <a:extLst>
               <a:ext uri="{FF2B5EF4-FFF2-40B4-BE49-F238E27FC236}">
-                <a16:creationId xmlns:a16="http://schemas.microsoft.com/office/drawing/2014/main" id="{A15988C7-BFA9-6900-35F8-B90F0481E31B}"/>
+                <a16:creationId xmlns:a16="http://schemas.microsoft.com/office/drawing/2014/main" id="{EB312707-24A2-B1EE-DBAE-82B48FB66FAA}"/>
               </a:ext>
             </a:extLst>
           </p:cNvPr>
@@ -1384,7 +1386,7 @@
           <p:cNvPr id="5" name="Datumsplatzhalter 4">
             <a:extLst>
               <a:ext uri="{FF2B5EF4-FFF2-40B4-BE49-F238E27FC236}">
-                <a16:creationId xmlns:a16="http://schemas.microsoft.com/office/drawing/2014/main" id="{233576AD-4267-058A-6262-3AC08A64C1AF}"/>
+                <a16:creationId xmlns:a16="http://schemas.microsoft.com/office/drawing/2014/main" id="{47D0E83C-5710-08FA-EBDD-FDBB7364CB7D}"/>
               </a:ext>
             </a:extLst>
           </p:cNvPr>
@@ -1400,7 +1402,7 @@
           <a:bodyPr/>
           <a:lstStyle/>
           <a:p>
-            <a:fld id="{B5996854-510B-471A-9832-4FFEEC0483F4}" type="datetimeFigureOut">
+            <a:fld id="{8DFF278A-23B3-4EF2-94AC-4635568519FC}" type="datetimeFigureOut">
               <a:rPr lang="de-DE" smtClean="0"/>
               <a:t>08.10.2026</a:t>
             </a:fld>
@@ -1413,7 +1415,7 @@
           <p:cNvPr id="6" name="Fußzeilenplatzhalter 5">
             <a:extLst>
               <a:ext uri="{FF2B5EF4-FFF2-40B4-BE49-F238E27FC236}">
-                <a16:creationId xmlns:a16="http://schemas.microsoft.com/office/drawing/2014/main" id="{B287659F-CE65-BF43-035D-A906697D7F8E}"/>
+                <a16:creationId xmlns:a16="http://schemas.microsoft.com/office/drawing/2014/main" id="{E769A96D-39D0-45F6-1138-05C4DBB38EFB}"/>
               </a:ext>
             </a:extLst>
           </p:cNvPr>
@@ -1438,7 +1440,7 @@
           <p:cNvPr id="7" name="Foliennummernplatzhalter 6">
             <a:extLst>
               <a:ext uri="{FF2B5EF4-FFF2-40B4-BE49-F238E27FC236}">
-                <a16:creationId xmlns:a16="http://schemas.microsoft.com/office/drawing/2014/main" id="{7CC3B27F-BE52-8B60-C7F1-C7186283EF99}"/>
+                <a16:creationId xmlns:a16="http://schemas.microsoft.com/office/drawing/2014/main" id="{8ACAD499-CB5E-FE26-D578-9E32837CD9D8}"/>
               </a:ext>
             </a:extLst>
           </p:cNvPr>
@@ -1454,7 +1456,7 @@
           <a:bodyPr/>
           <a:lstStyle/>
           <a:p>
-            <a:fld id="{32C934A3-C752-4D88-870D-A6DA01E5DE15}" type="slidenum">
+            <a:fld id="{D1E4F72E-E169-431D-AEEC-457F8EDE78E5}" type="slidenum">
               <a:rPr lang="de-DE" smtClean="0"/>
               <a:t>‹Nr.›</a:t>
             </a:fld>
@@ -1465,7 +1467,7 @@
     </p:spTree>
     <p:extLst>
       <p:ext uri="{BB962C8B-B14F-4D97-AF65-F5344CB8AC3E}">
-        <p14:creationId xmlns:p14="http://schemas.microsoft.com/office/powerpoint/2010/main" val="2915926225"/>
+        <p14:creationId xmlns:p14="http://schemas.microsoft.com/office/powerpoint/2010/main" val="4070955023"/>
       </p:ext>
     </p:extLst>
   </p:cSld>
@@ -1497,7 +1499,7 @@
           <p:cNvPr id="2" name="Titel 1">
             <a:extLst>
               <a:ext uri="{FF2B5EF4-FFF2-40B4-BE49-F238E27FC236}">
-                <a16:creationId xmlns:a16="http://schemas.microsoft.com/office/drawing/2014/main" id="{E1529C34-E81A-B282-B481-00BD4A27F71D}"/>
+                <a16:creationId xmlns:a16="http://schemas.microsoft.com/office/drawing/2014/main" id="{E132F6D3-A9B2-231E-162E-46C258418E41}"/>
               </a:ext>
             </a:extLst>
           </p:cNvPr>
@@ -1530,7 +1532,7 @@
           <p:cNvPr id="3" name="Textplatzhalter 2">
             <a:extLst>
               <a:ext uri="{FF2B5EF4-FFF2-40B4-BE49-F238E27FC236}">
-                <a16:creationId xmlns:a16="http://schemas.microsoft.com/office/drawing/2014/main" id="{1258BDB4-91AC-3E7D-41FC-C82CF9664E95}"/>
+                <a16:creationId xmlns:a16="http://schemas.microsoft.com/office/drawing/2014/main" id="{B36BD773-2267-DBA0-A080-07558CEF796C}"/>
               </a:ext>
             </a:extLst>
           </p:cNvPr>
@@ -1601,7 +1603,7 @@
           <p:cNvPr id="4" name="Inhaltsplatzhalter 3">
             <a:extLst>
               <a:ext uri="{FF2B5EF4-FFF2-40B4-BE49-F238E27FC236}">
-                <a16:creationId xmlns:a16="http://schemas.microsoft.com/office/drawing/2014/main" id="{7AB4A05B-761B-CCC3-100F-23A2AD6A8E87}"/>
+                <a16:creationId xmlns:a16="http://schemas.microsoft.com/office/drawing/2014/main" id="{D86F0ED9-4B6D-2E3B-56F8-1297705AC101}"/>
               </a:ext>
             </a:extLst>
           </p:cNvPr>
@@ -1663,7 +1665,7 @@
           <p:cNvPr id="5" name="Textplatzhalter 4">
             <a:extLst>
               <a:ext uri="{FF2B5EF4-FFF2-40B4-BE49-F238E27FC236}">
-                <a16:creationId xmlns:a16="http://schemas.microsoft.com/office/drawing/2014/main" id="{A54F2E5D-D73B-30F9-E8BA-E46E732E1E30}"/>
+                <a16:creationId xmlns:a16="http://schemas.microsoft.com/office/drawing/2014/main" id="{C4F24B05-7374-859C-B8B5-EA4A9122EFBC}"/>
               </a:ext>
             </a:extLst>
           </p:cNvPr>
@@ -1734,7 +1736,7 @@
           <p:cNvPr id="6" name="Inhaltsplatzhalter 5">
             <a:extLst>
               <a:ext uri="{FF2B5EF4-FFF2-40B4-BE49-F238E27FC236}">
-                <a16:creationId xmlns:a16="http://schemas.microsoft.com/office/drawing/2014/main" id="{35741300-83FF-4872-A615-4D81473CCCAC}"/>
+                <a16:creationId xmlns:a16="http://schemas.microsoft.com/office/drawing/2014/main" id="{377FCF99-547C-0336-3B0B-882CEFD4AD72}"/>
               </a:ext>
             </a:extLst>
           </p:cNvPr>
@@ -1796,7 +1798,7 @@
           <p:cNvPr id="7" name="Datumsplatzhalter 6">
             <a:extLst>
               <a:ext uri="{FF2B5EF4-FFF2-40B4-BE49-F238E27FC236}">
-                <a16:creationId xmlns:a16="http://schemas.microsoft.com/office/drawing/2014/main" id="{21B8151F-D893-DA24-D167-79518BCF9347}"/>
+                <a16:creationId xmlns:a16="http://schemas.microsoft.com/office/drawing/2014/main" id="{3E2B265D-1556-BFFB-E285-A0E080A61C17}"/>
               </a:ext>
             </a:extLst>
           </p:cNvPr>
@@ -1812,7 +1814,7 @@
           <a:bodyPr/>
           <a:lstStyle/>
           <a:p>
-            <a:fld id="{B5996854-510B-471A-9832-4FFEEC0483F4}" type="datetimeFigureOut">
+            <a:fld id="{8DFF278A-23B3-4EF2-94AC-4635568519FC}" type="datetimeFigureOut">
               <a:rPr lang="de-DE" smtClean="0"/>
               <a:t>08.10.2026</a:t>
             </a:fld>
@@ -1825,7 +1827,7 @@
           <p:cNvPr id="8" name="Fußzeilenplatzhalter 7">
             <a:extLst>
               <a:ext uri="{FF2B5EF4-FFF2-40B4-BE49-F238E27FC236}">
-                <a16:creationId xmlns:a16="http://schemas.microsoft.com/office/drawing/2014/main" id="{B8389069-7B7D-6224-3513-597B3D73D6FF}"/>
+                <a16:creationId xmlns:a16="http://schemas.microsoft.com/office/drawing/2014/main" id="{773E05E1-6560-9A9B-F990-2700623EF258}"/>
               </a:ext>
             </a:extLst>
           </p:cNvPr>
@@ -1850,7 +1852,7 @@
           <p:cNvPr id="9" name="Foliennummernplatzhalter 8">
             <a:extLst>
               <a:ext uri="{FF2B5EF4-FFF2-40B4-BE49-F238E27FC236}">
-                <a16:creationId xmlns:a16="http://schemas.microsoft.com/office/drawing/2014/main" id="{E26EC770-DC1E-DD6B-3FDB-555ACEC16C50}"/>
+                <a16:creationId xmlns:a16="http://schemas.microsoft.com/office/drawing/2014/main" id="{401632D5-AF3B-699E-1FE2-47FF8145CBAC}"/>
               </a:ext>
             </a:extLst>
           </p:cNvPr>
@@ -1866,7 +1868,7 @@
           <a:bodyPr/>
           <a:lstStyle/>
           <a:p>
-            <a:fld id="{32C934A3-C752-4D88-870D-A6DA01E5DE15}" type="slidenum">
+            <a:fld id="{D1E4F72E-E169-431D-AEEC-457F8EDE78E5}" type="slidenum">
               <a:rPr lang="de-DE" smtClean="0"/>
               <a:t>‹Nr.›</a:t>
             </a:fld>
@@ -1877,7 +1879,7 @@
     </p:spTree>
     <p:extLst>
       <p:ext uri="{BB962C8B-B14F-4D97-AF65-F5344CB8AC3E}">
-        <p14:creationId xmlns:p14="http://schemas.microsoft.com/office/powerpoint/2010/main" val="2151659719"/>
+        <p14:creationId xmlns:p14="http://schemas.microsoft.com/office/powerpoint/2010/main" val="3262806170"/>
       </p:ext>
     </p:extLst>
   </p:cSld>
@@ -1909,7 +1911,7 @@
           <p:cNvPr id="2" name="Titel 1">
             <a:extLst>
               <a:ext uri="{FF2B5EF4-FFF2-40B4-BE49-F238E27FC236}">
-                <a16:creationId xmlns:a16="http://schemas.microsoft.com/office/drawing/2014/main" id="{00A103B1-B076-4E72-512D-0F240F005C25}"/>
+                <a16:creationId xmlns:a16="http://schemas.microsoft.com/office/drawing/2014/main" id="{F05972D4-34B3-4854-4B89-BF8B8E699213}"/>
               </a:ext>
             </a:extLst>
           </p:cNvPr>
@@ -1937,7 +1939,7 @@
           <p:cNvPr id="3" name="Datumsplatzhalter 2">
             <a:extLst>
               <a:ext uri="{FF2B5EF4-FFF2-40B4-BE49-F238E27FC236}">
-                <a16:creationId xmlns:a16="http://schemas.microsoft.com/office/drawing/2014/main" id="{1A013BAB-8B2B-3AC8-04D9-A47BC31B1356}"/>
+                <a16:creationId xmlns:a16="http://schemas.microsoft.com/office/drawing/2014/main" id="{D6D7CD4F-61CE-0102-8FCB-AF9F3B444497}"/>
               </a:ext>
             </a:extLst>
           </p:cNvPr>
@@ -1953,7 +1955,7 @@
           <a:bodyPr/>
           <a:lstStyle/>
           <a:p>
-            <a:fld id="{B5996854-510B-471A-9832-4FFEEC0483F4}" type="datetimeFigureOut">
+            <a:fld id="{8DFF278A-23B3-4EF2-94AC-4635568519FC}" type="datetimeFigureOut">
               <a:rPr lang="de-DE" smtClean="0"/>
               <a:t>08.10.2026</a:t>
             </a:fld>
@@ -1966,7 +1968,7 @@
           <p:cNvPr id="4" name="Fußzeilenplatzhalter 3">
             <a:extLst>
               <a:ext uri="{FF2B5EF4-FFF2-40B4-BE49-F238E27FC236}">
-                <a16:creationId xmlns:a16="http://schemas.microsoft.com/office/drawing/2014/main" id="{685C912C-908B-DB73-1694-6A0643442F3F}"/>
+                <a16:creationId xmlns:a16="http://schemas.microsoft.com/office/drawing/2014/main" id="{5CEC1C6E-A3AE-26DF-63D8-20E610DBC778}"/>
               </a:ext>
             </a:extLst>
           </p:cNvPr>
@@ -1991,7 +1993,7 @@
           <p:cNvPr id="5" name="Foliennummernplatzhalter 4">
             <a:extLst>
               <a:ext uri="{FF2B5EF4-FFF2-40B4-BE49-F238E27FC236}">
-                <a16:creationId xmlns:a16="http://schemas.microsoft.com/office/drawing/2014/main" id="{FAAB0A6F-96FA-8009-FD53-12B0324B5C43}"/>
+                <a16:creationId xmlns:a16="http://schemas.microsoft.com/office/drawing/2014/main" id="{DEABA8E4-552E-B378-5A8D-06C92DBE0EC1}"/>
               </a:ext>
             </a:extLst>
           </p:cNvPr>
@@ -2007,7 +2009,7 @@
           <a:bodyPr/>
           <a:lstStyle/>
           <a:p>
-            <a:fld id="{32C934A3-C752-4D88-870D-A6DA01E5DE15}" type="slidenum">
+            <a:fld id="{D1E4F72E-E169-431D-AEEC-457F8EDE78E5}" type="slidenum">
               <a:rPr lang="de-DE" smtClean="0"/>
               <a:t>‹Nr.›</a:t>
             </a:fld>
@@ -2018,7 +2020,7 @@
     </p:spTree>
     <p:extLst>
       <p:ext uri="{BB962C8B-B14F-4D97-AF65-F5344CB8AC3E}">
-        <p14:creationId xmlns:p14="http://schemas.microsoft.com/office/powerpoint/2010/main" val="266733238"/>
+        <p14:creationId xmlns:p14="http://schemas.microsoft.com/office/powerpoint/2010/main" val="2404765367"/>
       </p:ext>
     </p:extLst>
   </p:cSld>
@@ -2050,7 +2052,7 @@
           <p:cNvPr id="2" name="Datumsplatzhalter 1">
             <a:extLst>
               <a:ext uri="{FF2B5EF4-FFF2-40B4-BE49-F238E27FC236}">
-                <a16:creationId xmlns:a16="http://schemas.microsoft.com/office/drawing/2014/main" id="{3E9315A2-6688-029D-7756-B68D51F2A2F6}"/>
+                <a16:creationId xmlns:a16="http://schemas.microsoft.com/office/drawing/2014/main" id="{22A26B68-39AC-8BD2-3F4B-DC9EEB2DD255}"/>
               </a:ext>
             </a:extLst>
           </p:cNvPr>
@@ -2066,7 +2068,7 @@
           <a:bodyPr/>
           <a:lstStyle/>
           <a:p>
-            <a:fld id="{B5996854-510B-471A-9832-4FFEEC0483F4}" type="datetimeFigureOut">
+            <a:fld id="{8DFF278A-23B3-4EF2-94AC-4635568519FC}" type="datetimeFigureOut">
               <a:rPr lang="de-DE" smtClean="0"/>
               <a:t>08.10.2026</a:t>
             </a:fld>
@@ -2079,7 +2081,7 @@
           <p:cNvPr id="3" name="Fußzeilenplatzhalter 2">
             <a:extLst>
               <a:ext uri="{FF2B5EF4-FFF2-40B4-BE49-F238E27FC236}">
-                <a16:creationId xmlns:a16="http://schemas.microsoft.com/office/drawing/2014/main" id="{76BD6B31-B801-77A5-E98A-5B49DE758A6C}"/>
+                <a16:creationId xmlns:a16="http://schemas.microsoft.com/office/drawing/2014/main" id="{3434D626-D30E-C8D2-4B4D-0313E042238C}"/>
               </a:ext>
             </a:extLst>
           </p:cNvPr>
@@ -2104,7 +2106,7 @@
           <p:cNvPr id="4" name="Foliennummernplatzhalter 3">
             <a:extLst>
               <a:ext uri="{FF2B5EF4-FFF2-40B4-BE49-F238E27FC236}">
-                <a16:creationId xmlns:a16="http://schemas.microsoft.com/office/drawing/2014/main" id="{4B3B0868-04A7-0784-BE65-B7AA38AC14C8}"/>
+                <a16:creationId xmlns:a16="http://schemas.microsoft.com/office/drawing/2014/main" id="{1A80D56D-AC21-6F32-F055-8752721641F7}"/>
               </a:ext>
             </a:extLst>
           </p:cNvPr>
@@ -2120,7 +2122,7 @@
           <a:bodyPr/>
           <a:lstStyle/>
           <a:p>
-            <a:fld id="{32C934A3-C752-4D88-870D-A6DA01E5DE15}" type="slidenum">
+            <a:fld id="{D1E4F72E-E169-431D-AEEC-457F8EDE78E5}" type="slidenum">
               <a:rPr lang="de-DE" smtClean="0"/>
               <a:t>‹Nr.›</a:t>
             </a:fld>
@@ -2131,7 +2133,7 @@
     </p:spTree>
     <p:extLst>
       <p:ext uri="{BB962C8B-B14F-4D97-AF65-F5344CB8AC3E}">
-        <p14:creationId xmlns:p14="http://schemas.microsoft.com/office/powerpoint/2010/main" val="2411331073"/>
+        <p14:creationId xmlns:p14="http://schemas.microsoft.com/office/powerpoint/2010/main" val="2115116568"/>
       </p:ext>
     </p:extLst>
   </p:cSld>
@@ -2163,7 +2165,7 @@
           <p:cNvPr id="2" name="Titel 1">
             <a:extLst>
               <a:ext uri="{FF2B5EF4-FFF2-40B4-BE49-F238E27FC236}">
-                <a16:creationId xmlns:a16="http://schemas.microsoft.com/office/drawing/2014/main" id="{25E3B8D9-25DA-DCD4-ABA7-DC90BEAE9547}"/>
+                <a16:creationId xmlns:a16="http://schemas.microsoft.com/office/drawing/2014/main" id="{4567E834-48F7-1A7F-B8CC-10E91AD2560E}"/>
               </a:ext>
             </a:extLst>
           </p:cNvPr>
@@ -2200,7 +2202,7 @@
           <p:cNvPr id="3" name="Inhaltsplatzhalter 2">
             <a:extLst>
               <a:ext uri="{FF2B5EF4-FFF2-40B4-BE49-F238E27FC236}">
-                <a16:creationId xmlns:a16="http://schemas.microsoft.com/office/drawing/2014/main" id="{A0655903-C353-92A5-1F61-B78B32DDF83F}"/>
+                <a16:creationId xmlns:a16="http://schemas.microsoft.com/office/drawing/2014/main" id="{1896D357-F1E3-8070-7908-73309404A57E}"/>
               </a:ext>
             </a:extLst>
           </p:cNvPr>
@@ -2290,7 +2292,7 @@
           <p:cNvPr id="4" name="Textplatzhalter 3">
             <a:extLst>
               <a:ext uri="{FF2B5EF4-FFF2-40B4-BE49-F238E27FC236}">
-                <a16:creationId xmlns:a16="http://schemas.microsoft.com/office/drawing/2014/main" id="{657AB233-648E-C443-FD4D-9DFE8278CC62}"/>
+                <a16:creationId xmlns:a16="http://schemas.microsoft.com/office/drawing/2014/main" id="{0701D548-D564-F8C6-D78A-F5C932D00EF8}"/>
               </a:ext>
             </a:extLst>
           </p:cNvPr>
@@ -2361,7 +2363,7 @@
           <p:cNvPr id="5" name="Datumsplatzhalter 4">
             <a:extLst>
               <a:ext uri="{FF2B5EF4-FFF2-40B4-BE49-F238E27FC236}">
-                <a16:creationId xmlns:a16="http://schemas.microsoft.com/office/drawing/2014/main" id="{C142AD84-5C18-A388-DF30-02C2AC662283}"/>
+                <a16:creationId xmlns:a16="http://schemas.microsoft.com/office/drawing/2014/main" id="{28376DDF-0E5F-75A5-CD9D-95AEB7D21D49}"/>
               </a:ext>
             </a:extLst>
           </p:cNvPr>
@@ -2377,7 +2379,7 @@
           <a:bodyPr/>
           <a:lstStyle/>
           <a:p>
-            <a:fld id="{B5996854-510B-471A-9832-4FFEEC0483F4}" type="datetimeFigureOut">
+            <a:fld id="{8DFF278A-23B3-4EF2-94AC-4635568519FC}" type="datetimeFigureOut">
               <a:rPr lang="de-DE" smtClean="0"/>
               <a:t>08.10.2026</a:t>
             </a:fld>
@@ -2390,7 +2392,7 @@
           <p:cNvPr id="6" name="Fußzeilenplatzhalter 5">
             <a:extLst>
               <a:ext uri="{FF2B5EF4-FFF2-40B4-BE49-F238E27FC236}">
-                <a16:creationId xmlns:a16="http://schemas.microsoft.com/office/drawing/2014/main" id="{72EF0596-B3C0-01A6-3C34-26E8D0341CFF}"/>
+                <a16:creationId xmlns:a16="http://schemas.microsoft.com/office/drawing/2014/main" id="{7172B23E-F8CE-9CE4-0F01-44AC5AB6ABE0}"/>
               </a:ext>
             </a:extLst>
           </p:cNvPr>
@@ -2415,7 +2417,7 @@
           <p:cNvPr id="7" name="Foliennummernplatzhalter 6">
             <a:extLst>
               <a:ext uri="{FF2B5EF4-FFF2-40B4-BE49-F238E27FC236}">
-                <a16:creationId xmlns:a16="http://schemas.microsoft.com/office/drawing/2014/main" id="{A38D1055-4877-917D-8E50-68C797C97147}"/>
+                <a16:creationId xmlns:a16="http://schemas.microsoft.com/office/drawing/2014/main" id="{E6472497-BBE0-0BBD-D6ED-DAA8279A6722}"/>
               </a:ext>
             </a:extLst>
           </p:cNvPr>
@@ -2431,7 +2433,7 @@
           <a:bodyPr/>
           <a:lstStyle/>
           <a:p>
-            <a:fld id="{32C934A3-C752-4D88-870D-A6DA01E5DE15}" type="slidenum">
+            <a:fld id="{D1E4F72E-E169-431D-AEEC-457F8EDE78E5}" type="slidenum">
               <a:rPr lang="de-DE" smtClean="0"/>
               <a:t>‹Nr.›</a:t>
             </a:fld>
@@ -2442,7 +2444,7 @@
     </p:spTree>
     <p:extLst>
       <p:ext uri="{BB962C8B-B14F-4D97-AF65-F5344CB8AC3E}">
-        <p14:creationId xmlns:p14="http://schemas.microsoft.com/office/powerpoint/2010/main" val="3401501608"/>
+        <p14:creationId xmlns:p14="http://schemas.microsoft.com/office/powerpoint/2010/main" val="670063054"/>
       </p:ext>
     </p:extLst>
   </p:cSld>
@@ -2474,7 +2476,7 @@
           <p:cNvPr id="2" name="Titel 1">
             <a:extLst>
               <a:ext uri="{FF2B5EF4-FFF2-40B4-BE49-F238E27FC236}">
-                <a16:creationId xmlns:a16="http://schemas.microsoft.com/office/drawing/2014/main" id="{E2C5931F-053C-FA65-6DB5-9262E9539908}"/>
+                <a16:creationId xmlns:a16="http://schemas.microsoft.com/office/drawing/2014/main" id="{07B4917F-0277-0B0A-8A93-93E0F630B94C}"/>
               </a:ext>
             </a:extLst>
           </p:cNvPr>
@@ -2511,7 +2513,7 @@
           <p:cNvPr id="3" name="Bildplatzhalter 2">
             <a:extLst>
               <a:ext uri="{FF2B5EF4-FFF2-40B4-BE49-F238E27FC236}">
-                <a16:creationId xmlns:a16="http://schemas.microsoft.com/office/drawing/2014/main" id="{A733BBB4-64FA-FE7B-5AB1-3925332CC027}"/>
+                <a16:creationId xmlns:a16="http://schemas.microsoft.com/office/drawing/2014/main" id="{809F7F5E-45FB-90FD-BB46-96632C5993BF}"/>
               </a:ext>
             </a:extLst>
           </p:cNvPr>
@@ -2578,7 +2580,7 @@
           <p:cNvPr id="4" name="Textplatzhalter 3">
             <a:extLst>
               <a:ext uri="{FF2B5EF4-FFF2-40B4-BE49-F238E27FC236}">
-                <a16:creationId xmlns:a16="http://schemas.microsoft.com/office/drawing/2014/main" id="{6FAE4DAA-D093-B1DA-05BC-DAB27997991E}"/>
+                <a16:creationId xmlns:a16="http://schemas.microsoft.com/office/drawing/2014/main" id="{D5BC07E6-57AF-2EDF-7AC3-7C427B52B9A7}"/>
               </a:ext>
             </a:extLst>
           </p:cNvPr>
@@ -2649,7 +2651,7 @@
           <p:cNvPr id="5" name="Datumsplatzhalter 4">
             <a:extLst>
               <a:ext uri="{FF2B5EF4-FFF2-40B4-BE49-F238E27FC236}">
-                <a16:creationId xmlns:a16="http://schemas.microsoft.com/office/drawing/2014/main" id="{3C40D264-518F-376F-BB00-508821AC3D68}"/>
+                <a16:creationId xmlns:a16="http://schemas.microsoft.com/office/drawing/2014/main" id="{885E8380-84DA-DD25-841E-AB24C7CAD658}"/>
               </a:ext>
             </a:extLst>
           </p:cNvPr>
@@ -2665,7 +2667,7 @@
           <a:bodyPr/>
           <a:lstStyle/>
           <a:p>
-            <a:fld id="{B5996854-510B-471A-9832-4FFEEC0483F4}" type="datetimeFigureOut">
+            <a:fld id="{8DFF278A-23B3-4EF2-94AC-4635568519FC}" type="datetimeFigureOut">
               <a:rPr lang="de-DE" smtClean="0"/>
               <a:t>08.10.2026</a:t>
             </a:fld>
@@ -2678,7 +2680,7 @@
           <p:cNvPr id="6" name="Fußzeilenplatzhalter 5">
             <a:extLst>
               <a:ext uri="{FF2B5EF4-FFF2-40B4-BE49-F238E27FC236}">
-                <a16:creationId xmlns:a16="http://schemas.microsoft.com/office/drawing/2014/main" id="{12CFEC37-8E35-5AF6-B6CE-547CB1E0BA1E}"/>
+                <a16:creationId xmlns:a16="http://schemas.microsoft.com/office/drawing/2014/main" id="{FFA7DECF-C0BE-7681-EDB3-FC6CA1AA45ED}"/>
               </a:ext>
             </a:extLst>
           </p:cNvPr>
@@ -2703,7 +2705,7 @@
           <p:cNvPr id="7" name="Foliennummernplatzhalter 6">
             <a:extLst>
               <a:ext uri="{FF2B5EF4-FFF2-40B4-BE49-F238E27FC236}">
-                <a16:creationId xmlns:a16="http://schemas.microsoft.com/office/drawing/2014/main" id="{B68E38C0-1B0D-FDA9-8CFB-2008D2D798E7}"/>
+                <a16:creationId xmlns:a16="http://schemas.microsoft.com/office/drawing/2014/main" id="{C3E81894-2A88-5EA8-B9E6-C5483FC7D629}"/>
               </a:ext>
             </a:extLst>
           </p:cNvPr>
@@ -2719,7 +2721,7 @@
           <a:bodyPr/>
           <a:lstStyle/>
           <a:p>
-            <a:fld id="{32C934A3-C752-4D88-870D-A6DA01E5DE15}" type="slidenum">
+            <a:fld id="{D1E4F72E-E169-431D-AEEC-457F8EDE78E5}" type="slidenum">
               <a:rPr lang="de-DE" smtClean="0"/>
               <a:t>‹Nr.›</a:t>
             </a:fld>
@@ -2730,7 +2732,7 @@
     </p:spTree>
     <p:extLst>
       <p:ext uri="{BB962C8B-B14F-4D97-AF65-F5344CB8AC3E}">
-        <p14:creationId xmlns:p14="http://schemas.microsoft.com/office/powerpoint/2010/main" val="796550564"/>
+        <p14:creationId xmlns:p14="http://schemas.microsoft.com/office/powerpoint/2010/main" val="4246152695"/>
       </p:ext>
     </p:extLst>
   </p:cSld>
@@ -2767,7 +2769,7 @@
           <p:cNvPr id="2" name="Titelplatzhalter 1">
             <a:extLst>
               <a:ext uri="{FF2B5EF4-FFF2-40B4-BE49-F238E27FC236}">
-                <a16:creationId xmlns:a16="http://schemas.microsoft.com/office/drawing/2014/main" id="{E0C78EC7-C5A8-39CF-E57B-B310C5AB06AB}"/>
+                <a16:creationId xmlns:a16="http://schemas.microsoft.com/office/drawing/2014/main" id="{9CAA1ED3-A622-07E9-EA00-F289985EB313}"/>
               </a:ext>
             </a:extLst>
           </p:cNvPr>
@@ -2805,7 +2807,7 @@
           <p:cNvPr id="3" name="Textplatzhalter 2">
             <a:extLst>
               <a:ext uri="{FF2B5EF4-FFF2-40B4-BE49-F238E27FC236}">
-                <a16:creationId xmlns:a16="http://schemas.microsoft.com/office/drawing/2014/main" id="{369ADDDB-884C-689E-6D75-EBED852FADAB}"/>
+                <a16:creationId xmlns:a16="http://schemas.microsoft.com/office/drawing/2014/main" id="{6EE45821-64B1-2C34-EA7D-9F328F91EB72}"/>
               </a:ext>
             </a:extLst>
           </p:cNvPr>
@@ -2872,7 +2874,7 @@
           <p:cNvPr id="4" name="Datumsplatzhalter 3">
             <a:extLst>
               <a:ext uri="{FF2B5EF4-FFF2-40B4-BE49-F238E27FC236}">
-                <a16:creationId xmlns:a16="http://schemas.microsoft.com/office/drawing/2014/main" id="{6206E5E1-4A5B-0D15-42BB-D0B9AE930E22}"/>
+                <a16:creationId xmlns:a16="http://schemas.microsoft.com/office/drawing/2014/main" id="{F6155319-E243-32CD-8EA4-480A1C18CBFB}"/>
               </a:ext>
             </a:extLst>
           </p:cNvPr>
@@ -2906,7 +2908,7 @@
             </a:lvl1pPr>
           </a:lstStyle>
           <a:p>
-            <a:fld id="{B5996854-510B-471A-9832-4FFEEC0483F4}" type="datetimeFigureOut">
+            <a:fld id="{8DFF278A-23B3-4EF2-94AC-4635568519FC}" type="datetimeFigureOut">
               <a:rPr lang="de-DE" smtClean="0"/>
               <a:t>08.10.2026</a:t>
             </a:fld>
@@ -2919,7 +2921,7 @@
           <p:cNvPr id="5" name="Fußzeilenplatzhalter 4">
             <a:extLst>
               <a:ext uri="{FF2B5EF4-FFF2-40B4-BE49-F238E27FC236}">
-                <a16:creationId xmlns:a16="http://schemas.microsoft.com/office/drawing/2014/main" id="{0F2DECE7-88D0-81E1-0791-08B857318961}"/>
+                <a16:creationId xmlns:a16="http://schemas.microsoft.com/office/drawing/2014/main" id="{69941F30-2D74-BCA1-2753-8D6397EE6D12}"/>
               </a:ext>
             </a:extLst>
           </p:cNvPr>
@@ -2962,7 +2964,7 @@
           <p:cNvPr id="6" name="Foliennummernplatzhalter 5">
             <a:extLst>
               <a:ext uri="{FF2B5EF4-FFF2-40B4-BE49-F238E27FC236}">
-                <a16:creationId xmlns:a16="http://schemas.microsoft.com/office/drawing/2014/main" id="{D5E1E0A8-A8A8-0183-14DF-BE82F7D1F750}"/>
+                <a16:creationId xmlns:a16="http://schemas.microsoft.com/office/drawing/2014/main" id="{2B4D98F1-25EB-297C-88FA-2F0A518A2682}"/>
               </a:ext>
             </a:extLst>
           </p:cNvPr>
@@ -2996,7 +2998,7 @@
             </a:lvl1pPr>
           </a:lstStyle>
           <a:p>
-            <a:fld id="{32C934A3-C752-4D88-870D-A6DA01E5DE15}" type="slidenum">
+            <a:fld id="{D1E4F72E-E169-431D-AEEC-457F8EDE78E5}" type="slidenum">
               <a:rPr lang="de-DE" smtClean="0"/>
               <a:t>‹Nr.›</a:t>
             </a:fld>
@@ -3007,7 +3009,7 @@
     </p:spTree>
     <p:extLst>
       <p:ext uri="{BB962C8B-B14F-4D97-AF65-F5344CB8AC3E}">
-        <p14:creationId xmlns:p14="http://schemas.microsoft.com/office/powerpoint/2010/main" val="99171240"/>
+        <p14:creationId xmlns:p14="http://schemas.microsoft.com/office/powerpoint/2010/main" val="3544171342"/>
       </p:ext>
     </p:extLst>
   </p:cSld>
@@ -3330,7 +3332,7 @@
           <p:cNvPr id="2" name="Rechteck 1">
             <a:extLst>
               <a:ext uri="{FF2B5EF4-FFF2-40B4-BE49-F238E27FC236}">
-                <a16:creationId xmlns:a16="http://schemas.microsoft.com/office/drawing/2014/main" id="{2535A23F-79D1-4269-87EC-9EE7AA40D282}"/>
+                <a16:creationId xmlns:a16="http://schemas.microsoft.com/office/drawing/2014/main" id="{7CC3BA7B-96F6-45E0-7899-485039C7147D}"/>
               </a:ext>
             </a:extLst>
           </p:cNvPr>
@@ -3411,7 +3413,7 @@
           <p:cNvPr id="3" name="Rechteck 2">
             <a:extLst>
               <a:ext uri="{FF2B5EF4-FFF2-40B4-BE49-F238E27FC236}">
-                <a16:creationId xmlns:a16="http://schemas.microsoft.com/office/drawing/2014/main" id="{0131ABC1-D44C-5078-5849-AA649CCB788D}"/>
+                <a16:creationId xmlns:a16="http://schemas.microsoft.com/office/drawing/2014/main" id="{23AFD8B1-4AAF-D8CD-F348-72FA3198A736}"/>
               </a:ext>
             </a:extLst>
           </p:cNvPr>
@@ -3492,7 +3494,7 @@
           <p:cNvPr id="4" name="Rechteck 3">
             <a:extLst>
               <a:ext uri="{FF2B5EF4-FFF2-40B4-BE49-F238E27FC236}">
-                <a16:creationId xmlns:a16="http://schemas.microsoft.com/office/drawing/2014/main" id="{6A1EF8AB-3F82-A4A3-9DA5-4C7C72F5768A}"/>
+                <a16:creationId xmlns:a16="http://schemas.microsoft.com/office/drawing/2014/main" id="{6E82F843-819E-D12A-F23D-5300FDB72E95}"/>
               </a:ext>
             </a:extLst>
           </p:cNvPr>
@@ -3573,7 +3575,7 @@
           <p:cNvPr id="5" name="Rechteck 4">
             <a:extLst>
               <a:ext uri="{FF2B5EF4-FFF2-40B4-BE49-F238E27FC236}">
-                <a16:creationId xmlns:a16="http://schemas.microsoft.com/office/drawing/2014/main" id="{1910BD33-9E6E-F791-C20B-6D0E80A99462}"/>
+                <a16:creationId xmlns:a16="http://schemas.microsoft.com/office/drawing/2014/main" id="{1C76B11C-3CAB-463E-224F-2E679A0AD5C7}"/>
               </a:ext>
             </a:extLst>
           </p:cNvPr>
@@ -3654,7 +3656,7 @@
           <p:cNvPr id="6" name="Rechteck 5">
             <a:extLst>
               <a:ext uri="{FF2B5EF4-FFF2-40B4-BE49-F238E27FC236}">
-                <a16:creationId xmlns:a16="http://schemas.microsoft.com/office/drawing/2014/main" id="{311366D7-5802-A3CC-905F-846208B90DB0}"/>
+                <a16:creationId xmlns:a16="http://schemas.microsoft.com/office/drawing/2014/main" id="{2CE89A78-E8F3-54B9-6C90-109A30335544}"/>
               </a:ext>
             </a:extLst>
           </p:cNvPr>
@@ -3735,7 +3737,7 @@
           <p:cNvPr id="7" name="Rechteck 6">
             <a:extLst>
               <a:ext uri="{FF2B5EF4-FFF2-40B4-BE49-F238E27FC236}">
-                <a16:creationId xmlns:a16="http://schemas.microsoft.com/office/drawing/2014/main" id="{1459E1EB-B5D4-6EDC-F675-ECC13B991CA7}"/>
+                <a16:creationId xmlns:a16="http://schemas.microsoft.com/office/drawing/2014/main" id="{EC998B28-F425-1569-B5AD-6A6CF1E4437E}"/>
               </a:ext>
             </a:extLst>
           </p:cNvPr>
@@ -3816,7 +3818,7 @@
           <p:cNvPr id="8" name="Rechteck 7">
             <a:extLst>
               <a:ext uri="{FF2B5EF4-FFF2-40B4-BE49-F238E27FC236}">
-                <a16:creationId xmlns:a16="http://schemas.microsoft.com/office/drawing/2014/main" id="{3A7E8A59-2672-69B8-12F4-CFDAD6E27B2B}"/>
+                <a16:creationId xmlns:a16="http://schemas.microsoft.com/office/drawing/2014/main" id="{48008A35-CC38-6690-7CC7-927929BDFE36}"/>
               </a:ext>
             </a:extLst>
           </p:cNvPr>
@@ -3895,7 +3897,7 @@
           <p:cNvPr id="9" name="Rechteck 8">
             <a:extLst>
               <a:ext uri="{FF2B5EF4-FFF2-40B4-BE49-F238E27FC236}">
-                <a16:creationId xmlns:a16="http://schemas.microsoft.com/office/drawing/2014/main" id="{30754F05-F5F5-A8D8-9D56-157463A9DD0F}"/>
+                <a16:creationId xmlns:a16="http://schemas.microsoft.com/office/drawing/2014/main" id="{AEB257E2-FFB8-705B-44C9-922A44F579D1}"/>
               </a:ext>
             </a:extLst>
           </p:cNvPr>
@@ -3972,7 +3974,7 @@
     </p:spTree>
     <p:extLst>
       <p:ext uri="{BB962C8B-B14F-4D97-AF65-F5344CB8AC3E}">
-        <p14:creationId xmlns:p14="http://schemas.microsoft.com/office/powerpoint/2010/main" val="2015045503"/>
+        <p14:creationId xmlns:p14="http://schemas.microsoft.com/office/powerpoint/2010/main" val="1095904850"/>
       </p:ext>
     </p:extLst>
   </p:cSld>
@@ -4004,7 +4006,7 @@
           <p:cNvPr id="2" name="Rechteck 1">
             <a:extLst>
               <a:ext uri="{FF2B5EF4-FFF2-40B4-BE49-F238E27FC236}">
-                <a16:creationId xmlns:a16="http://schemas.microsoft.com/office/drawing/2014/main" id="{EB7BC6DC-BDEE-5D7E-D66F-0E8A1D2E15B5}"/>
+                <a16:creationId xmlns:a16="http://schemas.microsoft.com/office/drawing/2014/main" id="{42F92B3B-EE68-6AFB-5517-03A6F03B5549}"/>
               </a:ext>
             </a:extLst>
           </p:cNvPr>
@@ -4084,7 +4086,7 @@
           <p:cNvPr id="3" name="Ellipse 2">
             <a:extLst>
               <a:ext uri="{FF2B5EF4-FFF2-40B4-BE49-F238E27FC236}">
-                <a16:creationId xmlns:a16="http://schemas.microsoft.com/office/drawing/2014/main" id="{5B85BA45-D79B-6799-DB37-6DAB281BAB2C}"/>
+                <a16:creationId xmlns:a16="http://schemas.microsoft.com/office/drawing/2014/main" id="{E93CF789-EB9D-C743-E1B7-348D1588BBBD}"/>
               </a:ext>
             </a:extLst>
           </p:cNvPr>
@@ -4164,7 +4166,7 @@
           <p:cNvPr id="4" name="Stern: 5 Zacken 3">
             <a:extLst>
               <a:ext uri="{FF2B5EF4-FFF2-40B4-BE49-F238E27FC236}">
-                <a16:creationId xmlns:a16="http://schemas.microsoft.com/office/drawing/2014/main" id="{1E745B2D-8AC3-5D65-28CE-4B94A3BE19DD}"/>
+                <a16:creationId xmlns:a16="http://schemas.microsoft.com/office/drawing/2014/main" id="{9D2919F1-4466-C423-5FCF-269A9D9970DD}"/>
               </a:ext>
             </a:extLst>
           </p:cNvPr>
@@ -4244,7 +4246,7 @@
           <p:cNvPr id="5" name="Sechseck 4">
             <a:extLst>
               <a:ext uri="{FF2B5EF4-FFF2-40B4-BE49-F238E27FC236}">
-                <a16:creationId xmlns:a16="http://schemas.microsoft.com/office/drawing/2014/main" id="{E4E047AE-F7E6-3D16-3368-625AD95E4656}"/>
+                <a16:creationId xmlns:a16="http://schemas.microsoft.com/office/drawing/2014/main" id="{69D325A6-1DF8-0864-9B0E-46325A2E1ABE}"/>
               </a:ext>
             </a:extLst>
           </p:cNvPr>
@@ -4324,7 +4326,7 @@
           <p:cNvPr id="6" name="Rechteck 5">
             <a:extLst>
               <a:ext uri="{FF2B5EF4-FFF2-40B4-BE49-F238E27FC236}">
-                <a16:creationId xmlns:a16="http://schemas.microsoft.com/office/drawing/2014/main" id="{63833661-7755-66BE-344B-3B8FD4994AD0}"/>
+                <a16:creationId xmlns:a16="http://schemas.microsoft.com/office/drawing/2014/main" id="{01A5939A-D2B4-0B81-D531-92340B82D153}"/>
               </a:ext>
             </a:extLst>
           </p:cNvPr>
@@ -4404,7 +4406,7 @@
           <p:cNvPr id="7" name="Rechteck: abgerundete Ecken 6">
             <a:extLst>
               <a:ext uri="{FF2B5EF4-FFF2-40B4-BE49-F238E27FC236}">
-                <a16:creationId xmlns:a16="http://schemas.microsoft.com/office/drawing/2014/main" id="{68E6E17A-0206-7928-BE9E-D67290654584}"/>
+                <a16:creationId xmlns:a16="http://schemas.microsoft.com/office/drawing/2014/main" id="{407F9401-1293-DE63-6175-D044F312A6B4}"/>
               </a:ext>
             </a:extLst>
           </p:cNvPr>
@@ -4484,7 +4486,7 @@
     </p:spTree>
     <p:extLst>
       <p:ext uri="{BB962C8B-B14F-4D97-AF65-F5344CB8AC3E}">
-        <p14:creationId xmlns:p14="http://schemas.microsoft.com/office/powerpoint/2010/main" val="856811921"/>
+        <p14:creationId xmlns:p14="http://schemas.microsoft.com/office/powerpoint/2010/main" val="936500150"/>
       </p:ext>
     </p:extLst>
   </p:cSld>
@@ -4516,7 +4518,7 @@
           <p:cNvPr id="2" name="Rechteck 1">
             <a:extLst>
               <a:ext uri="{FF2B5EF4-FFF2-40B4-BE49-F238E27FC236}">
-                <a16:creationId xmlns:a16="http://schemas.microsoft.com/office/drawing/2014/main" id="{75040B94-34F5-5FC5-8B44-12ACB0918EF9}"/>
+                <a16:creationId xmlns:a16="http://schemas.microsoft.com/office/drawing/2014/main" id="{86A3B7E5-FBD6-FDDB-2DAA-4C3BE9AF480C}"/>
               </a:ext>
             </a:extLst>
           </p:cNvPr>
@@ -4598,7 +4600,7 @@
           <p:cNvPr id="3" name="Rechteck 2">
             <a:extLst>
               <a:ext uri="{FF2B5EF4-FFF2-40B4-BE49-F238E27FC236}">
-                <a16:creationId xmlns:a16="http://schemas.microsoft.com/office/drawing/2014/main" id="{D3DDF721-4C3F-DFCB-EFE1-981EE8254761}"/>
+                <a16:creationId xmlns:a16="http://schemas.microsoft.com/office/drawing/2014/main" id="{A2BCEAB3-F867-D5D8-D02E-3C1FCE4C5458}"/>
               </a:ext>
             </a:extLst>
           </p:cNvPr>
@@ -4680,7 +4682,7 @@
           <p:cNvPr id="4" name="Rechteck 3">
             <a:extLst>
               <a:ext uri="{FF2B5EF4-FFF2-40B4-BE49-F238E27FC236}">
-                <a16:creationId xmlns:a16="http://schemas.microsoft.com/office/drawing/2014/main" id="{46282602-3C61-DC98-D5AB-CD18EE05906A}"/>
+                <a16:creationId xmlns:a16="http://schemas.microsoft.com/office/drawing/2014/main" id="{BD837A13-2E58-59D4-12D5-FA6E16100DEB}"/>
               </a:ext>
             </a:extLst>
           </p:cNvPr>
@@ -4762,7 +4764,7 @@
           <p:cNvPr id="5" name="Rechteck 4">
             <a:extLst>
               <a:ext uri="{FF2B5EF4-FFF2-40B4-BE49-F238E27FC236}">
-                <a16:creationId xmlns:a16="http://schemas.microsoft.com/office/drawing/2014/main" id="{DA3E5E15-22D9-2B6F-2B90-D62F3933D706}"/>
+                <a16:creationId xmlns:a16="http://schemas.microsoft.com/office/drawing/2014/main" id="{1389D06D-CB70-C011-7A2F-5BC496CCEE07}"/>
               </a:ext>
             </a:extLst>
           </p:cNvPr>
@@ -4844,7 +4846,7 @@
           <p:cNvPr id="6" name="Rechteck 5">
             <a:extLst>
               <a:ext uri="{FF2B5EF4-FFF2-40B4-BE49-F238E27FC236}">
-                <a16:creationId xmlns:a16="http://schemas.microsoft.com/office/drawing/2014/main" id="{A2D2B451-2EB9-90B1-96E1-36EBA2746F60}"/>
+                <a16:creationId xmlns:a16="http://schemas.microsoft.com/office/drawing/2014/main" id="{C79AA25F-9D1F-1382-DBAD-869445084AB8}"/>
               </a:ext>
             </a:extLst>
           </p:cNvPr>
@@ -4926,7 +4928,7 @@
           <p:cNvPr id="7" name="Rechteck 6">
             <a:extLst>
               <a:ext uri="{FF2B5EF4-FFF2-40B4-BE49-F238E27FC236}">
-                <a16:creationId xmlns:a16="http://schemas.microsoft.com/office/drawing/2014/main" id="{9EE4F95F-05CA-D7D1-B472-330DBEEEA9C0}"/>
+                <a16:creationId xmlns:a16="http://schemas.microsoft.com/office/drawing/2014/main" id="{3362AC92-36D4-C9B5-F27F-34152E19E074}"/>
               </a:ext>
             </a:extLst>
           </p:cNvPr>
@@ -5008,7 +5010,7 @@
           <p:cNvPr id="8" name="Rechteck 7">
             <a:extLst>
               <a:ext uri="{FF2B5EF4-FFF2-40B4-BE49-F238E27FC236}">
-                <a16:creationId xmlns:a16="http://schemas.microsoft.com/office/drawing/2014/main" id="{1822F6FD-636C-04A6-B85E-73B60B46BC5C}"/>
+                <a16:creationId xmlns:a16="http://schemas.microsoft.com/office/drawing/2014/main" id="{0CC4E675-8304-17B2-784E-D07E33A9294F}"/>
               </a:ext>
             </a:extLst>
           </p:cNvPr>
@@ -5090,7 +5092,7 @@
           <p:cNvPr id="9" name="Rechteck 8">
             <a:extLst>
               <a:ext uri="{FF2B5EF4-FFF2-40B4-BE49-F238E27FC236}">
-                <a16:creationId xmlns:a16="http://schemas.microsoft.com/office/drawing/2014/main" id="{411DF65F-8820-9FE4-ABBA-8539CB4E403F}"/>
+                <a16:creationId xmlns:a16="http://schemas.microsoft.com/office/drawing/2014/main" id="{AD7A483E-4400-ECC8-64C3-BFE36944DAA8}"/>
               </a:ext>
             </a:extLst>
           </p:cNvPr>
@@ -5172,7 +5174,7 @@
           <p:cNvPr id="10" name="Rechteck 9">
             <a:extLst>
               <a:ext uri="{FF2B5EF4-FFF2-40B4-BE49-F238E27FC236}">
-                <a16:creationId xmlns:a16="http://schemas.microsoft.com/office/drawing/2014/main" id="{A2950BE4-89A8-9C02-7E1A-0846152DED0A}"/>
+                <a16:creationId xmlns:a16="http://schemas.microsoft.com/office/drawing/2014/main" id="{A312E6CF-9831-F1A3-704D-05D40B5DEA08}"/>
               </a:ext>
             </a:extLst>
           </p:cNvPr>
@@ -5254,7 +5256,7 @@
           <p:cNvPr id="11" name="Rechteck 10">
             <a:extLst>
               <a:ext uri="{FF2B5EF4-FFF2-40B4-BE49-F238E27FC236}">
-                <a16:creationId xmlns:a16="http://schemas.microsoft.com/office/drawing/2014/main" id="{F1AF49B3-A472-5B8B-D0AB-80932A66F4E8}"/>
+                <a16:creationId xmlns:a16="http://schemas.microsoft.com/office/drawing/2014/main" id="{71B52D26-1D6C-0E27-E1D8-B68828921599}"/>
               </a:ext>
             </a:extLst>
           </p:cNvPr>
@@ -5336,7 +5338,7 @@
           <p:cNvPr id="12" name="Rechteck 11">
             <a:extLst>
               <a:ext uri="{FF2B5EF4-FFF2-40B4-BE49-F238E27FC236}">
-                <a16:creationId xmlns:a16="http://schemas.microsoft.com/office/drawing/2014/main" id="{4EFB83CC-493A-49DD-99CF-9297D4FB4AB3}"/>
+                <a16:creationId xmlns:a16="http://schemas.microsoft.com/office/drawing/2014/main" id="{833CC61A-6042-A0DB-D3FD-BE7248E34470}"/>
               </a:ext>
             </a:extLst>
           </p:cNvPr>
@@ -5418,7 +5420,7 @@
           <p:cNvPr id="13" name="Rechteck 12">
             <a:extLst>
               <a:ext uri="{FF2B5EF4-FFF2-40B4-BE49-F238E27FC236}">
-                <a16:creationId xmlns:a16="http://schemas.microsoft.com/office/drawing/2014/main" id="{1B5F07A3-9682-D67D-59E5-482C1743B694}"/>
+                <a16:creationId xmlns:a16="http://schemas.microsoft.com/office/drawing/2014/main" id="{63467DEA-4BEF-454C-A948-14CCF98FBE1D}"/>
               </a:ext>
             </a:extLst>
           </p:cNvPr>
@@ -5498,7 +5500,7 @@
     </p:spTree>
     <p:extLst>
       <p:ext uri="{BB962C8B-B14F-4D97-AF65-F5344CB8AC3E}">
-        <p14:creationId xmlns:p14="http://schemas.microsoft.com/office/powerpoint/2010/main" val="1650039938"/>
+        <p14:creationId xmlns:p14="http://schemas.microsoft.com/office/powerpoint/2010/main" val="1786974142"/>
       </p:ext>
     </p:extLst>
   </p:cSld>
@@ -5530,7 +5532,7 @@
           <p:cNvPr id="2" name="Ellipse 1">
             <a:extLst>
               <a:ext uri="{FF2B5EF4-FFF2-40B4-BE49-F238E27FC236}">
-                <a16:creationId xmlns:a16="http://schemas.microsoft.com/office/drawing/2014/main" id="{69EEE1B4-35E9-E7D8-1595-0B6BCD78C8F6}"/>
+                <a16:creationId xmlns:a16="http://schemas.microsoft.com/office/drawing/2014/main" id="{C1A42206-B55B-473E-BEE8-0A4336E5C061}"/>
               </a:ext>
             </a:extLst>
           </p:cNvPr>
@@ -5612,7 +5614,7 @@
           <p:cNvPr id="3" name="Rechteck: abgerundete Ecken 2">
             <a:extLst>
               <a:ext uri="{FF2B5EF4-FFF2-40B4-BE49-F238E27FC236}">
-                <a16:creationId xmlns:a16="http://schemas.microsoft.com/office/drawing/2014/main" id="{04590D80-44C0-927B-AA4F-1145D940303C}"/>
+                <a16:creationId xmlns:a16="http://schemas.microsoft.com/office/drawing/2014/main" id="{7996A9A6-BBE3-9994-B8CE-A06DA85147F7}"/>
               </a:ext>
             </a:extLst>
           </p:cNvPr>
@@ -5694,7 +5696,7 @@
           <p:cNvPr id="4" name="Ellipse 3">
             <a:extLst>
               <a:ext uri="{FF2B5EF4-FFF2-40B4-BE49-F238E27FC236}">
-                <a16:creationId xmlns:a16="http://schemas.microsoft.com/office/drawing/2014/main" id="{6DA034AB-156F-409B-0688-FA372FDC8C5E}"/>
+                <a16:creationId xmlns:a16="http://schemas.microsoft.com/office/drawing/2014/main" id="{0524099F-BC63-FC07-7A40-2AD1A27B6A9A}"/>
               </a:ext>
             </a:extLst>
           </p:cNvPr>
@@ -5776,7 +5778,7 @@
           <p:cNvPr id="5" name="Rechteck: abgerundete Ecken 4">
             <a:extLst>
               <a:ext uri="{FF2B5EF4-FFF2-40B4-BE49-F238E27FC236}">
-                <a16:creationId xmlns:a16="http://schemas.microsoft.com/office/drawing/2014/main" id="{211E9D2E-D091-E802-477E-FF0B2053C21B}"/>
+                <a16:creationId xmlns:a16="http://schemas.microsoft.com/office/drawing/2014/main" id="{A281F3EF-2DF2-34B3-3131-B29D0D2B1419}"/>
               </a:ext>
             </a:extLst>
           </p:cNvPr>
@@ -5858,7 +5860,7 @@
           <p:cNvPr id="6" name="Ellipse 5">
             <a:extLst>
               <a:ext uri="{FF2B5EF4-FFF2-40B4-BE49-F238E27FC236}">
-                <a16:creationId xmlns:a16="http://schemas.microsoft.com/office/drawing/2014/main" id="{86F803A5-CAEA-1EB6-8B08-B6A101ADD95D}"/>
+                <a16:creationId xmlns:a16="http://schemas.microsoft.com/office/drawing/2014/main" id="{A79CDEFB-0E09-3E5F-A329-75657A71AB72}"/>
               </a:ext>
             </a:extLst>
           </p:cNvPr>
@@ -5940,7 +5942,7 @@
           <p:cNvPr id="7" name="Rechteck: abgerundete Ecken 6">
             <a:extLst>
               <a:ext uri="{FF2B5EF4-FFF2-40B4-BE49-F238E27FC236}">
-                <a16:creationId xmlns:a16="http://schemas.microsoft.com/office/drawing/2014/main" id="{B0DF34C2-DDE4-B0BA-7622-85B9210C908A}"/>
+                <a16:creationId xmlns:a16="http://schemas.microsoft.com/office/drawing/2014/main" id="{05F0F22A-D008-FB79-D903-4BFE8D6C9653}"/>
               </a:ext>
             </a:extLst>
           </p:cNvPr>
@@ -6022,7 +6024,7 @@
           <p:cNvPr id="8" name="Ellipse 7">
             <a:extLst>
               <a:ext uri="{FF2B5EF4-FFF2-40B4-BE49-F238E27FC236}">
-                <a16:creationId xmlns:a16="http://schemas.microsoft.com/office/drawing/2014/main" id="{88231CAA-6663-5283-6661-EA23E780783F}"/>
+                <a16:creationId xmlns:a16="http://schemas.microsoft.com/office/drawing/2014/main" id="{59E29FDD-AB62-7236-7E14-9EE364B6939F}"/>
               </a:ext>
             </a:extLst>
           </p:cNvPr>
@@ -6104,7 +6106,7 @@
           <p:cNvPr id="9" name="Rechteck: abgerundete Ecken 8">
             <a:extLst>
               <a:ext uri="{FF2B5EF4-FFF2-40B4-BE49-F238E27FC236}">
-                <a16:creationId xmlns:a16="http://schemas.microsoft.com/office/drawing/2014/main" id="{4349F066-E6EB-9F38-C004-E79796344921}"/>
+                <a16:creationId xmlns:a16="http://schemas.microsoft.com/office/drawing/2014/main" id="{DC6176E7-71A3-B4B5-93CE-CCEB1D99DFE5}"/>
               </a:ext>
             </a:extLst>
           </p:cNvPr>
@@ -6186,7 +6188,7 @@
           <p:cNvPr id="10" name="Ellipse 9">
             <a:extLst>
               <a:ext uri="{FF2B5EF4-FFF2-40B4-BE49-F238E27FC236}">
-                <a16:creationId xmlns:a16="http://schemas.microsoft.com/office/drawing/2014/main" id="{0BD477B9-15AB-47E9-D71F-A1CE108FEF15}"/>
+                <a16:creationId xmlns:a16="http://schemas.microsoft.com/office/drawing/2014/main" id="{8628E87E-2A2A-2953-36AF-7066334EB5B7}"/>
               </a:ext>
             </a:extLst>
           </p:cNvPr>
@@ -6268,7 +6270,7 @@
           <p:cNvPr id="11" name="Rechteck: abgerundete Ecken 10">
             <a:extLst>
               <a:ext uri="{FF2B5EF4-FFF2-40B4-BE49-F238E27FC236}">
-                <a16:creationId xmlns:a16="http://schemas.microsoft.com/office/drawing/2014/main" id="{3143AE60-3A2F-D866-6E0E-A5D59D7EDC2F}"/>
+                <a16:creationId xmlns:a16="http://schemas.microsoft.com/office/drawing/2014/main" id="{623FCB0E-DE19-3E5C-C51C-F2C1919157E5}"/>
               </a:ext>
             </a:extLst>
           </p:cNvPr>
@@ -6348,7 +6350,7 @@
     </p:spTree>
     <p:extLst>
       <p:ext uri="{BB962C8B-B14F-4D97-AF65-F5344CB8AC3E}">
-        <p14:creationId xmlns:p14="http://schemas.microsoft.com/office/powerpoint/2010/main" val="146142710"/>
+        <p14:creationId xmlns:p14="http://schemas.microsoft.com/office/powerpoint/2010/main" val="1008262466"/>
       </p:ext>
     </p:extLst>
   </p:cSld>
@@ -6375,12 +6377,1107 @@
           <a:chExt cx="0" cy="0"/>
         </a:xfrm>
       </p:grpSpPr>
+      <p:pic>
+        <p:nvPicPr>
+          <p:cNvPr id="3" name="Grafik 2">
+            <a:extLst>
+              <a:ext uri="{FF2B5EF4-FFF2-40B4-BE49-F238E27FC236}">
+                <a16:creationId xmlns:a16="http://schemas.microsoft.com/office/drawing/2014/main" id="{DC27A9C9-A850-5375-E00E-3F6CBAE0824B}"/>
+              </a:ext>
+            </a:extLst>
+          </p:cNvPr>
+          <p:cNvPicPr>
+            <a:picLocks/>
+          </p:cNvPicPr>
+          <p:nvPr/>
+        </p:nvPicPr>
+        <p:blipFill>
+          <a:blip r:embed="rId2">
+            <a:extLst>
+              <a:ext uri="{28A0092B-C50C-407E-A947-70E740481C1C}">
+                <a14:useLocalDpi xmlns:a14="http://schemas.microsoft.com/office/drawing/2010/main" val="0"/>
+              </a:ext>
+            </a:extLst>
+          </a:blip>
+          <a:stretch>
+            <a:fillRect/>
+          </a:stretch>
+        </p:blipFill>
+        <p:spPr>
+          <a:xfrm>
+            <a:off x="508000" y="508000"/>
+            <a:ext cx="3302000" cy="2286000"/>
+          </a:xfrm>
+          <a:prstGeom prst="rect">
+            <a:avLst/>
+          </a:prstGeom>
+          <a:scene3d>
+            <a:camera prst="orthographicFront"/>
+            <a:lightRig rig="threePt" dir="t"/>
+          </a:scene3d>
+          <a:sp3d>
+            <a:bevelT w="177800" h="127000"/>
+          </a:sp3d>
+        </p:spPr>
+      </p:pic>
+      <p:pic>
+        <p:nvPicPr>
+          <p:cNvPr id="5" name="Grafik 4">
+            <a:extLst>
+              <a:ext uri="{FF2B5EF4-FFF2-40B4-BE49-F238E27FC236}">
+                <a16:creationId xmlns:a16="http://schemas.microsoft.com/office/drawing/2014/main" id="{D4D46807-6AAD-19F2-6A84-F3787DBFFDA8}"/>
+              </a:ext>
+            </a:extLst>
+          </p:cNvPr>
+          <p:cNvPicPr>
+            <a:picLocks/>
+          </p:cNvPicPr>
+          <p:nvPr/>
+        </p:nvPicPr>
+        <p:blipFill>
+          <a:blip r:embed="rId3">
+            <a:extLst>
+              <a:ext uri="{28A0092B-C50C-407E-A947-70E740481C1C}">
+                <a14:useLocalDpi xmlns:a14="http://schemas.microsoft.com/office/drawing/2010/main" val="0"/>
+              </a:ext>
+            </a:extLst>
+          </a:blip>
+          <a:stretch>
+            <a:fillRect/>
+          </a:stretch>
+        </p:blipFill>
+        <p:spPr>
+          <a:xfrm>
+            <a:off x="4318000" y="508000"/>
+            <a:ext cx="3302000" cy="2286000"/>
+          </a:xfrm>
+          <a:prstGeom prst="rect">
+            <a:avLst/>
+          </a:prstGeom>
+          <a:scene3d>
+            <a:camera prst="orthographicFront"/>
+            <a:lightRig rig="threePt" dir="t"/>
+          </a:scene3d>
+          <a:sp3d>
+            <a:bevelT w="177800" h="127000" prst="softRound"/>
+          </a:sp3d>
+        </p:spPr>
+      </p:pic>
+      <p:pic>
+        <p:nvPicPr>
+          <p:cNvPr id="7" name="Grafik 6">
+            <a:extLst>
+              <a:ext uri="{FF2B5EF4-FFF2-40B4-BE49-F238E27FC236}">
+                <a16:creationId xmlns:a16="http://schemas.microsoft.com/office/drawing/2014/main" id="{4C1ADEFD-4A76-D3BB-BDA2-EDDB935413A6}"/>
+              </a:ext>
+            </a:extLst>
+          </p:cNvPr>
+          <p:cNvPicPr>
+            <a:picLocks/>
+          </p:cNvPicPr>
+          <p:nvPr/>
+        </p:nvPicPr>
+        <p:blipFill>
+          <a:blip r:embed="rId2">
+            <a:extLst>
+              <a:ext uri="{28A0092B-C50C-407E-A947-70E740481C1C}">
+                <a14:useLocalDpi xmlns:a14="http://schemas.microsoft.com/office/drawing/2010/main" val="0"/>
+              </a:ext>
+            </a:extLst>
+          </a:blip>
+          <a:stretch>
+            <a:fillRect/>
+          </a:stretch>
+        </p:blipFill>
+        <p:spPr>
+          <a:xfrm>
+            <a:off x="8128000" y="508000"/>
+            <a:ext cx="3302000" cy="2286000"/>
+          </a:xfrm>
+          <a:prstGeom prst="rect">
+            <a:avLst/>
+          </a:prstGeom>
+          <a:scene3d>
+            <a:camera prst="orthographicFront"/>
+            <a:lightRig rig="threePt" dir="t"/>
+          </a:scene3d>
+          <a:sp3d>
+            <a:bevelT w="177800" h="127000" prst="slope"/>
+          </a:sp3d>
+        </p:spPr>
+      </p:pic>
+      <p:sp>
+        <p:nvSpPr>
+          <p:cNvPr id="8" name="Rechteck 7">
+            <a:extLst>
+              <a:ext uri="{FF2B5EF4-FFF2-40B4-BE49-F238E27FC236}">
+                <a16:creationId xmlns:a16="http://schemas.microsoft.com/office/drawing/2014/main" id="{FB30F7ED-7E6A-1147-6994-4242A5B0E67D}"/>
+              </a:ext>
+            </a:extLst>
+          </p:cNvPr>
+          <p:cNvSpPr/>
+          <p:nvPr/>
+        </p:nvSpPr>
+        <p:spPr>
+          <a:xfrm>
+            <a:off x="508000" y="3683000"/>
+            <a:ext cx="3302000" cy="2286000"/>
+          </a:xfrm>
+          <a:prstGeom prst="rect">
+            <a:avLst/>
+          </a:prstGeom>
+          <a:gradFill flip="none" rotWithShape="1">
+            <a:gsLst>
+              <a:gs pos="0">
+                <a:srgbClr val="4472C4"/>
+              </a:gs>
+              <a:gs pos="100000">
+                <a:srgbClr val="FFC000"/>
+              </a:gs>
+            </a:gsLst>
+            <a:lin ang="5400000" scaled="1"/>
+            <a:tileRect/>
+          </a:gradFill>
+          <a:ln w="19050" cap="flat" cmpd="sng" algn="ctr">
+            <a:noFill/>
+            <a:prstDash val="solid"/>
+            <a:miter lim="800000"/>
+          </a:ln>
+          <a:effectLst/>
+          <a:scene3d>
+            <a:camera prst="orthographicFront"/>
+            <a:lightRig rig="threePt" dir="t"/>
+          </a:scene3d>
+          <a:sp3d>
+            <a:bevelT w="203200" h="127000"/>
+          </a:sp3d>
+        </p:spPr>
+        <p:style>
+          <a:lnRef idx="2">
+            <a:schemeClr val="accent1">
+              <a:shade val="15000"/>
+            </a:schemeClr>
+          </a:lnRef>
+          <a:fillRef idx="1">
+            <a:schemeClr val="accent1"/>
+          </a:fillRef>
+          <a:effectRef idx="0">
+            <a:schemeClr val="accent1"/>
+          </a:effectRef>
+          <a:fontRef idx="minor">
+            <a:schemeClr val="lt1"/>
+          </a:fontRef>
+        </p:style>
+        <p:txBody>
+          <a:bodyPr rtlCol="0" anchor="ctr"/>
+          <a:lstStyle/>
+          <a:p>
+            <a:pPr algn="ctr"/>
+            <a:r>
+              <a:rPr lang="de-DE" sz="1600">
+                <a:solidFill>
+                  <a:srgbClr val="FFFFFF"/>
+                </a:solidFill>
+              </a:rPr>
+              <a:t>Gradient 1</a:t>
+            </a:r>
+          </a:p>
+        </p:txBody>
+      </p:sp>
+      <p:sp>
+        <p:nvSpPr>
+          <p:cNvPr id="9" name="Ellipse 8">
+            <a:extLst>
+              <a:ext uri="{FF2B5EF4-FFF2-40B4-BE49-F238E27FC236}">
+                <a16:creationId xmlns:a16="http://schemas.microsoft.com/office/drawing/2014/main" id="{61E1E75B-3A71-6284-CA38-90CF210232F3}"/>
+              </a:ext>
+            </a:extLst>
+          </p:cNvPr>
+          <p:cNvSpPr/>
+          <p:nvPr/>
+        </p:nvSpPr>
+        <p:spPr>
+          <a:xfrm>
+            <a:off x="4318000" y="3683000"/>
+            <a:ext cx="3302000" cy="2286000"/>
+          </a:xfrm>
+          <a:prstGeom prst="ellipse">
+            <a:avLst/>
+          </a:prstGeom>
+          <a:gradFill flip="none" rotWithShape="1">
+            <a:gsLst>
+              <a:gs pos="0">
+                <a:srgbClr val="4472C4"/>
+              </a:gs>
+              <a:gs pos="100000">
+                <a:srgbClr val="FFC000"/>
+              </a:gs>
+            </a:gsLst>
+            <a:lin ang="0" scaled="1"/>
+            <a:tileRect/>
+          </a:gradFill>
+          <a:ln w="19050" cap="flat" cmpd="sng" algn="ctr">
+            <a:noFill/>
+            <a:prstDash val="solid"/>
+            <a:miter lim="800000"/>
+          </a:ln>
+          <a:effectLst/>
+          <a:scene3d>
+            <a:camera prst="orthographicFront"/>
+            <a:lightRig rig="threePt" dir="t"/>
+          </a:scene3d>
+          <a:sp3d>
+            <a:bevelT w="203200" h="127000"/>
+          </a:sp3d>
+        </p:spPr>
+        <p:style>
+          <a:lnRef idx="2">
+            <a:schemeClr val="accent1">
+              <a:shade val="15000"/>
+            </a:schemeClr>
+          </a:lnRef>
+          <a:fillRef idx="1">
+            <a:schemeClr val="accent1"/>
+          </a:fillRef>
+          <a:effectRef idx="0">
+            <a:schemeClr val="accent1"/>
+          </a:effectRef>
+          <a:fontRef idx="minor">
+            <a:schemeClr val="lt1"/>
+          </a:fontRef>
+        </p:style>
+        <p:txBody>
+          <a:bodyPr rtlCol="0" anchor="ctr"/>
+          <a:lstStyle/>
+          <a:p>
+            <a:pPr algn="ctr"/>
+            <a:r>
+              <a:rPr lang="de-DE" sz="1600">
+                <a:solidFill>
+                  <a:srgbClr val="FFFFFF"/>
+                </a:solidFill>
+              </a:rPr>
+              <a:t>Gradient 2</a:t>
+            </a:r>
+          </a:p>
+        </p:txBody>
+      </p:sp>
+      <p:sp>
+        <p:nvSpPr>
+          <p:cNvPr id="10" name="Rechteck 9">
+            <a:extLst>
+              <a:ext uri="{FF2B5EF4-FFF2-40B4-BE49-F238E27FC236}">
+                <a16:creationId xmlns:a16="http://schemas.microsoft.com/office/drawing/2014/main" id="{963369C2-1719-A41F-E462-28DEAF237F59}"/>
+              </a:ext>
+            </a:extLst>
+          </p:cNvPr>
+          <p:cNvSpPr/>
+          <p:nvPr/>
+        </p:nvSpPr>
+        <p:spPr>
+          <a:xfrm>
+            <a:off x="8128000" y="3683000"/>
+            <a:ext cx="3302000" cy="2286000"/>
+          </a:xfrm>
+          <a:prstGeom prst="rect">
+            <a:avLst/>
+          </a:prstGeom>
+          <a:gradFill flip="none" rotWithShape="1">
+            <a:gsLst>
+              <a:gs pos="0">
+                <a:srgbClr val="4472C4"/>
+              </a:gs>
+              <a:gs pos="100000">
+                <a:srgbClr val="FFC000"/>
+              </a:gs>
+            </a:gsLst>
+            <a:lin ang="2700000" scaled="1"/>
+            <a:tileRect/>
+          </a:gradFill>
+          <a:ln w="19050" cap="flat" cmpd="sng" algn="ctr">
+            <a:noFill/>
+            <a:prstDash val="solid"/>
+            <a:miter lim="800000"/>
+          </a:ln>
+          <a:effectLst/>
+          <a:scene3d>
+            <a:camera prst="orthographicFront"/>
+            <a:lightRig rig="threePt" dir="t"/>
+          </a:scene3d>
+          <a:sp3d>
+            <a:bevelT w="203200" h="127000"/>
+          </a:sp3d>
+        </p:spPr>
+        <p:style>
+          <a:lnRef idx="2">
+            <a:schemeClr val="accent1">
+              <a:shade val="15000"/>
+            </a:schemeClr>
+          </a:lnRef>
+          <a:fillRef idx="1">
+            <a:schemeClr val="accent1"/>
+          </a:fillRef>
+          <a:effectRef idx="0">
+            <a:schemeClr val="accent1"/>
+          </a:effectRef>
+          <a:fontRef idx="minor">
+            <a:schemeClr val="lt1"/>
+          </a:fontRef>
+        </p:style>
+        <p:txBody>
+          <a:bodyPr rtlCol="0" anchor="ctr"/>
+          <a:lstStyle/>
+          <a:p>
+            <a:pPr algn="ctr"/>
+            <a:r>
+              <a:rPr lang="de-DE" sz="1600">
+                <a:solidFill>
+                  <a:srgbClr val="FFFFFF"/>
+                </a:solidFill>
+              </a:rPr>
+              <a:t>Gradient 3</a:t>
+            </a:r>
+          </a:p>
+        </p:txBody>
+      </p:sp>
+    </p:spTree>
+    <p:extLst>
+      <p:ext uri="{BB962C8B-B14F-4D97-AF65-F5344CB8AC3E}">
+        <p14:creationId xmlns:p14="http://schemas.microsoft.com/office/powerpoint/2010/main" val="2476825975"/>
+      </p:ext>
+    </p:extLst>
+  </p:cSld>
+  <p:clrMapOvr>
+    <a:masterClrMapping/>
+  </p:clrMapOvr>
+</p:sld>
+</file>
+
+<file path=ppt/slides/slide6.xml><?xml version="1.0" encoding="utf-8"?>
+<p:sld xmlns:a="http://schemas.openxmlformats.org/drawingml/2006/main" xmlns:r="http://schemas.openxmlformats.org/officeDocument/2006/relationships" xmlns:p="http://schemas.openxmlformats.org/presentationml/2006/main">
+  <p:cSld>
+    <p:spTree>
+      <p:nvGrpSpPr>
+        <p:cNvPr id="1" name=""/>
+        <p:cNvGrpSpPr/>
+        <p:nvPr/>
+      </p:nvGrpSpPr>
+      <p:grpSpPr>
+        <a:xfrm>
+          <a:off x="0" y="0"/>
+          <a:ext cx="0" cy="0"/>
+          <a:chOff x="0" y="0"/>
+          <a:chExt cx="0" cy="0"/>
+        </a:xfrm>
+      </p:grpSpPr>
+      <p:sp>
+        <p:nvSpPr>
+          <p:cNvPr id="2" name="Ellipse 1">
+            <a:extLst>
+              <a:ext uri="{FF2B5EF4-FFF2-40B4-BE49-F238E27FC236}">
+                <a16:creationId xmlns:a16="http://schemas.microsoft.com/office/drawing/2014/main" id="{7FB51541-3F7D-7AF6-A060-1F6ADFC998FF}"/>
+              </a:ext>
+            </a:extLst>
+          </p:cNvPr>
+          <p:cNvSpPr/>
+          <p:nvPr/>
+        </p:nvSpPr>
+        <p:spPr>
+          <a:xfrm>
+            <a:off x="508000" y="635000"/>
+            <a:ext cx="2413000" cy="2413000"/>
+          </a:xfrm>
+          <a:prstGeom prst="ellipse">
+            <a:avLst/>
+          </a:prstGeom>
+          <a:solidFill>
+            <a:srgbClr val="4472C4"/>
+          </a:solidFill>
+          <a:ln w="19050" cap="flat" cmpd="sng" algn="ctr">
+            <a:noFill/>
+            <a:prstDash val="solid"/>
+            <a:miter lim="800000"/>
+          </a:ln>
+          <a:effectLst/>
+          <a:scene3d>
+            <a:camera prst="orthographicFront"/>
+            <a:lightRig rig="threePt" dir="t">
+              <a:rot lat="0" lon="0" rev="0"/>
+            </a:lightRig>
+          </a:scene3d>
+          <a:sp3d>
+            <a:bevelT w="508000" h="508000" prst="angle"/>
+          </a:sp3d>
+          <a:extLst>
+            <a:ext uri="{91240B29-F687-4F45-9708-019B960494DF}">
+              <a14:hiddenLine xmlns:a14="http://schemas.microsoft.com/office/drawing/2010/main" w="19050" cap="flat" cmpd="sng" algn="ctr">
+                <a:solidFill>
+                  <a:schemeClr val="accent1">
+                    <a:shade val="15000"/>
+                  </a:schemeClr>
+                </a:solidFill>
+                <a:prstDash val="solid"/>
+                <a:miter lim="800000"/>
+              </a14:hiddenLine>
+            </a:ext>
+          </a:extLst>
+        </p:spPr>
+        <p:style>
+          <a:lnRef idx="2">
+            <a:schemeClr val="accent1">
+              <a:shade val="15000"/>
+            </a:schemeClr>
+          </a:lnRef>
+          <a:fillRef idx="1">
+            <a:schemeClr val="accent1"/>
+          </a:fillRef>
+          <a:effectRef idx="0">
+            <a:schemeClr val="accent1"/>
+          </a:effectRef>
+          <a:fontRef idx="minor">
+            <a:schemeClr val="lt1"/>
+          </a:fontRef>
+        </p:style>
+        <p:txBody>
+          <a:bodyPr rtlCol="0" anchor="ctr"/>
+          <a:lstStyle/>
+          <a:p>
+            <a:pPr algn="ctr"/>
+            <a:r>
+              <a:rPr lang="de-DE" sz="1600">
+                <a:solidFill>
+                  <a:srgbClr val="FFFFFF"/>
+                </a:solidFill>
+              </a:rPr>
+              <a:t>Angle 0</a:t>
+            </a:r>
+          </a:p>
+        </p:txBody>
+      </p:sp>
+      <p:sp>
+        <p:nvSpPr>
+          <p:cNvPr id="3" name="Ellipse 2">
+            <a:extLst>
+              <a:ext uri="{FF2B5EF4-FFF2-40B4-BE49-F238E27FC236}">
+                <a16:creationId xmlns:a16="http://schemas.microsoft.com/office/drawing/2014/main" id="{BADEE460-1871-AB31-23A2-D4E6402249E4}"/>
+              </a:ext>
+            </a:extLst>
+          </p:cNvPr>
+          <p:cNvSpPr/>
+          <p:nvPr/>
+        </p:nvSpPr>
+        <p:spPr>
+          <a:xfrm>
+            <a:off x="3429000" y="635000"/>
+            <a:ext cx="2413000" cy="2413000"/>
+          </a:xfrm>
+          <a:prstGeom prst="ellipse">
+            <a:avLst/>
+          </a:prstGeom>
+          <a:solidFill>
+            <a:srgbClr val="4472C4"/>
+          </a:solidFill>
+          <a:ln w="19050" cap="flat" cmpd="sng" algn="ctr">
+            <a:noFill/>
+            <a:prstDash val="solid"/>
+            <a:miter lim="800000"/>
+          </a:ln>
+          <a:effectLst/>
+          <a:scene3d>
+            <a:camera prst="orthographicFront"/>
+            <a:lightRig rig="threePt" dir="t">
+              <a:rot lat="0" lon="0" rev="2700000"/>
+            </a:lightRig>
+          </a:scene3d>
+          <a:sp3d>
+            <a:bevelT w="508000" h="508000" prst="angle"/>
+          </a:sp3d>
+          <a:extLst>
+            <a:ext uri="{91240B29-F687-4F45-9708-019B960494DF}">
+              <a14:hiddenLine xmlns:a14="http://schemas.microsoft.com/office/drawing/2010/main" w="19050" cap="flat" cmpd="sng" algn="ctr">
+                <a:solidFill>
+                  <a:schemeClr val="accent1">
+                    <a:shade val="15000"/>
+                  </a:schemeClr>
+                </a:solidFill>
+                <a:prstDash val="solid"/>
+                <a:miter lim="800000"/>
+              </a14:hiddenLine>
+            </a:ext>
+          </a:extLst>
+        </p:spPr>
+        <p:style>
+          <a:lnRef idx="2">
+            <a:schemeClr val="accent1">
+              <a:shade val="15000"/>
+            </a:schemeClr>
+          </a:lnRef>
+          <a:fillRef idx="1">
+            <a:schemeClr val="accent1"/>
+          </a:fillRef>
+          <a:effectRef idx="0">
+            <a:schemeClr val="accent1"/>
+          </a:effectRef>
+          <a:fontRef idx="minor">
+            <a:schemeClr val="lt1"/>
+          </a:fontRef>
+        </p:style>
+        <p:txBody>
+          <a:bodyPr rtlCol="0" anchor="ctr"/>
+          <a:lstStyle/>
+          <a:p>
+            <a:pPr algn="ctr"/>
+            <a:r>
+              <a:rPr lang="de-DE" sz="1600">
+                <a:solidFill>
+                  <a:srgbClr val="FFFFFF"/>
+                </a:solidFill>
+              </a:rPr>
+              <a:t>Angle 45</a:t>
+            </a:r>
+          </a:p>
+        </p:txBody>
+      </p:sp>
+      <p:sp>
+        <p:nvSpPr>
+          <p:cNvPr id="4" name="Ellipse 3">
+            <a:extLst>
+              <a:ext uri="{FF2B5EF4-FFF2-40B4-BE49-F238E27FC236}">
+                <a16:creationId xmlns:a16="http://schemas.microsoft.com/office/drawing/2014/main" id="{13BEFD63-2ECD-99FB-F459-D0B2F8B90F71}"/>
+              </a:ext>
+            </a:extLst>
+          </p:cNvPr>
+          <p:cNvSpPr/>
+          <p:nvPr/>
+        </p:nvSpPr>
+        <p:spPr>
+          <a:xfrm>
+            <a:off x="6350000" y="635000"/>
+            <a:ext cx="2413000" cy="2413000"/>
+          </a:xfrm>
+          <a:prstGeom prst="ellipse">
+            <a:avLst/>
+          </a:prstGeom>
+          <a:solidFill>
+            <a:srgbClr val="4472C4"/>
+          </a:solidFill>
+          <a:ln w="19050" cap="flat" cmpd="sng" algn="ctr">
+            <a:noFill/>
+            <a:prstDash val="solid"/>
+            <a:miter lim="800000"/>
+          </a:ln>
+          <a:effectLst/>
+          <a:scene3d>
+            <a:camera prst="orthographicFront"/>
+            <a:lightRig rig="threePt" dir="t">
+              <a:rot lat="0" lon="0" rev="5400000"/>
+            </a:lightRig>
+          </a:scene3d>
+          <a:sp3d>
+            <a:bevelT w="508000" h="508000" prst="angle"/>
+          </a:sp3d>
+          <a:extLst>
+            <a:ext uri="{91240B29-F687-4F45-9708-019B960494DF}">
+              <a14:hiddenLine xmlns:a14="http://schemas.microsoft.com/office/drawing/2010/main" w="19050" cap="flat" cmpd="sng" algn="ctr">
+                <a:solidFill>
+                  <a:schemeClr val="accent1">
+                    <a:shade val="15000"/>
+                  </a:schemeClr>
+                </a:solidFill>
+                <a:prstDash val="solid"/>
+                <a:miter lim="800000"/>
+              </a14:hiddenLine>
+            </a:ext>
+          </a:extLst>
+        </p:spPr>
+        <p:style>
+          <a:lnRef idx="2">
+            <a:schemeClr val="accent1">
+              <a:shade val="15000"/>
+            </a:schemeClr>
+          </a:lnRef>
+          <a:fillRef idx="1">
+            <a:schemeClr val="accent1"/>
+          </a:fillRef>
+          <a:effectRef idx="0">
+            <a:schemeClr val="accent1"/>
+          </a:effectRef>
+          <a:fontRef idx="minor">
+            <a:schemeClr val="lt1"/>
+          </a:fontRef>
+        </p:style>
+        <p:txBody>
+          <a:bodyPr rtlCol="0" anchor="ctr"/>
+          <a:lstStyle/>
+          <a:p>
+            <a:pPr algn="ctr"/>
+            <a:r>
+              <a:rPr lang="de-DE" sz="1600">
+                <a:solidFill>
+                  <a:srgbClr val="FFFFFF"/>
+                </a:solidFill>
+              </a:rPr>
+              <a:t>Angle 90</a:t>
+            </a:r>
+          </a:p>
+        </p:txBody>
+      </p:sp>
+      <p:sp>
+        <p:nvSpPr>
+          <p:cNvPr id="5" name="Ellipse 4">
+            <a:extLst>
+              <a:ext uri="{FF2B5EF4-FFF2-40B4-BE49-F238E27FC236}">
+                <a16:creationId xmlns:a16="http://schemas.microsoft.com/office/drawing/2014/main" id="{1EBB32A1-9280-0AF5-1D02-A630E4348D92}"/>
+              </a:ext>
+            </a:extLst>
+          </p:cNvPr>
+          <p:cNvSpPr/>
+          <p:nvPr/>
+        </p:nvSpPr>
+        <p:spPr>
+          <a:xfrm>
+            <a:off x="9271000" y="635000"/>
+            <a:ext cx="2413000" cy="2413000"/>
+          </a:xfrm>
+          <a:prstGeom prst="ellipse">
+            <a:avLst/>
+          </a:prstGeom>
+          <a:solidFill>
+            <a:srgbClr val="4472C4"/>
+          </a:solidFill>
+          <a:ln w="19050" cap="flat" cmpd="sng" algn="ctr">
+            <a:noFill/>
+            <a:prstDash val="solid"/>
+            <a:miter lim="800000"/>
+          </a:ln>
+          <a:effectLst/>
+          <a:scene3d>
+            <a:camera prst="orthographicFront"/>
+            <a:lightRig rig="threePt" dir="t">
+              <a:rot lat="0" lon="0" rev="8100000"/>
+            </a:lightRig>
+          </a:scene3d>
+          <a:sp3d>
+            <a:bevelT w="508000" h="508000" prst="angle"/>
+          </a:sp3d>
+          <a:extLst>
+            <a:ext uri="{91240B29-F687-4F45-9708-019B960494DF}">
+              <a14:hiddenLine xmlns:a14="http://schemas.microsoft.com/office/drawing/2010/main" w="19050" cap="flat" cmpd="sng" algn="ctr">
+                <a:solidFill>
+                  <a:schemeClr val="accent1">
+                    <a:shade val="15000"/>
+                  </a:schemeClr>
+                </a:solidFill>
+                <a:prstDash val="solid"/>
+                <a:miter lim="800000"/>
+              </a14:hiddenLine>
+            </a:ext>
+          </a:extLst>
+        </p:spPr>
+        <p:style>
+          <a:lnRef idx="2">
+            <a:schemeClr val="accent1">
+              <a:shade val="15000"/>
+            </a:schemeClr>
+          </a:lnRef>
+          <a:fillRef idx="1">
+            <a:schemeClr val="accent1"/>
+          </a:fillRef>
+          <a:effectRef idx="0">
+            <a:schemeClr val="accent1"/>
+          </a:effectRef>
+          <a:fontRef idx="minor">
+            <a:schemeClr val="lt1"/>
+          </a:fontRef>
+        </p:style>
+        <p:txBody>
+          <a:bodyPr rtlCol="0" anchor="ctr"/>
+          <a:lstStyle/>
+          <a:p>
+            <a:pPr algn="ctr"/>
+            <a:r>
+              <a:rPr lang="de-DE" sz="1600">
+                <a:solidFill>
+                  <a:srgbClr val="FFFFFF"/>
+                </a:solidFill>
+              </a:rPr>
+              <a:t>Angle 135</a:t>
+            </a:r>
+          </a:p>
+        </p:txBody>
+      </p:sp>
+      <p:sp>
+        <p:nvSpPr>
+          <p:cNvPr id="6" name="Ellipse 5">
+            <a:extLst>
+              <a:ext uri="{FF2B5EF4-FFF2-40B4-BE49-F238E27FC236}">
+                <a16:creationId xmlns:a16="http://schemas.microsoft.com/office/drawing/2014/main" id="{F0CF79B2-C2FA-C2ED-C8C1-9816DA40F552}"/>
+              </a:ext>
+            </a:extLst>
+          </p:cNvPr>
+          <p:cNvSpPr/>
+          <p:nvPr/>
+        </p:nvSpPr>
+        <p:spPr>
+          <a:xfrm>
+            <a:off x="508000" y="3683000"/>
+            <a:ext cx="2413000" cy="2413000"/>
+          </a:xfrm>
+          <a:prstGeom prst="ellipse">
+            <a:avLst/>
+          </a:prstGeom>
+          <a:solidFill>
+            <a:srgbClr val="4472C4"/>
+          </a:solidFill>
+          <a:ln w="19050" cap="flat" cmpd="sng" algn="ctr">
+            <a:noFill/>
+            <a:prstDash val="solid"/>
+            <a:miter lim="800000"/>
+          </a:ln>
+          <a:effectLst/>
+          <a:scene3d>
+            <a:camera prst="orthographicFront"/>
+            <a:lightRig rig="threePt" dir="t">
+              <a:rot lat="0" lon="0" rev="10800000"/>
+            </a:lightRig>
+          </a:scene3d>
+          <a:sp3d>
+            <a:bevelT w="508000" h="508000" prst="angle"/>
+          </a:sp3d>
+          <a:extLst>
+            <a:ext uri="{91240B29-F687-4F45-9708-019B960494DF}">
+              <a14:hiddenLine xmlns:a14="http://schemas.microsoft.com/office/drawing/2010/main" w="19050" cap="flat" cmpd="sng" algn="ctr">
+                <a:solidFill>
+                  <a:schemeClr val="accent1">
+                    <a:shade val="15000"/>
+                  </a:schemeClr>
+                </a:solidFill>
+                <a:prstDash val="solid"/>
+                <a:miter lim="800000"/>
+              </a14:hiddenLine>
+            </a:ext>
+          </a:extLst>
+        </p:spPr>
+        <p:style>
+          <a:lnRef idx="2">
+            <a:schemeClr val="accent1">
+              <a:shade val="15000"/>
+            </a:schemeClr>
+          </a:lnRef>
+          <a:fillRef idx="1">
+            <a:schemeClr val="accent1"/>
+          </a:fillRef>
+          <a:effectRef idx="0">
+            <a:schemeClr val="accent1"/>
+          </a:effectRef>
+          <a:fontRef idx="minor">
+            <a:schemeClr val="lt1"/>
+          </a:fontRef>
+        </p:style>
+        <p:txBody>
+          <a:bodyPr rtlCol="0" anchor="ctr"/>
+          <a:lstStyle/>
+          <a:p>
+            <a:pPr algn="ctr"/>
+            <a:r>
+              <a:rPr lang="de-DE" sz="1600">
+                <a:solidFill>
+                  <a:srgbClr val="FFFFFF"/>
+                </a:solidFill>
+              </a:rPr>
+              <a:t>Angle 180</a:t>
+            </a:r>
+          </a:p>
+        </p:txBody>
+      </p:sp>
+      <p:sp>
+        <p:nvSpPr>
+          <p:cNvPr id="7" name="Ellipse 6">
+            <a:extLst>
+              <a:ext uri="{FF2B5EF4-FFF2-40B4-BE49-F238E27FC236}">
+                <a16:creationId xmlns:a16="http://schemas.microsoft.com/office/drawing/2014/main" id="{FF28CB74-F322-0731-24D3-538C00FEF1FF}"/>
+              </a:ext>
+            </a:extLst>
+          </p:cNvPr>
+          <p:cNvSpPr/>
+          <p:nvPr/>
+        </p:nvSpPr>
+        <p:spPr>
+          <a:xfrm>
+            <a:off x="3429000" y="3683000"/>
+            <a:ext cx="2413000" cy="2413000"/>
+          </a:xfrm>
+          <a:prstGeom prst="ellipse">
+            <a:avLst/>
+          </a:prstGeom>
+          <a:solidFill>
+            <a:srgbClr val="4472C4"/>
+          </a:solidFill>
+          <a:ln w="19050" cap="flat" cmpd="sng" algn="ctr">
+            <a:noFill/>
+            <a:prstDash val="solid"/>
+            <a:miter lim="800000"/>
+          </a:ln>
+          <a:effectLst/>
+          <a:scene3d>
+            <a:camera prst="orthographicFront"/>
+            <a:lightRig rig="threePt" dir="t">
+              <a:rot lat="0" lon="0" rev="13500000"/>
+            </a:lightRig>
+          </a:scene3d>
+          <a:sp3d>
+            <a:bevelT w="508000" h="508000" prst="angle"/>
+          </a:sp3d>
+          <a:extLst>
+            <a:ext uri="{91240B29-F687-4F45-9708-019B960494DF}">
+              <a14:hiddenLine xmlns:a14="http://schemas.microsoft.com/office/drawing/2010/main" w="19050" cap="flat" cmpd="sng" algn="ctr">
+                <a:solidFill>
+                  <a:schemeClr val="accent1">
+                    <a:shade val="15000"/>
+                  </a:schemeClr>
+                </a:solidFill>
+                <a:prstDash val="solid"/>
+                <a:miter lim="800000"/>
+              </a14:hiddenLine>
+            </a:ext>
+          </a:extLst>
+        </p:spPr>
+        <p:style>
+          <a:lnRef idx="2">
+            <a:schemeClr val="accent1">
+              <a:shade val="15000"/>
+            </a:schemeClr>
+          </a:lnRef>
+          <a:fillRef idx="1">
+            <a:schemeClr val="accent1"/>
+          </a:fillRef>
+          <a:effectRef idx="0">
+            <a:schemeClr val="accent1"/>
+          </a:effectRef>
+          <a:fontRef idx="minor">
+            <a:schemeClr val="lt1"/>
+          </a:fontRef>
+        </p:style>
+        <p:txBody>
+          <a:bodyPr rtlCol="0" anchor="ctr"/>
+          <a:lstStyle/>
+          <a:p>
+            <a:pPr algn="ctr"/>
+            <a:r>
+              <a:rPr lang="de-DE" sz="1600">
+                <a:solidFill>
+                  <a:srgbClr val="FFFFFF"/>
+                </a:solidFill>
+              </a:rPr>
+              <a:t>Angle 225</a:t>
+            </a:r>
+          </a:p>
+        </p:txBody>
+      </p:sp>
+      <p:sp>
+        <p:nvSpPr>
+          <p:cNvPr id="8" name="Ellipse 7">
+            <a:extLst>
+              <a:ext uri="{FF2B5EF4-FFF2-40B4-BE49-F238E27FC236}">
+                <a16:creationId xmlns:a16="http://schemas.microsoft.com/office/drawing/2014/main" id="{92D6AE70-F6D0-4091-70FD-AFE0BA9EC170}"/>
+              </a:ext>
+            </a:extLst>
+          </p:cNvPr>
+          <p:cNvSpPr/>
+          <p:nvPr/>
+        </p:nvSpPr>
+        <p:spPr>
+          <a:xfrm>
+            <a:off x="6350000" y="3683000"/>
+            <a:ext cx="2413000" cy="2413000"/>
+          </a:xfrm>
+          <a:prstGeom prst="ellipse">
+            <a:avLst/>
+          </a:prstGeom>
+          <a:solidFill>
+            <a:srgbClr val="4472C4"/>
+          </a:solidFill>
+          <a:ln w="19050" cap="flat" cmpd="sng" algn="ctr">
+            <a:noFill/>
+            <a:prstDash val="solid"/>
+            <a:miter lim="800000"/>
+          </a:ln>
+          <a:effectLst/>
+          <a:scene3d>
+            <a:camera prst="orthographicFront"/>
+            <a:lightRig rig="threePt" dir="t">
+              <a:rot lat="0" lon="0" rev="16200000"/>
+            </a:lightRig>
+          </a:scene3d>
+          <a:sp3d>
+            <a:bevelT w="508000" h="508000" prst="angle"/>
+          </a:sp3d>
+          <a:extLst>
+            <a:ext uri="{91240B29-F687-4F45-9708-019B960494DF}">
+              <a14:hiddenLine xmlns:a14="http://schemas.microsoft.com/office/drawing/2010/main" w="19050" cap="flat" cmpd="sng" algn="ctr">
+                <a:solidFill>
+                  <a:schemeClr val="accent1">
+                    <a:shade val="15000"/>
+                  </a:schemeClr>
+                </a:solidFill>
+                <a:prstDash val="solid"/>
+                <a:miter lim="800000"/>
+              </a14:hiddenLine>
+            </a:ext>
+          </a:extLst>
+        </p:spPr>
+        <p:style>
+          <a:lnRef idx="2">
+            <a:schemeClr val="accent1">
+              <a:shade val="15000"/>
+            </a:schemeClr>
+          </a:lnRef>
+          <a:fillRef idx="1">
+            <a:schemeClr val="accent1"/>
+          </a:fillRef>
+          <a:effectRef idx="0">
+            <a:schemeClr val="accent1"/>
+          </a:effectRef>
+          <a:fontRef idx="minor">
+            <a:schemeClr val="lt1"/>
+          </a:fontRef>
+        </p:style>
+        <p:txBody>
+          <a:bodyPr rtlCol="0" anchor="ctr"/>
+          <a:lstStyle/>
+          <a:p>
+            <a:pPr algn="ctr"/>
+            <a:r>
+              <a:rPr lang="de-DE" sz="1600">
+                <a:solidFill>
+                  <a:srgbClr val="FFFFFF"/>
+                </a:solidFill>
+              </a:rPr>
+              <a:t>Angle 270</a:t>
+            </a:r>
+          </a:p>
+        </p:txBody>
+      </p:sp>
+      <p:sp>
+        <p:nvSpPr>
+          <p:cNvPr id="9" name="Ellipse 8">
+            <a:extLst>
+              <a:ext uri="{FF2B5EF4-FFF2-40B4-BE49-F238E27FC236}">
+                <a16:creationId xmlns:a16="http://schemas.microsoft.com/office/drawing/2014/main" id="{A74D6DC8-1E78-A335-0393-C64DD23DA392}"/>
+              </a:ext>
+            </a:extLst>
+          </p:cNvPr>
+          <p:cNvSpPr/>
+          <p:nvPr/>
+        </p:nvSpPr>
+        <p:spPr>
+          <a:xfrm>
+            <a:off x="9271000" y="3683000"/>
+            <a:ext cx="2413000" cy="2413000"/>
+          </a:xfrm>
+          <a:prstGeom prst="ellipse">
+            <a:avLst/>
+          </a:prstGeom>
+          <a:solidFill>
+            <a:srgbClr val="4472C4"/>
+          </a:solidFill>
+          <a:ln w="19050" cap="flat" cmpd="sng" algn="ctr">
+            <a:noFill/>
+            <a:prstDash val="solid"/>
+            <a:miter lim="800000"/>
+          </a:ln>
+          <a:effectLst/>
+          <a:scene3d>
+            <a:camera prst="orthographicFront"/>
+            <a:lightRig rig="threePt" dir="t">
+              <a:rot lat="0" lon="0" rev="18900000"/>
+            </a:lightRig>
+          </a:scene3d>
+          <a:sp3d>
+            <a:bevelT w="508000" h="508000" prst="angle"/>
+          </a:sp3d>
+          <a:extLst>
+            <a:ext uri="{91240B29-F687-4F45-9708-019B960494DF}">
+              <a14:hiddenLine xmlns:a14="http://schemas.microsoft.com/office/drawing/2010/main" w="19050" cap="flat" cmpd="sng" algn="ctr">
+                <a:solidFill>
+                  <a:schemeClr val="accent1">
+                    <a:shade val="15000"/>
+                  </a:schemeClr>
+                </a:solidFill>
+                <a:prstDash val="solid"/>
+                <a:miter lim="800000"/>
+              </a14:hiddenLine>
+            </a:ext>
+          </a:extLst>
+        </p:spPr>
+        <p:style>
+          <a:lnRef idx="2">
+            <a:schemeClr val="accent1">
+              <a:shade val="15000"/>
+            </a:schemeClr>
+          </a:lnRef>
+          <a:fillRef idx="1">
+            <a:schemeClr val="accent1"/>
+          </a:fillRef>
+          <a:effectRef idx="0">
+            <a:schemeClr val="accent1"/>
+          </a:effectRef>
+          <a:fontRef idx="minor">
+            <a:schemeClr val="lt1"/>
+          </a:fontRef>
+        </p:style>
+        <p:txBody>
+          <a:bodyPr rtlCol="0" anchor="ctr"/>
+          <a:lstStyle/>
+          <a:p>
+            <a:pPr algn="ctr"/>
+            <a:r>
+              <a:rPr lang="de-DE" sz="1600">
+                <a:solidFill>
+                  <a:srgbClr val="FFFFFF"/>
+                </a:solidFill>
+              </a:rPr>
+              <a:t>Angle 315</a:t>
+            </a:r>
+          </a:p>
+        </p:txBody>
+      </p:sp>
+    </p:spTree>
+    <p:extLst>
+      <p:ext uri="{BB962C8B-B14F-4D97-AF65-F5344CB8AC3E}">
+        <p14:creationId xmlns:p14="http://schemas.microsoft.com/office/powerpoint/2010/main" val="3143185988"/>
+      </p:ext>
+    </p:extLst>
+  </p:cSld>
+  <p:clrMapOvr>
+    <a:masterClrMapping/>
+  </p:clrMapOvr>
+</p:sld>
+</file>
+
+<file path=ppt/slides/slide7.xml><?xml version="1.0" encoding="utf-8"?>
+<p:sld xmlns:a="http://schemas.openxmlformats.org/drawingml/2006/main" xmlns:r="http://schemas.openxmlformats.org/officeDocument/2006/relationships" xmlns:p="http://schemas.openxmlformats.org/presentationml/2006/main">
+  <p:cSld>
+    <p:spTree>
+      <p:nvGrpSpPr>
+        <p:cNvPr id="1" name=""/>
+        <p:cNvGrpSpPr/>
+        <p:nvPr/>
+      </p:nvGrpSpPr>
+      <p:grpSpPr>
+        <a:xfrm>
+          <a:off x="0" y="0"/>
+          <a:ext cx="0" cy="0"/>
+          <a:chOff x="0" y="0"/>
+          <a:chExt cx="0" cy="0"/>
+        </a:xfrm>
+      </p:grpSpPr>
       <p:sp>
         <p:nvSpPr>
           <p:cNvPr id="2" name="Rechteck: abgerundete Ecken 1">
             <a:extLst>
               <a:ext uri="{FF2B5EF4-FFF2-40B4-BE49-F238E27FC236}">
-                <a16:creationId xmlns:a16="http://schemas.microsoft.com/office/drawing/2014/main" id="{F818A9F0-60EE-64CA-50FD-36630C745F76}"/>
+                <a16:creationId xmlns:a16="http://schemas.microsoft.com/office/drawing/2014/main" id="{D73CD33D-4F32-90CB-4A1E-EA56BFE71237}"/>
               </a:ext>
             </a:extLst>
           </p:cNvPr>
@@ -6464,7 +7561,7 @@
           <p:cNvPr id="3" name="Rechteck: abgerundete Ecken 2">
             <a:extLst>
               <a:ext uri="{FF2B5EF4-FFF2-40B4-BE49-F238E27FC236}">
-                <a16:creationId xmlns:a16="http://schemas.microsoft.com/office/drawing/2014/main" id="{C90FB439-B09A-707A-C0E6-D475171B626F}"/>
+                <a16:creationId xmlns:a16="http://schemas.microsoft.com/office/drawing/2014/main" id="{94778884-57DD-67E4-2D19-D38EC6D958F2}"/>
               </a:ext>
             </a:extLst>
           </p:cNvPr>
@@ -6548,7 +7645,7 @@
           <p:cNvPr id="4" name="Rechteck: abgerundete Ecken 3">
             <a:extLst>
               <a:ext uri="{FF2B5EF4-FFF2-40B4-BE49-F238E27FC236}">
-                <a16:creationId xmlns:a16="http://schemas.microsoft.com/office/drawing/2014/main" id="{C8756629-4110-9872-71FA-B46A20349B81}"/>
+                <a16:creationId xmlns:a16="http://schemas.microsoft.com/office/drawing/2014/main" id="{A9F72CC0-DAA0-7F9B-B527-E079C8ABBAD9}"/>
               </a:ext>
             </a:extLst>
           </p:cNvPr>
@@ -6632,7 +7729,7 @@
           <p:cNvPr id="5" name="Rechteck: abgerundete Ecken 4">
             <a:extLst>
               <a:ext uri="{FF2B5EF4-FFF2-40B4-BE49-F238E27FC236}">
-                <a16:creationId xmlns:a16="http://schemas.microsoft.com/office/drawing/2014/main" id="{B7ED13CE-D228-FD20-C151-2CC167C013C5}"/>
+                <a16:creationId xmlns:a16="http://schemas.microsoft.com/office/drawing/2014/main" id="{16C3D22F-C201-14BB-A991-5F8A9CDACD63}"/>
               </a:ext>
             </a:extLst>
           </p:cNvPr>
@@ -6716,7 +7813,7 @@
           <p:cNvPr id="6" name="Rechteck: abgerundete Ecken 5">
             <a:extLst>
               <a:ext uri="{FF2B5EF4-FFF2-40B4-BE49-F238E27FC236}">
-                <a16:creationId xmlns:a16="http://schemas.microsoft.com/office/drawing/2014/main" id="{2ECFED86-9C5C-386A-6A2F-3F31C329C692}"/>
+                <a16:creationId xmlns:a16="http://schemas.microsoft.com/office/drawing/2014/main" id="{A432F22F-AC2E-512D-2427-47B9FBE83173}"/>
               </a:ext>
             </a:extLst>
           </p:cNvPr>
@@ -6800,7 +7897,7 @@
           <p:cNvPr id="7" name="Rechteck: abgerundete Ecken 6">
             <a:extLst>
               <a:ext uri="{FF2B5EF4-FFF2-40B4-BE49-F238E27FC236}">
-                <a16:creationId xmlns:a16="http://schemas.microsoft.com/office/drawing/2014/main" id="{B29586AE-14C5-42D5-1C52-E7ADA0C7547A}"/>
+                <a16:creationId xmlns:a16="http://schemas.microsoft.com/office/drawing/2014/main" id="{566C3052-490F-6778-F624-C46150D8D979}"/>
               </a:ext>
             </a:extLst>
           </p:cNvPr>
@@ -6884,7 +7981,7 @@
           <p:cNvPr id="8" name="Rechteck: abgerundete Ecken 7">
             <a:extLst>
               <a:ext uri="{FF2B5EF4-FFF2-40B4-BE49-F238E27FC236}">
-                <a16:creationId xmlns:a16="http://schemas.microsoft.com/office/drawing/2014/main" id="{B26D590F-C2C2-12E6-B539-C0FFBF53467D}"/>
+                <a16:creationId xmlns:a16="http://schemas.microsoft.com/office/drawing/2014/main" id="{A6D23EA4-2014-5B70-3075-641F91D520A4}"/>
               </a:ext>
             </a:extLst>
           </p:cNvPr>
@@ -6968,7 +8065,7 @@
           <p:cNvPr id="9" name="Rechteck: abgerundete Ecken 8">
             <a:extLst>
               <a:ext uri="{FF2B5EF4-FFF2-40B4-BE49-F238E27FC236}">
-                <a16:creationId xmlns:a16="http://schemas.microsoft.com/office/drawing/2014/main" id="{F558B609-96D2-64D6-90FA-0E5CC64C37F5}"/>
+                <a16:creationId xmlns:a16="http://schemas.microsoft.com/office/drawing/2014/main" id="{52C45A04-B116-C084-606B-FF211B16A7C4}"/>
               </a:ext>
             </a:extLst>
           </p:cNvPr>
@@ -7052,7 +8149,7 @@
           <p:cNvPr id="10" name="Rechteck: abgerundete Ecken 9">
             <a:extLst>
               <a:ext uri="{FF2B5EF4-FFF2-40B4-BE49-F238E27FC236}">
-                <a16:creationId xmlns:a16="http://schemas.microsoft.com/office/drawing/2014/main" id="{78F73667-CF16-8B02-C300-3948EBCF9488}"/>
+                <a16:creationId xmlns:a16="http://schemas.microsoft.com/office/drawing/2014/main" id="{1DE2D5D5-61FE-8D63-CE3D-3F22BAB6E5F5}"/>
               </a:ext>
             </a:extLst>
           </p:cNvPr>
@@ -7136,7 +8233,7 @@
           <p:cNvPr id="11" name="Rechteck: abgerundete Ecken 10">
             <a:extLst>
               <a:ext uri="{FF2B5EF4-FFF2-40B4-BE49-F238E27FC236}">
-                <a16:creationId xmlns:a16="http://schemas.microsoft.com/office/drawing/2014/main" id="{AC1967C8-4D19-52B7-6866-5B372F49B21B}"/>
+                <a16:creationId xmlns:a16="http://schemas.microsoft.com/office/drawing/2014/main" id="{203FA1DB-0C8A-571E-87FA-6C20050BDC9F}"/>
               </a:ext>
             </a:extLst>
           </p:cNvPr>
@@ -7220,7 +8317,7 @@
           <p:cNvPr id="12" name="Rechteck: abgerundete Ecken 11">
             <a:extLst>
               <a:ext uri="{FF2B5EF4-FFF2-40B4-BE49-F238E27FC236}">
-                <a16:creationId xmlns:a16="http://schemas.microsoft.com/office/drawing/2014/main" id="{E820C3AB-D967-D107-6244-92FA27B2BCA2}"/>
+                <a16:creationId xmlns:a16="http://schemas.microsoft.com/office/drawing/2014/main" id="{A0E7108D-DA04-A725-4520-A90993258CED}"/>
               </a:ext>
             </a:extLst>
           </p:cNvPr>
@@ -7304,7 +8401,7 @@
           <p:cNvPr id="13" name="Rechteck: abgerundete Ecken 12">
             <a:extLst>
               <a:ext uri="{FF2B5EF4-FFF2-40B4-BE49-F238E27FC236}">
-                <a16:creationId xmlns:a16="http://schemas.microsoft.com/office/drawing/2014/main" id="{F3B89C9B-21D8-0F1C-1EE6-C4F521A1F8E1}"/>
+                <a16:creationId xmlns:a16="http://schemas.microsoft.com/office/drawing/2014/main" id="{C89A33DD-9952-2497-82D3-29CE96E03014}"/>
               </a:ext>
             </a:extLst>
           </p:cNvPr>
@@ -7388,7 +8485,7 @@
           <p:cNvPr id="14" name="Rechteck: abgerundete Ecken 13">
             <a:extLst>
               <a:ext uri="{FF2B5EF4-FFF2-40B4-BE49-F238E27FC236}">
-                <a16:creationId xmlns:a16="http://schemas.microsoft.com/office/drawing/2014/main" id="{95F23E23-0C7D-F94A-6ECC-2C2FAA65CB9C}"/>
+                <a16:creationId xmlns:a16="http://schemas.microsoft.com/office/drawing/2014/main" id="{F2E31027-232B-71B9-8A95-4781BE6F1A93}"/>
               </a:ext>
             </a:extLst>
           </p:cNvPr>
@@ -7472,7 +8569,7 @@
           <p:cNvPr id="15" name="Rechteck: abgerundete Ecken 14">
             <a:extLst>
               <a:ext uri="{FF2B5EF4-FFF2-40B4-BE49-F238E27FC236}">
-                <a16:creationId xmlns:a16="http://schemas.microsoft.com/office/drawing/2014/main" id="{DF9884FF-65F4-261C-5254-A25B59E670AE}"/>
+                <a16:creationId xmlns:a16="http://schemas.microsoft.com/office/drawing/2014/main" id="{9CB095B4-DFB1-C1F8-653E-005AA33C2DEC}"/>
               </a:ext>
             </a:extLst>
           </p:cNvPr>
@@ -7556,7 +8653,7 @@
           <p:cNvPr id="16" name="Rechteck: abgerundete Ecken 15">
             <a:extLst>
               <a:ext uri="{FF2B5EF4-FFF2-40B4-BE49-F238E27FC236}">
-                <a16:creationId xmlns:a16="http://schemas.microsoft.com/office/drawing/2014/main" id="{33B96013-FB92-0522-1ABC-109999571C66}"/>
+                <a16:creationId xmlns:a16="http://schemas.microsoft.com/office/drawing/2014/main" id="{ECF4276D-95C2-CE85-6050-C77163F9A354}"/>
               </a:ext>
             </a:extLst>
           </p:cNvPr>
@@ -7638,7 +8735,7 @@
     </p:spTree>
     <p:extLst>
       <p:ext uri="{BB962C8B-B14F-4D97-AF65-F5344CB8AC3E}">
-        <p14:creationId xmlns:p14="http://schemas.microsoft.com/office/powerpoint/2010/main" val="3575261642"/>
+        <p14:creationId xmlns:p14="http://schemas.microsoft.com/office/powerpoint/2010/main" val="612993826"/>
       </p:ext>
     </p:extLst>
   </p:cSld>

</xml_diff>

<commit_message>
3D: light rigs, materials, bottom bevels, contours, lines on bodies and z offsets
All 26 light rigs and 14 materials fitted to PowerPoint renderings: rigs as
Lambert/Phong light sets, materials as highlight strength, tint, edge fading
and sheen over threePt. The contour is a tube around the body's rims and
edges, partly covered by faces coming towards the eye; the shape's line is
part of the body (sides, bevel bands and back in its color). legacyWireframe
draws the mesh edges.

Co-Authored-By: Claude Opus 5.5 <noreply@anthropic.com>
</commit_message>
<xml_diff>
--- a/tests/corpus/pptx/generated/three-d.pptx
+++ b/tests/corpus/pptx/generated/three-d.pptx
@@ -12,6 +12,8 @@
     <p:sldId id="260" r:id="rId6"/>
     <p:sldId id="261" r:id="rId7"/>
     <p:sldId id="262" r:id="rId8"/>
+    <p:sldId id="263" r:id="rId9"/>
+    <p:sldId id="264" r:id="rId10"/>
   </p:sldIdLst>
   <p:sldSz cx="12192000" cy="6858000"/>
   <p:notesSz cx="6858000" cy="9144000"/>
@@ -135,7 +137,7 @@
           <p:cNvPr id="2" name="Titel 1">
             <a:extLst>
               <a:ext uri="{FF2B5EF4-FFF2-40B4-BE49-F238E27FC236}">
-                <a16:creationId xmlns:a16="http://schemas.microsoft.com/office/drawing/2014/main" id="{3086B9CB-5317-3D1E-B703-C53E153F8FD0}"/>
+                <a16:creationId xmlns:a16="http://schemas.microsoft.com/office/drawing/2014/main" id="{A132D864-7114-A28D-7C3C-E1EBA2499036}"/>
               </a:ext>
             </a:extLst>
           </p:cNvPr>
@@ -172,7 +174,7 @@
           <p:cNvPr id="3" name="Untertitel 2">
             <a:extLst>
               <a:ext uri="{FF2B5EF4-FFF2-40B4-BE49-F238E27FC236}">
-                <a16:creationId xmlns:a16="http://schemas.microsoft.com/office/drawing/2014/main" id="{7EFF0B3E-9321-D164-7B49-EF4F1D82691B}"/>
+                <a16:creationId xmlns:a16="http://schemas.microsoft.com/office/drawing/2014/main" id="{C202959B-EB72-C674-885A-6774136F5279}"/>
               </a:ext>
             </a:extLst>
           </p:cNvPr>
@@ -242,7 +244,7 @@
           <p:cNvPr id="4" name="Datumsplatzhalter 3">
             <a:extLst>
               <a:ext uri="{FF2B5EF4-FFF2-40B4-BE49-F238E27FC236}">
-                <a16:creationId xmlns:a16="http://schemas.microsoft.com/office/drawing/2014/main" id="{5A2C85ED-068B-43FF-515F-FD7DC5BE34AD}"/>
+                <a16:creationId xmlns:a16="http://schemas.microsoft.com/office/drawing/2014/main" id="{A7E4CCFB-8E83-C85D-A671-C2FA3B0033E5}"/>
               </a:ext>
             </a:extLst>
           </p:cNvPr>
@@ -258,7 +260,7 @@
           <a:bodyPr/>
           <a:lstStyle/>
           <a:p>
-            <a:fld id="{8DFF278A-23B3-4EF2-94AC-4635568519FC}" type="datetimeFigureOut">
+            <a:fld id="{F27B871D-E315-469F-BF57-7629DB4D7F4D}" type="datetimeFigureOut">
               <a:rPr lang="de-DE" smtClean="0"/>
               <a:t>08.10.2026</a:t>
             </a:fld>
@@ -271,7 +273,7 @@
           <p:cNvPr id="5" name="Fußzeilenplatzhalter 4">
             <a:extLst>
               <a:ext uri="{FF2B5EF4-FFF2-40B4-BE49-F238E27FC236}">
-                <a16:creationId xmlns:a16="http://schemas.microsoft.com/office/drawing/2014/main" id="{00FF9B0F-B59A-6F35-203C-F4AD10CBB079}"/>
+                <a16:creationId xmlns:a16="http://schemas.microsoft.com/office/drawing/2014/main" id="{A491B9A0-A8E0-C1C9-9723-DF9AA7929E52}"/>
               </a:ext>
             </a:extLst>
           </p:cNvPr>
@@ -296,7 +298,7 @@
           <p:cNvPr id="6" name="Foliennummernplatzhalter 5">
             <a:extLst>
               <a:ext uri="{FF2B5EF4-FFF2-40B4-BE49-F238E27FC236}">
-                <a16:creationId xmlns:a16="http://schemas.microsoft.com/office/drawing/2014/main" id="{E38BDAC6-C29A-3E73-6FD1-3C1C49B8E8A6}"/>
+                <a16:creationId xmlns:a16="http://schemas.microsoft.com/office/drawing/2014/main" id="{DC2BB56E-CBD8-7BE2-59D3-BF67C8FDEA44}"/>
               </a:ext>
             </a:extLst>
           </p:cNvPr>
@@ -312,7 +314,7 @@
           <a:bodyPr/>
           <a:lstStyle/>
           <a:p>
-            <a:fld id="{D1E4F72E-E169-431D-AEEC-457F8EDE78E5}" type="slidenum">
+            <a:fld id="{4384185C-CA1D-4D64-B747-FEE1A56E57CB}" type="slidenum">
               <a:rPr lang="de-DE" smtClean="0"/>
               <a:t>‹Nr.›</a:t>
             </a:fld>
@@ -323,7 +325,7 @@
     </p:spTree>
     <p:extLst>
       <p:ext uri="{BB962C8B-B14F-4D97-AF65-F5344CB8AC3E}">
-        <p14:creationId xmlns:p14="http://schemas.microsoft.com/office/powerpoint/2010/main" val="3470613746"/>
+        <p14:creationId xmlns:p14="http://schemas.microsoft.com/office/powerpoint/2010/main" val="2187965353"/>
       </p:ext>
     </p:extLst>
   </p:cSld>
@@ -355,7 +357,7 @@
           <p:cNvPr id="2" name="Titel 1">
             <a:extLst>
               <a:ext uri="{FF2B5EF4-FFF2-40B4-BE49-F238E27FC236}">
-                <a16:creationId xmlns:a16="http://schemas.microsoft.com/office/drawing/2014/main" id="{8E8FE892-9C35-15FF-AC27-3DCEA2E7DB3B}"/>
+                <a16:creationId xmlns:a16="http://schemas.microsoft.com/office/drawing/2014/main" id="{C9227B82-7016-A1FB-E0EC-A15F0C3BBF35}"/>
               </a:ext>
             </a:extLst>
           </p:cNvPr>
@@ -383,7 +385,7 @@
           <p:cNvPr id="3" name="Vertikaler Textplatzhalter 2">
             <a:extLst>
               <a:ext uri="{FF2B5EF4-FFF2-40B4-BE49-F238E27FC236}">
-                <a16:creationId xmlns:a16="http://schemas.microsoft.com/office/drawing/2014/main" id="{D6BF9F9E-DEC0-5EAB-776E-50B09613348B}"/>
+                <a16:creationId xmlns:a16="http://schemas.microsoft.com/office/drawing/2014/main" id="{DDC6730F-DC06-14B7-E75D-97A79477DD07}"/>
               </a:ext>
             </a:extLst>
           </p:cNvPr>
@@ -440,7 +442,7 @@
           <p:cNvPr id="4" name="Datumsplatzhalter 3">
             <a:extLst>
               <a:ext uri="{FF2B5EF4-FFF2-40B4-BE49-F238E27FC236}">
-                <a16:creationId xmlns:a16="http://schemas.microsoft.com/office/drawing/2014/main" id="{7980D30C-5F60-0C00-3876-B77A86681305}"/>
+                <a16:creationId xmlns:a16="http://schemas.microsoft.com/office/drawing/2014/main" id="{9AA9AA76-909B-D3D3-6D97-C25861293496}"/>
               </a:ext>
             </a:extLst>
           </p:cNvPr>
@@ -456,7 +458,7 @@
           <a:bodyPr/>
           <a:lstStyle/>
           <a:p>
-            <a:fld id="{8DFF278A-23B3-4EF2-94AC-4635568519FC}" type="datetimeFigureOut">
+            <a:fld id="{F27B871D-E315-469F-BF57-7629DB4D7F4D}" type="datetimeFigureOut">
               <a:rPr lang="de-DE" smtClean="0"/>
               <a:t>08.10.2026</a:t>
             </a:fld>
@@ -469,7 +471,7 @@
           <p:cNvPr id="5" name="Fußzeilenplatzhalter 4">
             <a:extLst>
               <a:ext uri="{FF2B5EF4-FFF2-40B4-BE49-F238E27FC236}">
-                <a16:creationId xmlns:a16="http://schemas.microsoft.com/office/drawing/2014/main" id="{117745B5-1633-2A0B-DA74-B7DD9DB128D0}"/>
+                <a16:creationId xmlns:a16="http://schemas.microsoft.com/office/drawing/2014/main" id="{9E495617-E85B-B122-026A-1B0F0DDA3872}"/>
               </a:ext>
             </a:extLst>
           </p:cNvPr>
@@ -494,7 +496,7 @@
           <p:cNvPr id="6" name="Foliennummernplatzhalter 5">
             <a:extLst>
               <a:ext uri="{FF2B5EF4-FFF2-40B4-BE49-F238E27FC236}">
-                <a16:creationId xmlns:a16="http://schemas.microsoft.com/office/drawing/2014/main" id="{1372A0A7-49BF-76C5-8C72-327954EAB859}"/>
+                <a16:creationId xmlns:a16="http://schemas.microsoft.com/office/drawing/2014/main" id="{423C2003-C4AF-AE71-24AC-BF85AFDC0653}"/>
               </a:ext>
             </a:extLst>
           </p:cNvPr>
@@ -510,7 +512,7 @@
           <a:bodyPr/>
           <a:lstStyle/>
           <a:p>
-            <a:fld id="{D1E4F72E-E169-431D-AEEC-457F8EDE78E5}" type="slidenum">
+            <a:fld id="{4384185C-CA1D-4D64-B747-FEE1A56E57CB}" type="slidenum">
               <a:rPr lang="de-DE" smtClean="0"/>
               <a:t>‹Nr.›</a:t>
             </a:fld>
@@ -521,7 +523,7 @@
     </p:spTree>
     <p:extLst>
       <p:ext uri="{BB962C8B-B14F-4D97-AF65-F5344CB8AC3E}">
-        <p14:creationId xmlns:p14="http://schemas.microsoft.com/office/powerpoint/2010/main" val="200738675"/>
+        <p14:creationId xmlns:p14="http://schemas.microsoft.com/office/powerpoint/2010/main" val="3970081019"/>
       </p:ext>
     </p:extLst>
   </p:cSld>
@@ -553,7 +555,7 @@
           <p:cNvPr id="2" name="Vertikaler Titel 1">
             <a:extLst>
               <a:ext uri="{FF2B5EF4-FFF2-40B4-BE49-F238E27FC236}">
-                <a16:creationId xmlns:a16="http://schemas.microsoft.com/office/drawing/2014/main" id="{8E3163E5-0C40-AB58-5118-B4FC5DAAA1EE}"/>
+                <a16:creationId xmlns:a16="http://schemas.microsoft.com/office/drawing/2014/main" id="{599B6405-2BAC-1B01-AEA6-EF8C9B9DCBFD}"/>
               </a:ext>
             </a:extLst>
           </p:cNvPr>
@@ -586,7 +588,7 @@
           <p:cNvPr id="3" name="Vertikaler Textplatzhalter 2">
             <a:extLst>
               <a:ext uri="{FF2B5EF4-FFF2-40B4-BE49-F238E27FC236}">
-                <a16:creationId xmlns:a16="http://schemas.microsoft.com/office/drawing/2014/main" id="{27044CD9-C976-51B6-45E3-5A1FAD08560E}"/>
+                <a16:creationId xmlns:a16="http://schemas.microsoft.com/office/drawing/2014/main" id="{82340C7D-16C1-624E-A915-2B0B7395984E}"/>
               </a:ext>
             </a:extLst>
           </p:cNvPr>
@@ -648,7 +650,7 @@
           <p:cNvPr id="4" name="Datumsplatzhalter 3">
             <a:extLst>
               <a:ext uri="{FF2B5EF4-FFF2-40B4-BE49-F238E27FC236}">
-                <a16:creationId xmlns:a16="http://schemas.microsoft.com/office/drawing/2014/main" id="{A89CF696-C947-ABFD-6382-7AC1539382A1}"/>
+                <a16:creationId xmlns:a16="http://schemas.microsoft.com/office/drawing/2014/main" id="{3734B373-1154-E13B-FE25-1814116329A4}"/>
               </a:ext>
             </a:extLst>
           </p:cNvPr>
@@ -664,7 +666,7 @@
           <a:bodyPr/>
           <a:lstStyle/>
           <a:p>
-            <a:fld id="{8DFF278A-23B3-4EF2-94AC-4635568519FC}" type="datetimeFigureOut">
+            <a:fld id="{F27B871D-E315-469F-BF57-7629DB4D7F4D}" type="datetimeFigureOut">
               <a:rPr lang="de-DE" smtClean="0"/>
               <a:t>08.10.2026</a:t>
             </a:fld>
@@ -677,7 +679,7 @@
           <p:cNvPr id="5" name="Fußzeilenplatzhalter 4">
             <a:extLst>
               <a:ext uri="{FF2B5EF4-FFF2-40B4-BE49-F238E27FC236}">
-                <a16:creationId xmlns:a16="http://schemas.microsoft.com/office/drawing/2014/main" id="{69D65BB5-D2FC-3887-1AB7-239842E9F529}"/>
+                <a16:creationId xmlns:a16="http://schemas.microsoft.com/office/drawing/2014/main" id="{A8DBE0EC-40AC-EE04-1605-EBE6DA695C6B}"/>
               </a:ext>
             </a:extLst>
           </p:cNvPr>
@@ -702,7 +704,7 @@
           <p:cNvPr id="6" name="Foliennummernplatzhalter 5">
             <a:extLst>
               <a:ext uri="{FF2B5EF4-FFF2-40B4-BE49-F238E27FC236}">
-                <a16:creationId xmlns:a16="http://schemas.microsoft.com/office/drawing/2014/main" id="{B418F604-C901-8EF7-135E-00991F1CD0AE}"/>
+                <a16:creationId xmlns:a16="http://schemas.microsoft.com/office/drawing/2014/main" id="{6C2DB883-10DE-BF35-CC8A-45624D65AEEC}"/>
               </a:ext>
             </a:extLst>
           </p:cNvPr>
@@ -718,7 +720,7 @@
           <a:bodyPr/>
           <a:lstStyle/>
           <a:p>
-            <a:fld id="{D1E4F72E-E169-431D-AEEC-457F8EDE78E5}" type="slidenum">
+            <a:fld id="{4384185C-CA1D-4D64-B747-FEE1A56E57CB}" type="slidenum">
               <a:rPr lang="de-DE" smtClean="0"/>
               <a:t>‹Nr.›</a:t>
             </a:fld>
@@ -729,7 +731,7 @@
     </p:spTree>
     <p:extLst>
       <p:ext uri="{BB962C8B-B14F-4D97-AF65-F5344CB8AC3E}">
-        <p14:creationId xmlns:p14="http://schemas.microsoft.com/office/powerpoint/2010/main" val="1900602023"/>
+        <p14:creationId xmlns:p14="http://schemas.microsoft.com/office/powerpoint/2010/main" val="2584112580"/>
       </p:ext>
     </p:extLst>
   </p:cSld>
@@ -761,7 +763,7 @@
           <p:cNvPr id="2" name="Titel 1">
             <a:extLst>
               <a:ext uri="{FF2B5EF4-FFF2-40B4-BE49-F238E27FC236}">
-                <a16:creationId xmlns:a16="http://schemas.microsoft.com/office/drawing/2014/main" id="{14254B91-D2BF-1E7B-E485-889A25AF9D0A}"/>
+                <a16:creationId xmlns:a16="http://schemas.microsoft.com/office/drawing/2014/main" id="{18A587EC-269E-0E98-E129-59FA86E957E3}"/>
               </a:ext>
             </a:extLst>
           </p:cNvPr>
@@ -789,7 +791,7 @@
           <p:cNvPr id="3" name="Inhaltsplatzhalter 2">
             <a:extLst>
               <a:ext uri="{FF2B5EF4-FFF2-40B4-BE49-F238E27FC236}">
-                <a16:creationId xmlns:a16="http://schemas.microsoft.com/office/drawing/2014/main" id="{5992DC21-1F09-B703-348D-2047BA52FDA5}"/>
+                <a16:creationId xmlns:a16="http://schemas.microsoft.com/office/drawing/2014/main" id="{2A0F2686-BF38-8688-8FA8-434CEFDD8D66}"/>
               </a:ext>
             </a:extLst>
           </p:cNvPr>
@@ -846,7 +848,7 @@
           <p:cNvPr id="4" name="Datumsplatzhalter 3">
             <a:extLst>
               <a:ext uri="{FF2B5EF4-FFF2-40B4-BE49-F238E27FC236}">
-                <a16:creationId xmlns:a16="http://schemas.microsoft.com/office/drawing/2014/main" id="{A158F9FA-A667-D3B4-EC96-A97DB1AA2880}"/>
+                <a16:creationId xmlns:a16="http://schemas.microsoft.com/office/drawing/2014/main" id="{DFA89D47-B370-CB81-5E65-7CACA4040512}"/>
               </a:ext>
             </a:extLst>
           </p:cNvPr>
@@ -862,7 +864,7 @@
           <a:bodyPr/>
           <a:lstStyle/>
           <a:p>
-            <a:fld id="{8DFF278A-23B3-4EF2-94AC-4635568519FC}" type="datetimeFigureOut">
+            <a:fld id="{F27B871D-E315-469F-BF57-7629DB4D7F4D}" type="datetimeFigureOut">
               <a:rPr lang="de-DE" smtClean="0"/>
               <a:t>08.10.2026</a:t>
             </a:fld>
@@ -875,7 +877,7 @@
           <p:cNvPr id="5" name="Fußzeilenplatzhalter 4">
             <a:extLst>
               <a:ext uri="{FF2B5EF4-FFF2-40B4-BE49-F238E27FC236}">
-                <a16:creationId xmlns:a16="http://schemas.microsoft.com/office/drawing/2014/main" id="{F87999E5-FB19-F3FB-4BAF-DB4D050441BD}"/>
+                <a16:creationId xmlns:a16="http://schemas.microsoft.com/office/drawing/2014/main" id="{38FA9A22-6B38-4A9B-1AEF-A1EC44E11C2C}"/>
               </a:ext>
             </a:extLst>
           </p:cNvPr>
@@ -900,7 +902,7 @@
           <p:cNvPr id="6" name="Foliennummernplatzhalter 5">
             <a:extLst>
               <a:ext uri="{FF2B5EF4-FFF2-40B4-BE49-F238E27FC236}">
-                <a16:creationId xmlns:a16="http://schemas.microsoft.com/office/drawing/2014/main" id="{2D66F9F2-943C-77FA-094C-56D214B57234}"/>
+                <a16:creationId xmlns:a16="http://schemas.microsoft.com/office/drawing/2014/main" id="{C81BB973-1D95-4C0A-CD88-3FBBD628CBE9}"/>
               </a:ext>
             </a:extLst>
           </p:cNvPr>
@@ -916,7 +918,7 @@
           <a:bodyPr/>
           <a:lstStyle/>
           <a:p>
-            <a:fld id="{D1E4F72E-E169-431D-AEEC-457F8EDE78E5}" type="slidenum">
+            <a:fld id="{4384185C-CA1D-4D64-B747-FEE1A56E57CB}" type="slidenum">
               <a:rPr lang="de-DE" smtClean="0"/>
               <a:t>‹Nr.›</a:t>
             </a:fld>
@@ -927,7 +929,7 @@
     </p:spTree>
     <p:extLst>
       <p:ext uri="{BB962C8B-B14F-4D97-AF65-F5344CB8AC3E}">
-        <p14:creationId xmlns:p14="http://schemas.microsoft.com/office/powerpoint/2010/main" val="314679000"/>
+        <p14:creationId xmlns:p14="http://schemas.microsoft.com/office/powerpoint/2010/main" val="3116036840"/>
       </p:ext>
     </p:extLst>
   </p:cSld>
@@ -959,7 +961,7 @@
           <p:cNvPr id="2" name="Titel 1">
             <a:extLst>
               <a:ext uri="{FF2B5EF4-FFF2-40B4-BE49-F238E27FC236}">
-                <a16:creationId xmlns:a16="http://schemas.microsoft.com/office/drawing/2014/main" id="{C225E834-BDA2-6C0A-9F0C-99A8FA26D823}"/>
+                <a16:creationId xmlns:a16="http://schemas.microsoft.com/office/drawing/2014/main" id="{80543DB6-1A80-7C81-6444-8F72C15AEFC2}"/>
               </a:ext>
             </a:extLst>
           </p:cNvPr>
@@ -996,7 +998,7 @@
           <p:cNvPr id="3" name="Textplatzhalter 2">
             <a:extLst>
               <a:ext uri="{FF2B5EF4-FFF2-40B4-BE49-F238E27FC236}">
-                <a16:creationId xmlns:a16="http://schemas.microsoft.com/office/drawing/2014/main" id="{92818C10-D25A-0482-12D5-09815E1B1EF0}"/>
+                <a16:creationId xmlns:a16="http://schemas.microsoft.com/office/drawing/2014/main" id="{7CE771E2-088E-1F0A-D99D-BF9F8F4523DE}"/>
               </a:ext>
             </a:extLst>
           </p:cNvPr>
@@ -1121,7 +1123,7 @@
           <p:cNvPr id="4" name="Datumsplatzhalter 3">
             <a:extLst>
               <a:ext uri="{FF2B5EF4-FFF2-40B4-BE49-F238E27FC236}">
-                <a16:creationId xmlns:a16="http://schemas.microsoft.com/office/drawing/2014/main" id="{E1624197-EAC6-DB4F-FB11-472F30088CCC}"/>
+                <a16:creationId xmlns:a16="http://schemas.microsoft.com/office/drawing/2014/main" id="{4B713D99-A374-7FC6-D8EC-0F307D668C9E}"/>
               </a:ext>
             </a:extLst>
           </p:cNvPr>
@@ -1137,7 +1139,7 @@
           <a:bodyPr/>
           <a:lstStyle/>
           <a:p>
-            <a:fld id="{8DFF278A-23B3-4EF2-94AC-4635568519FC}" type="datetimeFigureOut">
+            <a:fld id="{F27B871D-E315-469F-BF57-7629DB4D7F4D}" type="datetimeFigureOut">
               <a:rPr lang="de-DE" smtClean="0"/>
               <a:t>08.10.2026</a:t>
             </a:fld>
@@ -1150,7 +1152,7 @@
           <p:cNvPr id="5" name="Fußzeilenplatzhalter 4">
             <a:extLst>
               <a:ext uri="{FF2B5EF4-FFF2-40B4-BE49-F238E27FC236}">
-                <a16:creationId xmlns:a16="http://schemas.microsoft.com/office/drawing/2014/main" id="{A6C95215-26AF-EF8E-A6AD-90DAD768BDAC}"/>
+                <a16:creationId xmlns:a16="http://schemas.microsoft.com/office/drawing/2014/main" id="{BBA00B4C-D996-9C2C-26F3-F23CC3A1B11F}"/>
               </a:ext>
             </a:extLst>
           </p:cNvPr>
@@ -1175,7 +1177,7 @@
           <p:cNvPr id="6" name="Foliennummernplatzhalter 5">
             <a:extLst>
               <a:ext uri="{FF2B5EF4-FFF2-40B4-BE49-F238E27FC236}">
-                <a16:creationId xmlns:a16="http://schemas.microsoft.com/office/drawing/2014/main" id="{19494B76-2DA3-0FB4-2954-673F8D114282}"/>
+                <a16:creationId xmlns:a16="http://schemas.microsoft.com/office/drawing/2014/main" id="{83B00B77-0C43-2C5D-AFCC-FF1B67001B39}"/>
               </a:ext>
             </a:extLst>
           </p:cNvPr>
@@ -1191,7 +1193,7 @@
           <a:bodyPr/>
           <a:lstStyle/>
           <a:p>
-            <a:fld id="{D1E4F72E-E169-431D-AEEC-457F8EDE78E5}" type="slidenum">
+            <a:fld id="{4384185C-CA1D-4D64-B747-FEE1A56E57CB}" type="slidenum">
               <a:rPr lang="de-DE" smtClean="0"/>
               <a:t>‹Nr.›</a:t>
             </a:fld>
@@ -1202,7 +1204,7 @@
     </p:spTree>
     <p:extLst>
       <p:ext uri="{BB962C8B-B14F-4D97-AF65-F5344CB8AC3E}">
-        <p14:creationId xmlns:p14="http://schemas.microsoft.com/office/powerpoint/2010/main" val="1362218903"/>
+        <p14:creationId xmlns:p14="http://schemas.microsoft.com/office/powerpoint/2010/main" val="3210878781"/>
       </p:ext>
     </p:extLst>
   </p:cSld>
@@ -1234,7 +1236,7 @@
           <p:cNvPr id="2" name="Titel 1">
             <a:extLst>
               <a:ext uri="{FF2B5EF4-FFF2-40B4-BE49-F238E27FC236}">
-                <a16:creationId xmlns:a16="http://schemas.microsoft.com/office/drawing/2014/main" id="{5675038A-815D-758B-837B-EB0CD01C124A}"/>
+                <a16:creationId xmlns:a16="http://schemas.microsoft.com/office/drawing/2014/main" id="{D6F10CF9-5D62-997A-8C38-543F951F4C60}"/>
               </a:ext>
             </a:extLst>
           </p:cNvPr>
@@ -1262,7 +1264,7 @@
           <p:cNvPr id="3" name="Inhaltsplatzhalter 2">
             <a:extLst>
               <a:ext uri="{FF2B5EF4-FFF2-40B4-BE49-F238E27FC236}">
-                <a16:creationId xmlns:a16="http://schemas.microsoft.com/office/drawing/2014/main" id="{84511824-CB0D-6CBA-4531-5E7DCF6A6600}"/>
+                <a16:creationId xmlns:a16="http://schemas.microsoft.com/office/drawing/2014/main" id="{EA668153-DF90-70B7-EACF-6C75D75F46FB}"/>
               </a:ext>
             </a:extLst>
           </p:cNvPr>
@@ -1324,7 +1326,7 @@
           <p:cNvPr id="4" name="Inhaltsplatzhalter 3">
             <a:extLst>
               <a:ext uri="{FF2B5EF4-FFF2-40B4-BE49-F238E27FC236}">
-                <a16:creationId xmlns:a16="http://schemas.microsoft.com/office/drawing/2014/main" id="{EB312707-24A2-B1EE-DBAE-82B48FB66FAA}"/>
+                <a16:creationId xmlns:a16="http://schemas.microsoft.com/office/drawing/2014/main" id="{126AB400-226C-6FA4-97ED-50EABC00FB5B}"/>
               </a:ext>
             </a:extLst>
           </p:cNvPr>
@@ -1386,7 +1388,7 @@
           <p:cNvPr id="5" name="Datumsplatzhalter 4">
             <a:extLst>
               <a:ext uri="{FF2B5EF4-FFF2-40B4-BE49-F238E27FC236}">
-                <a16:creationId xmlns:a16="http://schemas.microsoft.com/office/drawing/2014/main" id="{47D0E83C-5710-08FA-EBDD-FDBB7364CB7D}"/>
+                <a16:creationId xmlns:a16="http://schemas.microsoft.com/office/drawing/2014/main" id="{E5C4E21D-59B4-A695-D6E1-A1EBEE262A72}"/>
               </a:ext>
             </a:extLst>
           </p:cNvPr>
@@ -1402,7 +1404,7 @@
           <a:bodyPr/>
           <a:lstStyle/>
           <a:p>
-            <a:fld id="{8DFF278A-23B3-4EF2-94AC-4635568519FC}" type="datetimeFigureOut">
+            <a:fld id="{F27B871D-E315-469F-BF57-7629DB4D7F4D}" type="datetimeFigureOut">
               <a:rPr lang="de-DE" smtClean="0"/>
               <a:t>08.10.2026</a:t>
             </a:fld>
@@ -1415,7 +1417,7 @@
           <p:cNvPr id="6" name="Fußzeilenplatzhalter 5">
             <a:extLst>
               <a:ext uri="{FF2B5EF4-FFF2-40B4-BE49-F238E27FC236}">
-                <a16:creationId xmlns:a16="http://schemas.microsoft.com/office/drawing/2014/main" id="{E769A96D-39D0-45F6-1138-05C4DBB38EFB}"/>
+                <a16:creationId xmlns:a16="http://schemas.microsoft.com/office/drawing/2014/main" id="{C534C3C9-4322-62DB-AE0C-7F6ABF6A77DD}"/>
               </a:ext>
             </a:extLst>
           </p:cNvPr>
@@ -1440,7 +1442,7 @@
           <p:cNvPr id="7" name="Foliennummernplatzhalter 6">
             <a:extLst>
               <a:ext uri="{FF2B5EF4-FFF2-40B4-BE49-F238E27FC236}">
-                <a16:creationId xmlns:a16="http://schemas.microsoft.com/office/drawing/2014/main" id="{8ACAD499-CB5E-FE26-D578-9E32837CD9D8}"/>
+                <a16:creationId xmlns:a16="http://schemas.microsoft.com/office/drawing/2014/main" id="{71A6434F-6C72-D9EB-9B9E-14EE8EE40E73}"/>
               </a:ext>
             </a:extLst>
           </p:cNvPr>
@@ -1456,7 +1458,7 @@
           <a:bodyPr/>
           <a:lstStyle/>
           <a:p>
-            <a:fld id="{D1E4F72E-E169-431D-AEEC-457F8EDE78E5}" type="slidenum">
+            <a:fld id="{4384185C-CA1D-4D64-B747-FEE1A56E57CB}" type="slidenum">
               <a:rPr lang="de-DE" smtClean="0"/>
               <a:t>‹Nr.›</a:t>
             </a:fld>
@@ -1467,7 +1469,7 @@
     </p:spTree>
     <p:extLst>
       <p:ext uri="{BB962C8B-B14F-4D97-AF65-F5344CB8AC3E}">
-        <p14:creationId xmlns:p14="http://schemas.microsoft.com/office/powerpoint/2010/main" val="4070955023"/>
+        <p14:creationId xmlns:p14="http://schemas.microsoft.com/office/powerpoint/2010/main" val="3991258416"/>
       </p:ext>
     </p:extLst>
   </p:cSld>
@@ -1499,7 +1501,7 @@
           <p:cNvPr id="2" name="Titel 1">
             <a:extLst>
               <a:ext uri="{FF2B5EF4-FFF2-40B4-BE49-F238E27FC236}">
-                <a16:creationId xmlns:a16="http://schemas.microsoft.com/office/drawing/2014/main" id="{E132F6D3-A9B2-231E-162E-46C258418E41}"/>
+                <a16:creationId xmlns:a16="http://schemas.microsoft.com/office/drawing/2014/main" id="{1575BA84-151B-0610-426F-24FFDBB1EEEE}"/>
               </a:ext>
             </a:extLst>
           </p:cNvPr>
@@ -1532,7 +1534,7 @@
           <p:cNvPr id="3" name="Textplatzhalter 2">
             <a:extLst>
               <a:ext uri="{FF2B5EF4-FFF2-40B4-BE49-F238E27FC236}">
-                <a16:creationId xmlns:a16="http://schemas.microsoft.com/office/drawing/2014/main" id="{B36BD773-2267-DBA0-A080-07558CEF796C}"/>
+                <a16:creationId xmlns:a16="http://schemas.microsoft.com/office/drawing/2014/main" id="{E78FCC7E-8C1D-E261-528F-748ADB26715F}"/>
               </a:ext>
             </a:extLst>
           </p:cNvPr>
@@ -1603,7 +1605,7 @@
           <p:cNvPr id="4" name="Inhaltsplatzhalter 3">
             <a:extLst>
               <a:ext uri="{FF2B5EF4-FFF2-40B4-BE49-F238E27FC236}">
-                <a16:creationId xmlns:a16="http://schemas.microsoft.com/office/drawing/2014/main" id="{D86F0ED9-4B6D-2E3B-56F8-1297705AC101}"/>
+                <a16:creationId xmlns:a16="http://schemas.microsoft.com/office/drawing/2014/main" id="{5300CACF-061C-C1F1-6ED6-70DE7414BBC8}"/>
               </a:ext>
             </a:extLst>
           </p:cNvPr>
@@ -1665,7 +1667,7 @@
           <p:cNvPr id="5" name="Textplatzhalter 4">
             <a:extLst>
               <a:ext uri="{FF2B5EF4-FFF2-40B4-BE49-F238E27FC236}">
-                <a16:creationId xmlns:a16="http://schemas.microsoft.com/office/drawing/2014/main" id="{C4F24B05-7374-859C-B8B5-EA4A9122EFBC}"/>
+                <a16:creationId xmlns:a16="http://schemas.microsoft.com/office/drawing/2014/main" id="{436C4C8E-E96B-912E-35CD-EF30C8C563D9}"/>
               </a:ext>
             </a:extLst>
           </p:cNvPr>
@@ -1736,7 +1738,7 @@
           <p:cNvPr id="6" name="Inhaltsplatzhalter 5">
             <a:extLst>
               <a:ext uri="{FF2B5EF4-FFF2-40B4-BE49-F238E27FC236}">
-                <a16:creationId xmlns:a16="http://schemas.microsoft.com/office/drawing/2014/main" id="{377FCF99-547C-0336-3B0B-882CEFD4AD72}"/>
+                <a16:creationId xmlns:a16="http://schemas.microsoft.com/office/drawing/2014/main" id="{1200B2B1-FA3B-2B08-93AD-BB2928A19899}"/>
               </a:ext>
             </a:extLst>
           </p:cNvPr>
@@ -1798,7 +1800,7 @@
           <p:cNvPr id="7" name="Datumsplatzhalter 6">
             <a:extLst>
               <a:ext uri="{FF2B5EF4-FFF2-40B4-BE49-F238E27FC236}">
-                <a16:creationId xmlns:a16="http://schemas.microsoft.com/office/drawing/2014/main" id="{3E2B265D-1556-BFFB-E285-A0E080A61C17}"/>
+                <a16:creationId xmlns:a16="http://schemas.microsoft.com/office/drawing/2014/main" id="{E54F4E43-D5E2-E281-9C91-50A439B54931}"/>
               </a:ext>
             </a:extLst>
           </p:cNvPr>
@@ -1814,7 +1816,7 @@
           <a:bodyPr/>
           <a:lstStyle/>
           <a:p>
-            <a:fld id="{8DFF278A-23B3-4EF2-94AC-4635568519FC}" type="datetimeFigureOut">
+            <a:fld id="{F27B871D-E315-469F-BF57-7629DB4D7F4D}" type="datetimeFigureOut">
               <a:rPr lang="de-DE" smtClean="0"/>
               <a:t>08.10.2026</a:t>
             </a:fld>
@@ -1827,7 +1829,7 @@
           <p:cNvPr id="8" name="Fußzeilenplatzhalter 7">
             <a:extLst>
               <a:ext uri="{FF2B5EF4-FFF2-40B4-BE49-F238E27FC236}">
-                <a16:creationId xmlns:a16="http://schemas.microsoft.com/office/drawing/2014/main" id="{773E05E1-6560-9A9B-F990-2700623EF258}"/>
+                <a16:creationId xmlns:a16="http://schemas.microsoft.com/office/drawing/2014/main" id="{CBA448B6-A855-802A-A323-DE926851A7FA}"/>
               </a:ext>
             </a:extLst>
           </p:cNvPr>
@@ -1852,7 +1854,7 @@
           <p:cNvPr id="9" name="Foliennummernplatzhalter 8">
             <a:extLst>
               <a:ext uri="{FF2B5EF4-FFF2-40B4-BE49-F238E27FC236}">
-                <a16:creationId xmlns:a16="http://schemas.microsoft.com/office/drawing/2014/main" id="{401632D5-AF3B-699E-1FE2-47FF8145CBAC}"/>
+                <a16:creationId xmlns:a16="http://schemas.microsoft.com/office/drawing/2014/main" id="{0FD203FD-B326-30D2-0DAD-5DDD32241CB2}"/>
               </a:ext>
             </a:extLst>
           </p:cNvPr>
@@ -1868,7 +1870,7 @@
           <a:bodyPr/>
           <a:lstStyle/>
           <a:p>
-            <a:fld id="{D1E4F72E-E169-431D-AEEC-457F8EDE78E5}" type="slidenum">
+            <a:fld id="{4384185C-CA1D-4D64-B747-FEE1A56E57CB}" type="slidenum">
               <a:rPr lang="de-DE" smtClean="0"/>
               <a:t>‹Nr.›</a:t>
             </a:fld>
@@ -1879,7 +1881,7 @@
     </p:spTree>
     <p:extLst>
       <p:ext uri="{BB962C8B-B14F-4D97-AF65-F5344CB8AC3E}">
-        <p14:creationId xmlns:p14="http://schemas.microsoft.com/office/powerpoint/2010/main" val="3262806170"/>
+        <p14:creationId xmlns:p14="http://schemas.microsoft.com/office/powerpoint/2010/main" val="1845825899"/>
       </p:ext>
     </p:extLst>
   </p:cSld>
@@ -1911,7 +1913,7 @@
           <p:cNvPr id="2" name="Titel 1">
             <a:extLst>
               <a:ext uri="{FF2B5EF4-FFF2-40B4-BE49-F238E27FC236}">
-                <a16:creationId xmlns:a16="http://schemas.microsoft.com/office/drawing/2014/main" id="{F05972D4-34B3-4854-4B89-BF8B8E699213}"/>
+                <a16:creationId xmlns:a16="http://schemas.microsoft.com/office/drawing/2014/main" id="{57B9A2BA-9B50-FDEB-4182-49D6E7120A95}"/>
               </a:ext>
             </a:extLst>
           </p:cNvPr>
@@ -1939,7 +1941,7 @@
           <p:cNvPr id="3" name="Datumsplatzhalter 2">
             <a:extLst>
               <a:ext uri="{FF2B5EF4-FFF2-40B4-BE49-F238E27FC236}">
-                <a16:creationId xmlns:a16="http://schemas.microsoft.com/office/drawing/2014/main" id="{D6D7CD4F-61CE-0102-8FCB-AF9F3B444497}"/>
+                <a16:creationId xmlns:a16="http://schemas.microsoft.com/office/drawing/2014/main" id="{A499734E-0542-DD01-FF3D-BB87498ACA15}"/>
               </a:ext>
             </a:extLst>
           </p:cNvPr>
@@ -1955,7 +1957,7 @@
           <a:bodyPr/>
           <a:lstStyle/>
           <a:p>
-            <a:fld id="{8DFF278A-23B3-4EF2-94AC-4635568519FC}" type="datetimeFigureOut">
+            <a:fld id="{F27B871D-E315-469F-BF57-7629DB4D7F4D}" type="datetimeFigureOut">
               <a:rPr lang="de-DE" smtClean="0"/>
               <a:t>08.10.2026</a:t>
             </a:fld>
@@ -1968,7 +1970,7 @@
           <p:cNvPr id="4" name="Fußzeilenplatzhalter 3">
             <a:extLst>
               <a:ext uri="{FF2B5EF4-FFF2-40B4-BE49-F238E27FC236}">
-                <a16:creationId xmlns:a16="http://schemas.microsoft.com/office/drawing/2014/main" id="{5CEC1C6E-A3AE-26DF-63D8-20E610DBC778}"/>
+                <a16:creationId xmlns:a16="http://schemas.microsoft.com/office/drawing/2014/main" id="{2CCF2ED4-7B38-60EB-FAA5-DF0D0F5FCDEF}"/>
               </a:ext>
             </a:extLst>
           </p:cNvPr>
@@ -1993,7 +1995,7 @@
           <p:cNvPr id="5" name="Foliennummernplatzhalter 4">
             <a:extLst>
               <a:ext uri="{FF2B5EF4-FFF2-40B4-BE49-F238E27FC236}">
-                <a16:creationId xmlns:a16="http://schemas.microsoft.com/office/drawing/2014/main" id="{DEABA8E4-552E-B378-5A8D-06C92DBE0EC1}"/>
+                <a16:creationId xmlns:a16="http://schemas.microsoft.com/office/drawing/2014/main" id="{BE120CFA-378B-06C9-FD00-9DE6D103E939}"/>
               </a:ext>
             </a:extLst>
           </p:cNvPr>
@@ -2009,7 +2011,7 @@
           <a:bodyPr/>
           <a:lstStyle/>
           <a:p>
-            <a:fld id="{D1E4F72E-E169-431D-AEEC-457F8EDE78E5}" type="slidenum">
+            <a:fld id="{4384185C-CA1D-4D64-B747-FEE1A56E57CB}" type="slidenum">
               <a:rPr lang="de-DE" smtClean="0"/>
               <a:t>‹Nr.›</a:t>
             </a:fld>
@@ -2020,7 +2022,7 @@
     </p:spTree>
     <p:extLst>
       <p:ext uri="{BB962C8B-B14F-4D97-AF65-F5344CB8AC3E}">
-        <p14:creationId xmlns:p14="http://schemas.microsoft.com/office/powerpoint/2010/main" val="2404765367"/>
+        <p14:creationId xmlns:p14="http://schemas.microsoft.com/office/powerpoint/2010/main" val="2165758644"/>
       </p:ext>
     </p:extLst>
   </p:cSld>
@@ -2052,7 +2054,7 @@
           <p:cNvPr id="2" name="Datumsplatzhalter 1">
             <a:extLst>
               <a:ext uri="{FF2B5EF4-FFF2-40B4-BE49-F238E27FC236}">
-                <a16:creationId xmlns:a16="http://schemas.microsoft.com/office/drawing/2014/main" id="{22A26B68-39AC-8BD2-3F4B-DC9EEB2DD255}"/>
+                <a16:creationId xmlns:a16="http://schemas.microsoft.com/office/drawing/2014/main" id="{E9467512-21EA-F3B2-5520-0D2F502FBA58}"/>
               </a:ext>
             </a:extLst>
           </p:cNvPr>
@@ -2068,7 +2070,7 @@
           <a:bodyPr/>
           <a:lstStyle/>
           <a:p>
-            <a:fld id="{8DFF278A-23B3-4EF2-94AC-4635568519FC}" type="datetimeFigureOut">
+            <a:fld id="{F27B871D-E315-469F-BF57-7629DB4D7F4D}" type="datetimeFigureOut">
               <a:rPr lang="de-DE" smtClean="0"/>
               <a:t>08.10.2026</a:t>
             </a:fld>
@@ -2081,7 +2083,7 @@
           <p:cNvPr id="3" name="Fußzeilenplatzhalter 2">
             <a:extLst>
               <a:ext uri="{FF2B5EF4-FFF2-40B4-BE49-F238E27FC236}">
-                <a16:creationId xmlns:a16="http://schemas.microsoft.com/office/drawing/2014/main" id="{3434D626-D30E-C8D2-4B4D-0313E042238C}"/>
+                <a16:creationId xmlns:a16="http://schemas.microsoft.com/office/drawing/2014/main" id="{222A0A02-EE3E-8076-D79A-B5554CF5DD07}"/>
               </a:ext>
             </a:extLst>
           </p:cNvPr>
@@ -2106,7 +2108,7 @@
           <p:cNvPr id="4" name="Foliennummernplatzhalter 3">
             <a:extLst>
               <a:ext uri="{FF2B5EF4-FFF2-40B4-BE49-F238E27FC236}">
-                <a16:creationId xmlns:a16="http://schemas.microsoft.com/office/drawing/2014/main" id="{1A80D56D-AC21-6F32-F055-8752721641F7}"/>
+                <a16:creationId xmlns:a16="http://schemas.microsoft.com/office/drawing/2014/main" id="{73AC7FE9-FA55-ABA3-CE4F-DAD689B890B4}"/>
               </a:ext>
             </a:extLst>
           </p:cNvPr>
@@ -2122,7 +2124,7 @@
           <a:bodyPr/>
           <a:lstStyle/>
           <a:p>
-            <a:fld id="{D1E4F72E-E169-431D-AEEC-457F8EDE78E5}" type="slidenum">
+            <a:fld id="{4384185C-CA1D-4D64-B747-FEE1A56E57CB}" type="slidenum">
               <a:rPr lang="de-DE" smtClean="0"/>
               <a:t>‹Nr.›</a:t>
             </a:fld>
@@ -2133,7 +2135,7 @@
     </p:spTree>
     <p:extLst>
       <p:ext uri="{BB962C8B-B14F-4D97-AF65-F5344CB8AC3E}">
-        <p14:creationId xmlns:p14="http://schemas.microsoft.com/office/powerpoint/2010/main" val="2115116568"/>
+        <p14:creationId xmlns:p14="http://schemas.microsoft.com/office/powerpoint/2010/main" val="2863925227"/>
       </p:ext>
     </p:extLst>
   </p:cSld>
@@ -2165,7 +2167,7 @@
           <p:cNvPr id="2" name="Titel 1">
             <a:extLst>
               <a:ext uri="{FF2B5EF4-FFF2-40B4-BE49-F238E27FC236}">
-                <a16:creationId xmlns:a16="http://schemas.microsoft.com/office/drawing/2014/main" id="{4567E834-48F7-1A7F-B8CC-10E91AD2560E}"/>
+                <a16:creationId xmlns:a16="http://schemas.microsoft.com/office/drawing/2014/main" id="{AC6B9428-9CE9-8DFE-A210-CA2DCC3E36EF}"/>
               </a:ext>
             </a:extLst>
           </p:cNvPr>
@@ -2202,7 +2204,7 @@
           <p:cNvPr id="3" name="Inhaltsplatzhalter 2">
             <a:extLst>
               <a:ext uri="{FF2B5EF4-FFF2-40B4-BE49-F238E27FC236}">
-                <a16:creationId xmlns:a16="http://schemas.microsoft.com/office/drawing/2014/main" id="{1896D357-F1E3-8070-7908-73309404A57E}"/>
+                <a16:creationId xmlns:a16="http://schemas.microsoft.com/office/drawing/2014/main" id="{AC5B6076-9E51-4C95-BB1C-C642AD36CCCE}"/>
               </a:ext>
             </a:extLst>
           </p:cNvPr>
@@ -2292,7 +2294,7 @@
           <p:cNvPr id="4" name="Textplatzhalter 3">
             <a:extLst>
               <a:ext uri="{FF2B5EF4-FFF2-40B4-BE49-F238E27FC236}">
-                <a16:creationId xmlns:a16="http://schemas.microsoft.com/office/drawing/2014/main" id="{0701D548-D564-F8C6-D78A-F5C932D00EF8}"/>
+                <a16:creationId xmlns:a16="http://schemas.microsoft.com/office/drawing/2014/main" id="{07F8BC55-EF9A-1C25-F377-C2893B40B7DA}"/>
               </a:ext>
             </a:extLst>
           </p:cNvPr>
@@ -2363,7 +2365,7 @@
           <p:cNvPr id="5" name="Datumsplatzhalter 4">
             <a:extLst>
               <a:ext uri="{FF2B5EF4-FFF2-40B4-BE49-F238E27FC236}">
-                <a16:creationId xmlns:a16="http://schemas.microsoft.com/office/drawing/2014/main" id="{28376DDF-0E5F-75A5-CD9D-95AEB7D21D49}"/>
+                <a16:creationId xmlns:a16="http://schemas.microsoft.com/office/drawing/2014/main" id="{8A2AF94D-1ECC-E76F-EADA-F55E8AD76865}"/>
               </a:ext>
             </a:extLst>
           </p:cNvPr>
@@ -2379,7 +2381,7 @@
           <a:bodyPr/>
           <a:lstStyle/>
           <a:p>
-            <a:fld id="{8DFF278A-23B3-4EF2-94AC-4635568519FC}" type="datetimeFigureOut">
+            <a:fld id="{F27B871D-E315-469F-BF57-7629DB4D7F4D}" type="datetimeFigureOut">
               <a:rPr lang="de-DE" smtClean="0"/>
               <a:t>08.10.2026</a:t>
             </a:fld>
@@ -2392,7 +2394,7 @@
           <p:cNvPr id="6" name="Fußzeilenplatzhalter 5">
             <a:extLst>
               <a:ext uri="{FF2B5EF4-FFF2-40B4-BE49-F238E27FC236}">
-                <a16:creationId xmlns:a16="http://schemas.microsoft.com/office/drawing/2014/main" id="{7172B23E-F8CE-9CE4-0F01-44AC5AB6ABE0}"/>
+                <a16:creationId xmlns:a16="http://schemas.microsoft.com/office/drawing/2014/main" id="{576F954B-52A6-4F9E-2772-75DB5189EA7A}"/>
               </a:ext>
             </a:extLst>
           </p:cNvPr>
@@ -2417,7 +2419,7 @@
           <p:cNvPr id="7" name="Foliennummernplatzhalter 6">
             <a:extLst>
               <a:ext uri="{FF2B5EF4-FFF2-40B4-BE49-F238E27FC236}">
-                <a16:creationId xmlns:a16="http://schemas.microsoft.com/office/drawing/2014/main" id="{E6472497-BBE0-0BBD-D6ED-DAA8279A6722}"/>
+                <a16:creationId xmlns:a16="http://schemas.microsoft.com/office/drawing/2014/main" id="{EAA0DB12-D714-7FF5-E1F0-1DE9CBF660F1}"/>
               </a:ext>
             </a:extLst>
           </p:cNvPr>
@@ -2433,7 +2435,7 @@
           <a:bodyPr/>
           <a:lstStyle/>
           <a:p>
-            <a:fld id="{D1E4F72E-E169-431D-AEEC-457F8EDE78E5}" type="slidenum">
+            <a:fld id="{4384185C-CA1D-4D64-B747-FEE1A56E57CB}" type="slidenum">
               <a:rPr lang="de-DE" smtClean="0"/>
               <a:t>‹Nr.›</a:t>
             </a:fld>
@@ -2444,7 +2446,7 @@
     </p:spTree>
     <p:extLst>
       <p:ext uri="{BB962C8B-B14F-4D97-AF65-F5344CB8AC3E}">
-        <p14:creationId xmlns:p14="http://schemas.microsoft.com/office/powerpoint/2010/main" val="670063054"/>
+        <p14:creationId xmlns:p14="http://schemas.microsoft.com/office/powerpoint/2010/main" val="4241391703"/>
       </p:ext>
     </p:extLst>
   </p:cSld>
@@ -2476,7 +2478,7 @@
           <p:cNvPr id="2" name="Titel 1">
             <a:extLst>
               <a:ext uri="{FF2B5EF4-FFF2-40B4-BE49-F238E27FC236}">
-                <a16:creationId xmlns:a16="http://schemas.microsoft.com/office/drawing/2014/main" id="{07B4917F-0277-0B0A-8A93-93E0F630B94C}"/>
+                <a16:creationId xmlns:a16="http://schemas.microsoft.com/office/drawing/2014/main" id="{F4524063-9A45-F19E-8DD2-F82814C2D5FC}"/>
               </a:ext>
             </a:extLst>
           </p:cNvPr>
@@ -2513,7 +2515,7 @@
           <p:cNvPr id="3" name="Bildplatzhalter 2">
             <a:extLst>
               <a:ext uri="{FF2B5EF4-FFF2-40B4-BE49-F238E27FC236}">
-                <a16:creationId xmlns:a16="http://schemas.microsoft.com/office/drawing/2014/main" id="{809F7F5E-45FB-90FD-BB46-96632C5993BF}"/>
+                <a16:creationId xmlns:a16="http://schemas.microsoft.com/office/drawing/2014/main" id="{05324348-40C6-18E5-F199-F9CCD3A8154F}"/>
               </a:ext>
             </a:extLst>
           </p:cNvPr>
@@ -2580,7 +2582,7 @@
           <p:cNvPr id="4" name="Textplatzhalter 3">
             <a:extLst>
               <a:ext uri="{FF2B5EF4-FFF2-40B4-BE49-F238E27FC236}">
-                <a16:creationId xmlns:a16="http://schemas.microsoft.com/office/drawing/2014/main" id="{D5BC07E6-57AF-2EDF-7AC3-7C427B52B9A7}"/>
+                <a16:creationId xmlns:a16="http://schemas.microsoft.com/office/drawing/2014/main" id="{365C1F6A-1A5B-ACB9-3EFE-39CFC338F6B4}"/>
               </a:ext>
             </a:extLst>
           </p:cNvPr>
@@ -2651,7 +2653,7 @@
           <p:cNvPr id="5" name="Datumsplatzhalter 4">
             <a:extLst>
               <a:ext uri="{FF2B5EF4-FFF2-40B4-BE49-F238E27FC236}">
-                <a16:creationId xmlns:a16="http://schemas.microsoft.com/office/drawing/2014/main" id="{885E8380-84DA-DD25-841E-AB24C7CAD658}"/>
+                <a16:creationId xmlns:a16="http://schemas.microsoft.com/office/drawing/2014/main" id="{53DB9755-5ED1-0ADE-F086-242DD7B996EF}"/>
               </a:ext>
             </a:extLst>
           </p:cNvPr>
@@ -2667,7 +2669,7 @@
           <a:bodyPr/>
           <a:lstStyle/>
           <a:p>
-            <a:fld id="{8DFF278A-23B3-4EF2-94AC-4635568519FC}" type="datetimeFigureOut">
+            <a:fld id="{F27B871D-E315-469F-BF57-7629DB4D7F4D}" type="datetimeFigureOut">
               <a:rPr lang="de-DE" smtClean="0"/>
               <a:t>08.10.2026</a:t>
             </a:fld>
@@ -2680,7 +2682,7 @@
           <p:cNvPr id="6" name="Fußzeilenplatzhalter 5">
             <a:extLst>
               <a:ext uri="{FF2B5EF4-FFF2-40B4-BE49-F238E27FC236}">
-                <a16:creationId xmlns:a16="http://schemas.microsoft.com/office/drawing/2014/main" id="{FFA7DECF-C0BE-7681-EDB3-FC6CA1AA45ED}"/>
+                <a16:creationId xmlns:a16="http://schemas.microsoft.com/office/drawing/2014/main" id="{1D63573D-6A38-13C9-B75E-877BF5CCF0C7}"/>
               </a:ext>
             </a:extLst>
           </p:cNvPr>
@@ -2705,7 +2707,7 @@
           <p:cNvPr id="7" name="Foliennummernplatzhalter 6">
             <a:extLst>
               <a:ext uri="{FF2B5EF4-FFF2-40B4-BE49-F238E27FC236}">
-                <a16:creationId xmlns:a16="http://schemas.microsoft.com/office/drawing/2014/main" id="{C3E81894-2A88-5EA8-B9E6-C5483FC7D629}"/>
+                <a16:creationId xmlns:a16="http://schemas.microsoft.com/office/drawing/2014/main" id="{DED6925B-72E9-63EF-F7D1-6CEA8AA97F1A}"/>
               </a:ext>
             </a:extLst>
           </p:cNvPr>
@@ -2721,7 +2723,7 @@
           <a:bodyPr/>
           <a:lstStyle/>
           <a:p>
-            <a:fld id="{D1E4F72E-E169-431D-AEEC-457F8EDE78E5}" type="slidenum">
+            <a:fld id="{4384185C-CA1D-4D64-B747-FEE1A56E57CB}" type="slidenum">
               <a:rPr lang="de-DE" smtClean="0"/>
               <a:t>‹Nr.›</a:t>
             </a:fld>
@@ -2732,7 +2734,7 @@
     </p:spTree>
     <p:extLst>
       <p:ext uri="{BB962C8B-B14F-4D97-AF65-F5344CB8AC3E}">
-        <p14:creationId xmlns:p14="http://schemas.microsoft.com/office/powerpoint/2010/main" val="4246152695"/>
+        <p14:creationId xmlns:p14="http://schemas.microsoft.com/office/powerpoint/2010/main" val="703854368"/>
       </p:ext>
     </p:extLst>
   </p:cSld>
@@ -2769,7 +2771,7 @@
           <p:cNvPr id="2" name="Titelplatzhalter 1">
             <a:extLst>
               <a:ext uri="{FF2B5EF4-FFF2-40B4-BE49-F238E27FC236}">
-                <a16:creationId xmlns:a16="http://schemas.microsoft.com/office/drawing/2014/main" id="{9CAA1ED3-A622-07E9-EA00-F289985EB313}"/>
+                <a16:creationId xmlns:a16="http://schemas.microsoft.com/office/drawing/2014/main" id="{36226261-8218-434A-24B9-BCA6922EF4D0}"/>
               </a:ext>
             </a:extLst>
           </p:cNvPr>
@@ -2807,7 +2809,7 @@
           <p:cNvPr id="3" name="Textplatzhalter 2">
             <a:extLst>
               <a:ext uri="{FF2B5EF4-FFF2-40B4-BE49-F238E27FC236}">
-                <a16:creationId xmlns:a16="http://schemas.microsoft.com/office/drawing/2014/main" id="{6EE45821-64B1-2C34-EA7D-9F328F91EB72}"/>
+                <a16:creationId xmlns:a16="http://schemas.microsoft.com/office/drawing/2014/main" id="{2267F6FC-120E-60E3-8E79-AE74631C28F8}"/>
               </a:ext>
             </a:extLst>
           </p:cNvPr>
@@ -2874,7 +2876,7 @@
           <p:cNvPr id="4" name="Datumsplatzhalter 3">
             <a:extLst>
               <a:ext uri="{FF2B5EF4-FFF2-40B4-BE49-F238E27FC236}">
-                <a16:creationId xmlns:a16="http://schemas.microsoft.com/office/drawing/2014/main" id="{F6155319-E243-32CD-8EA4-480A1C18CBFB}"/>
+                <a16:creationId xmlns:a16="http://schemas.microsoft.com/office/drawing/2014/main" id="{92C6048B-69BA-7FC7-7EAB-01287EE9C156}"/>
               </a:ext>
             </a:extLst>
           </p:cNvPr>
@@ -2908,7 +2910,7 @@
             </a:lvl1pPr>
           </a:lstStyle>
           <a:p>
-            <a:fld id="{8DFF278A-23B3-4EF2-94AC-4635568519FC}" type="datetimeFigureOut">
+            <a:fld id="{F27B871D-E315-469F-BF57-7629DB4D7F4D}" type="datetimeFigureOut">
               <a:rPr lang="de-DE" smtClean="0"/>
               <a:t>08.10.2026</a:t>
             </a:fld>
@@ -2921,7 +2923,7 @@
           <p:cNvPr id="5" name="Fußzeilenplatzhalter 4">
             <a:extLst>
               <a:ext uri="{FF2B5EF4-FFF2-40B4-BE49-F238E27FC236}">
-                <a16:creationId xmlns:a16="http://schemas.microsoft.com/office/drawing/2014/main" id="{69941F30-2D74-BCA1-2753-8D6397EE6D12}"/>
+                <a16:creationId xmlns:a16="http://schemas.microsoft.com/office/drawing/2014/main" id="{77C99940-3E79-E518-6FEF-E2180B01366D}"/>
               </a:ext>
             </a:extLst>
           </p:cNvPr>
@@ -2964,7 +2966,7 @@
           <p:cNvPr id="6" name="Foliennummernplatzhalter 5">
             <a:extLst>
               <a:ext uri="{FF2B5EF4-FFF2-40B4-BE49-F238E27FC236}">
-                <a16:creationId xmlns:a16="http://schemas.microsoft.com/office/drawing/2014/main" id="{2B4D98F1-25EB-297C-88FA-2F0A518A2682}"/>
+                <a16:creationId xmlns:a16="http://schemas.microsoft.com/office/drawing/2014/main" id="{5C975AAC-ECAF-ECF3-71FF-C2DC61D87C12}"/>
               </a:ext>
             </a:extLst>
           </p:cNvPr>
@@ -2998,7 +3000,7 @@
             </a:lvl1pPr>
           </a:lstStyle>
           <a:p>
-            <a:fld id="{D1E4F72E-E169-431D-AEEC-457F8EDE78E5}" type="slidenum">
+            <a:fld id="{4384185C-CA1D-4D64-B747-FEE1A56E57CB}" type="slidenum">
               <a:rPr lang="de-DE" smtClean="0"/>
               <a:t>‹Nr.›</a:t>
             </a:fld>
@@ -3009,7 +3011,7 @@
     </p:spTree>
     <p:extLst>
       <p:ext uri="{BB962C8B-B14F-4D97-AF65-F5344CB8AC3E}">
-        <p14:creationId xmlns:p14="http://schemas.microsoft.com/office/powerpoint/2010/main" val="3544171342"/>
+        <p14:creationId xmlns:p14="http://schemas.microsoft.com/office/powerpoint/2010/main" val="1149621710"/>
       </p:ext>
     </p:extLst>
   </p:cSld>
@@ -3332,7 +3334,7 @@
           <p:cNvPr id="2" name="Rechteck 1">
             <a:extLst>
               <a:ext uri="{FF2B5EF4-FFF2-40B4-BE49-F238E27FC236}">
-                <a16:creationId xmlns:a16="http://schemas.microsoft.com/office/drawing/2014/main" id="{7CC3BA7B-96F6-45E0-7899-485039C7147D}"/>
+                <a16:creationId xmlns:a16="http://schemas.microsoft.com/office/drawing/2014/main" id="{5232595D-5EB0-0482-78BF-7035316C1C62}"/>
               </a:ext>
             </a:extLst>
           </p:cNvPr>
@@ -3413,7 +3415,7 @@
           <p:cNvPr id="3" name="Rechteck 2">
             <a:extLst>
               <a:ext uri="{FF2B5EF4-FFF2-40B4-BE49-F238E27FC236}">
-                <a16:creationId xmlns:a16="http://schemas.microsoft.com/office/drawing/2014/main" id="{23AFD8B1-4AAF-D8CD-F348-72FA3198A736}"/>
+                <a16:creationId xmlns:a16="http://schemas.microsoft.com/office/drawing/2014/main" id="{70C7600A-5DAA-9E56-1483-41F019AC1E15}"/>
               </a:ext>
             </a:extLst>
           </p:cNvPr>
@@ -3494,7 +3496,7 @@
           <p:cNvPr id="4" name="Rechteck 3">
             <a:extLst>
               <a:ext uri="{FF2B5EF4-FFF2-40B4-BE49-F238E27FC236}">
-                <a16:creationId xmlns:a16="http://schemas.microsoft.com/office/drawing/2014/main" id="{6E82F843-819E-D12A-F23D-5300FDB72E95}"/>
+                <a16:creationId xmlns:a16="http://schemas.microsoft.com/office/drawing/2014/main" id="{54708EC2-3157-C2C7-719A-ACCA2D090418}"/>
               </a:ext>
             </a:extLst>
           </p:cNvPr>
@@ -3575,7 +3577,7 @@
           <p:cNvPr id="5" name="Rechteck 4">
             <a:extLst>
               <a:ext uri="{FF2B5EF4-FFF2-40B4-BE49-F238E27FC236}">
-                <a16:creationId xmlns:a16="http://schemas.microsoft.com/office/drawing/2014/main" id="{1C76B11C-3CAB-463E-224F-2E679A0AD5C7}"/>
+                <a16:creationId xmlns:a16="http://schemas.microsoft.com/office/drawing/2014/main" id="{B3BC98BB-A8F4-BDF9-82CD-E50AEAD8BC2E}"/>
               </a:ext>
             </a:extLst>
           </p:cNvPr>
@@ -3656,7 +3658,7 @@
           <p:cNvPr id="6" name="Rechteck 5">
             <a:extLst>
               <a:ext uri="{FF2B5EF4-FFF2-40B4-BE49-F238E27FC236}">
-                <a16:creationId xmlns:a16="http://schemas.microsoft.com/office/drawing/2014/main" id="{2CE89A78-E8F3-54B9-6C90-109A30335544}"/>
+                <a16:creationId xmlns:a16="http://schemas.microsoft.com/office/drawing/2014/main" id="{0B2E5006-0765-8183-5969-C200D38BCA06}"/>
               </a:ext>
             </a:extLst>
           </p:cNvPr>
@@ -3737,7 +3739,7 @@
           <p:cNvPr id="7" name="Rechteck 6">
             <a:extLst>
               <a:ext uri="{FF2B5EF4-FFF2-40B4-BE49-F238E27FC236}">
-                <a16:creationId xmlns:a16="http://schemas.microsoft.com/office/drawing/2014/main" id="{EC998B28-F425-1569-B5AD-6A6CF1E4437E}"/>
+                <a16:creationId xmlns:a16="http://schemas.microsoft.com/office/drawing/2014/main" id="{2ED429F0-DADA-B6BC-D5B5-01ED54D146D5}"/>
               </a:ext>
             </a:extLst>
           </p:cNvPr>
@@ -3818,7 +3820,7 @@
           <p:cNvPr id="8" name="Rechteck 7">
             <a:extLst>
               <a:ext uri="{FF2B5EF4-FFF2-40B4-BE49-F238E27FC236}">
-                <a16:creationId xmlns:a16="http://schemas.microsoft.com/office/drawing/2014/main" id="{48008A35-CC38-6690-7CC7-927929BDFE36}"/>
+                <a16:creationId xmlns:a16="http://schemas.microsoft.com/office/drawing/2014/main" id="{5FAC55C7-9AE4-3161-15E7-CD1E1519B464}"/>
               </a:ext>
             </a:extLst>
           </p:cNvPr>
@@ -3897,7 +3899,7 @@
           <p:cNvPr id="9" name="Rechteck 8">
             <a:extLst>
               <a:ext uri="{FF2B5EF4-FFF2-40B4-BE49-F238E27FC236}">
-                <a16:creationId xmlns:a16="http://schemas.microsoft.com/office/drawing/2014/main" id="{AEB257E2-FFB8-705B-44C9-922A44F579D1}"/>
+                <a16:creationId xmlns:a16="http://schemas.microsoft.com/office/drawing/2014/main" id="{2FF6C4AE-7CD2-7DD6-FF44-05AFB050FEA7}"/>
               </a:ext>
             </a:extLst>
           </p:cNvPr>
@@ -3974,7 +3976,7 @@
     </p:spTree>
     <p:extLst>
       <p:ext uri="{BB962C8B-B14F-4D97-AF65-F5344CB8AC3E}">
-        <p14:creationId xmlns:p14="http://schemas.microsoft.com/office/powerpoint/2010/main" val="1095904850"/>
+        <p14:creationId xmlns:p14="http://schemas.microsoft.com/office/powerpoint/2010/main" val="3509321800"/>
       </p:ext>
     </p:extLst>
   </p:cSld>
@@ -4006,7 +4008,7 @@
           <p:cNvPr id="2" name="Rechteck 1">
             <a:extLst>
               <a:ext uri="{FF2B5EF4-FFF2-40B4-BE49-F238E27FC236}">
-                <a16:creationId xmlns:a16="http://schemas.microsoft.com/office/drawing/2014/main" id="{42F92B3B-EE68-6AFB-5517-03A6F03B5549}"/>
+                <a16:creationId xmlns:a16="http://schemas.microsoft.com/office/drawing/2014/main" id="{488F83C2-8A05-E7AE-0623-8D09EA3C90B4}"/>
               </a:ext>
             </a:extLst>
           </p:cNvPr>
@@ -4086,7 +4088,7 @@
           <p:cNvPr id="3" name="Ellipse 2">
             <a:extLst>
               <a:ext uri="{FF2B5EF4-FFF2-40B4-BE49-F238E27FC236}">
-                <a16:creationId xmlns:a16="http://schemas.microsoft.com/office/drawing/2014/main" id="{E93CF789-EB9D-C743-E1B7-348D1588BBBD}"/>
+                <a16:creationId xmlns:a16="http://schemas.microsoft.com/office/drawing/2014/main" id="{7369ADAF-2BDC-2C28-4903-AA536C8E0E13}"/>
               </a:ext>
             </a:extLst>
           </p:cNvPr>
@@ -4166,7 +4168,7 @@
           <p:cNvPr id="4" name="Stern: 5 Zacken 3">
             <a:extLst>
               <a:ext uri="{FF2B5EF4-FFF2-40B4-BE49-F238E27FC236}">
-                <a16:creationId xmlns:a16="http://schemas.microsoft.com/office/drawing/2014/main" id="{9D2919F1-4466-C423-5FCF-269A9D9970DD}"/>
+                <a16:creationId xmlns:a16="http://schemas.microsoft.com/office/drawing/2014/main" id="{0433DF84-D397-5F82-B194-350B79F60545}"/>
               </a:ext>
             </a:extLst>
           </p:cNvPr>
@@ -4246,7 +4248,7 @@
           <p:cNvPr id="5" name="Sechseck 4">
             <a:extLst>
               <a:ext uri="{FF2B5EF4-FFF2-40B4-BE49-F238E27FC236}">
-                <a16:creationId xmlns:a16="http://schemas.microsoft.com/office/drawing/2014/main" id="{69D325A6-1DF8-0864-9B0E-46325A2E1ABE}"/>
+                <a16:creationId xmlns:a16="http://schemas.microsoft.com/office/drawing/2014/main" id="{0485CB82-C31E-BC79-9809-B19A365C2B9B}"/>
               </a:ext>
             </a:extLst>
           </p:cNvPr>
@@ -4326,7 +4328,7 @@
           <p:cNvPr id="6" name="Rechteck 5">
             <a:extLst>
               <a:ext uri="{FF2B5EF4-FFF2-40B4-BE49-F238E27FC236}">
-                <a16:creationId xmlns:a16="http://schemas.microsoft.com/office/drawing/2014/main" id="{01A5939A-D2B4-0B81-D531-92340B82D153}"/>
+                <a16:creationId xmlns:a16="http://schemas.microsoft.com/office/drawing/2014/main" id="{7F0E3521-FC46-BED3-D7ED-492BDA5F7C00}"/>
               </a:ext>
             </a:extLst>
           </p:cNvPr>
@@ -4406,7 +4408,7 @@
           <p:cNvPr id="7" name="Rechteck: abgerundete Ecken 6">
             <a:extLst>
               <a:ext uri="{FF2B5EF4-FFF2-40B4-BE49-F238E27FC236}">
-                <a16:creationId xmlns:a16="http://schemas.microsoft.com/office/drawing/2014/main" id="{407F9401-1293-DE63-6175-D044F312A6B4}"/>
+                <a16:creationId xmlns:a16="http://schemas.microsoft.com/office/drawing/2014/main" id="{C0CE6206-2444-E823-90AA-CE51AE298649}"/>
               </a:ext>
             </a:extLst>
           </p:cNvPr>
@@ -4486,7 +4488,7 @@
     </p:spTree>
     <p:extLst>
       <p:ext uri="{BB962C8B-B14F-4D97-AF65-F5344CB8AC3E}">
-        <p14:creationId xmlns:p14="http://schemas.microsoft.com/office/powerpoint/2010/main" val="936500150"/>
+        <p14:creationId xmlns:p14="http://schemas.microsoft.com/office/powerpoint/2010/main" val="1063233343"/>
       </p:ext>
     </p:extLst>
   </p:cSld>
@@ -4518,7 +4520,7 @@
           <p:cNvPr id="2" name="Rechteck 1">
             <a:extLst>
               <a:ext uri="{FF2B5EF4-FFF2-40B4-BE49-F238E27FC236}">
-                <a16:creationId xmlns:a16="http://schemas.microsoft.com/office/drawing/2014/main" id="{86A3B7E5-FBD6-FDDB-2DAA-4C3BE9AF480C}"/>
+                <a16:creationId xmlns:a16="http://schemas.microsoft.com/office/drawing/2014/main" id="{C1F09723-62BE-1DD0-F8D8-F9F7B3A7D16A}"/>
               </a:ext>
             </a:extLst>
           </p:cNvPr>
@@ -4600,7 +4602,7 @@
           <p:cNvPr id="3" name="Rechteck 2">
             <a:extLst>
               <a:ext uri="{FF2B5EF4-FFF2-40B4-BE49-F238E27FC236}">
-                <a16:creationId xmlns:a16="http://schemas.microsoft.com/office/drawing/2014/main" id="{A2BCEAB3-F867-D5D8-D02E-3C1FCE4C5458}"/>
+                <a16:creationId xmlns:a16="http://schemas.microsoft.com/office/drawing/2014/main" id="{9E2075B0-D0E8-A59B-0DAF-9ABBA1C27559}"/>
               </a:ext>
             </a:extLst>
           </p:cNvPr>
@@ -4682,7 +4684,7 @@
           <p:cNvPr id="4" name="Rechteck 3">
             <a:extLst>
               <a:ext uri="{FF2B5EF4-FFF2-40B4-BE49-F238E27FC236}">
-                <a16:creationId xmlns:a16="http://schemas.microsoft.com/office/drawing/2014/main" id="{BD837A13-2E58-59D4-12D5-FA6E16100DEB}"/>
+                <a16:creationId xmlns:a16="http://schemas.microsoft.com/office/drawing/2014/main" id="{CD8EF103-53B3-E023-313F-5B564F1C11E6}"/>
               </a:ext>
             </a:extLst>
           </p:cNvPr>
@@ -4764,7 +4766,7 @@
           <p:cNvPr id="5" name="Rechteck 4">
             <a:extLst>
               <a:ext uri="{FF2B5EF4-FFF2-40B4-BE49-F238E27FC236}">
-                <a16:creationId xmlns:a16="http://schemas.microsoft.com/office/drawing/2014/main" id="{1389D06D-CB70-C011-7A2F-5BC496CCEE07}"/>
+                <a16:creationId xmlns:a16="http://schemas.microsoft.com/office/drawing/2014/main" id="{D48856B2-2C51-D435-5A44-17DB3F4E4ADC}"/>
               </a:ext>
             </a:extLst>
           </p:cNvPr>
@@ -4846,7 +4848,7 @@
           <p:cNvPr id="6" name="Rechteck 5">
             <a:extLst>
               <a:ext uri="{FF2B5EF4-FFF2-40B4-BE49-F238E27FC236}">
-                <a16:creationId xmlns:a16="http://schemas.microsoft.com/office/drawing/2014/main" id="{C79AA25F-9D1F-1382-DBAD-869445084AB8}"/>
+                <a16:creationId xmlns:a16="http://schemas.microsoft.com/office/drawing/2014/main" id="{340A19EF-17F5-6603-7A9C-03AA95CEF7AE}"/>
               </a:ext>
             </a:extLst>
           </p:cNvPr>
@@ -4928,7 +4930,7 @@
           <p:cNvPr id="7" name="Rechteck 6">
             <a:extLst>
               <a:ext uri="{FF2B5EF4-FFF2-40B4-BE49-F238E27FC236}">
-                <a16:creationId xmlns:a16="http://schemas.microsoft.com/office/drawing/2014/main" id="{3362AC92-36D4-C9B5-F27F-34152E19E074}"/>
+                <a16:creationId xmlns:a16="http://schemas.microsoft.com/office/drawing/2014/main" id="{7449BCF9-A877-7CF7-C83E-2F2C3901CD1C}"/>
               </a:ext>
             </a:extLst>
           </p:cNvPr>
@@ -5010,7 +5012,7 @@
           <p:cNvPr id="8" name="Rechteck 7">
             <a:extLst>
               <a:ext uri="{FF2B5EF4-FFF2-40B4-BE49-F238E27FC236}">
-                <a16:creationId xmlns:a16="http://schemas.microsoft.com/office/drawing/2014/main" id="{0CC4E675-8304-17B2-784E-D07E33A9294F}"/>
+                <a16:creationId xmlns:a16="http://schemas.microsoft.com/office/drawing/2014/main" id="{5B16C07A-FA93-1719-21EB-7AE92CC75E60}"/>
               </a:ext>
             </a:extLst>
           </p:cNvPr>
@@ -5092,7 +5094,7 @@
           <p:cNvPr id="9" name="Rechteck 8">
             <a:extLst>
               <a:ext uri="{FF2B5EF4-FFF2-40B4-BE49-F238E27FC236}">
-                <a16:creationId xmlns:a16="http://schemas.microsoft.com/office/drawing/2014/main" id="{AD7A483E-4400-ECC8-64C3-BFE36944DAA8}"/>
+                <a16:creationId xmlns:a16="http://schemas.microsoft.com/office/drawing/2014/main" id="{CCCD913B-1888-32C5-C6A6-4B2264CD6B9B}"/>
               </a:ext>
             </a:extLst>
           </p:cNvPr>
@@ -5174,7 +5176,7 @@
           <p:cNvPr id="10" name="Rechteck 9">
             <a:extLst>
               <a:ext uri="{FF2B5EF4-FFF2-40B4-BE49-F238E27FC236}">
-                <a16:creationId xmlns:a16="http://schemas.microsoft.com/office/drawing/2014/main" id="{A312E6CF-9831-F1A3-704D-05D40B5DEA08}"/>
+                <a16:creationId xmlns:a16="http://schemas.microsoft.com/office/drawing/2014/main" id="{5EABEB3B-5A93-ED60-AA41-138CCCFA54D9}"/>
               </a:ext>
             </a:extLst>
           </p:cNvPr>
@@ -5256,7 +5258,7 @@
           <p:cNvPr id="11" name="Rechteck 10">
             <a:extLst>
               <a:ext uri="{FF2B5EF4-FFF2-40B4-BE49-F238E27FC236}">
-                <a16:creationId xmlns:a16="http://schemas.microsoft.com/office/drawing/2014/main" id="{71B52D26-1D6C-0E27-E1D8-B68828921599}"/>
+                <a16:creationId xmlns:a16="http://schemas.microsoft.com/office/drawing/2014/main" id="{3524196B-8D52-39C1-7414-CFDBCF573057}"/>
               </a:ext>
             </a:extLst>
           </p:cNvPr>
@@ -5338,7 +5340,7 @@
           <p:cNvPr id="12" name="Rechteck 11">
             <a:extLst>
               <a:ext uri="{FF2B5EF4-FFF2-40B4-BE49-F238E27FC236}">
-                <a16:creationId xmlns:a16="http://schemas.microsoft.com/office/drawing/2014/main" id="{833CC61A-6042-A0DB-D3FD-BE7248E34470}"/>
+                <a16:creationId xmlns:a16="http://schemas.microsoft.com/office/drawing/2014/main" id="{A4C3C907-D49A-3771-CBDB-160568255D59}"/>
               </a:ext>
             </a:extLst>
           </p:cNvPr>
@@ -5420,7 +5422,7 @@
           <p:cNvPr id="13" name="Rechteck 12">
             <a:extLst>
               <a:ext uri="{FF2B5EF4-FFF2-40B4-BE49-F238E27FC236}">
-                <a16:creationId xmlns:a16="http://schemas.microsoft.com/office/drawing/2014/main" id="{63467DEA-4BEF-454C-A948-14CCF98FBE1D}"/>
+                <a16:creationId xmlns:a16="http://schemas.microsoft.com/office/drawing/2014/main" id="{5B036758-997E-539B-A27B-B01D00DAF126}"/>
               </a:ext>
             </a:extLst>
           </p:cNvPr>
@@ -5500,7 +5502,7 @@
     </p:spTree>
     <p:extLst>
       <p:ext uri="{BB962C8B-B14F-4D97-AF65-F5344CB8AC3E}">
-        <p14:creationId xmlns:p14="http://schemas.microsoft.com/office/powerpoint/2010/main" val="1786974142"/>
+        <p14:creationId xmlns:p14="http://schemas.microsoft.com/office/powerpoint/2010/main" val="2006879415"/>
       </p:ext>
     </p:extLst>
   </p:cSld>
@@ -5532,7 +5534,7 @@
           <p:cNvPr id="2" name="Ellipse 1">
             <a:extLst>
               <a:ext uri="{FF2B5EF4-FFF2-40B4-BE49-F238E27FC236}">
-                <a16:creationId xmlns:a16="http://schemas.microsoft.com/office/drawing/2014/main" id="{C1A42206-B55B-473E-BEE8-0A4336E5C061}"/>
+                <a16:creationId xmlns:a16="http://schemas.microsoft.com/office/drawing/2014/main" id="{F3D3575D-67C7-2432-2EFF-55CD3DC5E656}"/>
               </a:ext>
             </a:extLst>
           </p:cNvPr>
@@ -5614,7 +5616,7 @@
           <p:cNvPr id="3" name="Rechteck: abgerundete Ecken 2">
             <a:extLst>
               <a:ext uri="{FF2B5EF4-FFF2-40B4-BE49-F238E27FC236}">
-                <a16:creationId xmlns:a16="http://schemas.microsoft.com/office/drawing/2014/main" id="{7996A9A6-BBE3-9994-B8CE-A06DA85147F7}"/>
+                <a16:creationId xmlns:a16="http://schemas.microsoft.com/office/drawing/2014/main" id="{FF979B3C-F762-ADDE-09BB-35AD9AEEF257}"/>
               </a:ext>
             </a:extLst>
           </p:cNvPr>
@@ -5696,7 +5698,7 @@
           <p:cNvPr id="4" name="Ellipse 3">
             <a:extLst>
               <a:ext uri="{FF2B5EF4-FFF2-40B4-BE49-F238E27FC236}">
-                <a16:creationId xmlns:a16="http://schemas.microsoft.com/office/drawing/2014/main" id="{0524099F-BC63-FC07-7A40-2AD1A27B6A9A}"/>
+                <a16:creationId xmlns:a16="http://schemas.microsoft.com/office/drawing/2014/main" id="{467E7370-C734-BF0F-46E7-C3371538048D}"/>
               </a:ext>
             </a:extLst>
           </p:cNvPr>
@@ -5778,7 +5780,7 @@
           <p:cNvPr id="5" name="Rechteck: abgerundete Ecken 4">
             <a:extLst>
               <a:ext uri="{FF2B5EF4-FFF2-40B4-BE49-F238E27FC236}">
-                <a16:creationId xmlns:a16="http://schemas.microsoft.com/office/drawing/2014/main" id="{A281F3EF-2DF2-34B3-3131-B29D0D2B1419}"/>
+                <a16:creationId xmlns:a16="http://schemas.microsoft.com/office/drawing/2014/main" id="{80EDEF26-EE08-D8C1-5A59-BC476B7C6CC4}"/>
               </a:ext>
             </a:extLst>
           </p:cNvPr>
@@ -5860,7 +5862,7 @@
           <p:cNvPr id="6" name="Ellipse 5">
             <a:extLst>
               <a:ext uri="{FF2B5EF4-FFF2-40B4-BE49-F238E27FC236}">
-                <a16:creationId xmlns:a16="http://schemas.microsoft.com/office/drawing/2014/main" id="{A79CDEFB-0E09-3E5F-A329-75657A71AB72}"/>
+                <a16:creationId xmlns:a16="http://schemas.microsoft.com/office/drawing/2014/main" id="{C3FEB6F7-EFC3-AC0F-B884-DC902F8A1A90}"/>
               </a:ext>
             </a:extLst>
           </p:cNvPr>
@@ -5942,7 +5944,7 @@
           <p:cNvPr id="7" name="Rechteck: abgerundete Ecken 6">
             <a:extLst>
               <a:ext uri="{FF2B5EF4-FFF2-40B4-BE49-F238E27FC236}">
-                <a16:creationId xmlns:a16="http://schemas.microsoft.com/office/drawing/2014/main" id="{05F0F22A-D008-FB79-D903-4BFE8D6C9653}"/>
+                <a16:creationId xmlns:a16="http://schemas.microsoft.com/office/drawing/2014/main" id="{0353028E-A747-025C-06D9-5B2F9EE47798}"/>
               </a:ext>
             </a:extLst>
           </p:cNvPr>
@@ -6024,7 +6026,7 @@
           <p:cNvPr id="8" name="Ellipse 7">
             <a:extLst>
               <a:ext uri="{FF2B5EF4-FFF2-40B4-BE49-F238E27FC236}">
-                <a16:creationId xmlns:a16="http://schemas.microsoft.com/office/drawing/2014/main" id="{59E29FDD-AB62-7236-7E14-9EE364B6939F}"/>
+                <a16:creationId xmlns:a16="http://schemas.microsoft.com/office/drawing/2014/main" id="{F7BDEEA9-1E65-C29C-9B38-B8027A1B2C2A}"/>
               </a:ext>
             </a:extLst>
           </p:cNvPr>
@@ -6106,7 +6108,7 @@
           <p:cNvPr id="9" name="Rechteck: abgerundete Ecken 8">
             <a:extLst>
               <a:ext uri="{FF2B5EF4-FFF2-40B4-BE49-F238E27FC236}">
-                <a16:creationId xmlns:a16="http://schemas.microsoft.com/office/drawing/2014/main" id="{DC6176E7-71A3-B4B5-93CE-CCEB1D99DFE5}"/>
+                <a16:creationId xmlns:a16="http://schemas.microsoft.com/office/drawing/2014/main" id="{3E9DDE44-5EF3-0272-189D-0D05872D9F6F}"/>
               </a:ext>
             </a:extLst>
           </p:cNvPr>
@@ -6188,7 +6190,7 @@
           <p:cNvPr id="10" name="Ellipse 9">
             <a:extLst>
               <a:ext uri="{FF2B5EF4-FFF2-40B4-BE49-F238E27FC236}">
-                <a16:creationId xmlns:a16="http://schemas.microsoft.com/office/drawing/2014/main" id="{8628E87E-2A2A-2953-36AF-7066334EB5B7}"/>
+                <a16:creationId xmlns:a16="http://schemas.microsoft.com/office/drawing/2014/main" id="{F19EC5E9-3886-1D05-510E-C37D4BC5CA44}"/>
               </a:ext>
             </a:extLst>
           </p:cNvPr>
@@ -6270,7 +6272,7 @@
           <p:cNvPr id="11" name="Rechteck: abgerundete Ecken 10">
             <a:extLst>
               <a:ext uri="{FF2B5EF4-FFF2-40B4-BE49-F238E27FC236}">
-                <a16:creationId xmlns:a16="http://schemas.microsoft.com/office/drawing/2014/main" id="{623FCB0E-DE19-3E5C-C51C-F2C1919157E5}"/>
+                <a16:creationId xmlns:a16="http://schemas.microsoft.com/office/drawing/2014/main" id="{24337DFA-68DE-CB93-EC0D-02846357DD9C}"/>
               </a:ext>
             </a:extLst>
           </p:cNvPr>
@@ -6350,7 +6352,7 @@
     </p:spTree>
     <p:extLst>
       <p:ext uri="{BB962C8B-B14F-4D97-AF65-F5344CB8AC3E}">
-        <p14:creationId xmlns:p14="http://schemas.microsoft.com/office/powerpoint/2010/main" val="1008262466"/>
+        <p14:creationId xmlns:p14="http://schemas.microsoft.com/office/powerpoint/2010/main" val="730369315"/>
       </p:ext>
     </p:extLst>
   </p:cSld>
@@ -6382,7 +6384,7 @@
           <p:cNvPr id="3" name="Grafik 2">
             <a:extLst>
               <a:ext uri="{FF2B5EF4-FFF2-40B4-BE49-F238E27FC236}">
-                <a16:creationId xmlns:a16="http://schemas.microsoft.com/office/drawing/2014/main" id="{DC27A9C9-A850-5375-E00E-3F6CBAE0824B}"/>
+                <a16:creationId xmlns:a16="http://schemas.microsoft.com/office/drawing/2014/main" id="{2E6FFE12-C14B-DAC5-E365-3786017226E0}"/>
               </a:ext>
             </a:extLst>
           </p:cNvPr>
@@ -6425,7 +6427,7 @@
           <p:cNvPr id="5" name="Grafik 4">
             <a:extLst>
               <a:ext uri="{FF2B5EF4-FFF2-40B4-BE49-F238E27FC236}">
-                <a16:creationId xmlns:a16="http://schemas.microsoft.com/office/drawing/2014/main" id="{D4D46807-6AAD-19F2-6A84-F3787DBFFDA8}"/>
+                <a16:creationId xmlns:a16="http://schemas.microsoft.com/office/drawing/2014/main" id="{B11FE111-6BDF-473A-BA6F-D88967D49072}"/>
               </a:ext>
             </a:extLst>
           </p:cNvPr>
@@ -6468,7 +6470,7 @@
           <p:cNvPr id="7" name="Grafik 6">
             <a:extLst>
               <a:ext uri="{FF2B5EF4-FFF2-40B4-BE49-F238E27FC236}">
-                <a16:creationId xmlns:a16="http://schemas.microsoft.com/office/drawing/2014/main" id="{4C1ADEFD-4A76-D3BB-BDA2-EDDB935413A6}"/>
+                <a16:creationId xmlns:a16="http://schemas.microsoft.com/office/drawing/2014/main" id="{3A7E25A6-CC56-5200-D81E-D6C21C7FFDF7}"/>
               </a:ext>
             </a:extLst>
           </p:cNvPr>
@@ -6511,7 +6513,7 @@
           <p:cNvPr id="8" name="Rechteck 7">
             <a:extLst>
               <a:ext uri="{FF2B5EF4-FFF2-40B4-BE49-F238E27FC236}">
-                <a16:creationId xmlns:a16="http://schemas.microsoft.com/office/drawing/2014/main" id="{FB30F7ED-7E6A-1147-6994-4242A5B0E67D}"/>
+                <a16:creationId xmlns:a16="http://schemas.microsoft.com/office/drawing/2014/main" id="{A1682089-9BB8-70BB-0815-996571129B0B}"/>
               </a:ext>
             </a:extLst>
           </p:cNvPr>
@@ -6589,7 +6591,7 @@
           <p:cNvPr id="9" name="Ellipse 8">
             <a:extLst>
               <a:ext uri="{FF2B5EF4-FFF2-40B4-BE49-F238E27FC236}">
-                <a16:creationId xmlns:a16="http://schemas.microsoft.com/office/drawing/2014/main" id="{61E1E75B-3A71-6284-CA38-90CF210232F3}"/>
+                <a16:creationId xmlns:a16="http://schemas.microsoft.com/office/drawing/2014/main" id="{CFC74A51-46D1-6543-8CA7-7E25D385EB6E}"/>
               </a:ext>
             </a:extLst>
           </p:cNvPr>
@@ -6667,7 +6669,7 @@
           <p:cNvPr id="10" name="Rechteck 9">
             <a:extLst>
               <a:ext uri="{FF2B5EF4-FFF2-40B4-BE49-F238E27FC236}">
-                <a16:creationId xmlns:a16="http://schemas.microsoft.com/office/drawing/2014/main" id="{963369C2-1719-A41F-E462-28DEAF237F59}"/>
+                <a16:creationId xmlns:a16="http://schemas.microsoft.com/office/drawing/2014/main" id="{60CADBA9-5D76-BF07-AEB8-A6A47CF61FD7}"/>
               </a:ext>
             </a:extLst>
           </p:cNvPr>
@@ -6743,7 +6745,7 @@
     </p:spTree>
     <p:extLst>
       <p:ext uri="{BB962C8B-B14F-4D97-AF65-F5344CB8AC3E}">
-        <p14:creationId xmlns:p14="http://schemas.microsoft.com/office/powerpoint/2010/main" val="2476825975"/>
+        <p14:creationId xmlns:p14="http://schemas.microsoft.com/office/powerpoint/2010/main" val="2467151238"/>
       </p:ext>
     </p:extLst>
   </p:cSld>
@@ -6775,7 +6777,7 @@
           <p:cNvPr id="2" name="Ellipse 1">
             <a:extLst>
               <a:ext uri="{FF2B5EF4-FFF2-40B4-BE49-F238E27FC236}">
-                <a16:creationId xmlns:a16="http://schemas.microsoft.com/office/drawing/2014/main" id="{7FB51541-3F7D-7AF6-A060-1F6ADFC998FF}"/>
+                <a16:creationId xmlns:a16="http://schemas.microsoft.com/office/drawing/2014/main" id="{FAFF818D-35C7-28CF-D742-795B5C5EF6A4}"/>
               </a:ext>
             </a:extLst>
           </p:cNvPr>
@@ -6859,7 +6861,7 @@
           <p:cNvPr id="3" name="Ellipse 2">
             <a:extLst>
               <a:ext uri="{FF2B5EF4-FFF2-40B4-BE49-F238E27FC236}">
-                <a16:creationId xmlns:a16="http://schemas.microsoft.com/office/drawing/2014/main" id="{BADEE460-1871-AB31-23A2-D4E6402249E4}"/>
+                <a16:creationId xmlns:a16="http://schemas.microsoft.com/office/drawing/2014/main" id="{5E189E8B-F10E-2DC9-972B-765075926D82}"/>
               </a:ext>
             </a:extLst>
           </p:cNvPr>
@@ -6943,7 +6945,7 @@
           <p:cNvPr id="4" name="Ellipse 3">
             <a:extLst>
               <a:ext uri="{FF2B5EF4-FFF2-40B4-BE49-F238E27FC236}">
-                <a16:creationId xmlns:a16="http://schemas.microsoft.com/office/drawing/2014/main" id="{13BEFD63-2ECD-99FB-F459-D0B2F8B90F71}"/>
+                <a16:creationId xmlns:a16="http://schemas.microsoft.com/office/drawing/2014/main" id="{730CE1F1-24C6-1A71-1001-D6CE458174CD}"/>
               </a:ext>
             </a:extLst>
           </p:cNvPr>
@@ -7027,7 +7029,7 @@
           <p:cNvPr id="5" name="Ellipse 4">
             <a:extLst>
               <a:ext uri="{FF2B5EF4-FFF2-40B4-BE49-F238E27FC236}">
-                <a16:creationId xmlns:a16="http://schemas.microsoft.com/office/drawing/2014/main" id="{1EBB32A1-9280-0AF5-1D02-A630E4348D92}"/>
+                <a16:creationId xmlns:a16="http://schemas.microsoft.com/office/drawing/2014/main" id="{3B404892-1CA4-12F9-01F4-96C715221166}"/>
               </a:ext>
             </a:extLst>
           </p:cNvPr>
@@ -7111,7 +7113,7 @@
           <p:cNvPr id="6" name="Ellipse 5">
             <a:extLst>
               <a:ext uri="{FF2B5EF4-FFF2-40B4-BE49-F238E27FC236}">
-                <a16:creationId xmlns:a16="http://schemas.microsoft.com/office/drawing/2014/main" id="{F0CF79B2-C2FA-C2ED-C8C1-9816DA40F552}"/>
+                <a16:creationId xmlns:a16="http://schemas.microsoft.com/office/drawing/2014/main" id="{D644E024-F42C-A91E-79CB-F35431539593}"/>
               </a:ext>
             </a:extLst>
           </p:cNvPr>
@@ -7195,7 +7197,7 @@
           <p:cNvPr id="7" name="Ellipse 6">
             <a:extLst>
               <a:ext uri="{FF2B5EF4-FFF2-40B4-BE49-F238E27FC236}">
-                <a16:creationId xmlns:a16="http://schemas.microsoft.com/office/drawing/2014/main" id="{FF28CB74-F322-0731-24D3-538C00FEF1FF}"/>
+                <a16:creationId xmlns:a16="http://schemas.microsoft.com/office/drawing/2014/main" id="{67E3423A-810B-49CE-040B-BEDA541673E2}"/>
               </a:ext>
             </a:extLst>
           </p:cNvPr>
@@ -7279,7 +7281,7 @@
           <p:cNvPr id="8" name="Ellipse 7">
             <a:extLst>
               <a:ext uri="{FF2B5EF4-FFF2-40B4-BE49-F238E27FC236}">
-                <a16:creationId xmlns:a16="http://schemas.microsoft.com/office/drawing/2014/main" id="{92D6AE70-F6D0-4091-70FD-AFE0BA9EC170}"/>
+                <a16:creationId xmlns:a16="http://schemas.microsoft.com/office/drawing/2014/main" id="{D50CF8DE-EBFB-527A-BCA4-CECBFAB2E087}"/>
               </a:ext>
             </a:extLst>
           </p:cNvPr>
@@ -7363,7 +7365,7 @@
           <p:cNvPr id="9" name="Ellipse 8">
             <a:extLst>
               <a:ext uri="{FF2B5EF4-FFF2-40B4-BE49-F238E27FC236}">
-                <a16:creationId xmlns:a16="http://schemas.microsoft.com/office/drawing/2014/main" id="{A74D6DC8-1E78-A335-0393-C64DD23DA392}"/>
+                <a16:creationId xmlns:a16="http://schemas.microsoft.com/office/drawing/2014/main" id="{19E7E531-0FC1-D4F0-A7A0-2F5E3C2FD398}"/>
               </a:ext>
             </a:extLst>
           </p:cNvPr>
@@ -7445,7 +7447,7 @@
     </p:spTree>
     <p:extLst>
       <p:ext uri="{BB962C8B-B14F-4D97-AF65-F5344CB8AC3E}">
-        <p14:creationId xmlns:p14="http://schemas.microsoft.com/office/powerpoint/2010/main" val="3143185988"/>
+        <p14:creationId xmlns:p14="http://schemas.microsoft.com/office/powerpoint/2010/main" val="1361675357"/>
       </p:ext>
     </p:extLst>
   </p:cSld>
@@ -7477,7 +7479,7 @@
           <p:cNvPr id="2" name="Rechteck: abgerundete Ecken 1">
             <a:extLst>
               <a:ext uri="{FF2B5EF4-FFF2-40B4-BE49-F238E27FC236}">
-                <a16:creationId xmlns:a16="http://schemas.microsoft.com/office/drawing/2014/main" id="{D73CD33D-4F32-90CB-4A1E-EA56BFE71237}"/>
+                <a16:creationId xmlns:a16="http://schemas.microsoft.com/office/drawing/2014/main" id="{66F373D0-53AA-4E53-520C-DA5648C7D7EB}"/>
               </a:ext>
             </a:extLst>
           </p:cNvPr>
@@ -7561,7 +7563,7 @@
           <p:cNvPr id="3" name="Rechteck: abgerundete Ecken 2">
             <a:extLst>
               <a:ext uri="{FF2B5EF4-FFF2-40B4-BE49-F238E27FC236}">
-                <a16:creationId xmlns:a16="http://schemas.microsoft.com/office/drawing/2014/main" id="{94778884-57DD-67E4-2D19-D38EC6D958F2}"/>
+                <a16:creationId xmlns:a16="http://schemas.microsoft.com/office/drawing/2014/main" id="{CDC23E9A-60FB-0200-AF5C-D36C3BAEADA4}"/>
               </a:ext>
             </a:extLst>
           </p:cNvPr>
@@ -7645,7 +7647,7 @@
           <p:cNvPr id="4" name="Rechteck: abgerundete Ecken 3">
             <a:extLst>
               <a:ext uri="{FF2B5EF4-FFF2-40B4-BE49-F238E27FC236}">
-                <a16:creationId xmlns:a16="http://schemas.microsoft.com/office/drawing/2014/main" id="{A9F72CC0-DAA0-7F9B-B527-E079C8ABBAD9}"/>
+                <a16:creationId xmlns:a16="http://schemas.microsoft.com/office/drawing/2014/main" id="{0C1B0A3E-4DD0-8587-3D5D-B7FB9FA0D8CA}"/>
               </a:ext>
             </a:extLst>
           </p:cNvPr>
@@ -7729,7 +7731,7 @@
           <p:cNvPr id="5" name="Rechteck: abgerundete Ecken 4">
             <a:extLst>
               <a:ext uri="{FF2B5EF4-FFF2-40B4-BE49-F238E27FC236}">
-                <a16:creationId xmlns:a16="http://schemas.microsoft.com/office/drawing/2014/main" id="{16C3D22F-C201-14BB-A991-5F8A9CDACD63}"/>
+                <a16:creationId xmlns:a16="http://schemas.microsoft.com/office/drawing/2014/main" id="{52A8E8EF-3EFC-1A3B-D817-0DB621076CC2}"/>
               </a:ext>
             </a:extLst>
           </p:cNvPr>
@@ -7813,7 +7815,7 @@
           <p:cNvPr id="6" name="Rechteck: abgerundete Ecken 5">
             <a:extLst>
               <a:ext uri="{FF2B5EF4-FFF2-40B4-BE49-F238E27FC236}">
-                <a16:creationId xmlns:a16="http://schemas.microsoft.com/office/drawing/2014/main" id="{A432F22F-AC2E-512D-2427-47B9FBE83173}"/>
+                <a16:creationId xmlns:a16="http://schemas.microsoft.com/office/drawing/2014/main" id="{E9062BC2-2693-665A-0BC1-6FF09E8EB501}"/>
               </a:ext>
             </a:extLst>
           </p:cNvPr>
@@ -7897,7 +7899,7 @@
           <p:cNvPr id="7" name="Rechteck: abgerundete Ecken 6">
             <a:extLst>
               <a:ext uri="{FF2B5EF4-FFF2-40B4-BE49-F238E27FC236}">
-                <a16:creationId xmlns:a16="http://schemas.microsoft.com/office/drawing/2014/main" id="{566C3052-490F-6778-F624-C46150D8D979}"/>
+                <a16:creationId xmlns:a16="http://schemas.microsoft.com/office/drawing/2014/main" id="{382F67E0-76F7-A6D9-BDAC-DAF0C3944646}"/>
               </a:ext>
             </a:extLst>
           </p:cNvPr>
@@ -7981,7 +7983,7 @@
           <p:cNvPr id="8" name="Rechteck: abgerundete Ecken 7">
             <a:extLst>
               <a:ext uri="{FF2B5EF4-FFF2-40B4-BE49-F238E27FC236}">
-                <a16:creationId xmlns:a16="http://schemas.microsoft.com/office/drawing/2014/main" id="{A6D23EA4-2014-5B70-3075-641F91D520A4}"/>
+                <a16:creationId xmlns:a16="http://schemas.microsoft.com/office/drawing/2014/main" id="{0EE460CF-7FC9-F3AE-3B2E-60FF1BE671CD}"/>
               </a:ext>
             </a:extLst>
           </p:cNvPr>
@@ -8065,7 +8067,7 @@
           <p:cNvPr id="9" name="Rechteck: abgerundete Ecken 8">
             <a:extLst>
               <a:ext uri="{FF2B5EF4-FFF2-40B4-BE49-F238E27FC236}">
-                <a16:creationId xmlns:a16="http://schemas.microsoft.com/office/drawing/2014/main" id="{52C45A04-B116-C084-606B-FF211B16A7C4}"/>
+                <a16:creationId xmlns:a16="http://schemas.microsoft.com/office/drawing/2014/main" id="{A09CE650-1B85-FC3D-B445-DBD158425E84}"/>
               </a:ext>
             </a:extLst>
           </p:cNvPr>
@@ -8149,7 +8151,7 @@
           <p:cNvPr id="10" name="Rechteck: abgerundete Ecken 9">
             <a:extLst>
               <a:ext uri="{FF2B5EF4-FFF2-40B4-BE49-F238E27FC236}">
-                <a16:creationId xmlns:a16="http://schemas.microsoft.com/office/drawing/2014/main" id="{1DE2D5D5-61FE-8D63-CE3D-3F22BAB6E5F5}"/>
+                <a16:creationId xmlns:a16="http://schemas.microsoft.com/office/drawing/2014/main" id="{6145ECC4-230A-F6DA-5465-7A62F641EEC0}"/>
               </a:ext>
             </a:extLst>
           </p:cNvPr>
@@ -8233,7 +8235,7 @@
           <p:cNvPr id="11" name="Rechteck: abgerundete Ecken 10">
             <a:extLst>
               <a:ext uri="{FF2B5EF4-FFF2-40B4-BE49-F238E27FC236}">
-                <a16:creationId xmlns:a16="http://schemas.microsoft.com/office/drawing/2014/main" id="{203FA1DB-0C8A-571E-87FA-6C20050BDC9F}"/>
+                <a16:creationId xmlns:a16="http://schemas.microsoft.com/office/drawing/2014/main" id="{3EEC64C9-BF9D-268B-BBDD-8DA4E9BBD19A}"/>
               </a:ext>
             </a:extLst>
           </p:cNvPr>
@@ -8317,7 +8319,7 @@
           <p:cNvPr id="12" name="Rechteck: abgerundete Ecken 11">
             <a:extLst>
               <a:ext uri="{FF2B5EF4-FFF2-40B4-BE49-F238E27FC236}">
-                <a16:creationId xmlns:a16="http://schemas.microsoft.com/office/drawing/2014/main" id="{A0E7108D-DA04-A725-4520-A90993258CED}"/>
+                <a16:creationId xmlns:a16="http://schemas.microsoft.com/office/drawing/2014/main" id="{91DDB35B-7B74-3734-A8E1-1713DEC7A67A}"/>
               </a:ext>
             </a:extLst>
           </p:cNvPr>
@@ -8401,7 +8403,7 @@
           <p:cNvPr id="13" name="Rechteck: abgerundete Ecken 12">
             <a:extLst>
               <a:ext uri="{FF2B5EF4-FFF2-40B4-BE49-F238E27FC236}">
-                <a16:creationId xmlns:a16="http://schemas.microsoft.com/office/drawing/2014/main" id="{C89A33DD-9952-2497-82D3-29CE96E03014}"/>
+                <a16:creationId xmlns:a16="http://schemas.microsoft.com/office/drawing/2014/main" id="{88096B02-FCDC-F000-515A-5A5EC89CBD0F}"/>
               </a:ext>
             </a:extLst>
           </p:cNvPr>
@@ -8485,7 +8487,7 @@
           <p:cNvPr id="14" name="Rechteck: abgerundete Ecken 13">
             <a:extLst>
               <a:ext uri="{FF2B5EF4-FFF2-40B4-BE49-F238E27FC236}">
-                <a16:creationId xmlns:a16="http://schemas.microsoft.com/office/drawing/2014/main" id="{F2E31027-232B-71B9-8A95-4781BE6F1A93}"/>
+                <a16:creationId xmlns:a16="http://schemas.microsoft.com/office/drawing/2014/main" id="{9B54D8D6-02A0-4A9C-4D22-1980A1E716B3}"/>
               </a:ext>
             </a:extLst>
           </p:cNvPr>
@@ -8569,7 +8571,7 @@
           <p:cNvPr id="15" name="Rechteck: abgerundete Ecken 14">
             <a:extLst>
               <a:ext uri="{FF2B5EF4-FFF2-40B4-BE49-F238E27FC236}">
-                <a16:creationId xmlns:a16="http://schemas.microsoft.com/office/drawing/2014/main" id="{9CB095B4-DFB1-C1F8-653E-005AA33C2DEC}"/>
+                <a16:creationId xmlns:a16="http://schemas.microsoft.com/office/drawing/2014/main" id="{A7F6C9F7-B8E7-CB12-C4BF-DDAABCE89C67}"/>
               </a:ext>
             </a:extLst>
           </p:cNvPr>
@@ -8653,7 +8655,7 @@
           <p:cNvPr id="16" name="Rechteck: abgerundete Ecken 15">
             <a:extLst>
               <a:ext uri="{FF2B5EF4-FFF2-40B4-BE49-F238E27FC236}">
-                <a16:creationId xmlns:a16="http://schemas.microsoft.com/office/drawing/2014/main" id="{ECF4276D-95C2-CE85-6050-C77163F9A354}"/>
+                <a16:creationId xmlns:a16="http://schemas.microsoft.com/office/drawing/2014/main" id="{D6BC0DA3-348E-7684-BD88-D30BF2570620}"/>
               </a:ext>
             </a:extLst>
           </p:cNvPr>
@@ -8735,7 +8737,1298 @@
     </p:spTree>
     <p:extLst>
       <p:ext uri="{BB962C8B-B14F-4D97-AF65-F5344CB8AC3E}">
-        <p14:creationId xmlns:p14="http://schemas.microsoft.com/office/powerpoint/2010/main" val="612993826"/>
+        <p14:creationId xmlns:p14="http://schemas.microsoft.com/office/powerpoint/2010/main" val="3118207982"/>
+      </p:ext>
+    </p:extLst>
+  </p:cSld>
+  <p:clrMapOvr>
+    <a:masterClrMapping/>
+  </p:clrMapOvr>
+</p:sld>
+</file>
+
+<file path=ppt/slides/slide8.xml><?xml version="1.0" encoding="utf-8"?>
+<p:sld xmlns:a="http://schemas.openxmlformats.org/drawingml/2006/main" xmlns:r="http://schemas.openxmlformats.org/officeDocument/2006/relationships" xmlns:p="http://schemas.openxmlformats.org/presentationml/2006/main">
+  <p:cSld>
+    <p:spTree>
+      <p:nvGrpSpPr>
+        <p:cNvPr id="1" name=""/>
+        <p:cNvGrpSpPr/>
+        <p:nvPr/>
+      </p:nvGrpSpPr>
+      <p:grpSpPr>
+        <a:xfrm>
+          <a:off x="0" y="0"/>
+          <a:ext cx="0" cy="0"/>
+          <a:chOff x="0" y="0"/>
+          <a:chExt cx="0" cy="0"/>
+        </a:xfrm>
+      </p:grpSpPr>
+      <p:sp>
+        <p:nvSpPr>
+          <p:cNvPr id="2" name="Rechteck 1">
+            <a:extLst>
+              <a:ext uri="{FF2B5EF4-FFF2-40B4-BE49-F238E27FC236}">
+                <a16:creationId xmlns:a16="http://schemas.microsoft.com/office/drawing/2014/main" id="{ACD19885-3820-89F0-352E-9C3CD34BB0BF}"/>
+              </a:ext>
+            </a:extLst>
+          </p:cNvPr>
+          <p:cNvSpPr/>
+          <p:nvPr/>
+        </p:nvSpPr>
+        <p:spPr>
+          <a:xfrm>
+            <a:off x="508000" y="762000"/>
+            <a:ext cx="2032000" cy="1397000"/>
+          </a:xfrm>
+          <a:prstGeom prst="rect">
+            <a:avLst/>
+          </a:prstGeom>
+          <a:solidFill>
+            <a:srgbClr val="4472C4"/>
+          </a:solidFill>
+          <a:ln w="19050" cap="flat" cmpd="sng" algn="ctr">
+            <a:noFill/>
+            <a:prstDash val="solid"/>
+            <a:miter lim="800000"/>
+          </a:ln>
+          <a:effectLst/>
+          <a:scene3d>
+            <a:camera prst="isometricLeftDown"/>
+            <a:lightRig rig="threePt" dir="t"/>
+          </a:scene3d>
+          <a:sp3d extrusionH="254000">
+            <a:bevelB w="152400" h="152400"/>
+          </a:sp3d>
+          <a:extLst>
+            <a:ext uri="{91240B29-F687-4F45-9708-019B960494DF}">
+              <a14:hiddenLine xmlns:a14="http://schemas.microsoft.com/office/drawing/2010/main" w="19050" cap="flat" cmpd="sng" algn="ctr">
+                <a:solidFill>
+                  <a:schemeClr val="accent1">
+                    <a:shade val="15000"/>
+                  </a:schemeClr>
+                </a:solidFill>
+                <a:prstDash val="solid"/>
+                <a:miter lim="800000"/>
+              </a14:hiddenLine>
+            </a:ext>
+          </a:extLst>
+        </p:spPr>
+        <p:style>
+          <a:lnRef idx="2">
+            <a:schemeClr val="accent1">
+              <a:shade val="15000"/>
+            </a:schemeClr>
+          </a:lnRef>
+          <a:fillRef idx="1">
+            <a:schemeClr val="accent1"/>
+          </a:fillRef>
+          <a:effectRef idx="0">
+            <a:schemeClr val="accent1"/>
+          </a:effectRef>
+          <a:fontRef idx="minor">
+            <a:schemeClr val="lt1"/>
+          </a:fontRef>
+        </p:style>
+        <p:txBody>
+          <a:bodyPr rtlCol="0" anchor="ctr"/>
+          <a:lstStyle/>
+          <a:p>
+            <a:pPr algn="ctr"/>
+            <a:endParaRPr lang="de-DE" sz="1600">
+              <a:solidFill>
+                <a:srgbClr val="FFFFFF"/>
+              </a:solidFill>
+            </a:endParaRPr>
+          </a:p>
+        </p:txBody>
+      </p:sp>
+      <p:sp>
+        <p:nvSpPr>
+          <p:cNvPr id="3" name="Rechteck 2">
+            <a:extLst>
+              <a:ext uri="{FF2B5EF4-FFF2-40B4-BE49-F238E27FC236}">
+                <a16:creationId xmlns:a16="http://schemas.microsoft.com/office/drawing/2014/main" id="{9662068D-3558-3311-4C50-17C62E036EDE}"/>
+              </a:ext>
+            </a:extLst>
+          </p:cNvPr>
+          <p:cNvSpPr/>
+          <p:nvPr/>
+        </p:nvSpPr>
+        <p:spPr>
+          <a:xfrm>
+            <a:off x="3492500" y="762000"/>
+            <a:ext cx="2032000" cy="1397000"/>
+          </a:xfrm>
+          <a:prstGeom prst="rect">
+            <a:avLst/>
+          </a:prstGeom>
+          <a:solidFill>
+            <a:srgbClr val="4472C4"/>
+          </a:solidFill>
+          <a:ln w="19050" cap="flat" cmpd="sng" algn="ctr">
+            <a:noFill/>
+            <a:prstDash val="solid"/>
+            <a:miter lim="800000"/>
+          </a:ln>
+          <a:effectLst/>
+          <a:scene3d>
+            <a:camera prst="isometricLeftDown"/>
+            <a:lightRig rig="threePt" dir="t"/>
+          </a:scene3d>
+          <a:sp3d extrusionH="254000">
+            <a:bevelT w="152400" h="152400"/>
+            <a:bevelB w="152400" h="152400" prst="angle"/>
+          </a:sp3d>
+          <a:extLst>
+            <a:ext uri="{91240B29-F687-4F45-9708-019B960494DF}">
+              <a14:hiddenLine xmlns:a14="http://schemas.microsoft.com/office/drawing/2010/main" w="19050" cap="flat" cmpd="sng" algn="ctr">
+                <a:solidFill>
+                  <a:schemeClr val="accent1">
+                    <a:shade val="15000"/>
+                  </a:schemeClr>
+                </a:solidFill>
+                <a:prstDash val="solid"/>
+                <a:miter lim="800000"/>
+              </a14:hiddenLine>
+            </a:ext>
+          </a:extLst>
+        </p:spPr>
+        <p:style>
+          <a:lnRef idx="2">
+            <a:schemeClr val="accent1">
+              <a:shade val="15000"/>
+            </a:schemeClr>
+          </a:lnRef>
+          <a:fillRef idx="1">
+            <a:schemeClr val="accent1"/>
+          </a:fillRef>
+          <a:effectRef idx="0">
+            <a:schemeClr val="accent1"/>
+          </a:effectRef>
+          <a:fontRef idx="minor">
+            <a:schemeClr val="lt1"/>
+          </a:fontRef>
+        </p:style>
+        <p:txBody>
+          <a:bodyPr rtlCol="0" anchor="ctr"/>
+          <a:lstStyle/>
+          <a:p>
+            <a:pPr algn="ctr"/>
+            <a:endParaRPr lang="de-DE" sz="1600">
+              <a:solidFill>
+                <a:srgbClr val="FFFFFF"/>
+              </a:solidFill>
+            </a:endParaRPr>
+          </a:p>
+        </p:txBody>
+      </p:sp>
+      <p:sp>
+        <p:nvSpPr>
+          <p:cNvPr id="4" name="Rechteck 3">
+            <a:extLst>
+              <a:ext uri="{FF2B5EF4-FFF2-40B4-BE49-F238E27FC236}">
+                <a16:creationId xmlns:a16="http://schemas.microsoft.com/office/drawing/2014/main" id="{A9AB5F10-D55A-065B-235C-50737CBECB09}"/>
+              </a:ext>
+            </a:extLst>
+          </p:cNvPr>
+          <p:cNvSpPr/>
+          <p:nvPr/>
+        </p:nvSpPr>
+        <p:spPr>
+          <a:xfrm>
+            <a:off x="6477000" y="762000"/>
+            <a:ext cx="2032000" cy="1397000"/>
+          </a:xfrm>
+          <a:prstGeom prst="rect">
+            <a:avLst/>
+          </a:prstGeom>
+          <a:solidFill>
+            <a:srgbClr val="4472C4"/>
+          </a:solidFill>
+          <a:ln w="19050" cap="flat" cmpd="sng" algn="ctr">
+            <a:noFill/>
+            <a:prstDash val="solid"/>
+            <a:miter lim="800000"/>
+          </a:ln>
+          <a:effectLst/>
+          <a:scene3d>
+            <a:camera prst="orthographicFront"/>
+            <a:lightRig rig="threePt" dir="t"/>
+          </a:scene3d>
+          <a:sp3d contourW="101600">
+            <a:contourClr>
+              <a:srgbClr val="FFC000"/>
+            </a:contourClr>
+          </a:sp3d>
+          <a:extLst>
+            <a:ext uri="{91240B29-F687-4F45-9708-019B960494DF}">
+              <a14:hiddenLine xmlns:a14="http://schemas.microsoft.com/office/drawing/2010/main" w="19050" cap="flat" cmpd="sng" algn="ctr">
+                <a:solidFill>
+                  <a:schemeClr val="accent1">
+                    <a:shade val="15000"/>
+                  </a:schemeClr>
+                </a:solidFill>
+                <a:prstDash val="solid"/>
+                <a:miter lim="800000"/>
+              </a14:hiddenLine>
+            </a:ext>
+          </a:extLst>
+        </p:spPr>
+        <p:style>
+          <a:lnRef idx="2">
+            <a:schemeClr val="accent1">
+              <a:shade val="15000"/>
+            </a:schemeClr>
+          </a:lnRef>
+          <a:fillRef idx="1">
+            <a:schemeClr val="accent1"/>
+          </a:fillRef>
+          <a:effectRef idx="0">
+            <a:schemeClr val="accent1"/>
+          </a:effectRef>
+          <a:fontRef idx="minor">
+            <a:schemeClr val="lt1"/>
+          </a:fontRef>
+        </p:style>
+        <p:txBody>
+          <a:bodyPr rtlCol="0" anchor="ctr"/>
+          <a:lstStyle/>
+          <a:p>
+            <a:pPr algn="ctr"/>
+            <a:endParaRPr lang="de-DE" sz="1600">
+              <a:solidFill>
+                <a:srgbClr val="FFFFFF"/>
+              </a:solidFill>
+            </a:endParaRPr>
+          </a:p>
+        </p:txBody>
+      </p:sp>
+      <p:sp>
+        <p:nvSpPr>
+          <p:cNvPr id="5" name="Ellipse 4">
+            <a:extLst>
+              <a:ext uri="{FF2B5EF4-FFF2-40B4-BE49-F238E27FC236}">
+                <a16:creationId xmlns:a16="http://schemas.microsoft.com/office/drawing/2014/main" id="{DE2B1147-EFC8-63B0-A64F-F9BF6D25EA21}"/>
+              </a:ext>
+            </a:extLst>
+          </p:cNvPr>
+          <p:cNvSpPr/>
+          <p:nvPr/>
+        </p:nvSpPr>
+        <p:spPr>
+          <a:xfrm>
+            <a:off x="9461500" y="762000"/>
+            <a:ext cx="2032000" cy="1397000"/>
+          </a:xfrm>
+          <a:prstGeom prst="ellipse">
+            <a:avLst/>
+          </a:prstGeom>
+          <a:solidFill>
+            <a:srgbClr val="4472C4"/>
+          </a:solidFill>
+          <a:ln w="19050" cap="flat" cmpd="sng" algn="ctr">
+            <a:noFill/>
+            <a:prstDash val="solid"/>
+            <a:miter lim="800000"/>
+          </a:ln>
+          <a:effectLst/>
+          <a:scene3d>
+            <a:camera prst="orthographicFront"/>
+            <a:lightRig rig="threePt" dir="t"/>
+          </a:scene3d>
+          <a:sp3d contourW="76200">
+            <a:bevelT w="190500" h="127000"/>
+            <a:contourClr>
+              <a:srgbClr val="FFC000"/>
+            </a:contourClr>
+          </a:sp3d>
+          <a:extLst>
+            <a:ext uri="{91240B29-F687-4F45-9708-019B960494DF}">
+              <a14:hiddenLine xmlns:a14="http://schemas.microsoft.com/office/drawing/2010/main" w="19050" cap="flat" cmpd="sng" algn="ctr">
+                <a:solidFill>
+                  <a:schemeClr val="accent1">
+                    <a:shade val="15000"/>
+                  </a:schemeClr>
+                </a:solidFill>
+                <a:prstDash val="solid"/>
+                <a:miter lim="800000"/>
+              </a14:hiddenLine>
+            </a:ext>
+          </a:extLst>
+        </p:spPr>
+        <p:style>
+          <a:lnRef idx="2">
+            <a:schemeClr val="accent1">
+              <a:shade val="15000"/>
+            </a:schemeClr>
+          </a:lnRef>
+          <a:fillRef idx="1">
+            <a:schemeClr val="accent1"/>
+          </a:fillRef>
+          <a:effectRef idx="0">
+            <a:schemeClr val="accent1"/>
+          </a:effectRef>
+          <a:fontRef idx="minor">
+            <a:schemeClr val="lt1"/>
+          </a:fontRef>
+        </p:style>
+        <p:txBody>
+          <a:bodyPr rtlCol="0" anchor="ctr"/>
+          <a:lstStyle/>
+          <a:p>
+            <a:pPr algn="ctr"/>
+            <a:endParaRPr lang="de-DE" sz="1600">
+              <a:solidFill>
+                <a:srgbClr val="FFFFFF"/>
+              </a:solidFill>
+            </a:endParaRPr>
+          </a:p>
+        </p:txBody>
+      </p:sp>
+      <p:sp>
+        <p:nvSpPr>
+          <p:cNvPr id="6" name="Rechteck 5">
+            <a:extLst>
+              <a:ext uri="{FF2B5EF4-FFF2-40B4-BE49-F238E27FC236}">
+                <a16:creationId xmlns:a16="http://schemas.microsoft.com/office/drawing/2014/main" id="{01FE8E46-B0F0-43F5-A046-1B8BFD8FA2DA}"/>
+              </a:ext>
+            </a:extLst>
+          </p:cNvPr>
+          <p:cNvSpPr/>
+          <p:nvPr/>
+        </p:nvSpPr>
+        <p:spPr>
+          <a:xfrm>
+            <a:off x="508000" y="3937000"/>
+            <a:ext cx="2032000" cy="1397000"/>
+          </a:xfrm>
+          <a:prstGeom prst="rect">
+            <a:avLst/>
+          </a:prstGeom>
+          <a:solidFill>
+            <a:srgbClr val="4472C4"/>
+          </a:solidFill>
+          <a:ln w="19050" cap="flat" cmpd="sng" algn="ctr">
+            <a:noFill/>
+            <a:prstDash val="solid"/>
+            <a:miter lim="800000"/>
+          </a:ln>
+          <a:effectLst/>
+          <a:scene3d>
+            <a:camera prst="isometricLeftDown"/>
+            <a:lightRig rig="threePt" dir="t"/>
+          </a:scene3d>
+          <a:sp3d extrusionH="381000" contourW="76200">
+            <a:contourClr>
+              <a:srgbClr val="FFC000"/>
+            </a:contourClr>
+          </a:sp3d>
+          <a:extLst>
+            <a:ext uri="{91240B29-F687-4F45-9708-019B960494DF}">
+              <a14:hiddenLine xmlns:a14="http://schemas.microsoft.com/office/drawing/2010/main" w="19050" cap="flat" cmpd="sng" algn="ctr">
+                <a:solidFill>
+                  <a:schemeClr val="accent1">
+                    <a:shade val="15000"/>
+                  </a:schemeClr>
+                </a:solidFill>
+                <a:prstDash val="solid"/>
+                <a:miter lim="800000"/>
+              </a14:hiddenLine>
+            </a:ext>
+          </a:extLst>
+        </p:spPr>
+        <p:style>
+          <a:lnRef idx="2">
+            <a:schemeClr val="accent1">
+              <a:shade val="15000"/>
+            </a:schemeClr>
+          </a:lnRef>
+          <a:fillRef idx="1">
+            <a:schemeClr val="accent1"/>
+          </a:fillRef>
+          <a:effectRef idx="0">
+            <a:schemeClr val="accent1"/>
+          </a:effectRef>
+          <a:fontRef idx="minor">
+            <a:schemeClr val="lt1"/>
+          </a:fontRef>
+        </p:style>
+        <p:txBody>
+          <a:bodyPr rtlCol="0" anchor="ctr"/>
+          <a:lstStyle/>
+          <a:p>
+            <a:pPr algn="ctr"/>
+            <a:endParaRPr lang="de-DE" sz="1600">
+              <a:solidFill>
+                <a:srgbClr val="FFFFFF"/>
+              </a:solidFill>
+            </a:endParaRPr>
+          </a:p>
+        </p:txBody>
+      </p:sp>
+      <p:sp>
+        <p:nvSpPr>
+          <p:cNvPr id="7" name="Ellipse 6">
+            <a:extLst>
+              <a:ext uri="{FF2B5EF4-FFF2-40B4-BE49-F238E27FC236}">
+                <a16:creationId xmlns:a16="http://schemas.microsoft.com/office/drawing/2014/main" id="{511F3FE4-8054-C6E2-D3B4-CD58E38FECC9}"/>
+              </a:ext>
+            </a:extLst>
+          </p:cNvPr>
+          <p:cNvSpPr/>
+          <p:nvPr/>
+        </p:nvSpPr>
+        <p:spPr>
+          <a:xfrm>
+            <a:off x="3492500" y="3937000"/>
+            <a:ext cx="2032000" cy="1397000"/>
+          </a:xfrm>
+          <a:prstGeom prst="ellipse">
+            <a:avLst/>
+          </a:prstGeom>
+          <a:solidFill>
+            <a:srgbClr val="4472C4"/>
+          </a:solidFill>
+          <a:ln w="19050" cap="flat" cmpd="sng" algn="ctr">
+            <a:noFill/>
+            <a:prstDash val="solid"/>
+            <a:miter lim="800000"/>
+          </a:ln>
+          <a:effectLst/>
+          <a:scene3d>
+            <a:camera prst="isometricLeftDown"/>
+            <a:lightRig rig="threePt" dir="t"/>
+          </a:scene3d>
+          <a:sp3d extrusionH="508000" contourW="76200">
+            <a:contourClr>
+              <a:srgbClr val="FFC000"/>
+            </a:contourClr>
+          </a:sp3d>
+          <a:extLst>
+            <a:ext uri="{91240B29-F687-4F45-9708-019B960494DF}">
+              <a14:hiddenLine xmlns:a14="http://schemas.microsoft.com/office/drawing/2010/main" w="19050" cap="flat" cmpd="sng" algn="ctr">
+                <a:solidFill>
+                  <a:schemeClr val="accent1">
+                    <a:shade val="15000"/>
+                  </a:schemeClr>
+                </a:solidFill>
+                <a:prstDash val="solid"/>
+                <a:miter lim="800000"/>
+              </a14:hiddenLine>
+            </a:ext>
+          </a:extLst>
+        </p:spPr>
+        <p:style>
+          <a:lnRef idx="2">
+            <a:schemeClr val="accent1">
+              <a:shade val="15000"/>
+            </a:schemeClr>
+          </a:lnRef>
+          <a:fillRef idx="1">
+            <a:schemeClr val="accent1"/>
+          </a:fillRef>
+          <a:effectRef idx="0">
+            <a:schemeClr val="accent1"/>
+          </a:effectRef>
+          <a:fontRef idx="minor">
+            <a:schemeClr val="lt1"/>
+          </a:fontRef>
+        </p:style>
+        <p:txBody>
+          <a:bodyPr rtlCol="0" anchor="ctr"/>
+          <a:lstStyle/>
+          <a:p>
+            <a:pPr algn="ctr"/>
+            <a:endParaRPr lang="de-DE" sz="1600">
+              <a:solidFill>
+                <a:srgbClr val="FFFFFF"/>
+              </a:solidFill>
+            </a:endParaRPr>
+          </a:p>
+        </p:txBody>
+      </p:sp>
+      <p:sp>
+        <p:nvSpPr>
+          <p:cNvPr id="8" name="Rechteck 7">
+            <a:extLst>
+              <a:ext uri="{FF2B5EF4-FFF2-40B4-BE49-F238E27FC236}">
+                <a16:creationId xmlns:a16="http://schemas.microsoft.com/office/drawing/2014/main" id="{C93E26C8-72E1-8A96-63B4-4D4616D33835}"/>
+              </a:ext>
+            </a:extLst>
+          </p:cNvPr>
+          <p:cNvSpPr/>
+          <p:nvPr/>
+        </p:nvSpPr>
+        <p:spPr>
+          <a:xfrm>
+            <a:off x="6477000" y="3937000"/>
+            <a:ext cx="2032000" cy="1397000"/>
+          </a:xfrm>
+          <a:prstGeom prst="rect">
+            <a:avLst/>
+          </a:prstGeom>
+          <a:solidFill>
+            <a:srgbClr val="4472C4"/>
+          </a:solidFill>
+          <a:ln w="19050" cap="flat" cmpd="sng" algn="ctr">
+            <a:noFill/>
+            <a:prstDash val="solid"/>
+            <a:miter lim="800000"/>
+          </a:ln>
+          <a:effectLst/>
+          <a:scene3d>
+            <a:camera prst="orthographicFront"/>
+            <a:lightRig rig="threePt" dir="t"/>
+          </a:scene3d>
+          <a:sp3d contourW="76200">
+            <a:bevelT w="254000" h="127000" prst="angle"/>
+            <a:contourClr>
+              <a:srgbClr val="FFC000"/>
+            </a:contourClr>
+          </a:sp3d>
+          <a:extLst>
+            <a:ext uri="{91240B29-F687-4F45-9708-019B960494DF}">
+              <a14:hiddenLine xmlns:a14="http://schemas.microsoft.com/office/drawing/2010/main" w="19050" cap="flat" cmpd="sng" algn="ctr">
+                <a:solidFill>
+                  <a:schemeClr val="accent1">
+                    <a:shade val="15000"/>
+                  </a:schemeClr>
+                </a:solidFill>
+                <a:prstDash val="solid"/>
+                <a:miter lim="800000"/>
+              </a14:hiddenLine>
+            </a:ext>
+          </a:extLst>
+        </p:spPr>
+        <p:style>
+          <a:lnRef idx="2">
+            <a:schemeClr val="accent1">
+              <a:shade val="15000"/>
+            </a:schemeClr>
+          </a:lnRef>
+          <a:fillRef idx="1">
+            <a:schemeClr val="accent1"/>
+          </a:fillRef>
+          <a:effectRef idx="0">
+            <a:schemeClr val="accent1"/>
+          </a:effectRef>
+          <a:fontRef idx="minor">
+            <a:schemeClr val="lt1"/>
+          </a:fontRef>
+        </p:style>
+        <p:txBody>
+          <a:bodyPr rtlCol="0" anchor="ctr"/>
+          <a:lstStyle/>
+          <a:p>
+            <a:pPr algn="ctr"/>
+            <a:endParaRPr lang="de-DE" sz="1600">
+              <a:solidFill>
+                <a:srgbClr val="FFFFFF"/>
+              </a:solidFill>
+            </a:endParaRPr>
+          </a:p>
+        </p:txBody>
+      </p:sp>
+      <p:sp>
+        <p:nvSpPr>
+          <p:cNvPr id="9" name="Stern: 5 Zacken 8">
+            <a:extLst>
+              <a:ext uri="{FF2B5EF4-FFF2-40B4-BE49-F238E27FC236}">
+                <a16:creationId xmlns:a16="http://schemas.microsoft.com/office/drawing/2014/main" id="{BD3E175F-0757-61C8-4336-2F9B3BF54936}"/>
+              </a:ext>
+            </a:extLst>
+          </p:cNvPr>
+          <p:cNvSpPr/>
+          <p:nvPr/>
+        </p:nvSpPr>
+        <p:spPr>
+          <a:xfrm>
+            <a:off x="9461500" y="3937000"/>
+            <a:ext cx="2032000" cy="1397000"/>
+          </a:xfrm>
+          <a:prstGeom prst="star5">
+            <a:avLst/>
+          </a:prstGeom>
+          <a:solidFill>
+            <a:srgbClr val="4472C4"/>
+          </a:solidFill>
+          <a:ln w="19050" cap="flat" cmpd="sng" algn="ctr">
+            <a:noFill/>
+            <a:prstDash val="solid"/>
+            <a:miter lim="800000"/>
+          </a:ln>
+          <a:effectLst/>
+          <a:scene3d>
+            <a:camera prst="orthographicFront">
+              <a:rot lat="0" lon="19200000" rev="0"/>
+            </a:camera>
+            <a:lightRig rig="threePt" dir="t"/>
+          </a:scene3d>
+          <a:sp3d contourW="63500">
+            <a:contourClr>
+              <a:srgbClr val="FFC000"/>
+            </a:contourClr>
+          </a:sp3d>
+          <a:extLst>
+            <a:ext uri="{91240B29-F687-4F45-9708-019B960494DF}">
+              <a14:hiddenLine xmlns:a14="http://schemas.microsoft.com/office/drawing/2010/main" w="19050" cap="flat" cmpd="sng" algn="ctr">
+                <a:solidFill>
+                  <a:schemeClr val="accent1">
+                    <a:shade val="15000"/>
+                  </a:schemeClr>
+                </a:solidFill>
+                <a:prstDash val="solid"/>
+                <a:miter lim="800000"/>
+              </a14:hiddenLine>
+            </a:ext>
+          </a:extLst>
+        </p:spPr>
+        <p:style>
+          <a:lnRef idx="2">
+            <a:schemeClr val="accent1">
+              <a:shade val="15000"/>
+            </a:schemeClr>
+          </a:lnRef>
+          <a:fillRef idx="1">
+            <a:schemeClr val="accent1"/>
+          </a:fillRef>
+          <a:effectRef idx="0">
+            <a:schemeClr val="accent1"/>
+          </a:effectRef>
+          <a:fontRef idx="minor">
+            <a:schemeClr val="lt1"/>
+          </a:fontRef>
+        </p:style>
+        <p:txBody>
+          <a:bodyPr rtlCol="0" anchor="ctr"/>
+          <a:lstStyle/>
+          <a:p>
+            <a:pPr algn="ctr"/>
+            <a:endParaRPr lang="de-DE" sz="1600">
+              <a:solidFill>
+                <a:srgbClr val="FFFFFF"/>
+              </a:solidFill>
+            </a:endParaRPr>
+          </a:p>
+        </p:txBody>
+      </p:sp>
+    </p:spTree>
+    <p:extLst>
+      <p:ext uri="{BB962C8B-B14F-4D97-AF65-F5344CB8AC3E}">
+        <p14:creationId xmlns:p14="http://schemas.microsoft.com/office/powerpoint/2010/main" val="735073390"/>
+      </p:ext>
+    </p:extLst>
+  </p:cSld>
+  <p:clrMapOvr>
+    <a:masterClrMapping/>
+  </p:clrMapOvr>
+</p:sld>
+</file>
+
+<file path=ppt/slides/slide9.xml><?xml version="1.0" encoding="utf-8"?>
+<p:sld xmlns:a="http://schemas.openxmlformats.org/drawingml/2006/main" xmlns:r="http://schemas.openxmlformats.org/officeDocument/2006/relationships" xmlns:p="http://schemas.openxmlformats.org/presentationml/2006/main">
+  <p:cSld>
+    <p:spTree>
+      <p:nvGrpSpPr>
+        <p:cNvPr id="1" name=""/>
+        <p:cNvGrpSpPr/>
+        <p:nvPr/>
+      </p:nvGrpSpPr>
+      <p:grpSpPr>
+        <a:xfrm>
+          <a:off x="0" y="0"/>
+          <a:ext cx="0" cy="0"/>
+          <a:chOff x="0" y="0"/>
+          <a:chExt cx="0" cy="0"/>
+        </a:xfrm>
+      </p:grpSpPr>
+      <p:sp>
+        <p:nvSpPr>
+          <p:cNvPr id="2" name="Rechteck 1">
+            <a:extLst>
+              <a:ext uri="{FF2B5EF4-FFF2-40B4-BE49-F238E27FC236}">
+                <a16:creationId xmlns:a16="http://schemas.microsoft.com/office/drawing/2014/main" id="{72C9959D-53F8-0CD7-1242-775A92AF7D35}"/>
+              </a:ext>
+            </a:extLst>
+          </p:cNvPr>
+          <p:cNvSpPr/>
+          <p:nvPr/>
+        </p:nvSpPr>
+        <p:spPr>
+          <a:xfrm>
+            <a:off x="508000" y="762000"/>
+            <a:ext cx="2032000" cy="1397000"/>
+          </a:xfrm>
+          <a:prstGeom prst="rect">
+            <a:avLst/>
+          </a:prstGeom>
+          <a:solidFill>
+            <a:srgbClr val="4472C4"/>
+          </a:solidFill>
+          <a:ln w="101600" cap="flat" cmpd="sng" algn="ctr">
+            <a:solidFill>
+              <a:srgbClr val="DC0000"/>
+            </a:solidFill>
+            <a:prstDash val="solid"/>
+            <a:miter lim="800000"/>
+          </a:ln>
+          <a:effectLst/>
+          <a:scene3d>
+            <a:camera prst="isometricLeftDown"/>
+            <a:lightRig rig="threePt" dir="t"/>
+          </a:scene3d>
+          <a:sp3d extrusionH="508000"/>
+        </p:spPr>
+        <p:style>
+          <a:lnRef idx="2">
+            <a:schemeClr val="accent1">
+              <a:shade val="15000"/>
+            </a:schemeClr>
+          </a:lnRef>
+          <a:fillRef idx="1">
+            <a:schemeClr val="accent1"/>
+          </a:fillRef>
+          <a:effectRef idx="0">
+            <a:schemeClr val="accent1"/>
+          </a:effectRef>
+          <a:fontRef idx="minor">
+            <a:schemeClr val="lt1"/>
+          </a:fontRef>
+        </p:style>
+        <p:txBody>
+          <a:bodyPr rtlCol="0" anchor="ctr"/>
+          <a:lstStyle/>
+          <a:p>
+            <a:pPr algn="ctr"/>
+            <a:endParaRPr lang="de-DE" sz="1600">
+              <a:solidFill>
+                <a:srgbClr val="FFFFFF"/>
+              </a:solidFill>
+            </a:endParaRPr>
+          </a:p>
+        </p:txBody>
+      </p:sp>
+      <p:sp>
+        <p:nvSpPr>
+          <p:cNvPr id="3" name="Rechteck 2">
+            <a:extLst>
+              <a:ext uri="{FF2B5EF4-FFF2-40B4-BE49-F238E27FC236}">
+                <a16:creationId xmlns:a16="http://schemas.microsoft.com/office/drawing/2014/main" id="{8E5B65CA-C897-37E1-6330-6F62276396AD}"/>
+              </a:ext>
+            </a:extLst>
+          </p:cNvPr>
+          <p:cNvSpPr/>
+          <p:nvPr/>
+        </p:nvSpPr>
+        <p:spPr>
+          <a:xfrm>
+            <a:off x="3492500" y="762000"/>
+            <a:ext cx="2032000" cy="1397000"/>
+          </a:xfrm>
+          <a:prstGeom prst="rect">
+            <a:avLst/>
+          </a:prstGeom>
+          <a:solidFill>
+            <a:srgbClr val="4472C4"/>
+          </a:solidFill>
+          <a:ln w="101600" cap="flat" cmpd="sng" algn="ctr">
+            <a:solidFill>
+              <a:srgbClr val="DC0000"/>
+            </a:solidFill>
+            <a:prstDash val="solid"/>
+            <a:miter lim="800000"/>
+          </a:ln>
+          <a:effectLst/>
+          <a:scene3d>
+            <a:camera prst="isometricLeftDown"/>
+            <a:lightRig rig="threePt" dir="t"/>
+          </a:scene3d>
+          <a:sp3d extrusionH="508000">
+            <a:extrusionClr>
+              <a:srgbClr val="00B000"/>
+            </a:extrusionClr>
+          </a:sp3d>
+        </p:spPr>
+        <p:style>
+          <a:lnRef idx="2">
+            <a:schemeClr val="accent1">
+              <a:shade val="15000"/>
+            </a:schemeClr>
+          </a:lnRef>
+          <a:fillRef idx="1">
+            <a:schemeClr val="accent1"/>
+          </a:fillRef>
+          <a:effectRef idx="0">
+            <a:schemeClr val="accent1"/>
+          </a:effectRef>
+          <a:fontRef idx="minor">
+            <a:schemeClr val="lt1"/>
+          </a:fontRef>
+        </p:style>
+        <p:txBody>
+          <a:bodyPr rtlCol="0" anchor="ctr"/>
+          <a:lstStyle/>
+          <a:p>
+            <a:pPr algn="ctr"/>
+            <a:endParaRPr lang="de-DE" sz="1600">
+              <a:solidFill>
+                <a:srgbClr val="FFFFFF"/>
+              </a:solidFill>
+            </a:endParaRPr>
+          </a:p>
+        </p:txBody>
+      </p:sp>
+      <p:sp>
+        <p:nvSpPr>
+          <p:cNvPr id="4" name="Rechteck 3">
+            <a:extLst>
+              <a:ext uri="{FF2B5EF4-FFF2-40B4-BE49-F238E27FC236}">
+                <a16:creationId xmlns:a16="http://schemas.microsoft.com/office/drawing/2014/main" id="{E96CEE94-6BEB-1271-F5FE-FB934B7ABF3F}"/>
+              </a:ext>
+            </a:extLst>
+          </p:cNvPr>
+          <p:cNvSpPr/>
+          <p:nvPr/>
+        </p:nvSpPr>
+        <p:spPr>
+          <a:xfrm>
+            <a:off x="6477000" y="762000"/>
+            <a:ext cx="2032000" cy="1397000"/>
+          </a:xfrm>
+          <a:prstGeom prst="rect">
+            <a:avLst/>
+          </a:prstGeom>
+          <a:solidFill>
+            <a:srgbClr val="4472C4"/>
+          </a:solidFill>
+          <a:ln w="101600" cap="flat" cmpd="sng" algn="ctr">
+            <a:solidFill>
+              <a:srgbClr val="DC0000"/>
+            </a:solidFill>
+            <a:prstDash val="solid"/>
+            <a:miter lim="800000"/>
+          </a:ln>
+          <a:effectLst/>
+          <a:scene3d>
+            <a:camera prst="orthographicFront"/>
+            <a:lightRig rig="threePt" dir="t"/>
+          </a:scene3d>
+          <a:sp3d>
+            <a:bevelT w="190500" h="127000"/>
+          </a:sp3d>
+        </p:spPr>
+        <p:style>
+          <a:lnRef idx="2">
+            <a:schemeClr val="accent1">
+              <a:shade val="15000"/>
+            </a:schemeClr>
+          </a:lnRef>
+          <a:fillRef idx="1">
+            <a:schemeClr val="accent1"/>
+          </a:fillRef>
+          <a:effectRef idx="0">
+            <a:schemeClr val="accent1"/>
+          </a:effectRef>
+          <a:fontRef idx="minor">
+            <a:schemeClr val="lt1"/>
+          </a:fontRef>
+        </p:style>
+        <p:txBody>
+          <a:bodyPr rtlCol="0" anchor="ctr"/>
+          <a:lstStyle/>
+          <a:p>
+            <a:pPr algn="ctr"/>
+            <a:endParaRPr lang="de-DE" sz="1600">
+              <a:solidFill>
+                <a:srgbClr val="FFFFFF"/>
+              </a:solidFill>
+            </a:endParaRPr>
+          </a:p>
+        </p:txBody>
+      </p:sp>
+      <p:sp>
+        <p:nvSpPr>
+          <p:cNvPr id="5" name="Rechteck 4">
+            <a:extLst>
+              <a:ext uri="{FF2B5EF4-FFF2-40B4-BE49-F238E27FC236}">
+                <a16:creationId xmlns:a16="http://schemas.microsoft.com/office/drawing/2014/main" id="{CC7D4B64-7146-831D-3505-42D447A9943B}"/>
+              </a:ext>
+            </a:extLst>
+          </p:cNvPr>
+          <p:cNvSpPr/>
+          <p:nvPr/>
+        </p:nvSpPr>
+        <p:spPr>
+          <a:xfrm>
+            <a:off x="9461500" y="762000"/>
+            <a:ext cx="2032000" cy="1397000"/>
+          </a:xfrm>
+          <a:prstGeom prst="rect">
+            <a:avLst/>
+          </a:prstGeom>
+          <a:solidFill>
+            <a:srgbClr val="4472C4"/>
+          </a:solidFill>
+          <a:ln w="101600" cap="flat" cmpd="sng" algn="ctr">
+            <a:solidFill>
+              <a:srgbClr val="DC0000"/>
+            </a:solidFill>
+            <a:prstDash val="solid"/>
+            <a:miter lim="800000"/>
+          </a:ln>
+          <a:effectLst/>
+          <a:scene3d>
+            <a:camera prst="isometricLeftDown"/>
+            <a:lightRig rig="threePt" dir="t"/>
+          </a:scene3d>
+          <a:sp3d extrusionH="381000">
+            <a:bevelT w="190500" h="127000"/>
+          </a:sp3d>
+        </p:spPr>
+        <p:style>
+          <a:lnRef idx="2">
+            <a:schemeClr val="accent1">
+              <a:shade val="15000"/>
+            </a:schemeClr>
+          </a:lnRef>
+          <a:fillRef idx="1">
+            <a:schemeClr val="accent1"/>
+          </a:fillRef>
+          <a:effectRef idx="0">
+            <a:schemeClr val="accent1"/>
+          </a:effectRef>
+          <a:fontRef idx="minor">
+            <a:schemeClr val="lt1"/>
+          </a:fontRef>
+        </p:style>
+        <p:txBody>
+          <a:bodyPr rtlCol="0" anchor="ctr"/>
+          <a:lstStyle/>
+          <a:p>
+            <a:pPr algn="ctr"/>
+            <a:endParaRPr lang="de-DE" sz="1600">
+              <a:solidFill>
+                <a:srgbClr val="FFFFFF"/>
+              </a:solidFill>
+            </a:endParaRPr>
+          </a:p>
+        </p:txBody>
+      </p:sp>
+      <p:sp>
+        <p:nvSpPr>
+          <p:cNvPr id="6" name="Rechteck 5">
+            <a:extLst>
+              <a:ext uri="{FF2B5EF4-FFF2-40B4-BE49-F238E27FC236}">
+                <a16:creationId xmlns:a16="http://schemas.microsoft.com/office/drawing/2014/main" id="{387A2CCA-8CC5-BE04-6BB4-F58E3C433F5A}"/>
+              </a:ext>
+            </a:extLst>
+          </p:cNvPr>
+          <p:cNvSpPr/>
+          <p:nvPr/>
+        </p:nvSpPr>
+        <p:spPr>
+          <a:xfrm>
+            <a:off x="508000" y="3937000"/>
+            <a:ext cx="2032000" cy="1397000"/>
+          </a:xfrm>
+          <a:prstGeom prst="rect">
+            <a:avLst/>
+          </a:prstGeom>
+          <a:solidFill>
+            <a:srgbClr val="4472C4"/>
+          </a:solidFill>
+          <a:ln w="19050" cap="flat" cmpd="sng" algn="ctr">
+            <a:noFill/>
+            <a:prstDash val="solid"/>
+            <a:miter lim="800000"/>
+          </a:ln>
+          <a:effectLst/>
+          <a:scene3d>
+            <a:camera prst="perspectiveFront"/>
+            <a:lightRig rig="threePt" dir="t"/>
+          </a:scene3d>
+          <a:sp3d z="1524000"/>
+          <a:extLst>
+            <a:ext uri="{91240B29-F687-4F45-9708-019B960494DF}">
+              <a14:hiddenLine xmlns:a14="http://schemas.microsoft.com/office/drawing/2010/main" w="19050" cap="flat" cmpd="sng" algn="ctr">
+                <a:solidFill>
+                  <a:schemeClr val="accent1">
+                    <a:shade val="15000"/>
+                  </a:schemeClr>
+                </a:solidFill>
+                <a:prstDash val="solid"/>
+                <a:miter lim="800000"/>
+              </a14:hiddenLine>
+            </a:ext>
+          </a:extLst>
+        </p:spPr>
+        <p:style>
+          <a:lnRef idx="2">
+            <a:schemeClr val="accent1">
+              <a:shade val="15000"/>
+            </a:schemeClr>
+          </a:lnRef>
+          <a:fillRef idx="1">
+            <a:schemeClr val="accent1"/>
+          </a:fillRef>
+          <a:effectRef idx="0">
+            <a:schemeClr val="accent1"/>
+          </a:effectRef>
+          <a:fontRef idx="minor">
+            <a:schemeClr val="lt1"/>
+          </a:fontRef>
+        </p:style>
+        <p:txBody>
+          <a:bodyPr rtlCol="0" anchor="ctr"/>
+          <a:lstStyle/>
+          <a:p>
+            <a:pPr algn="ctr"/>
+            <a:r>
+              <a:rPr lang="de-DE" sz="1600">
+                <a:solidFill>
+                  <a:srgbClr val="FFFFFF"/>
+                </a:solidFill>
+              </a:rPr>
+              <a:t>z 120</a:t>
+            </a:r>
+          </a:p>
+        </p:txBody>
+      </p:sp>
+      <p:sp>
+        <p:nvSpPr>
+          <p:cNvPr id="7" name="Rechteck 6">
+            <a:extLst>
+              <a:ext uri="{FF2B5EF4-FFF2-40B4-BE49-F238E27FC236}">
+                <a16:creationId xmlns:a16="http://schemas.microsoft.com/office/drawing/2014/main" id="{4E77CC75-A489-CB2A-ED56-8CEE9EF3A3A2}"/>
+              </a:ext>
+            </a:extLst>
+          </p:cNvPr>
+          <p:cNvSpPr/>
+          <p:nvPr/>
+        </p:nvSpPr>
+        <p:spPr>
+          <a:xfrm>
+            <a:off x="3492500" y="3937000"/>
+            <a:ext cx="2032000" cy="1397000"/>
+          </a:xfrm>
+          <a:prstGeom prst="rect">
+            <a:avLst/>
+          </a:prstGeom>
+          <a:solidFill>
+            <a:srgbClr val="4472C4"/>
+          </a:solidFill>
+          <a:ln w="19050" cap="flat" cmpd="sng" algn="ctr">
+            <a:noFill/>
+            <a:prstDash val="solid"/>
+            <a:miter lim="800000"/>
+          </a:ln>
+          <a:effectLst/>
+          <a:scene3d>
+            <a:camera prst="perspectiveFront"/>
+            <a:lightRig rig="threePt" dir="t"/>
+          </a:scene3d>
+          <a:sp3d z="-1905000"/>
+          <a:extLst>
+            <a:ext uri="{91240B29-F687-4F45-9708-019B960494DF}">
+              <a14:hiddenLine xmlns:a14="http://schemas.microsoft.com/office/drawing/2010/main" w="19050" cap="flat" cmpd="sng" algn="ctr">
+                <a:solidFill>
+                  <a:schemeClr val="accent1">
+                    <a:shade val="15000"/>
+                  </a:schemeClr>
+                </a:solidFill>
+                <a:prstDash val="solid"/>
+                <a:miter lim="800000"/>
+              </a14:hiddenLine>
+            </a:ext>
+          </a:extLst>
+        </p:spPr>
+        <p:style>
+          <a:lnRef idx="2">
+            <a:schemeClr val="accent1">
+              <a:shade val="15000"/>
+            </a:schemeClr>
+          </a:lnRef>
+          <a:fillRef idx="1">
+            <a:schemeClr val="accent1"/>
+          </a:fillRef>
+          <a:effectRef idx="0">
+            <a:schemeClr val="accent1"/>
+          </a:effectRef>
+          <a:fontRef idx="minor">
+            <a:schemeClr val="lt1"/>
+          </a:fontRef>
+        </p:style>
+        <p:txBody>
+          <a:bodyPr rtlCol="0" anchor="ctr"/>
+          <a:lstStyle/>
+          <a:p>
+            <a:pPr algn="ctr"/>
+            <a:r>
+              <a:rPr lang="de-DE" sz="1600">
+                <a:solidFill>
+                  <a:srgbClr val="FFFFFF"/>
+                </a:solidFill>
+              </a:rPr>
+              <a:t>z -150</a:t>
+            </a:r>
+          </a:p>
+        </p:txBody>
+      </p:sp>
+      <p:sp>
+        <p:nvSpPr>
+          <p:cNvPr id="8" name="Rechteck 7">
+            <a:extLst>
+              <a:ext uri="{FF2B5EF4-FFF2-40B4-BE49-F238E27FC236}">
+                <a16:creationId xmlns:a16="http://schemas.microsoft.com/office/drawing/2014/main" id="{C196E8DC-7481-72F7-40A4-588427D6735E}"/>
+              </a:ext>
+            </a:extLst>
+          </p:cNvPr>
+          <p:cNvSpPr/>
+          <p:nvPr/>
+        </p:nvSpPr>
+        <p:spPr>
+          <a:xfrm>
+            <a:off x="6477000" y="3302000"/>
+            <a:ext cx="2032000" cy="1397000"/>
+          </a:xfrm>
+          <a:prstGeom prst="rect">
+            <a:avLst/>
+          </a:prstGeom>
+          <a:solidFill>
+            <a:srgbClr val="4472C4"/>
+          </a:solidFill>
+          <a:ln w="19050" cap="flat" cmpd="sng" algn="ctr">
+            <a:noFill/>
+            <a:prstDash val="solid"/>
+            <a:miter lim="800000"/>
+          </a:ln>
+          <a:effectLst/>
+          <a:scene3d>
+            <a:camera prst="orthographicFront">
+              <a:rot lat="2400000" lon="0" rev="0"/>
+            </a:camera>
+            <a:lightRig rig="threePt" dir="t"/>
+          </a:scene3d>
+          <a:sp3d z="1270000"/>
+          <a:extLst>
+            <a:ext uri="{91240B29-F687-4F45-9708-019B960494DF}">
+              <a14:hiddenLine xmlns:a14="http://schemas.microsoft.com/office/drawing/2010/main" w="19050" cap="flat" cmpd="sng" algn="ctr">
+                <a:solidFill>
+                  <a:schemeClr val="accent1">
+                    <a:shade val="15000"/>
+                  </a:schemeClr>
+                </a:solidFill>
+                <a:prstDash val="solid"/>
+                <a:miter lim="800000"/>
+              </a14:hiddenLine>
+            </a:ext>
+          </a:extLst>
+        </p:spPr>
+        <p:style>
+          <a:lnRef idx="2">
+            <a:schemeClr val="accent1">
+              <a:shade val="15000"/>
+            </a:schemeClr>
+          </a:lnRef>
+          <a:fillRef idx="1">
+            <a:schemeClr val="accent1"/>
+          </a:fillRef>
+          <a:effectRef idx="0">
+            <a:schemeClr val="accent1"/>
+          </a:effectRef>
+          <a:fontRef idx="minor">
+            <a:schemeClr val="lt1"/>
+          </a:fontRef>
+        </p:style>
+        <p:txBody>
+          <a:bodyPr rtlCol="0" anchor="ctr"/>
+          <a:lstStyle/>
+          <a:p>
+            <a:pPr algn="ctr"/>
+            <a:r>
+              <a:rPr lang="de-DE" sz="1600">
+                <a:solidFill>
+                  <a:srgbClr val="FFFFFF"/>
+                </a:solidFill>
+              </a:rPr>
+              <a:t>z 100</a:t>
+            </a:r>
+          </a:p>
+        </p:txBody>
+      </p:sp>
+      <p:sp>
+        <p:nvSpPr>
+          <p:cNvPr id="9" name="Rechteck 8">
+            <a:extLst>
+              <a:ext uri="{FF2B5EF4-FFF2-40B4-BE49-F238E27FC236}">
+                <a16:creationId xmlns:a16="http://schemas.microsoft.com/office/drawing/2014/main" id="{5263C4FF-D843-17C1-4F64-1583D6167E39}"/>
+              </a:ext>
+            </a:extLst>
+          </p:cNvPr>
+          <p:cNvSpPr/>
+          <p:nvPr/>
+        </p:nvSpPr>
+        <p:spPr>
+          <a:xfrm>
+            <a:off x="9461500" y="3937000"/>
+            <a:ext cx="2032000" cy="1397000"/>
+          </a:xfrm>
+          <a:prstGeom prst="rect">
+            <a:avLst/>
+          </a:prstGeom>
+          <a:solidFill>
+            <a:srgbClr val="4472C4"/>
+          </a:solidFill>
+          <a:ln w="101600" cap="flat" cmpd="sng" algn="ctr">
+            <a:solidFill>
+              <a:srgbClr val="DC0000"/>
+            </a:solidFill>
+            <a:prstDash val="solid"/>
+            <a:miter lim="800000"/>
+          </a:ln>
+          <a:effectLst/>
+          <a:scene3d>
+            <a:camera prst="orthographicFront">
+              <a:rot lat="1200000" lon="12600000" rev="0"/>
+            </a:camera>
+            <a:lightRig rig="threePt" dir="t"/>
+          </a:scene3d>
+          <a:sp3d extrusionH="381000"/>
+        </p:spPr>
+        <p:style>
+          <a:lnRef idx="2">
+            <a:schemeClr val="accent1">
+              <a:shade val="15000"/>
+            </a:schemeClr>
+          </a:lnRef>
+          <a:fillRef idx="1">
+            <a:schemeClr val="accent1"/>
+          </a:fillRef>
+          <a:effectRef idx="0">
+            <a:schemeClr val="accent1"/>
+          </a:effectRef>
+          <a:fontRef idx="minor">
+            <a:schemeClr val="lt1"/>
+          </a:fontRef>
+        </p:style>
+        <p:txBody>
+          <a:bodyPr rtlCol="0" anchor="ctr"/>
+          <a:lstStyle/>
+          <a:p>
+            <a:pPr algn="ctr"/>
+            <a:endParaRPr lang="de-DE" sz="1600">
+              <a:solidFill>
+                <a:srgbClr val="FFFFFF"/>
+              </a:solidFill>
+            </a:endParaRPr>
+          </a:p>
+        </p:txBody>
+      </p:sp>
+    </p:spTree>
+    <p:extLst>
+      <p:ext uri="{BB962C8B-B14F-4D97-AF65-F5344CB8AC3E}">
+        <p14:creationId xmlns:p14="http://schemas.microsoft.com/office/powerpoint/2010/main" val="4051782149"/>
       </p:ext>
     </p:extLst>
   </p:cSld>

</xml_diff>

<commit_message>
3D: shadows and glow cast from the body's back, no soft edges on bodies
Co-Authored-By: Claude Opus 5.5 <noreply@anthropic.com>
</commit_message>
<xml_diff>
--- a/tests/corpus/pptx/generated/three-d.pptx
+++ b/tests/corpus/pptx/generated/three-d.pptx
@@ -14,6 +14,7 @@
     <p:sldId id="262" r:id="rId8"/>
     <p:sldId id="263" r:id="rId9"/>
     <p:sldId id="264" r:id="rId10"/>
+    <p:sldId id="265" r:id="rId11"/>
   </p:sldIdLst>
   <p:sldSz cx="12192000" cy="6858000"/>
   <p:notesSz cx="6858000" cy="9144000"/>
@@ -137,7 +138,7 @@
           <p:cNvPr id="2" name="Titel 1">
             <a:extLst>
               <a:ext uri="{FF2B5EF4-FFF2-40B4-BE49-F238E27FC236}">
-                <a16:creationId xmlns:a16="http://schemas.microsoft.com/office/drawing/2014/main" id="{A132D864-7114-A28D-7C3C-E1EBA2499036}"/>
+                <a16:creationId xmlns:a16="http://schemas.microsoft.com/office/drawing/2014/main" id="{331819BD-00C1-D7BC-1A02-A5BDE650BEB0}"/>
               </a:ext>
             </a:extLst>
           </p:cNvPr>
@@ -174,7 +175,7 @@
           <p:cNvPr id="3" name="Untertitel 2">
             <a:extLst>
               <a:ext uri="{FF2B5EF4-FFF2-40B4-BE49-F238E27FC236}">
-                <a16:creationId xmlns:a16="http://schemas.microsoft.com/office/drawing/2014/main" id="{C202959B-EB72-C674-885A-6774136F5279}"/>
+                <a16:creationId xmlns:a16="http://schemas.microsoft.com/office/drawing/2014/main" id="{0EDA2377-1F54-8614-A358-5601F4B2F965}"/>
               </a:ext>
             </a:extLst>
           </p:cNvPr>
@@ -244,7 +245,7 @@
           <p:cNvPr id="4" name="Datumsplatzhalter 3">
             <a:extLst>
               <a:ext uri="{FF2B5EF4-FFF2-40B4-BE49-F238E27FC236}">
-                <a16:creationId xmlns:a16="http://schemas.microsoft.com/office/drawing/2014/main" id="{A7E4CCFB-8E83-C85D-A671-C2FA3B0033E5}"/>
+                <a16:creationId xmlns:a16="http://schemas.microsoft.com/office/drawing/2014/main" id="{1AD4390D-EAB5-E9FB-172A-A8E22397186E}"/>
               </a:ext>
             </a:extLst>
           </p:cNvPr>
@@ -260,7 +261,7 @@
           <a:bodyPr/>
           <a:lstStyle/>
           <a:p>
-            <a:fld id="{F27B871D-E315-469F-BF57-7629DB4D7F4D}" type="datetimeFigureOut">
+            <a:fld id="{4865B0A2-5436-4E13-91FA-8671EA735516}" type="datetimeFigureOut">
               <a:rPr lang="de-DE" smtClean="0"/>
               <a:t>08.10.2026</a:t>
             </a:fld>
@@ -273,7 +274,7 @@
           <p:cNvPr id="5" name="Fußzeilenplatzhalter 4">
             <a:extLst>
               <a:ext uri="{FF2B5EF4-FFF2-40B4-BE49-F238E27FC236}">
-                <a16:creationId xmlns:a16="http://schemas.microsoft.com/office/drawing/2014/main" id="{A491B9A0-A8E0-C1C9-9723-DF9AA7929E52}"/>
+                <a16:creationId xmlns:a16="http://schemas.microsoft.com/office/drawing/2014/main" id="{DC9E9FD6-8DF2-08BF-24B0-5B8F8376DF04}"/>
               </a:ext>
             </a:extLst>
           </p:cNvPr>
@@ -298,7 +299,7 @@
           <p:cNvPr id="6" name="Foliennummernplatzhalter 5">
             <a:extLst>
               <a:ext uri="{FF2B5EF4-FFF2-40B4-BE49-F238E27FC236}">
-                <a16:creationId xmlns:a16="http://schemas.microsoft.com/office/drawing/2014/main" id="{DC2BB56E-CBD8-7BE2-59D3-BF67C8FDEA44}"/>
+                <a16:creationId xmlns:a16="http://schemas.microsoft.com/office/drawing/2014/main" id="{2FD06AC8-9F73-5A46-0BC2-9B12138743D3}"/>
               </a:ext>
             </a:extLst>
           </p:cNvPr>
@@ -314,7 +315,7 @@
           <a:bodyPr/>
           <a:lstStyle/>
           <a:p>
-            <a:fld id="{4384185C-CA1D-4D64-B747-FEE1A56E57CB}" type="slidenum">
+            <a:fld id="{44BE951E-0096-43E3-935D-E21731B98C07}" type="slidenum">
               <a:rPr lang="de-DE" smtClean="0"/>
               <a:t>‹Nr.›</a:t>
             </a:fld>
@@ -325,7 +326,7 @@
     </p:spTree>
     <p:extLst>
       <p:ext uri="{BB962C8B-B14F-4D97-AF65-F5344CB8AC3E}">
-        <p14:creationId xmlns:p14="http://schemas.microsoft.com/office/powerpoint/2010/main" val="2187965353"/>
+        <p14:creationId xmlns:p14="http://schemas.microsoft.com/office/powerpoint/2010/main" val="302700014"/>
       </p:ext>
     </p:extLst>
   </p:cSld>
@@ -357,7 +358,7 @@
           <p:cNvPr id="2" name="Titel 1">
             <a:extLst>
               <a:ext uri="{FF2B5EF4-FFF2-40B4-BE49-F238E27FC236}">
-                <a16:creationId xmlns:a16="http://schemas.microsoft.com/office/drawing/2014/main" id="{C9227B82-7016-A1FB-E0EC-A15F0C3BBF35}"/>
+                <a16:creationId xmlns:a16="http://schemas.microsoft.com/office/drawing/2014/main" id="{4069DDC1-5A0B-4E1B-956F-276EC513E6D1}"/>
               </a:ext>
             </a:extLst>
           </p:cNvPr>
@@ -385,7 +386,7 @@
           <p:cNvPr id="3" name="Vertikaler Textplatzhalter 2">
             <a:extLst>
               <a:ext uri="{FF2B5EF4-FFF2-40B4-BE49-F238E27FC236}">
-                <a16:creationId xmlns:a16="http://schemas.microsoft.com/office/drawing/2014/main" id="{DDC6730F-DC06-14B7-E75D-97A79477DD07}"/>
+                <a16:creationId xmlns:a16="http://schemas.microsoft.com/office/drawing/2014/main" id="{F02C346F-1D1C-2CC6-9C96-325C73D3981E}"/>
               </a:ext>
             </a:extLst>
           </p:cNvPr>
@@ -442,7 +443,7 @@
           <p:cNvPr id="4" name="Datumsplatzhalter 3">
             <a:extLst>
               <a:ext uri="{FF2B5EF4-FFF2-40B4-BE49-F238E27FC236}">
-                <a16:creationId xmlns:a16="http://schemas.microsoft.com/office/drawing/2014/main" id="{9AA9AA76-909B-D3D3-6D97-C25861293496}"/>
+                <a16:creationId xmlns:a16="http://schemas.microsoft.com/office/drawing/2014/main" id="{35BF3E12-5F08-91FC-3BE5-8B6295BAFE29}"/>
               </a:ext>
             </a:extLst>
           </p:cNvPr>
@@ -458,7 +459,7 @@
           <a:bodyPr/>
           <a:lstStyle/>
           <a:p>
-            <a:fld id="{F27B871D-E315-469F-BF57-7629DB4D7F4D}" type="datetimeFigureOut">
+            <a:fld id="{4865B0A2-5436-4E13-91FA-8671EA735516}" type="datetimeFigureOut">
               <a:rPr lang="de-DE" smtClean="0"/>
               <a:t>08.10.2026</a:t>
             </a:fld>
@@ -471,7 +472,7 @@
           <p:cNvPr id="5" name="Fußzeilenplatzhalter 4">
             <a:extLst>
               <a:ext uri="{FF2B5EF4-FFF2-40B4-BE49-F238E27FC236}">
-                <a16:creationId xmlns:a16="http://schemas.microsoft.com/office/drawing/2014/main" id="{9E495617-E85B-B122-026A-1B0F0DDA3872}"/>
+                <a16:creationId xmlns:a16="http://schemas.microsoft.com/office/drawing/2014/main" id="{2740DC8B-3925-80A4-F5D3-85A696F0F3A3}"/>
               </a:ext>
             </a:extLst>
           </p:cNvPr>
@@ -496,7 +497,7 @@
           <p:cNvPr id="6" name="Foliennummernplatzhalter 5">
             <a:extLst>
               <a:ext uri="{FF2B5EF4-FFF2-40B4-BE49-F238E27FC236}">
-                <a16:creationId xmlns:a16="http://schemas.microsoft.com/office/drawing/2014/main" id="{423C2003-C4AF-AE71-24AC-BF85AFDC0653}"/>
+                <a16:creationId xmlns:a16="http://schemas.microsoft.com/office/drawing/2014/main" id="{61DB4B2E-CFD3-B0C6-2949-46FE1E6F7E66}"/>
               </a:ext>
             </a:extLst>
           </p:cNvPr>
@@ -512,7 +513,7 @@
           <a:bodyPr/>
           <a:lstStyle/>
           <a:p>
-            <a:fld id="{4384185C-CA1D-4D64-B747-FEE1A56E57CB}" type="slidenum">
+            <a:fld id="{44BE951E-0096-43E3-935D-E21731B98C07}" type="slidenum">
               <a:rPr lang="de-DE" smtClean="0"/>
               <a:t>‹Nr.›</a:t>
             </a:fld>
@@ -523,7 +524,7 @@
     </p:spTree>
     <p:extLst>
       <p:ext uri="{BB962C8B-B14F-4D97-AF65-F5344CB8AC3E}">
-        <p14:creationId xmlns:p14="http://schemas.microsoft.com/office/powerpoint/2010/main" val="3970081019"/>
+        <p14:creationId xmlns:p14="http://schemas.microsoft.com/office/powerpoint/2010/main" val="2647253693"/>
       </p:ext>
     </p:extLst>
   </p:cSld>
@@ -555,7 +556,7 @@
           <p:cNvPr id="2" name="Vertikaler Titel 1">
             <a:extLst>
               <a:ext uri="{FF2B5EF4-FFF2-40B4-BE49-F238E27FC236}">
-                <a16:creationId xmlns:a16="http://schemas.microsoft.com/office/drawing/2014/main" id="{599B6405-2BAC-1B01-AEA6-EF8C9B9DCBFD}"/>
+                <a16:creationId xmlns:a16="http://schemas.microsoft.com/office/drawing/2014/main" id="{2EDD2D26-D1D6-CFD3-B0BE-A3C9EFBC793C}"/>
               </a:ext>
             </a:extLst>
           </p:cNvPr>
@@ -588,7 +589,7 @@
           <p:cNvPr id="3" name="Vertikaler Textplatzhalter 2">
             <a:extLst>
               <a:ext uri="{FF2B5EF4-FFF2-40B4-BE49-F238E27FC236}">
-                <a16:creationId xmlns:a16="http://schemas.microsoft.com/office/drawing/2014/main" id="{82340C7D-16C1-624E-A915-2B0B7395984E}"/>
+                <a16:creationId xmlns:a16="http://schemas.microsoft.com/office/drawing/2014/main" id="{0718988D-A5AA-DB77-7B44-83986F39F32A}"/>
               </a:ext>
             </a:extLst>
           </p:cNvPr>
@@ -650,7 +651,7 @@
           <p:cNvPr id="4" name="Datumsplatzhalter 3">
             <a:extLst>
               <a:ext uri="{FF2B5EF4-FFF2-40B4-BE49-F238E27FC236}">
-                <a16:creationId xmlns:a16="http://schemas.microsoft.com/office/drawing/2014/main" id="{3734B373-1154-E13B-FE25-1814116329A4}"/>
+                <a16:creationId xmlns:a16="http://schemas.microsoft.com/office/drawing/2014/main" id="{276EC9D2-966E-586B-24F9-747C41424E2D}"/>
               </a:ext>
             </a:extLst>
           </p:cNvPr>
@@ -666,7 +667,7 @@
           <a:bodyPr/>
           <a:lstStyle/>
           <a:p>
-            <a:fld id="{F27B871D-E315-469F-BF57-7629DB4D7F4D}" type="datetimeFigureOut">
+            <a:fld id="{4865B0A2-5436-4E13-91FA-8671EA735516}" type="datetimeFigureOut">
               <a:rPr lang="de-DE" smtClean="0"/>
               <a:t>08.10.2026</a:t>
             </a:fld>
@@ -679,7 +680,7 @@
           <p:cNvPr id="5" name="Fußzeilenplatzhalter 4">
             <a:extLst>
               <a:ext uri="{FF2B5EF4-FFF2-40B4-BE49-F238E27FC236}">
-                <a16:creationId xmlns:a16="http://schemas.microsoft.com/office/drawing/2014/main" id="{A8DBE0EC-40AC-EE04-1605-EBE6DA695C6B}"/>
+                <a16:creationId xmlns:a16="http://schemas.microsoft.com/office/drawing/2014/main" id="{31AEDF34-230A-E58E-355A-46D917E5F4F7}"/>
               </a:ext>
             </a:extLst>
           </p:cNvPr>
@@ -704,7 +705,7 @@
           <p:cNvPr id="6" name="Foliennummernplatzhalter 5">
             <a:extLst>
               <a:ext uri="{FF2B5EF4-FFF2-40B4-BE49-F238E27FC236}">
-                <a16:creationId xmlns:a16="http://schemas.microsoft.com/office/drawing/2014/main" id="{6C2DB883-10DE-BF35-CC8A-45624D65AEEC}"/>
+                <a16:creationId xmlns:a16="http://schemas.microsoft.com/office/drawing/2014/main" id="{F39844DB-94B0-A75E-7420-D7624A9AA849}"/>
               </a:ext>
             </a:extLst>
           </p:cNvPr>
@@ -720,7 +721,7 @@
           <a:bodyPr/>
           <a:lstStyle/>
           <a:p>
-            <a:fld id="{4384185C-CA1D-4D64-B747-FEE1A56E57CB}" type="slidenum">
+            <a:fld id="{44BE951E-0096-43E3-935D-E21731B98C07}" type="slidenum">
               <a:rPr lang="de-DE" smtClean="0"/>
               <a:t>‹Nr.›</a:t>
             </a:fld>
@@ -731,7 +732,7 @@
     </p:spTree>
     <p:extLst>
       <p:ext uri="{BB962C8B-B14F-4D97-AF65-F5344CB8AC3E}">
-        <p14:creationId xmlns:p14="http://schemas.microsoft.com/office/powerpoint/2010/main" val="2584112580"/>
+        <p14:creationId xmlns:p14="http://schemas.microsoft.com/office/powerpoint/2010/main" val="40970687"/>
       </p:ext>
     </p:extLst>
   </p:cSld>
@@ -763,7 +764,7 @@
           <p:cNvPr id="2" name="Titel 1">
             <a:extLst>
               <a:ext uri="{FF2B5EF4-FFF2-40B4-BE49-F238E27FC236}">
-                <a16:creationId xmlns:a16="http://schemas.microsoft.com/office/drawing/2014/main" id="{18A587EC-269E-0E98-E129-59FA86E957E3}"/>
+                <a16:creationId xmlns:a16="http://schemas.microsoft.com/office/drawing/2014/main" id="{110899F3-3110-F493-A131-93D03BEDE296}"/>
               </a:ext>
             </a:extLst>
           </p:cNvPr>
@@ -791,7 +792,7 @@
           <p:cNvPr id="3" name="Inhaltsplatzhalter 2">
             <a:extLst>
               <a:ext uri="{FF2B5EF4-FFF2-40B4-BE49-F238E27FC236}">
-                <a16:creationId xmlns:a16="http://schemas.microsoft.com/office/drawing/2014/main" id="{2A0F2686-BF38-8688-8FA8-434CEFDD8D66}"/>
+                <a16:creationId xmlns:a16="http://schemas.microsoft.com/office/drawing/2014/main" id="{FCEEC00A-061C-DAF6-7498-09B71F3922C8}"/>
               </a:ext>
             </a:extLst>
           </p:cNvPr>
@@ -848,7 +849,7 @@
           <p:cNvPr id="4" name="Datumsplatzhalter 3">
             <a:extLst>
               <a:ext uri="{FF2B5EF4-FFF2-40B4-BE49-F238E27FC236}">
-                <a16:creationId xmlns:a16="http://schemas.microsoft.com/office/drawing/2014/main" id="{DFA89D47-B370-CB81-5E65-7CACA4040512}"/>
+                <a16:creationId xmlns:a16="http://schemas.microsoft.com/office/drawing/2014/main" id="{A6190865-1D9D-E2C6-0B3C-3312335035AB}"/>
               </a:ext>
             </a:extLst>
           </p:cNvPr>
@@ -864,7 +865,7 @@
           <a:bodyPr/>
           <a:lstStyle/>
           <a:p>
-            <a:fld id="{F27B871D-E315-469F-BF57-7629DB4D7F4D}" type="datetimeFigureOut">
+            <a:fld id="{4865B0A2-5436-4E13-91FA-8671EA735516}" type="datetimeFigureOut">
               <a:rPr lang="de-DE" smtClean="0"/>
               <a:t>08.10.2026</a:t>
             </a:fld>
@@ -877,7 +878,7 @@
           <p:cNvPr id="5" name="Fußzeilenplatzhalter 4">
             <a:extLst>
               <a:ext uri="{FF2B5EF4-FFF2-40B4-BE49-F238E27FC236}">
-                <a16:creationId xmlns:a16="http://schemas.microsoft.com/office/drawing/2014/main" id="{38FA9A22-6B38-4A9B-1AEF-A1EC44E11C2C}"/>
+                <a16:creationId xmlns:a16="http://schemas.microsoft.com/office/drawing/2014/main" id="{177C5E88-2191-E4F0-BF96-446D56EED7E7}"/>
               </a:ext>
             </a:extLst>
           </p:cNvPr>
@@ -902,7 +903,7 @@
           <p:cNvPr id="6" name="Foliennummernplatzhalter 5">
             <a:extLst>
               <a:ext uri="{FF2B5EF4-FFF2-40B4-BE49-F238E27FC236}">
-                <a16:creationId xmlns:a16="http://schemas.microsoft.com/office/drawing/2014/main" id="{C81BB973-1D95-4C0A-CD88-3FBBD628CBE9}"/>
+                <a16:creationId xmlns:a16="http://schemas.microsoft.com/office/drawing/2014/main" id="{F7CD833A-C98B-C033-B5DE-89EF5E255A7D}"/>
               </a:ext>
             </a:extLst>
           </p:cNvPr>
@@ -918,7 +919,7 @@
           <a:bodyPr/>
           <a:lstStyle/>
           <a:p>
-            <a:fld id="{4384185C-CA1D-4D64-B747-FEE1A56E57CB}" type="slidenum">
+            <a:fld id="{44BE951E-0096-43E3-935D-E21731B98C07}" type="slidenum">
               <a:rPr lang="de-DE" smtClean="0"/>
               <a:t>‹Nr.›</a:t>
             </a:fld>
@@ -929,7 +930,7 @@
     </p:spTree>
     <p:extLst>
       <p:ext uri="{BB962C8B-B14F-4D97-AF65-F5344CB8AC3E}">
-        <p14:creationId xmlns:p14="http://schemas.microsoft.com/office/powerpoint/2010/main" val="3116036840"/>
+        <p14:creationId xmlns:p14="http://schemas.microsoft.com/office/powerpoint/2010/main" val="2459776342"/>
       </p:ext>
     </p:extLst>
   </p:cSld>
@@ -961,7 +962,7 @@
           <p:cNvPr id="2" name="Titel 1">
             <a:extLst>
               <a:ext uri="{FF2B5EF4-FFF2-40B4-BE49-F238E27FC236}">
-                <a16:creationId xmlns:a16="http://schemas.microsoft.com/office/drawing/2014/main" id="{80543DB6-1A80-7C81-6444-8F72C15AEFC2}"/>
+                <a16:creationId xmlns:a16="http://schemas.microsoft.com/office/drawing/2014/main" id="{9052C324-E530-D408-2D0C-087DD7082890}"/>
               </a:ext>
             </a:extLst>
           </p:cNvPr>
@@ -998,7 +999,7 @@
           <p:cNvPr id="3" name="Textplatzhalter 2">
             <a:extLst>
               <a:ext uri="{FF2B5EF4-FFF2-40B4-BE49-F238E27FC236}">
-                <a16:creationId xmlns:a16="http://schemas.microsoft.com/office/drawing/2014/main" id="{7CE771E2-088E-1F0A-D99D-BF9F8F4523DE}"/>
+                <a16:creationId xmlns:a16="http://schemas.microsoft.com/office/drawing/2014/main" id="{E9EBF28D-3E73-65B4-1CF9-CC8943902111}"/>
               </a:ext>
             </a:extLst>
           </p:cNvPr>
@@ -1123,7 +1124,7 @@
           <p:cNvPr id="4" name="Datumsplatzhalter 3">
             <a:extLst>
               <a:ext uri="{FF2B5EF4-FFF2-40B4-BE49-F238E27FC236}">
-                <a16:creationId xmlns:a16="http://schemas.microsoft.com/office/drawing/2014/main" id="{4B713D99-A374-7FC6-D8EC-0F307D668C9E}"/>
+                <a16:creationId xmlns:a16="http://schemas.microsoft.com/office/drawing/2014/main" id="{4A93150D-BD4B-12AE-5BA0-1AA49BD5E4A3}"/>
               </a:ext>
             </a:extLst>
           </p:cNvPr>
@@ -1139,7 +1140,7 @@
           <a:bodyPr/>
           <a:lstStyle/>
           <a:p>
-            <a:fld id="{F27B871D-E315-469F-BF57-7629DB4D7F4D}" type="datetimeFigureOut">
+            <a:fld id="{4865B0A2-5436-4E13-91FA-8671EA735516}" type="datetimeFigureOut">
               <a:rPr lang="de-DE" smtClean="0"/>
               <a:t>08.10.2026</a:t>
             </a:fld>
@@ -1152,7 +1153,7 @@
           <p:cNvPr id="5" name="Fußzeilenplatzhalter 4">
             <a:extLst>
               <a:ext uri="{FF2B5EF4-FFF2-40B4-BE49-F238E27FC236}">
-                <a16:creationId xmlns:a16="http://schemas.microsoft.com/office/drawing/2014/main" id="{BBA00B4C-D996-9C2C-26F3-F23CC3A1B11F}"/>
+                <a16:creationId xmlns:a16="http://schemas.microsoft.com/office/drawing/2014/main" id="{18513C0B-2867-0D6E-4BEA-BDC440875992}"/>
               </a:ext>
             </a:extLst>
           </p:cNvPr>
@@ -1177,7 +1178,7 @@
           <p:cNvPr id="6" name="Foliennummernplatzhalter 5">
             <a:extLst>
               <a:ext uri="{FF2B5EF4-FFF2-40B4-BE49-F238E27FC236}">
-                <a16:creationId xmlns:a16="http://schemas.microsoft.com/office/drawing/2014/main" id="{83B00B77-0C43-2C5D-AFCC-FF1B67001B39}"/>
+                <a16:creationId xmlns:a16="http://schemas.microsoft.com/office/drawing/2014/main" id="{02B3C2E5-E6EF-A14D-BC3C-4058B62B93CB}"/>
               </a:ext>
             </a:extLst>
           </p:cNvPr>
@@ -1193,7 +1194,7 @@
           <a:bodyPr/>
           <a:lstStyle/>
           <a:p>
-            <a:fld id="{4384185C-CA1D-4D64-B747-FEE1A56E57CB}" type="slidenum">
+            <a:fld id="{44BE951E-0096-43E3-935D-E21731B98C07}" type="slidenum">
               <a:rPr lang="de-DE" smtClean="0"/>
               <a:t>‹Nr.›</a:t>
             </a:fld>
@@ -1204,7 +1205,7 @@
     </p:spTree>
     <p:extLst>
       <p:ext uri="{BB962C8B-B14F-4D97-AF65-F5344CB8AC3E}">
-        <p14:creationId xmlns:p14="http://schemas.microsoft.com/office/powerpoint/2010/main" val="3210878781"/>
+        <p14:creationId xmlns:p14="http://schemas.microsoft.com/office/powerpoint/2010/main" val="4115470478"/>
       </p:ext>
     </p:extLst>
   </p:cSld>
@@ -1236,7 +1237,7 @@
           <p:cNvPr id="2" name="Titel 1">
             <a:extLst>
               <a:ext uri="{FF2B5EF4-FFF2-40B4-BE49-F238E27FC236}">
-                <a16:creationId xmlns:a16="http://schemas.microsoft.com/office/drawing/2014/main" id="{D6F10CF9-5D62-997A-8C38-543F951F4C60}"/>
+                <a16:creationId xmlns:a16="http://schemas.microsoft.com/office/drawing/2014/main" id="{2B1BD50E-ADD5-80EE-58E3-46E002766AD8}"/>
               </a:ext>
             </a:extLst>
           </p:cNvPr>
@@ -1264,7 +1265,7 @@
           <p:cNvPr id="3" name="Inhaltsplatzhalter 2">
             <a:extLst>
               <a:ext uri="{FF2B5EF4-FFF2-40B4-BE49-F238E27FC236}">
-                <a16:creationId xmlns:a16="http://schemas.microsoft.com/office/drawing/2014/main" id="{EA668153-DF90-70B7-EACF-6C75D75F46FB}"/>
+                <a16:creationId xmlns:a16="http://schemas.microsoft.com/office/drawing/2014/main" id="{0078AAF4-ECF4-7DBB-553A-BBAC398179C7}"/>
               </a:ext>
             </a:extLst>
           </p:cNvPr>
@@ -1326,7 +1327,7 @@
           <p:cNvPr id="4" name="Inhaltsplatzhalter 3">
             <a:extLst>
               <a:ext uri="{FF2B5EF4-FFF2-40B4-BE49-F238E27FC236}">
-                <a16:creationId xmlns:a16="http://schemas.microsoft.com/office/drawing/2014/main" id="{126AB400-226C-6FA4-97ED-50EABC00FB5B}"/>
+                <a16:creationId xmlns:a16="http://schemas.microsoft.com/office/drawing/2014/main" id="{D920A715-F07A-156B-104C-A20B88C471D6}"/>
               </a:ext>
             </a:extLst>
           </p:cNvPr>
@@ -1388,7 +1389,7 @@
           <p:cNvPr id="5" name="Datumsplatzhalter 4">
             <a:extLst>
               <a:ext uri="{FF2B5EF4-FFF2-40B4-BE49-F238E27FC236}">
-                <a16:creationId xmlns:a16="http://schemas.microsoft.com/office/drawing/2014/main" id="{E5C4E21D-59B4-A695-D6E1-A1EBEE262A72}"/>
+                <a16:creationId xmlns:a16="http://schemas.microsoft.com/office/drawing/2014/main" id="{3C5F5F7E-936B-7A0F-30D3-1385CF14FE1B}"/>
               </a:ext>
             </a:extLst>
           </p:cNvPr>
@@ -1404,7 +1405,7 @@
           <a:bodyPr/>
           <a:lstStyle/>
           <a:p>
-            <a:fld id="{F27B871D-E315-469F-BF57-7629DB4D7F4D}" type="datetimeFigureOut">
+            <a:fld id="{4865B0A2-5436-4E13-91FA-8671EA735516}" type="datetimeFigureOut">
               <a:rPr lang="de-DE" smtClean="0"/>
               <a:t>08.10.2026</a:t>
             </a:fld>
@@ -1417,7 +1418,7 @@
           <p:cNvPr id="6" name="Fußzeilenplatzhalter 5">
             <a:extLst>
               <a:ext uri="{FF2B5EF4-FFF2-40B4-BE49-F238E27FC236}">
-                <a16:creationId xmlns:a16="http://schemas.microsoft.com/office/drawing/2014/main" id="{C534C3C9-4322-62DB-AE0C-7F6ABF6A77DD}"/>
+                <a16:creationId xmlns:a16="http://schemas.microsoft.com/office/drawing/2014/main" id="{A7AFA412-65F5-1442-DA4B-516D82A96A4A}"/>
               </a:ext>
             </a:extLst>
           </p:cNvPr>
@@ -1442,7 +1443,7 @@
           <p:cNvPr id="7" name="Foliennummernplatzhalter 6">
             <a:extLst>
               <a:ext uri="{FF2B5EF4-FFF2-40B4-BE49-F238E27FC236}">
-                <a16:creationId xmlns:a16="http://schemas.microsoft.com/office/drawing/2014/main" id="{71A6434F-6C72-D9EB-9B9E-14EE8EE40E73}"/>
+                <a16:creationId xmlns:a16="http://schemas.microsoft.com/office/drawing/2014/main" id="{196FABBC-F746-9BC9-968C-BAA9BAA9920A}"/>
               </a:ext>
             </a:extLst>
           </p:cNvPr>
@@ -1458,7 +1459,7 @@
           <a:bodyPr/>
           <a:lstStyle/>
           <a:p>
-            <a:fld id="{4384185C-CA1D-4D64-B747-FEE1A56E57CB}" type="slidenum">
+            <a:fld id="{44BE951E-0096-43E3-935D-E21731B98C07}" type="slidenum">
               <a:rPr lang="de-DE" smtClean="0"/>
               <a:t>‹Nr.›</a:t>
             </a:fld>
@@ -1469,7 +1470,7 @@
     </p:spTree>
     <p:extLst>
       <p:ext uri="{BB962C8B-B14F-4D97-AF65-F5344CB8AC3E}">
-        <p14:creationId xmlns:p14="http://schemas.microsoft.com/office/powerpoint/2010/main" val="3991258416"/>
+        <p14:creationId xmlns:p14="http://schemas.microsoft.com/office/powerpoint/2010/main" val="3642104851"/>
       </p:ext>
     </p:extLst>
   </p:cSld>
@@ -1501,7 +1502,7 @@
           <p:cNvPr id="2" name="Titel 1">
             <a:extLst>
               <a:ext uri="{FF2B5EF4-FFF2-40B4-BE49-F238E27FC236}">
-                <a16:creationId xmlns:a16="http://schemas.microsoft.com/office/drawing/2014/main" id="{1575BA84-151B-0610-426F-24FFDBB1EEEE}"/>
+                <a16:creationId xmlns:a16="http://schemas.microsoft.com/office/drawing/2014/main" id="{465AB78A-6A3B-3AD4-A8C3-0188149424C0}"/>
               </a:ext>
             </a:extLst>
           </p:cNvPr>
@@ -1534,7 +1535,7 @@
           <p:cNvPr id="3" name="Textplatzhalter 2">
             <a:extLst>
               <a:ext uri="{FF2B5EF4-FFF2-40B4-BE49-F238E27FC236}">
-                <a16:creationId xmlns:a16="http://schemas.microsoft.com/office/drawing/2014/main" id="{E78FCC7E-8C1D-E261-528F-748ADB26715F}"/>
+                <a16:creationId xmlns:a16="http://schemas.microsoft.com/office/drawing/2014/main" id="{9F27608A-0572-1C78-CEBD-70A481D58A62}"/>
               </a:ext>
             </a:extLst>
           </p:cNvPr>
@@ -1605,7 +1606,7 @@
           <p:cNvPr id="4" name="Inhaltsplatzhalter 3">
             <a:extLst>
               <a:ext uri="{FF2B5EF4-FFF2-40B4-BE49-F238E27FC236}">
-                <a16:creationId xmlns:a16="http://schemas.microsoft.com/office/drawing/2014/main" id="{5300CACF-061C-C1F1-6ED6-70DE7414BBC8}"/>
+                <a16:creationId xmlns:a16="http://schemas.microsoft.com/office/drawing/2014/main" id="{C28A25F2-B77C-87EB-0C47-BEECAF4FDC6C}"/>
               </a:ext>
             </a:extLst>
           </p:cNvPr>
@@ -1667,7 +1668,7 @@
           <p:cNvPr id="5" name="Textplatzhalter 4">
             <a:extLst>
               <a:ext uri="{FF2B5EF4-FFF2-40B4-BE49-F238E27FC236}">
-                <a16:creationId xmlns:a16="http://schemas.microsoft.com/office/drawing/2014/main" id="{436C4C8E-E96B-912E-35CD-EF30C8C563D9}"/>
+                <a16:creationId xmlns:a16="http://schemas.microsoft.com/office/drawing/2014/main" id="{83F2618C-3A1C-E242-CB9E-255AEF65B3FB}"/>
               </a:ext>
             </a:extLst>
           </p:cNvPr>
@@ -1738,7 +1739,7 @@
           <p:cNvPr id="6" name="Inhaltsplatzhalter 5">
             <a:extLst>
               <a:ext uri="{FF2B5EF4-FFF2-40B4-BE49-F238E27FC236}">
-                <a16:creationId xmlns:a16="http://schemas.microsoft.com/office/drawing/2014/main" id="{1200B2B1-FA3B-2B08-93AD-BB2928A19899}"/>
+                <a16:creationId xmlns:a16="http://schemas.microsoft.com/office/drawing/2014/main" id="{A87B8685-2654-DEF0-8292-2F29FE533205}"/>
               </a:ext>
             </a:extLst>
           </p:cNvPr>
@@ -1800,7 +1801,7 @@
           <p:cNvPr id="7" name="Datumsplatzhalter 6">
             <a:extLst>
               <a:ext uri="{FF2B5EF4-FFF2-40B4-BE49-F238E27FC236}">
-                <a16:creationId xmlns:a16="http://schemas.microsoft.com/office/drawing/2014/main" id="{E54F4E43-D5E2-E281-9C91-50A439B54931}"/>
+                <a16:creationId xmlns:a16="http://schemas.microsoft.com/office/drawing/2014/main" id="{488ECD43-E0FC-03E9-8DF7-518D6545EE45}"/>
               </a:ext>
             </a:extLst>
           </p:cNvPr>
@@ -1816,7 +1817,7 @@
           <a:bodyPr/>
           <a:lstStyle/>
           <a:p>
-            <a:fld id="{F27B871D-E315-469F-BF57-7629DB4D7F4D}" type="datetimeFigureOut">
+            <a:fld id="{4865B0A2-5436-4E13-91FA-8671EA735516}" type="datetimeFigureOut">
               <a:rPr lang="de-DE" smtClean="0"/>
               <a:t>08.10.2026</a:t>
             </a:fld>
@@ -1829,7 +1830,7 @@
           <p:cNvPr id="8" name="Fußzeilenplatzhalter 7">
             <a:extLst>
               <a:ext uri="{FF2B5EF4-FFF2-40B4-BE49-F238E27FC236}">
-                <a16:creationId xmlns:a16="http://schemas.microsoft.com/office/drawing/2014/main" id="{CBA448B6-A855-802A-A323-DE926851A7FA}"/>
+                <a16:creationId xmlns:a16="http://schemas.microsoft.com/office/drawing/2014/main" id="{C41AF9F1-D108-01C7-AA50-382BA91700A7}"/>
               </a:ext>
             </a:extLst>
           </p:cNvPr>
@@ -1854,7 +1855,7 @@
           <p:cNvPr id="9" name="Foliennummernplatzhalter 8">
             <a:extLst>
               <a:ext uri="{FF2B5EF4-FFF2-40B4-BE49-F238E27FC236}">
-                <a16:creationId xmlns:a16="http://schemas.microsoft.com/office/drawing/2014/main" id="{0FD203FD-B326-30D2-0DAD-5DDD32241CB2}"/>
+                <a16:creationId xmlns:a16="http://schemas.microsoft.com/office/drawing/2014/main" id="{F0CAD56D-51BE-A9AF-8C29-02539B876308}"/>
               </a:ext>
             </a:extLst>
           </p:cNvPr>
@@ -1870,7 +1871,7 @@
           <a:bodyPr/>
           <a:lstStyle/>
           <a:p>
-            <a:fld id="{4384185C-CA1D-4D64-B747-FEE1A56E57CB}" type="slidenum">
+            <a:fld id="{44BE951E-0096-43E3-935D-E21731B98C07}" type="slidenum">
               <a:rPr lang="de-DE" smtClean="0"/>
               <a:t>‹Nr.›</a:t>
             </a:fld>
@@ -1881,7 +1882,7 @@
     </p:spTree>
     <p:extLst>
       <p:ext uri="{BB962C8B-B14F-4D97-AF65-F5344CB8AC3E}">
-        <p14:creationId xmlns:p14="http://schemas.microsoft.com/office/powerpoint/2010/main" val="1845825899"/>
+        <p14:creationId xmlns:p14="http://schemas.microsoft.com/office/powerpoint/2010/main" val="486906432"/>
       </p:ext>
     </p:extLst>
   </p:cSld>
@@ -1913,7 +1914,7 @@
           <p:cNvPr id="2" name="Titel 1">
             <a:extLst>
               <a:ext uri="{FF2B5EF4-FFF2-40B4-BE49-F238E27FC236}">
-                <a16:creationId xmlns:a16="http://schemas.microsoft.com/office/drawing/2014/main" id="{57B9A2BA-9B50-FDEB-4182-49D6E7120A95}"/>
+                <a16:creationId xmlns:a16="http://schemas.microsoft.com/office/drawing/2014/main" id="{8B495AD8-0B89-2BB0-BADF-186F7B0822A9}"/>
               </a:ext>
             </a:extLst>
           </p:cNvPr>
@@ -1941,7 +1942,7 @@
           <p:cNvPr id="3" name="Datumsplatzhalter 2">
             <a:extLst>
               <a:ext uri="{FF2B5EF4-FFF2-40B4-BE49-F238E27FC236}">
-                <a16:creationId xmlns:a16="http://schemas.microsoft.com/office/drawing/2014/main" id="{A499734E-0542-DD01-FF3D-BB87498ACA15}"/>
+                <a16:creationId xmlns:a16="http://schemas.microsoft.com/office/drawing/2014/main" id="{FB8ECB95-C7D7-DE53-F43E-396B3F0B2CDE}"/>
               </a:ext>
             </a:extLst>
           </p:cNvPr>
@@ -1957,7 +1958,7 @@
           <a:bodyPr/>
           <a:lstStyle/>
           <a:p>
-            <a:fld id="{F27B871D-E315-469F-BF57-7629DB4D7F4D}" type="datetimeFigureOut">
+            <a:fld id="{4865B0A2-5436-4E13-91FA-8671EA735516}" type="datetimeFigureOut">
               <a:rPr lang="de-DE" smtClean="0"/>
               <a:t>08.10.2026</a:t>
             </a:fld>
@@ -1970,7 +1971,7 @@
           <p:cNvPr id="4" name="Fußzeilenplatzhalter 3">
             <a:extLst>
               <a:ext uri="{FF2B5EF4-FFF2-40B4-BE49-F238E27FC236}">
-                <a16:creationId xmlns:a16="http://schemas.microsoft.com/office/drawing/2014/main" id="{2CCF2ED4-7B38-60EB-FAA5-DF0D0F5FCDEF}"/>
+                <a16:creationId xmlns:a16="http://schemas.microsoft.com/office/drawing/2014/main" id="{C1F61E22-3961-8726-EB4E-C7A904BAF8FA}"/>
               </a:ext>
             </a:extLst>
           </p:cNvPr>
@@ -1995,7 +1996,7 @@
           <p:cNvPr id="5" name="Foliennummernplatzhalter 4">
             <a:extLst>
               <a:ext uri="{FF2B5EF4-FFF2-40B4-BE49-F238E27FC236}">
-                <a16:creationId xmlns:a16="http://schemas.microsoft.com/office/drawing/2014/main" id="{BE120CFA-378B-06C9-FD00-9DE6D103E939}"/>
+                <a16:creationId xmlns:a16="http://schemas.microsoft.com/office/drawing/2014/main" id="{125D6EA2-8412-ABC6-2FF8-DB002B390B4E}"/>
               </a:ext>
             </a:extLst>
           </p:cNvPr>
@@ -2011,7 +2012,7 @@
           <a:bodyPr/>
           <a:lstStyle/>
           <a:p>
-            <a:fld id="{4384185C-CA1D-4D64-B747-FEE1A56E57CB}" type="slidenum">
+            <a:fld id="{44BE951E-0096-43E3-935D-E21731B98C07}" type="slidenum">
               <a:rPr lang="de-DE" smtClean="0"/>
               <a:t>‹Nr.›</a:t>
             </a:fld>
@@ -2022,7 +2023,7 @@
     </p:spTree>
     <p:extLst>
       <p:ext uri="{BB962C8B-B14F-4D97-AF65-F5344CB8AC3E}">
-        <p14:creationId xmlns:p14="http://schemas.microsoft.com/office/powerpoint/2010/main" val="2165758644"/>
+        <p14:creationId xmlns:p14="http://schemas.microsoft.com/office/powerpoint/2010/main" val="2856277011"/>
       </p:ext>
     </p:extLst>
   </p:cSld>
@@ -2054,7 +2055,7 @@
           <p:cNvPr id="2" name="Datumsplatzhalter 1">
             <a:extLst>
               <a:ext uri="{FF2B5EF4-FFF2-40B4-BE49-F238E27FC236}">
-                <a16:creationId xmlns:a16="http://schemas.microsoft.com/office/drawing/2014/main" id="{E9467512-21EA-F3B2-5520-0D2F502FBA58}"/>
+                <a16:creationId xmlns:a16="http://schemas.microsoft.com/office/drawing/2014/main" id="{C8C060C0-0EA9-AB78-FF60-7138C931B250}"/>
               </a:ext>
             </a:extLst>
           </p:cNvPr>
@@ -2070,7 +2071,7 @@
           <a:bodyPr/>
           <a:lstStyle/>
           <a:p>
-            <a:fld id="{F27B871D-E315-469F-BF57-7629DB4D7F4D}" type="datetimeFigureOut">
+            <a:fld id="{4865B0A2-5436-4E13-91FA-8671EA735516}" type="datetimeFigureOut">
               <a:rPr lang="de-DE" smtClean="0"/>
               <a:t>08.10.2026</a:t>
             </a:fld>
@@ -2083,7 +2084,7 @@
           <p:cNvPr id="3" name="Fußzeilenplatzhalter 2">
             <a:extLst>
               <a:ext uri="{FF2B5EF4-FFF2-40B4-BE49-F238E27FC236}">
-                <a16:creationId xmlns:a16="http://schemas.microsoft.com/office/drawing/2014/main" id="{222A0A02-EE3E-8076-D79A-B5554CF5DD07}"/>
+                <a16:creationId xmlns:a16="http://schemas.microsoft.com/office/drawing/2014/main" id="{79A1E215-E94F-438C-DB60-496D27C96C88}"/>
               </a:ext>
             </a:extLst>
           </p:cNvPr>
@@ -2108,7 +2109,7 @@
           <p:cNvPr id="4" name="Foliennummernplatzhalter 3">
             <a:extLst>
               <a:ext uri="{FF2B5EF4-FFF2-40B4-BE49-F238E27FC236}">
-                <a16:creationId xmlns:a16="http://schemas.microsoft.com/office/drawing/2014/main" id="{73AC7FE9-FA55-ABA3-CE4F-DAD689B890B4}"/>
+                <a16:creationId xmlns:a16="http://schemas.microsoft.com/office/drawing/2014/main" id="{D12EC338-AE95-707A-910D-37ECEE40D61A}"/>
               </a:ext>
             </a:extLst>
           </p:cNvPr>
@@ -2124,7 +2125,7 @@
           <a:bodyPr/>
           <a:lstStyle/>
           <a:p>
-            <a:fld id="{4384185C-CA1D-4D64-B747-FEE1A56E57CB}" type="slidenum">
+            <a:fld id="{44BE951E-0096-43E3-935D-E21731B98C07}" type="slidenum">
               <a:rPr lang="de-DE" smtClean="0"/>
               <a:t>‹Nr.›</a:t>
             </a:fld>
@@ -2135,7 +2136,7 @@
     </p:spTree>
     <p:extLst>
       <p:ext uri="{BB962C8B-B14F-4D97-AF65-F5344CB8AC3E}">
-        <p14:creationId xmlns:p14="http://schemas.microsoft.com/office/powerpoint/2010/main" val="2863925227"/>
+        <p14:creationId xmlns:p14="http://schemas.microsoft.com/office/powerpoint/2010/main" val="3218750571"/>
       </p:ext>
     </p:extLst>
   </p:cSld>
@@ -2167,7 +2168,7 @@
           <p:cNvPr id="2" name="Titel 1">
             <a:extLst>
               <a:ext uri="{FF2B5EF4-FFF2-40B4-BE49-F238E27FC236}">
-                <a16:creationId xmlns:a16="http://schemas.microsoft.com/office/drawing/2014/main" id="{AC6B9428-9CE9-8DFE-A210-CA2DCC3E36EF}"/>
+                <a16:creationId xmlns:a16="http://schemas.microsoft.com/office/drawing/2014/main" id="{451B2D73-4ADC-E0C4-93B0-B1F36F973DED}"/>
               </a:ext>
             </a:extLst>
           </p:cNvPr>
@@ -2204,7 +2205,7 @@
           <p:cNvPr id="3" name="Inhaltsplatzhalter 2">
             <a:extLst>
               <a:ext uri="{FF2B5EF4-FFF2-40B4-BE49-F238E27FC236}">
-                <a16:creationId xmlns:a16="http://schemas.microsoft.com/office/drawing/2014/main" id="{AC5B6076-9E51-4C95-BB1C-C642AD36CCCE}"/>
+                <a16:creationId xmlns:a16="http://schemas.microsoft.com/office/drawing/2014/main" id="{F12CF347-A822-7267-BA97-93DB2523107F}"/>
               </a:ext>
             </a:extLst>
           </p:cNvPr>
@@ -2294,7 +2295,7 @@
           <p:cNvPr id="4" name="Textplatzhalter 3">
             <a:extLst>
               <a:ext uri="{FF2B5EF4-FFF2-40B4-BE49-F238E27FC236}">
-                <a16:creationId xmlns:a16="http://schemas.microsoft.com/office/drawing/2014/main" id="{07F8BC55-EF9A-1C25-F377-C2893B40B7DA}"/>
+                <a16:creationId xmlns:a16="http://schemas.microsoft.com/office/drawing/2014/main" id="{568836B4-6187-07CB-0AFD-6C70DD122AEF}"/>
               </a:ext>
             </a:extLst>
           </p:cNvPr>
@@ -2365,7 +2366,7 @@
           <p:cNvPr id="5" name="Datumsplatzhalter 4">
             <a:extLst>
               <a:ext uri="{FF2B5EF4-FFF2-40B4-BE49-F238E27FC236}">
-                <a16:creationId xmlns:a16="http://schemas.microsoft.com/office/drawing/2014/main" id="{8A2AF94D-1ECC-E76F-EADA-F55E8AD76865}"/>
+                <a16:creationId xmlns:a16="http://schemas.microsoft.com/office/drawing/2014/main" id="{C04E247C-CAAF-7E99-3B18-E909A1D47FE6}"/>
               </a:ext>
             </a:extLst>
           </p:cNvPr>
@@ -2381,7 +2382,7 @@
           <a:bodyPr/>
           <a:lstStyle/>
           <a:p>
-            <a:fld id="{F27B871D-E315-469F-BF57-7629DB4D7F4D}" type="datetimeFigureOut">
+            <a:fld id="{4865B0A2-5436-4E13-91FA-8671EA735516}" type="datetimeFigureOut">
               <a:rPr lang="de-DE" smtClean="0"/>
               <a:t>08.10.2026</a:t>
             </a:fld>
@@ -2394,7 +2395,7 @@
           <p:cNvPr id="6" name="Fußzeilenplatzhalter 5">
             <a:extLst>
               <a:ext uri="{FF2B5EF4-FFF2-40B4-BE49-F238E27FC236}">
-                <a16:creationId xmlns:a16="http://schemas.microsoft.com/office/drawing/2014/main" id="{576F954B-52A6-4F9E-2772-75DB5189EA7A}"/>
+                <a16:creationId xmlns:a16="http://schemas.microsoft.com/office/drawing/2014/main" id="{4886C3C1-00E5-8AF3-3182-1AC18586F401}"/>
               </a:ext>
             </a:extLst>
           </p:cNvPr>
@@ -2419,7 +2420,7 @@
           <p:cNvPr id="7" name="Foliennummernplatzhalter 6">
             <a:extLst>
               <a:ext uri="{FF2B5EF4-FFF2-40B4-BE49-F238E27FC236}">
-                <a16:creationId xmlns:a16="http://schemas.microsoft.com/office/drawing/2014/main" id="{EAA0DB12-D714-7FF5-E1F0-1DE9CBF660F1}"/>
+                <a16:creationId xmlns:a16="http://schemas.microsoft.com/office/drawing/2014/main" id="{69494465-747B-27B1-0C1B-7340AA8AA196}"/>
               </a:ext>
             </a:extLst>
           </p:cNvPr>
@@ -2435,7 +2436,7 @@
           <a:bodyPr/>
           <a:lstStyle/>
           <a:p>
-            <a:fld id="{4384185C-CA1D-4D64-B747-FEE1A56E57CB}" type="slidenum">
+            <a:fld id="{44BE951E-0096-43E3-935D-E21731B98C07}" type="slidenum">
               <a:rPr lang="de-DE" smtClean="0"/>
               <a:t>‹Nr.›</a:t>
             </a:fld>
@@ -2446,7 +2447,7 @@
     </p:spTree>
     <p:extLst>
       <p:ext uri="{BB962C8B-B14F-4D97-AF65-F5344CB8AC3E}">
-        <p14:creationId xmlns:p14="http://schemas.microsoft.com/office/powerpoint/2010/main" val="4241391703"/>
+        <p14:creationId xmlns:p14="http://schemas.microsoft.com/office/powerpoint/2010/main" val="2320170575"/>
       </p:ext>
     </p:extLst>
   </p:cSld>
@@ -2478,7 +2479,7 @@
           <p:cNvPr id="2" name="Titel 1">
             <a:extLst>
               <a:ext uri="{FF2B5EF4-FFF2-40B4-BE49-F238E27FC236}">
-                <a16:creationId xmlns:a16="http://schemas.microsoft.com/office/drawing/2014/main" id="{F4524063-9A45-F19E-8DD2-F82814C2D5FC}"/>
+                <a16:creationId xmlns:a16="http://schemas.microsoft.com/office/drawing/2014/main" id="{77C20D71-187C-AF4B-2029-F77CF7EDEBF4}"/>
               </a:ext>
             </a:extLst>
           </p:cNvPr>
@@ -2515,7 +2516,7 @@
           <p:cNvPr id="3" name="Bildplatzhalter 2">
             <a:extLst>
               <a:ext uri="{FF2B5EF4-FFF2-40B4-BE49-F238E27FC236}">
-                <a16:creationId xmlns:a16="http://schemas.microsoft.com/office/drawing/2014/main" id="{05324348-40C6-18E5-F199-F9CCD3A8154F}"/>
+                <a16:creationId xmlns:a16="http://schemas.microsoft.com/office/drawing/2014/main" id="{03803851-DBFD-B29C-C606-D9EC45BBC8EB}"/>
               </a:ext>
             </a:extLst>
           </p:cNvPr>
@@ -2582,7 +2583,7 @@
           <p:cNvPr id="4" name="Textplatzhalter 3">
             <a:extLst>
               <a:ext uri="{FF2B5EF4-FFF2-40B4-BE49-F238E27FC236}">
-                <a16:creationId xmlns:a16="http://schemas.microsoft.com/office/drawing/2014/main" id="{365C1F6A-1A5B-ACB9-3EFE-39CFC338F6B4}"/>
+                <a16:creationId xmlns:a16="http://schemas.microsoft.com/office/drawing/2014/main" id="{D8EE6492-2CB8-87A5-F9FF-86847A1F9504}"/>
               </a:ext>
             </a:extLst>
           </p:cNvPr>
@@ -2653,7 +2654,7 @@
           <p:cNvPr id="5" name="Datumsplatzhalter 4">
             <a:extLst>
               <a:ext uri="{FF2B5EF4-FFF2-40B4-BE49-F238E27FC236}">
-                <a16:creationId xmlns:a16="http://schemas.microsoft.com/office/drawing/2014/main" id="{53DB9755-5ED1-0ADE-F086-242DD7B996EF}"/>
+                <a16:creationId xmlns:a16="http://schemas.microsoft.com/office/drawing/2014/main" id="{B60B1D4D-0DB3-CAE3-C50A-0EB5893F238B}"/>
               </a:ext>
             </a:extLst>
           </p:cNvPr>
@@ -2669,7 +2670,7 @@
           <a:bodyPr/>
           <a:lstStyle/>
           <a:p>
-            <a:fld id="{F27B871D-E315-469F-BF57-7629DB4D7F4D}" type="datetimeFigureOut">
+            <a:fld id="{4865B0A2-5436-4E13-91FA-8671EA735516}" type="datetimeFigureOut">
               <a:rPr lang="de-DE" smtClean="0"/>
               <a:t>08.10.2026</a:t>
             </a:fld>
@@ -2682,7 +2683,7 @@
           <p:cNvPr id="6" name="Fußzeilenplatzhalter 5">
             <a:extLst>
               <a:ext uri="{FF2B5EF4-FFF2-40B4-BE49-F238E27FC236}">
-                <a16:creationId xmlns:a16="http://schemas.microsoft.com/office/drawing/2014/main" id="{1D63573D-6A38-13C9-B75E-877BF5CCF0C7}"/>
+                <a16:creationId xmlns:a16="http://schemas.microsoft.com/office/drawing/2014/main" id="{059D5BFE-90B1-EB1F-221E-708B5D0BBEA3}"/>
               </a:ext>
             </a:extLst>
           </p:cNvPr>
@@ -2707,7 +2708,7 @@
           <p:cNvPr id="7" name="Foliennummernplatzhalter 6">
             <a:extLst>
               <a:ext uri="{FF2B5EF4-FFF2-40B4-BE49-F238E27FC236}">
-                <a16:creationId xmlns:a16="http://schemas.microsoft.com/office/drawing/2014/main" id="{DED6925B-72E9-63EF-F7D1-6CEA8AA97F1A}"/>
+                <a16:creationId xmlns:a16="http://schemas.microsoft.com/office/drawing/2014/main" id="{0DD6277C-71C7-9EB4-2715-47BEC9699FB3}"/>
               </a:ext>
             </a:extLst>
           </p:cNvPr>
@@ -2723,7 +2724,7 @@
           <a:bodyPr/>
           <a:lstStyle/>
           <a:p>
-            <a:fld id="{4384185C-CA1D-4D64-B747-FEE1A56E57CB}" type="slidenum">
+            <a:fld id="{44BE951E-0096-43E3-935D-E21731B98C07}" type="slidenum">
               <a:rPr lang="de-DE" smtClean="0"/>
               <a:t>‹Nr.›</a:t>
             </a:fld>
@@ -2734,7 +2735,7 @@
     </p:spTree>
     <p:extLst>
       <p:ext uri="{BB962C8B-B14F-4D97-AF65-F5344CB8AC3E}">
-        <p14:creationId xmlns:p14="http://schemas.microsoft.com/office/powerpoint/2010/main" val="703854368"/>
+        <p14:creationId xmlns:p14="http://schemas.microsoft.com/office/powerpoint/2010/main" val="3815187276"/>
       </p:ext>
     </p:extLst>
   </p:cSld>
@@ -2771,7 +2772,7 @@
           <p:cNvPr id="2" name="Titelplatzhalter 1">
             <a:extLst>
               <a:ext uri="{FF2B5EF4-FFF2-40B4-BE49-F238E27FC236}">
-                <a16:creationId xmlns:a16="http://schemas.microsoft.com/office/drawing/2014/main" id="{36226261-8218-434A-24B9-BCA6922EF4D0}"/>
+                <a16:creationId xmlns:a16="http://schemas.microsoft.com/office/drawing/2014/main" id="{1B58C65A-DF89-7014-E69F-A44B0A7992FA}"/>
               </a:ext>
             </a:extLst>
           </p:cNvPr>
@@ -2809,7 +2810,7 @@
           <p:cNvPr id="3" name="Textplatzhalter 2">
             <a:extLst>
               <a:ext uri="{FF2B5EF4-FFF2-40B4-BE49-F238E27FC236}">
-                <a16:creationId xmlns:a16="http://schemas.microsoft.com/office/drawing/2014/main" id="{2267F6FC-120E-60E3-8E79-AE74631C28F8}"/>
+                <a16:creationId xmlns:a16="http://schemas.microsoft.com/office/drawing/2014/main" id="{E71E5C8C-DC3B-EBA6-322D-C43F7DA2DBA5}"/>
               </a:ext>
             </a:extLst>
           </p:cNvPr>
@@ -2876,7 +2877,7 @@
           <p:cNvPr id="4" name="Datumsplatzhalter 3">
             <a:extLst>
               <a:ext uri="{FF2B5EF4-FFF2-40B4-BE49-F238E27FC236}">
-                <a16:creationId xmlns:a16="http://schemas.microsoft.com/office/drawing/2014/main" id="{92C6048B-69BA-7FC7-7EAB-01287EE9C156}"/>
+                <a16:creationId xmlns:a16="http://schemas.microsoft.com/office/drawing/2014/main" id="{96ABD1CF-0D8A-2214-C853-119F966590F4}"/>
               </a:ext>
             </a:extLst>
           </p:cNvPr>
@@ -2910,7 +2911,7 @@
             </a:lvl1pPr>
           </a:lstStyle>
           <a:p>
-            <a:fld id="{F27B871D-E315-469F-BF57-7629DB4D7F4D}" type="datetimeFigureOut">
+            <a:fld id="{4865B0A2-5436-4E13-91FA-8671EA735516}" type="datetimeFigureOut">
               <a:rPr lang="de-DE" smtClean="0"/>
               <a:t>08.10.2026</a:t>
             </a:fld>
@@ -2923,7 +2924,7 @@
           <p:cNvPr id="5" name="Fußzeilenplatzhalter 4">
             <a:extLst>
               <a:ext uri="{FF2B5EF4-FFF2-40B4-BE49-F238E27FC236}">
-                <a16:creationId xmlns:a16="http://schemas.microsoft.com/office/drawing/2014/main" id="{77C99940-3E79-E518-6FEF-E2180B01366D}"/>
+                <a16:creationId xmlns:a16="http://schemas.microsoft.com/office/drawing/2014/main" id="{6E7471B5-06D9-65F2-FE87-870592DF04B8}"/>
               </a:ext>
             </a:extLst>
           </p:cNvPr>
@@ -2966,7 +2967,7 @@
           <p:cNvPr id="6" name="Foliennummernplatzhalter 5">
             <a:extLst>
               <a:ext uri="{FF2B5EF4-FFF2-40B4-BE49-F238E27FC236}">
-                <a16:creationId xmlns:a16="http://schemas.microsoft.com/office/drawing/2014/main" id="{5C975AAC-ECAF-ECF3-71FF-C2DC61D87C12}"/>
+                <a16:creationId xmlns:a16="http://schemas.microsoft.com/office/drawing/2014/main" id="{7BDCCFDE-9DBB-FA11-22C2-24A39FCEE00E}"/>
               </a:ext>
             </a:extLst>
           </p:cNvPr>
@@ -3000,7 +3001,7 @@
             </a:lvl1pPr>
           </a:lstStyle>
           <a:p>
-            <a:fld id="{4384185C-CA1D-4D64-B747-FEE1A56E57CB}" type="slidenum">
+            <a:fld id="{44BE951E-0096-43E3-935D-E21731B98C07}" type="slidenum">
               <a:rPr lang="de-DE" smtClean="0"/>
               <a:t>‹Nr.›</a:t>
             </a:fld>
@@ -3011,7 +3012,7 @@
     </p:spTree>
     <p:extLst>
       <p:ext uri="{BB962C8B-B14F-4D97-AF65-F5344CB8AC3E}">
-        <p14:creationId xmlns:p14="http://schemas.microsoft.com/office/powerpoint/2010/main" val="1149621710"/>
+        <p14:creationId xmlns:p14="http://schemas.microsoft.com/office/powerpoint/2010/main" val="633474046"/>
       </p:ext>
     </p:extLst>
   </p:cSld>
@@ -3334,7 +3335,7 @@
           <p:cNvPr id="2" name="Rechteck 1">
             <a:extLst>
               <a:ext uri="{FF2B5EF4-FFF2-40B4-BE49-F238E27FC236}">
-                <a16:creationId xmlns:a16="http://schemas.microsoft.com/office/drawing/2014/main" id="{5232595D-5EB0-0482-78BF-7035316C1C62}"/>
+                <a16:creationId xmlns:a16="http://schemas.microsoft.com/office/drawing/2014/main" id="{23959CA3-D325-1784-E61A-559D4FC7B100}"/>
               </a:ext>
             </a:extLst>
           </p:cNvPr>
@@ -3415,7 +3416,7 @@
           <p:cNvPr id="3" name="Rechteck 2">
             <a:extLst>
               <a:ext uri="{FF2B5EF4-FFF2-40B4-BE49-F238E27FC236}">
-                <a16:creationId xmlns:a16="http://schemas.microsoft.com/office/drawing/2014/main" id="{70C7600A-5DAA-9E56-1483-41F019AC1E15}"/>
+                <a16:creationId xmlns:a16="http://schemas.microsoft.com/office/drawing/2014/main" id="{17E884F0-0C32-5B31-25EA-EF5BDDBEDB11}"/>
               </a:ext>
             </a:extLst>
           </p:cNvPr>
@@ -3496,7 +3497,7 @@
           <p:cNvPr id="4" name="Rechteck 3">
             <a:extLst>
               <a:ext uri="{FF2B5EF4-FFF2-40B4-BE49-F238E27FC236}">
-                <a16:creationId xmlns:a16="http://schemas.microsoft.com/office/drawing/2014/main" id="{54708EC2-3157-C2C7-719A-ACCA2D090418}"/>
+                <a16:creationId xmlns:a16="http://schemas.microsoft.com/office/drawing/2014/main" id="{964E85DA-29DE-1164-AF33-ADF679799373}"/>
               </a:ext>
             </a:extLst>
           </p:cNvPr>
@@ -3577,7 +3578,7 @@
           <p:cNvPr id="5" name="Rechteck 4">
             <a:extLst>
               <a:ext uri="{FF2B5EF4-FFF2-40B4-BE49-F238E27FC236}">
-                <a16:creationId xmlns:a16="http://schemas.microsoft.com/office/drawing/2014/main" id="{B3BC98BB-A8F4-BDF9-82CD-E50AEAD8BC2E}"/>
+                <a16:creationId xmlns:a16="http://schemas.microsoft.com/office/drawing/2014/main" id="{AD89D78C-A350-4939-424D-79444994E45E}"/>
               </a:ext>
             </a:extLst>
           </p:cNvPr>
@@ -3658,7 +3659,7 @@
           <p:cNvPr id="6" name="Rechteck 5">
             <a:extLst>
               <a:ext uri="{FF2B5EF4-FFF2-40B4-BE49-F238E27FC236}">
-                <a16:creationId xmlns:a16="http://schemas.microsoft.com/office/drawing/2014/main" id="{0B2E5006-0765-8183-5969-C200D38BCA06}"/>
+                <a16:creationId xmlns:a16="http://schemas.microsoft.com/office/drawing/2014/main" id="{76CA79CD-4EF2-D280-02BA-6EFB81F92216}"/>
               </a:ext>
             </a:extLst>
           </p:cNvPr>
@@ -3739,7 +3740,7 @@
           <p:cNvPr id="7" name="Rechteck 6">
             <a:extLst>
               <a:ext uri="{FF2B5EF4-FFF2-40B4-BE49-F238E27FC236}">
-                <a16:creationId xmlns:a16="http://schemas.microsoft.com/office/drawing/2014/main" id="{2ED429F0-DADA-B6BC-D5B5-01ED54D146D5}"/>
+                <a16:creationId xmlns:a16="http://schemas.microsoft.com/office/drawing/2014/main" id="{C47A227E-2482-F508-E85C-A9169DF22ED3}"/>
               </a:ext>
             </a:extLst>
           </p:cNvPr>
@@ -3820,7 +3821,7 @@
           <p:cNvPr id="8" name="Rechteck 7">
             <a:extLst>
               <a:ext uri="{FF2B5EF4-FFF2-40B4-BE49-F238E27FC236}">
-                <a16:creationId xmlns:a16="http://schemas.microsoft.com/office/drawing/2014/main" id="{5FAC55C7-9AE4-3161-15E7-CD1E1519B464}"/>
+                <a16:creationId xmlns:a16="http://schemas.microsoft.com/office/drawing/2014/main" id="{FDC0F0EE-A6EC-0399-0B0D-578CC1F87A5F}"/>
               </a:ext>
             </a:extLst>
           </p:cNvPr>
@@ -3899,7 +3900,7 @@
           <p:cNvPr id="9" name="Rechteck 8">
             <a:extLst>
               <a:ext uri="{FF2B5EF4-FFF2-40B4-BE49-F238E27FC236}">
-                <a16:creationId xmlns:a16="http://schemas.microsoft.com/office/drawing/2014/main" id="{2FF6C4AE-7CD2-7DD6-FF44-05AFB050FEA7}"/>
+                <a16:creationId xmlns:a16="http://schemas.microsoft.com/office/drawing/2014/main" id="{1DC38825-5D3D-15AC-F211-1EF1E5821A77}"/>
               </a:ext>
             </a:extLst>
           </p:cNvPr>
@@ -3976,7 +3977,554 @@
     </p:spTree>
     <p:extLst>
       <p:ext uri="{BB962C8B-B14F-4D97-AF65-F5344CB8AC3E}">
-        <p14:creationId xmlns:p14="http://schemas.microsoft.com/office/powerpoint/2010/main" val="3509321800"/>
+        <p14:creationId xmlns:p14="http://schemas.microsoft.com/office/powerpoint/2010/main" val="3704888372"/>
+      </p:ext>
+    </p:extLst>
+  </p:cSld>
+  <p:clrMapOvr>
+    <a:masterClrMapping/>
+  </p:clrMapOvr>
+</p:sld>
+</file>
+
+<file path=ppt/slides/slide10.xml><?xml version="1.0" encoding="utf-8"?>
+<p:sld xmlns:a="http://schemas.openxmlformats.org/drawingml/2006/main" xmlns:r="http://schemas.openxmlformats.org/officeDocument/2006/relationships" xmlns:p="http://schemas.openxmlformats.org/presentationml/2006/main">
+  <p:cSld>
+    <p:spTree>
+      <p:nvGrpSpPr>
+        <p:cNvPr id="1" name=""/>
+        <p:cNvGrpSpPr/>
+        <p:nvPr/>
+      </p:nvGrpSpPr>
+      <p:grpSpPr>
+        <a:xfrm>
+          <a:off x="0" y="0"/>
+          <a:ext cx="0" cy="0"/>
+          <a:chOff x="0" y="0"/>
+          <a:chExt cx="0" cy="0"/>
+        </a:xfrm>
+      </p:grpSpPr>
+      <p:sp>
+        <p:nvSpPr>
+          <p:cNvPr id="2" name="Rechteck 1">
+            <a:extLst>
+              <a:ext uri="{FF2B5EF4-FFF2-40B4-BE49-F238E27FC236}">
+                <a16:creationId xmlns:a16="http://schemas.microsoft.com/office/drawing/2014/main" id="{285DFD11-0711-4013-D971-CDF5CA0AC392}"/>
+              </a:ext>
+            </a:extLst>
+          </p:cNvPr>
+          <p:cNvSpPr/>
+          <p:nvPr/>
+        </p:nvSpPr>
+        <p:spPr>
+          <a:xfrm>
+            <a:off x="762000" y="762000"/>
+            <a:ext cx="2286000" cy="1524000"/>
+          </a:xfrm>
+          <a:prstGeom prst="rect">
+            <a:avLst/>
+          </a:prstGeom>
+          <a:solidFill>
+            <a:srgbClr val="4472C4"/>
+          </a:solidFill>
+          <a:ln w="19050" cap="flat" cmpd="sng" algn="ctr">
+            <a:noFill/>
+            <a:prstDash val="solid"/>
+            <a:miter lim="800000"/>
+          </a:ln>
+          <a:effectLst>
+            <a:outerShdw blurRad="50800" dist="251448" dir="2699995" rotWithShape="0">
+              <a:srgbClr val="000000">
+                <a:alpha val="60000"/>
+              </a:srgbClr>
+            </a:outerShdw>
+          </a:effectLst>
+          <a:scene3d>
+            <a:camera prst="orthographicFront"/>
+            <a:lightRig rig="threePt" dir="t"/>
+          </a:scene3d>
+          <a:sp3d>
+            <a:bevelT w="254000" h="127000"/>
+          </a:sp3d>
+          <a:extLst>
+            <a:ext uri="{91240B29-F687-4F45-9708-019B960494DF}">
+              <a14:hiddenLine xmlns:a14="http://schemas.microsoft.com/office/drawing/2010/main" w="19050" cap="flat" cmpd="sng" algn="ctr">
+                <a:solidFill>
+                  <a:schemeClr val="accent1">
+                    <a:shade val="15000"/>
+                  </a:schemeClr>
+                </a:solidFill>
+                <a:prstDash val="solid"/>
+                <a:miter lim="800000"/>
+              </a14:hiddenLine>
+            </a:ext>
+          </a:extLst>
+        </p:spPr>
+        <p:style>
+          <a:lnRef idx="2">
+            <a:schemeClr val="accent1">
+              <a:shade val="15000"/>
+            </a:schemeClr>
+          </a:lnRef>
+          <a:fillRef idx="1">
+            <a:schemeClr val="accent1"/>
+          </a:fillRef>
+          <a:effectRef idx="0">
+            <a:schemeClr val="accent1"/>
+          </a:effectRef>
+          <a:fontRef idx="minor">
+            <a:schemeClr val="lt1"/>
+          </a:fontRef>
+        </p:style>
+        <p:txBody>
+          <a:bodyPr rtlCol="0" anchor="ctr"/>
+          <a:lstStyle/>
+          <a:p>
+            <a:pPr algn="ctr"/>
+            <a:r>
+              <a:rPr lang="de-DE" sz="1600">
+                <a:solidFill>
+                  <a:srgbClr val="FFFFFF"/>
+                </a:solidFill>
+              </a:rPr>
+              <a:t>Shadow</a:t>
+            </a:r>
+          </a:p>
+        </p:txBody>
+      </p:sp>
+      <p:sp>
+        <p:nvSpPr>
+          <p:cNvPr id="3" name="Rechteck 2">
+            <a:extLst>
+              <a:ext uri="{FF2B5EF4-FFF2-40B4-BE49-F238E27FC236}">
+                <a16:creationId xmlns:a16="http://schemas.microsoft.com/office/drawing/2014/main" id="{DACE8906-7FDA-608A-9532-570C516B1FC8}"/>
+              </a:ext>
+            </a:extLst>
+          </p:cNvPr>
+          <p:cNvSpPr/>
+          <p:nvPr/>
+        </p:nvSpPr>
+        <p:spPr>
+          <a:xfrm>
+            <a:off x="4572000" y="762000"/>
+            <a:ext cx="2286000" cy="1524000"/>
+          </a:xfrm>
+          <a:prstGeom prst="rect">
+            <a:avLst/>
+          </a:prstGeom>
+          <a:solidFill>
+            <a:srgbClr val="4472C4"/>
+          </a:solidFill>
+          <a:ln w="19050" cap="flat" cmpd="sng" algn="ctr">
+            <a:noFill/>
+            <a:prstDash val="solid"/>
+            <a:miter lim="800000"/>
+          </a:ln>
+          <a:effectLst>
+            <a:outerShdw blurRad="50800" dist="251448" dir="2699995" rotWithShape="0">
+              <a:srgbClr val="000000">
+                <a:alpha val="60000"/>
+              </a:srgbClr>
+            </a:outerShdw>
+          </a:effectLst>
+          <a:scene3d>
+            <a:camera prst="isometricLeftDown"/>
+            <a:lightRig rig="threePt" dir="t"/>
+          </a:scene3d>
+          <a:sp3d extrusionH="508000"/>
+          <a:extLst>
+            <a:ext uri="{91240B29-F687-4F45-9708-019B960494DF}">
+              <a14:hiddenLine xmlns:a14="http://schemas.microsoft.com/office/drawing/2010/main" w="19050" cap="flat" cmpd="sng" algn="ctr">
+                <a:solidFill>
+                  <a:schemeClr val="accent1">
+                    <a:shade val="15000"/>
+                  </a:schemeClr>
+                </a:solidFill>
+                <a:prstDash val="solid"/>
+                <a:miter lim="800000"/>
+              </a14:hiddenLine>
+            </a:ext>
+          </a:extLst>
+        </p:spPr>
+        <p:style>
+          <a:lnRef idx="2">
+            <a:schemeClr val="accent1">
+              <a:shade val="15000"/>
+            </a:schemeClr>
+          </a:lnRef>
+          <a:fillRef idx="1">
+            <a:schemeClr val="accent1"/>
+          </a:fillRef>
+          <a:effectRef idx="0">
+            <a:schemeClr val="accent1"/>
+          </a:effectRef>
+          <a:fontRef idx="minor">
+            <a:schemeClr val="lt1"/>
+          </a:fontRef>
+        </p:style>
+        <p:txBody>
+          <a:bodyPr rtlCol="0" anchor="ctr"/>
+          <a:lstStyle/>
+          <a:p>
+            <a:pPr algn="ctr"/>
+            <a:r>
+              <a:rPr lang="de-DE" sz="1600">
+                <a:solidFill>
+                  <a:srgbClr val="FFFFFF"/>
+                </a:solidFill>
+              </a:rPr>
+              <a:t>Shadow</a:t>
+            </a:r>
+          </a:p>
+        </p:txBody>
+      </p:sp>
+      <p:sp>
+        <p:nvSpPr>
+          <p:cNvPr id="4" name="Rechteck 3">
+            <a:extLst>
+              <a:ext uri="{FF2B5EF4-FFF2-40B4-BE49-F238E27FC236}">
+                <a16:creationId xmlns:a16="http://schemas.microsoft.com/office/drawing/2014/main" id="{FD36E13F-95B0-A840-3B8E-221805202AFA}"/>
+              </a:ext>
+            </a:extLst>
+          </p:cNvPr>
+          <p:cNvSpPr/>
+          <p:nvPr/>
+        </p:nvSpPr>
+        <p:spPr>
+          <a:xfrm>
+            <a:off x="8382000" y="762000"/>
+            <a:ext cx="2286000" cy="1524000"/>
+          </a:xfrm>
+          <a:prstGeom prst="rect">
+            <a:avLst/>
+          </a:prstGeom>
+          <a:solidFill>
+            <a:srgbClr val="4472C4"/>
+          </a:solidFill>
+          <a:ln w="19050" cap="flat" cmpd="sng" algn="ctr">
+            <a:noFill/>
+            <a:prstDash val="solid"/>
+            <a:miter lim="800000"/>
+          </a:ln>
+          <a:effectLst>
+            <a:outerShdw blurRad="50800" dist="251448" dir="2699995" rotWithShape="0">
+              <a:srgbClr val="000000">
+                <a:alpha val="60000"/>
+              </a:srgbClr>
+            </a:outerShdw>
+          </a:effectLst>
+          <a:scene3d>
+            <a:camera prst="perspectiveFront">
+              <a:rot lat="0" lon="19200000" rev="0"/>
+            </a:camera>
+            <a:lightRig rig="threePt" dir="t"/>
+          </a:scene3d>
+          <a:extLst>
+            <a:ext uri="{91240B29-F687-4F45-9708-019B960494DF}">
+              <a14:hiddenLine xmlns:a14="http://schemas.microsoft.com/office/drawing/2010/main" w="19050" cap="flat" cmpd="sng" algn="ctr">
+                <a:solidFill>
+                  <a:schemeClr val="accent1">
+                    <a:shade val="15000"/>
+                  </a:schemeClr>
+                </a:solidFill>
+                <a:prstDash val="solid"/>
+                <a:miter lim="800000"/>
+              </a14:hiddenLine>
+            </a:ext>
+          </a:extLst>
+        </p:spPr>
+        <p:style>
+          <a:lnRef idx="2">
+            <a:schemeClr val="accent1">
+              <a:shade val="15000"/>
+            </a:schemeClr>
+          </a:lnRef>
+          <a:fillRef idx="1">
+            <a:schemeClr val="accent1"/>
+          </a:fillRef>
+          <a:effectRef idx="0">
+            <a:schemeClr val="accent1"/>
+          </a:effectRef>
+          <a:fontRef idx="minor">
+            <a:schemeClr val="lt1"/>
+          </a:fontRef>
+        </p:style>
+        <p:txBody>
+          <a:bodyPr rtlCol="0" anchor="ctr"/>
+          <a:lstStyle/>
+          <a:p>
+            <a:pPr algn="ctr"/>
+            <a:r>
+              <a:rPr lang="de-DE" sz="1600">
+                <a:solidFill>
+                  <a:srgbClr val="FFFFFF"/>
+                </a:solidFill>
+              </a:rPr>
+              <a:t>Shadow</a:t>
+            </a:r>
+          </a:p>
+        </p:txBody>
+      </p:sp>
+      <p:sp>
+        <p:nvSpPr>
+          <p:cNvPr id="5" name="Rechteck 4">
+            <a:extLst>
+              <a:ext uri="{FF2B5EF4-FFF2-40B4-BE49-F238E27FC236}">
+                <a16:creationId xmlns:a16="http://schemas.microsoft.com/office/drawing/2014/main" id="{E480A7DA-B479-5D5D-8024-669DD31B8DA6}"/>
+              </a:ext>
+            </a:extLst>
+          </p:cNvPr>
+          <p:cNvSpPr/>
+          <p:nvPr/>
+        </p:nvSpPr>
+        <p:spPr>
+          <a:xfrm>
+            <a:off x="762000" y="3810000"/>
+            <a:ext cx="2286000" cy="1524000"/>
+          </a:xfrm>
+          <a:prstGeom prst="rect">
+            <a:avLst/>
+          </a:prstGeom>
+          <a:solidFill>
+            <a:srgbClr val="4472C4"/>
+          </a:solidFill>
+          <a:ln w="19050" cap="flat" cmpd="sng" algn="ctr">
+            <a:noFill/>
+            <a:prstDash val="solid"/>
+            <a:miter lim="800000"/>
+          </a:ln>
+          <a:effectLst>
+            <a:glow rad="152400">
+              <a:srgbClr val="FFC000"/>
+            </a:glow>
+          </a:effectLst>
+          <a:scene3d>
+            <a:camera prst="isometricLeftDown"/>
+            <a:lightRig rig="threePt" dir="t"/>
+          </a:scene3d>
+          <a:sp3d extrusionH="508000"/>
+          <a:extLst>
+            <a:ext uri="{91240B29-F687-4F45-9708-019B960494DF}">
+              <a14:hiddenLine xmlns:a14="http://schemas.microsoft.com/office/drawing/2010/main" w="19050" cap="flat" cmpd="sng" algn="ctr">
+                <a:solidFill>
+                  <a:schemeClr val="accent1">
+                    <a:shade val="15000"/>
+                  </a:schemeClr>
+                </a:solidFill>
+                <a:prstDash val="solid"/>
+                <a:miter lim="800000"/>
+              </a14:hiddenLine>
+            </a:ext>
+          </a:extLst>
+        </p:spPr>
+        <p:style>
+          <a:lnRef idx="2">
+            <a:schemeClr val="accent1">
+              <a:shade val="15000"/>
+            </a:schemeClr>
+          </a:lnRef>
+          <a:fillRef idx="1">
+            <a:schemeClr val="accent1"/>
+          </a:fillRef>
+          <a:effectRef idx="0">
+            <a:schemeClr val="accent1"/>
+          </a:effectRef>
+          <a:fontRef idx="minor">
+            <a:schemeClr val="lt1"/>
+          </a:fontRef>
+        </p:style>
+        <p:txBody>
+          <a:bodyPr rtlCol="0" anchor="ctr"/>
+          <a:lstStyle/>
+          <a:p>
+            <a:pPr algn="ctr"/>
+            <a:r>
+              <a:rPr lang="de-DE" sz="1600">
+                <a:solidFill>
+                  <a:srgbClr val="FFFFFF"/>
+                </a:solidFill>
+              </a:rPr>
+              <a:t>Glow</a:t>
+            </a:r>
+          </a:p>
+        </p:txBody>
+      </p:sp>
+      <p:sp>
+        <p:nvSpPr>
+          <p:cNvPr id="6" name="Rechteck 5">
+            <a:extLst>
+              <a:ext uri="{FF2B5EF4-FFF2-40B4-BE49-F238E27FC236}">
+                <a16:creationId xmlns:a16="http://schemas.microsoft.com/office/drawing/2014/main" id="{ACA3921F-DABE-5B56-AD49-8C9DF788FA08}"/>
+              </a:ext>
+            </a:extLst>
+          </p:cNvPr>
+          <p:cNvSpPr/>
+          <p:nvPr/>
+        </p:nvSpPr>
+        <p:spPr>
+          <a:xfrm>
+            <a:off x="4572000" y="3810000"/>
+            <a:ext cx="2286000" cy="1524000"/>
+          </a:xfrm>
+          <a:prstGeom prst="rect">
+            <a:avLst/>
+          </a:prstGeom>
+          <a:solidFill>
+            <a:srgbClr val="4472C4"/>
+          </a:solidFill>
+          <a:ln w="19050" cap="flat" cmpd="sng" algn="ctr">
+            <a:noFill/>
+            <a:prstDash val="solid"/>
+            <a:miter lim="800000"/>
+          </a:ln>
+          <a:effectLst>
+            <a:softEdge rad="127000"/>
+          </a:effectLst>
+          <a:scene3d>
+            <a:camera prst="orthographicFront"/>
+            <a:lightRig rig="threePt" dir="t"/>
+          </a:scene3d>
+          <a:sp3d>
+            <a:bevelT w="254000" h="127000"/>
+          </a:sp3d>
+          <a:extLst>
+            <a:ext uri="{91240B29-F687-4F45-9708-019B960494DF}">
+              <a14:hiddenLine xmlns:a14="http://schemas.microsoft.com/office/drawing/2010/main" w="19050" cap="flat" cmpd="sng" algn="ctr">
+                <a:solidFill>
+                  <a:schemeClr val="accent1">
+                    <a:shade val="15000"/>
+                  </a:schemeClr>
+                </a:solidFill>
+                <a:prstDash val="solid"/>
+                <a:miter lim="800000"/>
+              </a14:hiddenLine>
+            </a:ext>
+          </a:extLst>
+        </p:spPr>
+        <p:style>
+          <a:lnRef idx="2">
+            <a:schemeClr val="accent1">
+              <a:shade val="15000"/>
+            </a:schemeClr>
+          </a:lnRef>
+          <a:fillRef idx="1">
+            <a:schemeClr val="accent1"/>
+          </a:fillRef>
+          <a:effectRef idx="0">
+            <a:schemeClr val="accent1"/>
+          </a:effectRef>
+          <a:fontRef idx="minor">
+            <a:schemeClr val="lt1"/>
+          </a:fontRef>
+        </p:style>
+        <p:txBody>
+          <a:bodyPr rtlCol="0" anchor="ctr"/>
+          <a:lstStyle/>
+          <a:p>
+            <a:pPr algn="ctr"/>
+            <a:r>
+              <a:rPr lang="de-DE" sz="1600">
+                <a:solidFill>
+                  <a:srgbClr val="FFFFFF"/>
+                </a:solidFill>
+              </a:rPr>
+              <a:t>Soft edges</a:t>
+            </a:r>
+          </a:p>
+        </p:txBody>
+      </p:sp>
+      <p:sp>
+        <p:nvSpPr>
+          <p:cNvPr id="7" name="Ellipse 6">
+            <a:extLst>
+              <a:ext uri="{FF2B5EF4-FFF2-40B4-BE49-F238E27FC236}">
+                <a16:creationId xmlns:a16="http://schemas.microsoft.com/office/drawing/2014/main" id="{3D607A6C-0914-DF20-716D-EE54EDDAB77B}"/>
+              </a:ext>
+            </a:extLst>
+          </p:cNvPr>
+          <p:cNvSpPr/>
+          <p:nvPr/>
+        </p:nvSpPr>
+        <p:spPr>
+          <a:xfrm>
+            <a:off x="8382000" y="3810000"/>
+            <a:ext cx="2286000" cy="1524000"/>
+          </a:xfrm>
+          <a:prstGeom prst="ellipse">
+            <a:avLst/>
+          </a:prstGeom>
+          <a:solidFill>
+            <a:srgbClr val="4472C4"/>
+          </a:solidFill>
+          <a:ln w="19050" cap="flat" cmpd="sng" algn="ctr">
+            <a:noFill/>
+            <a:prstDash val="solid"/>
+            <a:miter lim="800000"/>
+          </a:ln>
+          <a:effectLst>
+            <a:outerShdw blurRad="50800" dist="251448" dir="2699995" rotWithShape="0">
+              <a:srgbClr val="000000">
+                <a:alpha val="60000"/>
+              </a:srgbClr>
+            </a:outerShdw>
+          </a:effectLst>
+          <a:scene3d>
+            <a:camera prst="perspectiveRelaxed"/>
+            <a:lightRig rig="threePt" dir="t"/>
+          </a:scene3d>
+          <a:sp3d extrusionH="381000">
+            <a:bevelT w="152400" h="101600"/>
+          </a:sp3d>
+          <a:extLst>
+            <a:ext uri="{91240B29-F687-4F45-9708-019B960494DF}">
+              <a14:hiddenLine xmlns:a14="http://schemas.microsoft.com/office/drawing/2010/main" w="19050" cap="flat" cmpd="sng" algn="ctr">
+                <a:solidFill>
+                  <a:schemeClr val="accent1">
+                    <a:shade val="15000"/>
+                  </a:schemeClr>
+                </a:solidFill>
+                <a:prstDash val="solid"/>
+                <a:miter lim="800000"/>
+              </a14:hiddenLine>
+            </a:ext>
+          </a:extLst>
+        </p:spPr>
+        <p:style>
+          <a:lnRef idx="2">
+            <a:schemeClr val="accent1">
+              <a:shade val="15000"/>
+            </a:schemeClr>
+          </a:lnRef>
+          <a:fillRef idx="1">
+            <a:schemeClr val="accent1"/>
+          </a:fillRef>
+          <a:effectRef idx="0">
+            <a:schemeClr val="accent1"/>
+          </a:effectRef>
+          <a:fontRef idx="minor">
+            <a:schemeClr val="lt1"/>
+          </a:fontRef>
+        </p:style>
+        <p:txBody>
+          <a:bodyPr rtlCol="0" anchor="ctr"/>
+          <a:lstStyle/>
+          <a:p>
+            <a:pPr algn="ctr"/>
+            <a:r>
+              <a:rPr lang="de-DE" sz="1600">
+                <a:solidFill>
+                  <a:srgbClr val="FFFFFF"/>
+                </a:solidFill>
+              </a:rPr>
+              <a:t>Shadow</a:t>
+            </a:r>
+          </a:p>
+        </p:txBody>
+      </p:sp>
+    </p:spTree>
+    <p:extLst>
+      <p:ext uri="{BB962C8B-B14F-4D97-AF65-F5344CB8AC3E}">
+        <p14:creationId xmlns:p14="http://schemas.microsoft.com/office/powerpoint/2010/main" val="3001869473"/>
       </p:ext>
     </p:extLst>
   </p:cSld>
@@ -4008,7 +4556,7 @@
           <p:cNvPr id="2" name="Rechteck 1">
             <a:extLst>
               <a:ext uri="{FF2B5EF4-FFF2-40B4-BE49-F238E27FC236}">
-                <a16:creationId xmlns:a16="http://schemas.microsoft.com/office/drawing/2014/main" id="{488F83C2-8A05-E7AE-0623-8D09EA3C90B4}"/>
+                <a16:creationId xmlns:a16="http://schemas.microsoft.com/office/drawing/2014/main" id="{7AE89F09-E737-BCAA-3EEA-31D90C1A861F}"/>
               </a:ext>
             </a:extLst>
           </p:cNvPr>
@@ -4088,7 +4636,7 @@
           <p:cNvPr id="3" name="Ellipse 2">
             <a:extLst>
               <a:ext uri="{FF2B5EF4-FFF2-40B4-BE49-F238E27FC236}">
-                <a16:creationId xmlns:a16="http://schemas.microsoft.com/office/drawing/2014/main" id="{7369ADAF-2BDC-2C28-4903-AA536C8E0E13}"/>
+                <a16:creationId xmlns:a16="http://schemas.microsoft.com/office/drawing/2014/main" id="{81BE0AB2-135A-F95B-CD4D-C4ABCE612D1B}"/>
               </a:ext>
             </a:extLst>
           </p:cNvPr>
@@ -4168,7 +4716,7 @@
           <p:cNvPr id="4" name="Stern: 5 Zacken 3">
             <a:extLst>
               <a:ext uri="{FF2B5EF4-FFF2-40B4-BE49-F238E27FC236}">
-                <a16:creationId xmlns:a16="http://schemas.microsoft.com/office/drawing/2014/main" id="{0433DF84-D397-5F82-B194-350B79F60545}"/>
+                <a16:creationId xmlns:a16="http://schemas.microsoft.com/office/drawing/2014/main" id="{CE9EFA21-4FFA-CEED-85E1-071A8099E2F9}"/>
               </a:ext>
             </a:extLst>
           </p:cNvPr>
@@ -4248,7 +4796,7 @@
           <p:cNvPr id="5" name="Sechseck 4">
             <a:extLst>
               <a:ext uri="{FF2B5EF4-FFF2-40B4-BE49-F238E27FC236}">
-                <a16:creationId xmlns:a16="http://schemas.microsoft.com/office/drawing/2014/main" id="{0485CB82-C31E-BC79-9809-B19A365C2B9B}"/>
+                <a16:creationId xmlns:a16="http://schemas.microsoft.com/office/drawing/2014/main" id="{D5C377B7-B02D-8200-4A23-B5E02822EDD3}"/>
               </a:ext>
             </a:extLst>
           </p:cNvPr>
@@ -4328,7 +4876,7 @@
           <p:cNvPr id="6" name="Rechteck 5">
             <a:extLst>
               <a:ext uri="{FF2B5EF4-FFF2-40B4-BE49-F238E27FC236}">
-                <a16:creationId xmlns:a16="http://schemas.microsoft.com/office/drawing/2014/main" id="{7F0E3521-FC46-BED3-D7ED-492BDA5F7C00}"/>
+                <a16:creationId xmlns:a16="http://schemas.microsoft.com/office/drawing/2014/main" id="{D679F230-D423-2B38-C49B-B359EEEB6157}"/>
               </a:ext>
             </a:extLst>
           </p:cNvPr>
@@ -4408,7 +4956,7 @@
           <p:cNvPr id="7" name="Rechteck: abgerundete Ecken 6">
             <a:extLst>
               <a:ext uri="{FF2B5EF4-FFF2-40B4-BE49-F238E27FC236}">
-                <a16:creationId xmlns:a16="http://schemas.microsoft.com/office/drawing/2014/main" id="{C0CE6206-2444-E823-90AA-CE51AE298649}"/>
+                <a16:creationId xmlns:a16="http://schemas.microsoft.com/office/drawing/2014/main" id="{A99DB30D-D70E-FAD7-655E-91395B881ECB}"/>
               </a:ext>
             </a:extLst>
           </p:cNvPr>
@@ -4488,7 +5036,7 @@
     </p:spTree>
     <p:extLst>
       <p:ext uri="{BB962C8B-B14F-4D97-AF65-F5344CB8AC3E}">
-        <p14:creationId xmlns:p14="http://schemas.microsoft.com/office/powerpoint/2010/main" val="1063233343"/>
+        <p14:creationId xmlns:p14="http://schemas.microsoft.com/office/powerpoint/2010/main" val="1709279239"/>
       </p:ext>
     </p:extLst>
   </p:cSld>
@@ -4520,7 +5068,7 @@
           <p:cNvPr id="2" name="Rechteck 1">
             <a:extLst>
               <a:ext uri="{FF2B5EF4-FFF2-40B4-BE49-F238E27FC236}">
-                <a16:creationId xmlns:a16="http://schemas.microsoft.com/office/drawing/2014/main" id="{C1F09723-62BE-1DD0-F8D8-F9F7B3A7D16A}"/>
+                <a16:creationId xmlns:a16="http://schemas.microsoft.com/office/drawing/2014/main" id="{7F5C8964-CB2E-9701-4F76-10427843614E}"/>
               </a:ext>
             </a:extLst>
           </p:cNvPr>
@@ -4602,7 +5150,7 @@
           <p:cNvPr id="3" name="Rechteck 2">
             <a:extLst>
               <a:ext uri="{FF2B5EF4-FFF2-40B4-BE49-F238E27FC236}">
-                <a16:creationId xmlns:a16="http://schemas.microsoft.com/office/drawing/2014/main" id="{9E2075B0-D0E8-A59B-0DAF-9ABBA1C27559}"/>
+                <a16:creationId xmlns:a16="http://schemas.microsoft.com/office/drawing/2014/main" id="{DE797A22-E37A-F51E-9FD7-313E2DEBCBB1}"/>
               </a:ext>
             </a:extLst>
           </p:cNvPr>
@@ -4684,7 +5232,7 @@
           <p:cNvPr id="4" name="Rechteck 3">
             <a:extLst>
               <a:ext uri="{FF2B5EF4-FFF2-40B4-BE49-F238E27FC236}">
-                <a16:creationId xmlns:a16="http://schemas.microsoft.com/office/drawing/2014/main" id="{CD8EF103-53B3-E023-313F-5B564F1C11E6}"/>
+                <a16:creationId xmlns:a16="http://schemas.microsoft.com/office/drawing/2014/main" id="{35563B98-6539-E3E2-EC90-9E5E743C232B}"/>
               </a:ext>
             </a:extLst>
           </p:cNvPr>
@@ -4766,7 +5314,7 @@
           <p:cNvPr id="5" name="Rechteck 4">
             <a:extLst>
               <a:ext uri="{FF2B5EF4-FFF2-40B4-BE49-F238E27FC236}">
-                <a16:creationId xmlns:a16="http://schemas.microsoft.com/office/drawing/2014/main" id="{D48856B2-2C51-D435-5A44-17DB3F4E4ADC}"/>
+                <a16:creationId xmlns:a16="http://schemas.microsoft.com/office/drawing/2014/main" id="{0162625F-B839-AB72-7C84-39FF92C6E08D}"/>
               </a:ext>
             </a:extLst>
           </p:cNvPr>
@@ -4848,7 +5396,7 @@
           <p:cNvPr id="6" name="Rechteck 5">
             <a:extLst>
               <a:ext uri="{FF2B5EF4-FFF2-40B4-BE49-F238E27FC236}">
-                <a16:creationId xmlns:a16="http://schemas.microsoft.com/office/drawing/2014/main" id="{340A19EF-17F5-6603-7A9C-03AA95CEF7AE}"/>
+                <a16:creationId xmlns:a16="http://schemas.microsoft.com/office/drawing/2014/main" id="{1465EE45-4598-A766-54DF-77C7E5E6B28D}"/>
               </a:ext>
             </a:extLst>
           </p:cNvPr>
@@ -4930,7 +5478,7 @@
           <p:cNvPr id="7" name="Rechteck 6">
             <a:extLst>
               <a:ext uri="{FF2B5EF4-FFF2-40B4-BE49-F238E27FC236}">
-                <a16:creationId xmlns:a16="http://schemas.microsoft.com/office/drawing/2014/main" id="{7449BCF9-A877-7CF7-C83E-2F2C3901CD1C}"/>
+                <a16:creationId xmlns:a16="http://schemas.microsoft.com/office/drawing/2014/main" id="{5AD84C93-71EB-A52B-E5DA-97A8770E8B25}"/>
               </a:ext>
             </a:extLst>
           </p:cNvPr>
@@ -5012,7 +5560,7 @@
           <p:cNvPr id="8" name="Rechteck 7">
             <a:extLst>
               <a:ext uri="{FF2B5EF4-FFF2-40B4-BE49-F238E27FC236}">
-                <a16:creationId xmlns:a16="http://schemas.microsoft.com/office/drawing/2014/main" id="{5B16C07A-FA93-1719-21EB-7AE92CC75E60}"/>
+                <a16:creationId xmlns:a16="http://schemas.microsoft.com/office/drawing/2014/main" id="{53665567-9F98-04F6-2D18-36E77A898251}"/>
               </a:ext>
             </a:extLst>
           </p:cNvPr>
@@ -5094,7 +5642,7 @@
           <p:cNvPr id="9" name="Rechteck 8">
             <a:extLst>
               <a:ext uri="{FF2B5EF4-FFF2-40B4-BE49-F238E27FC236}">
-                <a16:creationId xmlns:a16="http://schemas.microsoft.com/office/drawing/2014/main" id="{CCCD913B-1888-32C5-C6A6-4B2264CD6B9B}"/>
+                <a16:creationId xmlns:a16="http://schemas.microsoft.com/office/drawing/2014/main" id="{1775BA2F-D916-584E-4FA3-83296D918FE0}"/>
               </a:ext>
             </a:extLst>
           </p:cNvPr>
@@ -5176,7 +5724,7 @@
           <p:cNvPr id="10" name="Rechteck 9">
             <a:extLst>
               <a:ext uri="{FF2B5EF4-FFF2-40B4-BE49-F238E27FC236}">
-                <a16:creationId xmlns:a16="http://schemas.microsoft.com/office/drawing/2014/main" id="{5EABEB3B-5A93-ED60-AA41-138CCCFA54D9}"/>
+                <a16:creationId xmlns:a16="http://schemas.microsoft.com/office/drawing/2014/main" id="{125F962E-2A43-DE4E-66C0-EA3A5FBA9A2E}"/>
               </a:ext>
             </a:extLst>
           </p:cNvPr>
@@ -5258,7 +5806,7 @@
           <p:cNvPr id="11" name="Rechteck 10">
             <a:extLst>
               <a:ext uri="{FF2B5EF4-FFF2-40B4-BE49-F238E27FC236}">
-                <a16:creationId xmlns:a16="http://schemas.microsoft.com/office/drawing/2014/main" id="{3524196B-8D52-39C1-7414-CFDBCF573057}"/>
+                <a16:creationId xmlns:a16="http://schemas.microsoft.com/office/drawing/2014/main" id="{0E0D3DF5-0E11-9E8D-F4D3-EE45AF15857A}"/>
               </a:ext>
             </a:extLst>
           </p:cNvPr>
@@ -5340,7 +5888,7 @@
           <p:cNvPr id="12" name="Rechteck 11">
             <a:extLst>
               <a:ext uri="{FF2B5EF4-FFF2-40B4-BE49-F238E27FC236}">
-                <a16:creationId xmlns:a16="http://schemas.microsoft.com/office/drawing/2014/main" id="{A4C3C907-D49A-3771-CBDB-160568255D59}"/>
+                <a16:creationId xmlns:a16="http://schemas.microsoft.com/office/drawing/2014/main" id="{4D5AB248-3ED2-8150-D2DB-7FCE674618C5}"/>
               </a:ext>
             </a:extLst>
           </p:cNvPr>
@@ -5422,7 +5970,7 @@
           <p:cNvPr id="13" name="Rechteck 12">
             <a:extLst>
               <a:ext uri="{FF2B5EF4-FFF2-40B4-BE49-F238E27FC236}">
-                <a16:creationId xmlns:a16="http://schemas.microsoft.com/office/drawing/2014/main" id="{5B036758-997E-539B-A27B-B01D00DAF126}"/>
+                <a16:creationId xmlns:a16="http://schemas.microsoft.com/office/drawing/2014/main" id="{82C6E285-DE99-B55C-55A5-B8BB8F3DAC71}"/>
               </a:ext>
             </a:extLst>
           </p:cNvPr>
@@ -5502,7 +6050,7 @@
     </p:spTree>
     <p:extLst>
       <p:ext uri="{BB962C8B-B14F-4D97-AF65-F5344CB8AC3E}">
-        <p14:creationId xmlns:p14="http://schemas.microsoft.com/office/powerpoint/2010/main" val="2006879415"/>
+        <p14:creationId xmlns:p14="http://schemas.microsoft.com/office/powerpoint/2010/main" val="4260155303"/>
       </p:ext>
     </p:extLst>
   </p:cSld>
@@ -5534,7 +6082,7 @@
           <p:cNvPr id="2" name="Ellipse 1">
             <a:extLst>
               <a:ext uri="{FF2B5EF4-FFF2-40B4-BE49-F238E27FC236}">
-                <a16:creationId xmlns:a16="http://schemas.microsoft.com/office/drawing/2014/main" id="{F3D3575D-67C7-2432-2EFF-55CD3DC5E656}"/>
+                <a16:creationId xmlns:a16="http://schemas.microsoft.com/office/drawing/2014/main" id="{0A5ED3A8-CB4E-D563-941A-6F6D5361045C}"/>
               </a:ext>
             </a:extLst>
           </p:cNvPr>
@@ -5616,7 +6164,7 @@
           <p:cNvPr id="3" name="Rechteck: abgerundete Ecken 2">
             <a:extLst>
               <a:ext uri="{FF2B5EF4-FFF2-40B4-BE49-F238E27FC236}">
-                <a16:creationId xmlns:a16="http://schemas.microsoft.com/office/drawing/2014/main" id="{FF979B3C-F762-ADDE-09BB-35AD9AEEF257}"/>
+                <a16:creationId xmlns:a16="http://schemas.microsoft.com/office/drawing/2014/main" id="{A04C90E2-F0A9-7DFC-CA18-A8774FCA0F2A}"/>
               </a:ext>
             </a:extLst>
           </p:cNvPr>
@@ -5698,7 +6246,7 @@
           <p:cNvPr id="4" name="Ellipse 3">
             <a:extLst>
               <a:ext uri="{FF2B5EF4-FFF2-40B4-BE49-F238E27FC236}">
-                <a16:creationId xmlns:a16="http://schemas.microsoft.com/office/drawing/2014/main" id="{467E7370-C734-BF0F-46E7-C3371538048D}"/>
+                <a16:creationId xmlns:a16="http://schemas.microsoft.com/office/drawing/2014/main" id="{FFB18F86-2009-9CF1-3BB0-0246550F54C0}"/>
               </a:ext>
             </a:extLst>
           </p:cNvPr>
@@ -5780,7 +6328,7 @@
           <p:cNvPr id="5" name="Rechteck: abgerundete Ecken 4">
             <a:extLst>
               <a:ext uri="{FF2B5EF4-FFF2-40B4-BE49-F238E27FC236}">
-                <a16:creationId xmlns:a16="http://schemas.microsoft.com/office/drawing/2014/main" id="{80EDEF26-EE08-D8C1-5A59-BC476B7C6CC4}"/>
+                <a16:creationId xmlns:a16="http://schemas.microsoft.com/office/drawing/2014/main" id="{4BA32328-4D36-BB2B-3034-4CB41E91F4B9}"/>
               </a:ext>
             </a:extLst>
           </p:cNvPr>
@@ -5862,7 +6410,7 @@
           <p:cNvPr id="6" name="Ellipse 5">
             <a:extLst>
               <a:ext uri="{FF2B5EF4-FFF2-40B4-BE49-F238E27FC236}">
-                <a16:creationId xmlns:a16="http://schemas.microsoft.com/office/drawing/2014/main" id="{C3FEB6F7-EFC3-AC0F-B884-DC902F8A1A90}"/>
+                <a16:creationId xmlns:a16="http://schemas.microsoft.com/office/drawing/2014/main" id="{3D2459F3-DB61-29FA-5DB8-87D710C45F3F}"/>
               </a:ext>
             </a:extLst>
           </p:cNvPr>
@@ -5944,7 +6492,7 @@
           <p:cNvPr id="7" name="Rechteck: abgerundete Ecken 6">
             <a:extLst>
               <a:ext uri="{FF2B5EF4-FFF2-40B4-BE49-F238E27FC236}">
-                <a16:creationId xmlns:a16="http://schemas.microsoft.com/office/drawing/2014/main" id="{0353028E-A747-025C-06D9-5B2F9EE47798}"/>
+                <a16:creationId xmlns:a16="http://schemas.microsoft.com/office/drawing/2014/main" id="{455DC0E0-55C7-CFAD-B440-84D24B775AF7}"/>
               </a:ext>
             </a:extLst>
           </p:cNvPr>
@@ -6026,7 +6574,7 @@
           <p:cNvPr id="8" name="Ellipse 7">
             <a:extLst>
               <a:ext uri="{FF2B5EF4-FFF2-40B4-BE49-F238E27FC236}">
-                <a16:creationId xmlns:a16="http://schemas.microsoft.com/office/drawing/2014/main" id="{F7BDEEA9-1E65-C29C-9B38-B8027A1B2C2A}"/>
+                <a16:creationId xmlns:a16="http://schemas.microsoft.com/office/drawing/2014/main" id="{DABFCADB-381D-8C8E-BB61-7626A19239FC}"/>
               </a:ext>
             </a:extLst>
           </p:cNvPr>
@@ -6108,7 +6656,7 @@
           <p:cNvPr id="9" name="Rechteck: abgerundete Ecken 8">
             <a:extLst>
               <a:ext uri="{FF2B5EF4-FFF2-40B4-BE49-F238E27FC236}">
-                <a16:creationId xmlns:a16="http://schemas.microsoft.com/office/drawing/2014/main" id="{3E9DDE44-5EF3-0272-189D-0D05872D9F6F}"/>
+                <a16:creationId xmlns:a16="http://schemas.microsoft.com/office/drawing/2014/main" id="{202E4ACC-BE24-049A-42BC-559702AC660F}"/>
               </a:ext>
             </a:extLst>
           </p:cNvPr>
@@ -6190,7 +6738,7 @@
           <p:cNvPr id="10" name="Ellipse 9">
             <a:extLst>
               <a:ext uri="{FF2B5EF4-FFF2-40B4-BE49-F238E27FC236}">
-                <a16:creationId xmlns:a16="http://schemas.microsoft.com/office/drawing/2014/main" id="{F19EC5E9-3886-1D05-510E-C37D4BC5CA44}"/>
+                <a16:creationId xmlns:a16="http://schemas.microsoft.com/office/drawing/2014/main" id="{795854A9-2D42-8BBD-4E87-76DFC2B986F1}"/>
               </a:ext>
             </a:extLst>
           </p:cNvPr>
@@ -6272,7 +6820,7 @@
           <p:cNvPr id="11" name="Rechteck: abgerundete Ecken 10">
             <a:extLst>
               <a:ext uri="{FF2B5EF4-FFF2-40B4-BE49-F238E27FC236}">
-                <a16:creationId xmlns:a16="http://schemas.microsoft.com/office/drawing/2014/main" id="{24337DFA-68DE-CB93-EC0D-02846357DD9C}"/>
+                <a16:creationId xmlns:a16="http://schemas.microsoft.com/office/drawing/2014/main" id="{4FCAE23B-7053-3FFC-4C4D-9DCA9F9E1732}"/>
               </a:ext>
             </a:extLst>
           </p:cNvPr>
@@ -6352,7 +6900,7 @@
     </p:spTree>
     <p:extLst>
       <p:ext uri="{BB962C8B-B14F-4D97-AF65-F5344CB8AC3E}">
-        <p14:creationId xmlns:p14="http://schemas.microsoft.com/office/powerpoint/2010/main" val="730369315"/>
+        <p14:creationId xmlns:p14="http://schemas.microsoft.com/office/powerpoint/2010/main" val="586896043"/>
       </p:ext>
     </p:extLst>
   </p:cSld>
@@ -6384,7 +6932,7 @@
           <p:cNvPr id="3" name="Grafik 2">
             <a:extLst>
               <a:ext uri="{FF2B5EF4-FFF2-40B4-BE49-F238E27FC236}">
-                <a16:creationId xmlns:a16="http://schemas.microsoft.com/office/drawing/2014/main" id="{2E6FFE12-C14B-DAC5-E365-3786017226E0}"/>
+                <a16:creationId xmlns:a16="http://schemas.microsoft.com/office/drawing/2014/main" id="{E22372F1-131F-0179-8E50-3816D0D13A8A}"/>
               </a:ext>
             </a:extLst>
           </p:cNvPr>
@@ -6427,7 +6975,7 @@
           <p:cNvPr id="5" name="Grafik 4">
             <a:extLst>
               <a:ext uri="{FF2B5EF4-FFF2-40B4-BE49-F238E27FC236}">
-                <a16:creationId xmlns:a16="http://schemas.microsoft.com/office/drawing/2014/main" id="{B11FE111-6BDF-473A-BA6F-D88967D49072}"/>
+                <a16:creationId xmlns:a16="http://schemas.microsoft.com/office/drawing/2014/main" id="{6EADD641-C38E-AA3C-CB8A-8FA0ADD38937}"/>
               </a:ext>
             </a:extLst>
           </p:cNvPr>
@@ -6470,7 +7018,7 @@
           <p:cNvPr id="7" name="Grafik 6">
             <a:extLst>
               <a:ext uri="{FF2B5EF4-FFF2-40B4-BE49-F238E27FC236}">
-                <a16:creationId xmlns:a16="http://schemas.microsoft.com/office/drawing/2014/main" id="{3A7E25A6-CC56-5200-D81E-D6C21C7FFDF7}"/>
+                <a16:creationId xmlns:a16="http://schemas.microsoft.com/office/drawing/2014/main" id="{4E68D3AA-62E6-36B7-A89F-09E75D5003CD}"/>
               </a:ext>
             </a:extLst>
           </p:cNvPr>
@@ -6513,7 +7061,7 @@
           <p:cNvPr id="8" name="Rechteck 7">
             <a:extLst>
               <a:ext uri="{FF2B5EF4-FFF2-40B4-BE49-F238E27FC236}">
-                <a16:creationId xmlns:a16="http://schemas.microsoft.com/office/drawing/2014/main" id="{A1682089-9BB8-70BB-0815-996571129B0B}"/>
+                <a16:creationId xmlns:a16="http://schemas.microsoft.com/office/drawing/2014/main" id="{ADCB96CE-44A0-604B-5501-0F2A283A3895}"/>
               </a:ext>
             </a:extLst>
           </p:cNvPr>
@@ -6591,7 +7139,7 @@
           <p:cNvPr id="9" name="Ellipse 8">
             <a:extLst>
               <a:ext uri="{FF2B5EF4-FFF2-40B4-BE49-F238E27FC236}">
-                <a16:creationId xmlns:a16="http://schemas.microsoft.com/office/drawing/2014/main" id="{CFC74A51-46D1-6543-8CA7-7E25D385EB6E}"/>
+                <a16:creationId xmlns:a16="http://schemas.microsoft.com/office/drawing/2014/main" id="{D76C6595-112E-EEBA-DD85-3931C977754E}"/>
               </a:ext>
             </a:extLst>
           </p:cNvPr>
@@ -6669,7 +7217,7 @@
           <p:cNvPr id="10" name="Rechteck 9">
             <a:extLst>
               <a:ext uri="{FF2B5EF4-FFF2-40B4-BE49-F238E27FC236}">
-                <a16:creationId xmlns:a16="http://schemas.microsoft.com/office/drawing/2014/main" id="{60CADBA9-5D76-BF07-AEB8-A6A47CF61FD7}"/>
+                <a16:creationId xmlns:a16="http://schemas.microsoft.com/office/drawing/2014/main" id="{8365DC65-7A5C-C41C-78EA-32229FBA5D50}"/>
               </a:ext>
             </a:extLst>
           </p:cNvPr>
@@ -6745,7 +7293,7 @@
     </p:spTree>
     <p:extLst>
       <p:ext uri="{BB962C8B-B14F-4D97-AF65-F5344CB8AC3E}">
-        <p14:creationId xmlns:p14="http://schemas.microsoft.com/office/powerpoint/2010/main" val="2467151238"/>
+        <p14:creationId xmlns:p14="http://schemas.microsoft.com/office/powerpoint/2010/main" val="3651226478"/>
       </p:ext>
     </p:extLst>
   </p:cSld>
@@ -6777,7 +7325,7 @@
           <p:cNvPr id="2" name="Ellipse 1">
             <a:extLst>
               <a:ext uri="{FF2B5EF4-FFF2-40B4-BE49-F238E27FC236}">
-                <a16:creationId xmlns:a16="http://schemas.microsoft.com/office/drawing/2014/main" id="{FAFF818D-35C7-28CF-D742-795B5C5EF6A4}"/>
+                <a16:creationId xmlns:a16="http://schemas.microsoft.com/office/drawing/2014/main" id="{BC57519C-7EA4-11F4-46B9-44541490B51A}"/>
               </a:ext>
             </a:extLst>
           </p:cNvPr>
@@ -6861,7 +7409,7 @@
           <p:cNvPr id="3" name="Ellipse 2">
             <a:extLst>
               <a:ext uri="{FF2B5EF4-FFF2-40B4-BE49-F238E27FC236}">
-                <a16:creationId xmlns:a16="http://schemas.microsoft.com/office/drawing/2014/main" id="{5E189E8B-F10E-2DC9-972B-765075926D82}"/>
+                <a16:creationId xmlns:a16="http://schemas.microsoft.com/office/drawing/2014/main" id="{98E49E4A-CEF5-3227-59F0-0C3699781B1A}"/>
               </a:ext>
             </a:extLst>
           </p:cNvPr>
@@ -6945,7 +7493,7 @@
           <p:cNvPr id="4" name="Ellipse 3">
             <a:extLst>
               <a:ext uri="{FF2B5EF4-FFF2-40B4-BE49-F238E27FC236}">
-                <a16:creationId xmlns:a16="http://schemas.microsoft.com/office/drawing/2014/main" id="{730CE1F1-24C6-1A71-1001-D6CE458174CD}"/>
+                <a16:creationId xmlns:a16="http://schemas.microsoft.com/office/drawing/2014/main" id="{9484E46A-519C-C64C-C676-340E424DE9BA}"/>
               </a:ext>
             </a:extLst>
           </p:cNvPr>
@@ -7029,7 +7577,7 @@
           <p:cNvPr id="5" name="Ellipse 4">
             <a:extLst>
               <a:ext uri="{FF2B5EF4-FFF2-40B4-BE49-F238E27FC236}">
-                <a16:creationId xmlns:a16="http://schemas.microsoft.com/office/drawing/2014/main" id="{3B404892-1CA4-12F9-01F4-96C715221166}"/>
+                <a16:creationId xmlns:a16="http://schemas.microsoft.com/office/drawing/2014/main" id="{C303E852-88D3-E10C-D1F9-489D911A7A8E}"/>
               </a:ext>
             </a:extLst>
           </p:cNvPr>
@@ -7113,7 +7661,7 @@
           <p:cNvPr id="6" name="Ellipse 5">
             <a:extLst>
               <a:ext uri="{FF2B5EF4-FFF2-40B4-BE49-F238E27FC236}">
-                <a16:creationId xmlns:a16="http://schemas.microsoft.com/office/drawing/2014/main" id="{D644E024-F42C-A91E-79CB-F35431539593}"/>
+                <a16:creationId xmlns:a16="http://schemas.microsoft.com/office/drawing/2014/main" id="{F97FCBC9-0CD4-4CBC-096A-AA88ABE10F95}"/>
               </a:ext>
             </a:extLst>
           </p:cNvPr>
@@ -7197,7 +7745,7 @@
           <p:cNvPr id="7" name="Ellipse 6">
             <a:extLst>
               <a:ext uri="{FF2B5EF4-FFF2-40B4-BE49-F238E27FC236}">
-                <a16:creationId xmlns:a16="http://schemas.microsoft.com/office/drawing/2014/main" id="{67E3423A-810B-49CE-040B-BEDA541673E2}"/>
+                <a16:creationId xmlns:a16="http://schemas.microsoft.com/office/drawing/2014/main" id="{2D643C7E-6074-AF02-0BDC-4528465F3028}"/>
               </a:ext>
             </a:extLst>
           </p:cNvPr>
@@ -7281,7 +7829,7 @@
           <p:cNvPr id="8" name="Ellipse 7">
             <a:extLst>
               <a:ext uri="{FF2B5EF4-FFF2-40B4-BE49-F238E27FC236}">
-                <a16:creationId xmlns:a16="http://schemas.microsoft.com/office/drawing/2014/main" id="{D50CF8DE-EBFB-527A-BCA4-CECBFAB2E087}"/>
+                <a16:creationId xmlns:a16="http://schemas.microsoft.com/office/drawing/2014/main" id="{7D15A591-2428-41BB-6F31-0B5F41B88964}"/>
               </a:ext>
             </a:extLst>
           </p:cNvPr>
@@ -7365,7 +7913,7 @@
           <p:cNvPr id="9" name="Ellipse 8">
             <a:extLst>
               <a:ext uri="{FF2B5EF4-FFF2-40B4-BE49-F238E27FC236}">
-                <a16:creationId xmlns:a16="http://schemas.microsoft.com/office/drawing/2014/main" id="{19E7E531-0FC1-D4F0-A7A0-2F5E3C2FD398}"/>
+                <a16:creationId xmlns:a16="http://schemas.microsoft.com/office/drawing/2014/main" id="{88853A1A-4F69-36C5-8778-694AB41ECB2D}"/>
               </a:ext>
             </a:extLst>
           </p:cNvPr>
@@ -7447,7 +7995,7 @@
     </p:spTree>
     <p:extLst>
       <p:ext uri="{BB962C8B-B14F-4D97-AF65-F5344CB8AC3E}">
-        <p14:creationId xmlns:p14="http://schemas.microsoft.com/office/powerpoint/2010/main" val="1361675357"/>
+        <p14:creationId xmlns:p14="http://schemas.microsoft.com/office/powerpoint/2010/main" val="3459221159"/>
       </p:ext>
     </p:extLst>
   </p:cSld>
@@ -7479,7 +8027,7 @@
           <p:cNvPr id="2" name="Rechteck: abgerundete Ecken 1">
             <a:extLst>
               <a:ext uri="{FF2B5EF4-FFF2-40B4-BE49-F238E27FC236}">
-                <a16:creationId xmlns:a16="http://schemas.microsoft.com/office/drawing/2014/main" id="{66F373D0-53AA-4E53-520C-DA5648C7D7EB}"/>
+                <a16:creationId xmlns:a16="http://schemas.microsoft.com/office/drawing/2014/main" id="{7304D51C-7529-63E9-75FE-1B6945133429}"/>
               </a:ext>
             </a:extLst>
           </p:cNvPr>
@@ -7563,7 +8111,7 @@
           <p:cNvPr id="3" name="Rechteck: abgerundete Ecken 2">
             <a:extLst>
               <a:ext uri="{FF2B5EF4-FFF2-40B4-BE49-F238E27FC236}">
-                <a16:creationId xmlns:a16="http://schemas.microsoft.com/office/drawing/2014/main" id="{CDC23E9A-60FB-0200-AF5C-D36C3BAEADA4}"/>
+                <a16:creationId xmlns:a16="http://schemas.microsoft.com/office/drawing/2014/main" id="{152D45B9-5A16-5694-8853-0DBB6C3CE93E}"/>
               </a:ext>
             </a:extLst>
           </p:cNvPr>
@@ -7647,7 +8195,7 @@
           <p:cNvPr id="4" name="Rechteck: abgerundete Ecken 3">
             <a:extLst>
               <a:ext uri="{FF2B5EF4-FFF2-40B4-BE49-F238E27FC236}">
-                <a16:creationId xmlns:a16="http://schemas.microsoft.com/office/drawing/2014/main" id="{0C1B0A3E-4DD0-8587-3D5D-B7FB9FA0D8CA}"/>
+                <a16:creationId xmlns:a16="http://schemas.microsoft.com/office/drawing/2014/main" id="{5D519DEB-4642-A2AA-4273-0CD0638FA94F}"/>
               </a:ext>
             </a:extLst>
           </p:cNvPr>
@@ -7731,7 +8279,7 @@
           <p:cNvPr id="5" name="Rechteck: abgerundete Ecken 4">
             <a:extLst>
               <a:ext uri="{FF2B5EF4-FFF2-40B4-BE49-F238E27FC236}">
-                <a16:creationId xmlns:a16="http://schemas.microsoft.com/office/drawing/2014/main" id="{52A8E8EF-3EFC-1A3B-D817-0DB621076CC2}"/>
+                <a16:creationId xmlns:a16="http://schemas.microsoft.com/office/drawing/2014/main" id="{7E800194-1E06-8FD3-648F-A2A26FB8C878}"/>
               </a:ext>
             </a:extLst>
           </p:cNvPr>
@@ -7815,7 +8363,7 @@
           <p:cNvPr id="6" name="Rechteck: abgerundete Ecken 5">
             <a:extLst>
               <a:ext uri="{FF2B5EF4-FFF2-40B4-BE49-F238E27FC236}">
-                <a16:creationId xmlns:a16="http://schemas.microsoft.com/office/drawing/2014/main" id="{E9062BC2-2693-665A-0BC1-6FF09E8EB501}"/>
+                <a16:creationId xmlns:a16="http://schemas.microsoft.com/office/drawing/2014/main" id="{948DC4AE-2104-FD96-8A2A-0C10A4C725D1}"/>
               </a:ext>
             </a:extLst>
           </p:cNvPr>
@@ -7899,7 +8447,7 @@
           <p:cNvPr id="7" name="Rechteck: abgerundete Ecken 6">
             <a:extLst>
               <a:ext uri="{FF2B5EF4-FFF2-40B4-BE49-F238E27FC236}">
-                <a16:creationId xmlns:a16="http://schemas.microsoft.com/office/drawing/2014/main" id="{382F67E0-76F7-A6D9-BDAC-DAF0C3944646}"/>
+                <a16:creationId xmlns:a16="http://schemas.microsoft.com/office/drawing/2014/main" id="{6784AFBE-A2BD-685D-490F-36DD5CFC348D}"/>
               </a:ext>
             </a:extLst>
           </p:cNvPr>
@@ -7983,7 +8531,7 @@
           <p:cNvPr id="8" name="Rechteck: abgerundete Ecken 7">
             <a:extLst>
               <a:ext uri="{FF2B5EF4-FFF2-40B4-BE49-F238E27FC236}">
-                <a16:creationId xmlns:a16="http://schemas.microsoft.com/office/drawing/2014/main" id="{0EE460CF-7FC9-F3AE-3B2E-60FF1BE671CD}"/>
+                <a16:creationId xmlns:a16="http://schemas.microsoft.com/office/drawing/2014/main" id="{4F205306-736A-4A8E-E8A3-35D9DE48EC08}"/>
               </a:ext>
             </a:extLst>
           </p:cNvPr>
@@ -8067,7 +8615,7 @@
           <p:cNvPr id="9" name="Rechteck: abgerundete Ecken 8">
             <a:extLst>
               <a:ext uri="{FF2B5EF4-FFF2-40B4-BE49-F238E27FC236}">
-                <a16:creationId xmlns:a16="http://schemas.microsoft.com/office/drawing/2014/main" id="{A09CE650-1B85-FC3D-B445-DBD158425E84}"/>
+                <a16:creationId xmlns:a16="http://schemas.microsoft.com/office/drawing/2014/main" id="{E637A683-41E0-A60F-ADD6-DD7890E264AC}"/>
               </a:ext>
             </a:extLst>
           </p:cNvPr>
@@ -8151,7 +8699,7 @@
           <p:cNvPr id="10" name="Rechteck: abgerundete Ecken 9">
             <a:extLst>
               <a:ext uri="{FF2B5EF4-FFF2-40B4-BE49-F238E27FC236}">
-                <a16:creationId xmlns:a16="http://schemas.microsoft.com/office/drawing/2014/main" id="{6145ECC4-230A-F6DA-5465-7A62F641EEC0}"/>
+                <a16:creationId xmlns:a16="http://schemas.microsoft.com/office/drawing/2014/main" id="{0D966F6A-509B-8E14-0390-B48D3E2FA349}"/>
               </a:ext>
             </a:extLst>
           </p:cNvPr>
@@ -8235,7 +8783,7 @@
           <p:cNvPr id="11" name="Rechteck: abgerundete Ecken 10">
             <a:extLst>
               <a:ext uri="{FF2B5EF4-FFF2-40B4-BE49-F238E27FC236}">
-                <a16:creationId xmlns:a16="http://schemas.microsoft.com/office/drawing/2014/main" id="{3EEC64C9-BF9D-268B-BBDD-8DA4E9BBD19A}"/>
+                <a16:creationId xmlns:a16="http://schemas.microsoft.com/office/drawing/2014/main" id="{E65A8047-406D-4DAA-F332-B9FD232423D2}"/>
               </a:ext>
             </a:extLst>
           </p:cNvPr>
@@ -8319,7 +8867,7 @@
           <p:cNvPr id="12" name="Rechteck: abgerundete Ecken 11">
             <a:extLst>
               <a:ext uri="{FF2B5EF4-FFF2-40B4-BE49-F238E27FC236}">
-                <a16:creationId xmlns:a16="http://schemas.microsoft.com/office/drawing/2014/main" id="{91DDB35B-7B74-3734-A8E1-1713DEC7A67A}"/>
+                <a16:creationId xmlns:a16="http://schemas.microsoft.com/office/drawing/2014/main" id="{225FE03F-2341-AA62-59CF-00DEBDA5119B}"/>
               </a:ext>
             </a:extLst>
           </p:cNvPr>
@@ -8403,7 +8951,7 @@
           <p:cNvPr id="13" name="Rechteck: abgerundete Ecken 12">
             <a:extLst>
               <a:ext uri="{FF2B5EF4-FFF2-40B4-BE49-F238E27FC236}">
-                <a16:creationId xmlns:a16="http://schemas.microsoft.com/office/drawing/2014/main" id="{88096B02-FCDC-F000-515A-5A5EC89CBD0F}"/>
+                <a16:creationId xmlns:a16="http://schemas.microsoft.com/office/drawing/2014/main" id="{BD98204D-D291-5D6A-AF7B-D4B17393F825}"/>
               </a:ext>
             </a:extLst>
           </p:cNvPr>
@@ -8487,7 +9035,7 @@
           <p:cNvPr id="14" name="Rechteck: abgerundete Ecken 13">
             <a:extLst>
               <a:ext uri="{FF2B5EF4-FFF2-40B4-BE49-F238E27FC236}">
-                <a16:creationId xmlns:a16="http://schemas.microsoft.com/office/drawing/2014/main" id="{9B54D8D6-02A0-4A9C-4D22-1980A1E716B3}"/>
+                <a16:creationId xmlns:a16="http://schemas.microsoft.com/office/drawing/2014/main" id="{9D8CDBF8-560B-F4EF-2D23-D3E3D37CB100}"/>
               </a:ext>
             </a:extLst>
           </p:cNvPr>
@@ -8571,7 +9119,7 @@
           <p:cNvPr id="15" name="Rechteck: abgerundete Ecken 14">
             <a:extLst>
               <a:ext uri="{FF2B5EF4-FFF2-40B4-BE49-F238E27FC236}">
-                <a16:creationId xmlns:a16="http://schemas.microsoft.com/office/drawing/2014/main" id="{A7F6C9F7-B8E7-CB12-C4BF-DDAABCE89C67}"/>
+                <a16:creationId xmlns:a16="http://schemas.microsoft.com/office/drawing/2014/main" id="{42B2B87B-BF66-CC00-F90C-048D4A8DC8C5}"/>
               </a:ext>
             </a:extLst>
           </p:cNvPr>
@@ -8655,7 +9203,7 @@
           <p:cNvPr id="16" name="Rechteck: abgerundete Ecken 15">
             <a:extLst>
               <a:ext uri="{FF2B5EF4-FFF2-40B4-BE49-F238E27FC236}">
-                <a16:creationId xmlns:a16="http://schemas.microsoft.com/office/drawing/2014/main" id="{D6BC0DA3-348E-7684-BD88-D30BF2570620}"/>
+                <a16:creationId xmlns:a16="http://schemas.microsoft.com/office/drawing/2014/main" id="{BD8CE85C-14CC-9AFB-0280-A150158A03EF}"/>
               </a:ext>
             </a:extLst>
           </p:cNvPr>
@@ -8737,7 +9285,7 @@
     </p:spTree>
     <p:extLst>
       <p:ext uri="{BB962C8B-B14F-4D97-AF65-F5344CB8AC3E}">
-        <p14:creationId xmlns:p14="http://schemas.microsoft.com/office/powerpoint/2010/main" val="3118207982"/>
+        <p14:creationId xmlns:p14="http://schemas.microsoft.com/office/powerpoint/2010/main" val="1011131547"/>
       </p:ext>
     </p:extLst>
   </p:cSld>
@@ -8769,7 +9317,7 @@
           <p:cNvPr id="2" name="Rechteck 1">
             <a:extLst>
               <a:ext uri="{FF2B5EF4-FFF2-40B4-BE49-F238E27FC236}">
-                <a16:creationId xmlns:a16="http://schemas.microsoft.com/office/drawing/2014/main" id="{ACD19885-3820-89F0-352E-9C3CD34BB0BF}"/>
+                <a16:creationId xmlns:a16="http://schemas.microsoft.com/office/drawing/2014/main" id="{786C424C-9A94-D4FC-1072-FDED55D004CA}"/>
               </a:ext>
             </a:extLst>
           </p:cNvPr>
@@ -8848,7 +9396,7 @@
           <p:cNvPr id="3" name="Rechteck 2">
             <a:extLst>
               <a:ext uri="{FF2B5EF4-FFF2-40B4-BE49-F238E27FC236}">
-                <a16:creationId xmlns:a16="http://schemas.microsoft.com/office/drawing/2014/main" id="{9662068D-3558-3311-4C50-17C62E036EDE}"/>
+                <a16:creationId xmlns:a16="http://schemas.microsoft.com/office/drawing/2014/main" id="{77A15596-1919-9947-AF3C-F577E1461C26}"/>
               </a:ext>
             </a:extLst>
           </p:cNvPr>
@@ -8928,7 +9476,7 @@
           <p:cNvPr id="4" name="Rechteck 3">
             <a:extLst>
               <a:ext uri="{FF2B5EF4-FFF2-40B4-BE49-F238E27FC236}">
-                <a16:creationId xmlns:a16="http://schemas.microsoft.com/office/drawing/2014/main" id="{A9AB5F10-D55A-065B-235C-50737CBECB09}"/>
+                <a16:creationId xmlns:a16="http://schemas.microsoft.com/office/drawing/2014/main" id="{44715B6E-AB2F-A319-0E7A-B58426C9EC0B}"/>
               </a:ext>
             </a:extLst>
           </p:cNvPr>
@@ -9009,7 +9557,7 @@
           <p:cNvPr id="5" name="Ellipse 4">
             <a:extLst>
               <a:ext uri="{FF2B5EF4-FFF2-40B4-BE49-F238E27FC236}">
-                <a16:creationId xmlns:a16="http://schemas.microsoft.com/office/drawing/2014/main" id="{DE2B1147-EFC8-63B0-A64F-F9BF6D25EA21}"/>
+                <a16:creationId xmlns:a16="http://schemas.microsoft.com/office/drawing/2014/main" id="{A7B50469-61C5-3F93-91D2-6656F5F2805B}"/>
               </a:ext>
             </a:extLst>
           </p:cNvPr>
@@ -9091,7 +9639,7 @@
           <p:cNvPr id="6" name="Rechteck 5">
             <a:extLst>
               <a:ext uri="{FF2B5EF4-FFF2-40B4-BE49-F238E27FC236}">
-                <a16:creationId xmlns:a16="http://schemas.microsoft.com/office/drawing/2014/main" id="{01FE8E46-B0F0-43F5-A046-1B8BFD8FA2DA}"/>
+                <a16:creationId xmlns:a16="http://schemas.microsoft.com/office/drawing/2014/main" id="{CF3CDFCD-2928-47BE-E958-6F593B948418}"/>
               </a:ext>
             </a:extLst>
           </p:cNvPr>
@@ -9172,7 +9720,7 @@
           <p:cNvPr id="7" name="Ellipse 6">
             <a:extLst>
               <a:ext uri="{FF2B5EF4-FFF2-40B4-BE49-F238E27FC236}">
-                <a16:creationId xmlns:a16="http://schemas.microsoft.com/office/drawing/2014/main" id="{511F3FE4-8054-C6E2-D3B4-CD58E38FECC9}"/>
+                <a16:creationId xmlns:a16="http://schemas.microsoft.com/office/drawing/2014/main" id="{FEC43B5F-C160-A14C-EEEB-0024DDFEE69F}"/>
               </a:ext>
             </a:extLst>
           </p:cNvPr>
@@ -9253,7 +9801,7 @@
           <p:cNvPr id="8" name="Rechteck 7">
             <a:extLst>
               <a:ext uri="{FF2B5EF4-FFF2-40B4-BE49-F238E27FC236}">
-                <a16:creationId xmlns:a16="http://schemas.microsoft.com/office/drawing/2014/main" id="{C93E26C8-72E1-8A96-63B4-4D4616D33835}"/>
+                <a16:creationId xmlns:a16="http://schemas.microsoft.com/office/drawing/2014/main" id="{805460B9-E6F1-A6FE-FEDD-68CA8D26A9D6}"/>
               </a:ext>
             </a:extLst>
           </p:cNvPr>
@@ -9335,7 +9883,7 @@
           <p:cNvPr id="9" name="Stern: 5 Zacken 8">
             <a:extLst>
               <a:ext uri="{FF2B5EF4-FFF2-40B4-BE49-F238E27FC236}">
-                <a16:creationId xmlns:a16="http://schemas.microsoft.com/office/drawing/2014/main" id="{BD3E175F-0757-61C8-4336-2F9B3BF54936}"/>
+                <a16:creationId xmlns:a16="http://schemas.microsoft.com/office/drawing/2014/main" id="{7B9965ED-CA07-1254-42E4-BE094DB7B903}"/>
               </a:ext>
             </a:extLst>
           </p:cNvPr>
@@ -9416,7 +9964,7 @@
     </p:spTree>
     <p:extLst>
       <p:ext uri="{BB962C8B-B14F-4D97-AF65-F5344CB8AC3E}">
-        <p14:creationId xmlns:p14="http://schemas.microsoft.com/office/powerpoint/2010/main" val="735073390"/>
+        <p14:creationId xmlns:p14="http://schemas.microsoft.com/office/powerpoint/2010/main" val="3392242350"/>
       </p:ext>
     </p:extLst>
   </p:cSld>
@@ -9448,7 +9996,7 @@
           <p:cNvPr id="2" name="Rechteck 1">
             <a:extLst>
               <a:ext uri="{FF2B5EF4-FFF2-40B4-BE49-F238E27FC236}">
-                <a16:creationId xmlns:a16="http://schemas.microsoft.com/office/drawing/2014/main" id="{72C9959D-53F8-0CD7-1242-775A92AF7D35}"/>
+                <a16:creationId xmlns:a16="http://schemas.microsoft.com/office/drawing/2014/main" id="{0A1BB0AE-D215-6C94-62AD-5F9CCAA7AEFA}"/>
               </a:ext>
             </a:extLst>
           </p:cNvPr>
@@ -9514,7 +10062,7 @@
           <p:cNvPr id="3" name="Rechteck 2">
             <a:extLst>
               <a:ext uri="{FF2B5EF4-FFF2-40B4-BE49-F238E27FC236}">
-                <a16:creationId xmlns:a16="http://schemas.microsoft.com/office/drawing/2014/main" id="{8E5B65CA-C897-37E1-6330-6F62276396AD}"/>
+                <a16:creationId xmlns:a16="http://schemas.microsoft.com/office/drawing/2014/main" id="{16BE5AEA-0C28-9552-475A-DE107C9B3692}"/>
               </a:ext>
             </a:extLst>
           </p:cNvPr>
@@ -9584,7 +10132,7 @@
           <p:cNvPr id="4" name="Rechteck 3">
             <a:extLst>
               <a:ext uri="{FF2B5EF4-FFF2-40B4-BE49-F238E27FC236}">
-                <a16:creationId xmlns:a16="http://schemas.microsoft.com/office/drawing/2014/main" id="{E96CEE94-6BEB-1271-F5FE-FB934B7ABF3F}"/>
+                <a16:creationId xmlns:a16="http://schemas.microsoft.com/office/drawing/2014/main" id="{ADBC0C74-9F11-171B-0341-286AC6013EDF}"/>
               </a:ext>
             </a:extLst>
           </p:cNvPr>
@@ -9652,7 +10200,7 @@
           <p:cNvPr id="5" name="Rechteck 4">
             <a:extLst>
               <a:ext uri="{FF2B5EF4-FFF2-40B4-BE49-F238E27FC236}">
-                <a16:creationId xmlns:a16="http://schemas.microsoft.com/office/drawing/2014/main" id="{CC7D4B64-7146-831D-3505-42D447A9943B}"/>
+                <a16:creationId xmlns:a16="http://schemas.microsoft.com/office/drawing/2014/main" id="{186FAB92-A840-3A8A-C730-DCFF37EBC5A3}"/>
               </a:ext>
             </a:extLst>
           </p:cNvPr>
@@ -9720,7 +10268,7 @@
           <p:cNvPr id="6" name="Rechteck 5">
             <a:extLst>
               <a:ext uri="{FF2B5EF4-FFF2-40B4-BE49-F238E27FC236}">
-                <a16:creationId xmlns:a16="http://schemas.microsoft.com/office/drawing/2014/main" id="{387A2CCA-8CC5-BE04-6BB4-F58E3C433F5A}"/>
+                <a16:creationId xmlns:a16="http://schemas.microsoft.com/office/drawing/2014/main" id="{6DF32223-0E88-EC4B-6BF7-8586D2EC6B3A}"/>
               </a:ext>
             </a:extLst>
           </p:cNvPr>
@@ -9800,7 +10348,7 @@
           <p:cNvPr id="7" name="Rechteck 6">
             <a:extLst>
               <a:ext uri="{FF2B5EF4-FFF2-40B4-BE49-F238E27FC236}">
-                <a16:creationId xmlns:a16="http://schemas.microsoft.com/office/drawing/2014/main" id="{4E77CC75-A489-CB2A-ED56-8CEE9EF3A3A2}"/>
+                <a16:creationId xmlns:a16="http://schemas.microsoft.com/office/drawing/2014/main" id="{5D8809B1-F211-3C3A-E917-65E0DEE18A58}"/>
               </a:ext>
             </a:extLst>
           </p:cNvPr>
@@ -9880,7 +10428,7 @@
           <p:cNvPr id="8" name="Rechteck 7">
             <a:extLst>
               <a:ext uri="{FF2B5EF4-FFF2-40B4-BE49-F238E27FC236}">
-                <a16:creationId xmlns:a16="http://schemas.microsoft.com/office/drawing/2014/main" id="{C196E8DC-7481-72F7-40A4-588427D6735E}"/>
+                <a16:creationId xmlns:a16="http://schemas.microsoft.com/office/drawing/2014/main" id="{58847585-0E42-B588-6779-9E3A82266B77}"/>
               </a:ext>
             </a:extLst>
           </p:cNvPr>
@@ -9962,7 +10510,7 @@
           <p:cNvPr id="9" name="Rechteck 8">
             <a:extLst>
               <a:ext uri="{FF2B5EF4-FFF2-40B4-BE49-F238E27FC236}">
-                <a16:creationId xmlns:a16="http://schemas.microsoft.com/office/drawing/2014/main" id="{5263C4FF-D843-17C1-4F64-1583D6167E39}"/>
+                <a16:creationId xmlns:a16="http://schemas.microsoft.com/office/drawing/2014/main" id="{52B202E6-E947-35A6-C755-8403FFA13FF4}"/>
               </a:ext>
             </a:extLst>
           </p:cNvPr>
@@ -10028,7 +10576,7 @@
     </p:spTree>
     <p:extLst>
       <p:ext uri="{BB962C8B-B14F-4D97-AF65-F5344CB8AC3E}">
-        <p14:creationId xmlns:p14="http://schemas.microsoft.com/office/powerpoint/2010/main" val="4051782149"/>
+        <p14:creationId xmlns:p14="http://schemas.microsoft.com/office/powerpoint/2010/main" val="143005091"/>
       </p:ext>
     </p:extLst>
   </p:cSld>

</xml_diff>